<commit_message>
Give the evidence figure a clinical palette
</commit_message>
<xml_diff>
--- a/docs/figures/clearbill-evidence-path/editable/clearbill-evidence-path.pptx
+++ b/docs/figures/clearbill-evidence-path/editable/clearbill-evidence-path.pptx
@@ -2,13 +2,13 @@
 <file path=ppt/presentation.xml><?xml version="1.0" encoding="utf-8"?>
 <p:presentation xmlns:p="http://schemas.openxmlformats.org/presentationml/2006/main">
   <p:sldMasterIdLst>
-    <p:sldMasterId xmlns:r="http://schemas.openxmlformats.org/officeDocument/2006/relationships" id="2147483648" r:id="Rabfe1a2278ce4ecf"/>
+    <p:sldMasterId xmlns:r="http://schemas.openxmlformats.org/officeDocument/2006/relationships" id="2147483648" r:id="Ra6355a825d83480e"/>
   </p:sldMasterIdLst>
   <p:notesMasterIdLst>
-    <p:notesMasterId xmlns:r="http://schemas.openxmlformats.org/officeDocument/2006/relationships" r:id="R2eeded662f0a486a"/>
+    <p:notesMasterId xmlns:r="http://schemas.openxmlformats.org/officeDocument/2006/relationships" r:id="Rf14e2c77280b45ea"/>
   </p:notesMasterIdLst>
   <p:sldIdLst>
-    <p:sldId xmlns:r="http://schemas.openxmlformats.org/officeDocument/2006/relationships" id="256" r:id="R1eff57ebccdd4c6e"/>
+    <p:sldId xmlns:r="http://schemas.openxmlformats.org/officeDocument/2006/relationships" id="256" r:id="Rdb03795d362a45d4"/>
   </p:sldIdLst>
   <p:sldSz cx="12192000" cy="6858000"/>
   <p:notesSz cx="6858000" cy="9144000"/>
@@ -601,7 +601,7 @@
   </p:cSld>
   <p:clrMap bg1="lt1" tx1="dk1" bg2="lt2" tx2="dk2" accent1="accent1" accent2="accent2" accent3="accent3" accent4="accent4" accent5="accent5" accent6="accent6" hlink="hlink" folHlink="folHlink"/>
   <p:sldLayoutIdLst>
-    <p:sldLayoutId xmlns:r="http://schemas.openxmlformats.org/officeDocument/2006/relationships" id="2147483649" r:id="R140e69ada3b9428b"/>
+    <p:sldLayoutId xmlns:r="http://schemas.openxmlformats.org/officeDocument/2006/relationships" id="2147483649" r:id="R950533e171914176"/>
   </p:sldLayoutIdLst>
   <p:txStyles>
     <p:titleStyle>
@@ -1134,7 +1134,7 @@
     <p:bg>
       <p:bgPr>
         <a:solidFill xmlns:a="http://schemas.openxmlformats.org/drawingml/2006/main">
-          <a:srgbClr val="F6F5F0"/>
+          <a:srgbClr val="F2F6FC"/>
         </a:solidFill>
       </p:bgPr>
     </p:bg>
@@ -1152,7 +1152,7 @@
           <p:cNvPr id="89" name="title">
             <a:extLst xmlns:a="http://schemas.openxmlformats.org/drawingml/2006/main">
               <a:ext uri="{FF2B5EF4-FFF2-40B4-BE49-F238E27FC236}">
-                <a16:creationId xmlns:a16="http://schemas.microsoft.com/office/drawing/2014/main" id="{FC198598-ADE2-45DB-B690-431493C34F0D}"/>
+                <a16:creationId xmlns:a16="http://schemas.microsoft.com/office/drawing/2014/main" id="{BD4FA41E-9AB2-4119-90EC-A932AA4AF835}"/>
               </a:ext>
             </a:extLst>
           </p:cNvPr>
@@ -1182,14 +1182,14 @@
             <a:pPr algn="l">
               <a:defRPr sz="2475" b="1">
                 <a:solidFill>
-                  <a:srgbClr val="172033"/>
+                  <a:srgbClr val="15213B"/>
                 </a:solidFill>
               </a:defRPr>
             </a:pPr>
             <a:r>
               <a:rPr sz="2475" b="1">
                 <a:solidFill>
-                  <a:srgbClr val="172033"/>
+                  <a:srgbClr val="15213B"/>
                 </a:solidFill>
               </a:rPr>
               <a:t>ClearBill keeps the explanation attached to the synthetic statement</a:t>
@@ -1202,7 +1202,7 @@
           <p:cNvPr id="2" name="subtitle">
             <a:extLst xmlns:a="http://schemas.openxmlformats.org/drawingml/2006/main">
               <a:ext uri="{FF2B5EF4-FFF2-40B4-BE49-F238E27FC236}">
-                <a16:creationId xmlns:a16="http://schemas.microsoft.com/office/drawing/2014/main" id="{2E1C8167-276F-48B8-BE1C-F028E216F167}"/>
+                <a16:creationId xmlns:a16="http://schemas.microsoft.com/office/drawing/2014/main" id="{EB67E8F7-24DB-4E4E-A19C-76C2D197777B}"/>
               </a:ext>
             </a:extLst>
           </p:cNvPr>
@@ -1232,14 +1232,14 @@
             <a:pPr algn="l">
               <a:defRPr sz="1200" b="0">
                 <a:solidFill>
-                  <a:srgbClr val="667084"/>
+                  <a:srgbClr val="63708A"/>
                 </a:solidFill>
               </a:defRPr>
             </a:pPr>
             <a:r>
               <a:rPr sz="1200" b="0">
                 <a:solidFill>
-                  <a:srgbClr val="667084"/>
+                  <a:srgbClr val="63708A"/>
                 </a:solidFill>
               </a:rPr>
               <a:t>One EOB is annotated in place: the answer names the fields to compare, cites public guidance, and keeps live refusal separate from the fixture.</a:t>
@@ -1252,7 +1252,7 @@
           <p:cNvPr id="3" name="header-rule">
             <a:extLst xmlns:a="http://schemas.openxmlformats.org/drawingml/2006/main">
               <a:ext uri="{FF2B5EF4-FFF2-40B4-BE49-F238E27FC236}">
-                <a16:creationId xmlns:a16="http://schemas.microsoft.com/office/drawing/2014/main" id="{96EF8707-7F8E-4A65-AA31-0C6653D9579D}"/>
+                <a16:creationId xmlns:a16="http://schemas.microsoft.com/office/drawing/2014/main" id="{0F344A6D-9953-421D-917D-9E2333D1E8F1}"/>
               </a:ext>
             </a:extLst>
           </p:cNvPr>
@@ -1272,7 +1272,7 @@
           <a:noFill xmlns:a="http://schemas.openxmlformats.org/drawingml/2006/main"/>
           <a:ln xmlns:a="http://schemas.openxmlformats.org/drawingml/2006/main" w="14288">
             <a:solidFill>
-              <a:srgbClr val="172033"/>
+              <a:srgbClr val="15213B"/>
             </a:solidFill>
             <a:prstDash val="solid"/>
           </a:ln>
@@ -1283,7 +1283,7 @@
           <p:cNvPr id="4" name="document-label">
             <a:extLst xmlns:a="http://schemas.openxmlformats.org/drawingml/2006/main">
               <a:ext uri="{FF2B5EF4-FFF2-40B4-BE49-F238E27FC236}">
-                <a16:creationId xmlns:a16="http://schemas.microsoft.com/office/drawing/2014/main" id="{EB7240B2-F354-4718-A586-4040F2C21E85}"/>
+                <a16:creationId xmlns:a16="http://schemas.microsoft.com/office/drawing/2014/main" id="{24A746B7-AFC0-467F-BB33-08AEF2246851}"/>
               </a:ext>
             </a:extLst>
           </p:cNvPr>
@@ -1313,14 +1313,14 @@
             <a:pPr algn="l">
               <a:defRPr sz="900" b="1">
                 <a:solidFill>
-                  <a:srgbClr val="295AC8"/>
+                  <a:srgbClr val="165DFF"/>
                 </a:solidFill>
               </a:defRPr>
             </a:pPr>
             <a:r>
               <a:rPr sz="900" b="1">
                 <a:solidFill>
-                  <a:srgbClr val="295AC8"/>
+                  <a:srgbClr val="165DFF"/>
                 </a:solidFill>
               </a:rPr>
               <a:t>SYNTHETIC EXPLANATION OF BENEFITS</a:t>
@@ -1333,7 +1333,7 @@
           <p:cNvPr id="5" name="document">
             <a:extLst xmlns:a="http://schemas.openxmlformats.org/drawingml/2006/main">
               <a:ext uri="{FF2B5EF4-FFF2-40B4-BE49-F238E27FC236}">
-                <a16:creationId xmlns:a16="http://schemas.microsoft.com/office/drawing/2014/main" id="{6B597B15-DEF8-49C6-AFDD-F0420A983C24}"/>
+                <a16:creationId xmlns:a16="http://schemas.microsoft.com/office/drawing/2014/main" id="{14B29E59-9192-4B0D-98A6-02C918A40CDA}"/>
               </a:ext>
             </a:extLst>
           </p:cNvPr>
@@ -1355,7 +1355,7 @@
           </a:solidFill>
           <a:ln xmlns:a="http://schemas.openxmlformats.org/drawingml/2006/main" w="12383">
             <a:solidFill>
-              <a:srgbClr val="17243B"/>
+              <a:srgbClr val="102A56"/>
             </a:solidFill>
             <a:prstDash val="solid"/>
           </a:ln>
@@ -1366,7 +1366,7 @@
           <p:cNvPr id="6" name="document-accent">
             <a:extLst xmlns:a="http://schemas.openxmlformats.org/drawingml/2006/main">
               <a:ext uri="{FF2B5EF4-FFF2-40B4-BE49-F238E27FC236}">
-                <a16:creationId xmlns:a16="http://schemas.microsoft.com/office/drawing/2014/main" id="{3291621A-A571-41BC-9E4C-48FDDFD66353}"/>
+                <a16:creationId xmlns:a16="http://schemas.microsoft.com/office/drawing/2014/main" id="{4B1B4C43-B7EE-46E5-84A0-D74FEE90165A}"/>
               </a:ext>
             </a:extLst>
           </p:cNvPr>
@@ -1384,11 +1384,11 @@
             <a:avLst/>
           </a:prstGeom>
           <a:solidFill xmlns:a="http://schemas.openxmlformats.org/drawingml/2006/main">
-            <a:srgbClr val="295AC8"/>
+            <a:srgbClr val="165DFF"/>
           </a:solidFill>
           <a:ln xmlns:a="http://schemas.openxmlformats.org/drawingml/2006/main" w="0">
             <a:solidFill>
-              <a:srgbClr val="295AC8"/>
+              <a:srgbClr val="165DFF"/>
             </a:solidFill>
             <a:prstDash val="solid"/>
           </a:ln>
@@ -1399,7 +1399,7 @@
           <p:cNvPr id="7" name="doc-eyebrow">
             <a:extLst xmlns:a="http://schemas.openxmlformats.org/drawingml/2006/main">
               <a:ext uri="{FF2B5EF4-FFF2-40B4-BE49-F238E27FC236}">
-                <a16:creationId xmlns:a16="http://schemas.microsoft.com/office/drawing/2014/main" id="{6C145B1A-3DE3-4F30-B2D8-EDBE34EA0985}"/>
+                <a16:creationId xmlns:a16="http://schemas.microsoft.com/office/drawing/2014/main" id="{D9D29C14-6F93-4BEE-90BB-1CEF70258A87}"/>
               </a:ext>
             </a:extLst>
           </p:cNvPr>
@@ -1429,14 +1429,14 @@
             <a:pPr algn="l">
               <a:defRPr sz="750" b="1">
                 <a:solidFill>
-                  <a:srgbClr val="295AC8"/>
+                  <a:srgbClr val="165DFF"/>
                 </a:solidFill>
               </a:defRPr>
             </a:pPr>
             <a:r>
               <a:rPr sz="750" b="1">
                 <a:solidFill>
-                  <a:srgbClr val="295AC8"/>
+                  <a:srgbClr val="165DFF"/>
                 </a:solidFill>
               </a:rPr>
               <a:t>EXPLANATION OF BENEFITS</a:t>
@@ -1449,7 +1449,7 @@
           <p:cNvPr id="8" name="doc-title">
             <a:extLst xmlns:a="http://schemas.openxmlformats.org/drawingml/2006/main">
               <a:ext uri="{FF2B5EF4-FFF2-40B4-BE49-F238E27FC236}">
-                <a16:creationId xmlns:a16="http://schemas.microsoft.com/office/drawing/2014/main" id="{386545C2-DFF0-41DD-8453-4D1AE7BF59A4}"/>
+                <a16:creationId xmlns:a16="http://schemas.microsoft.com/office/drawing/2014/main" id="{5F54ADF5-98CD-4C32-82BB-8E4E5D84E97A}"/>
               </a:ext>
             </a:extLst>
           </p:cNvPr>
@@ -1479,14 +1479,14 @@
             <a:pPr algn="l">
               <a:defRPr sz="1575" b="1">
                 <a:solidFill>
-                  <a:srgbClr val="17243B"/>
+                  <a:srgbClr val="102A56"/>
                 </a:solidFill>
               </a:defRPr>
             </a:pPr>
             <a:r>
               <a:rPr sz="1575" b="1">
                 <a:solidFill>
-                  <a:srgbClr val="17243B"/>
+                  <a:srgbClr val="102A56"/>
                 </a:solidFill>
               </a:rPr>
               <a:t>Claim 04-2719</a:t>
@@ -1499,7 +1499,7 @@
           <p:cNvPr id="9" name="doc-subtitle">
             <a:extLst xmlns:a="http://schemas.openxmlformats.org/drawingml/2006/main">
               <a:ext uri="{FF2B5EF4-FFF2-40B4-BE49-F238E27FC236}">
-                <a16:creationId xmlns:a16="http://schemas.microsoft.com/office/drawing/2014/main" id="{93778D9D-CA7A-4F22-83C0-B489F505E550}"/>
+                <a16:creationId xmlns:a16="http://schemas.microsoft.com/office/drawing/2014/main" id="{107EA676-3709-41A6-B6FE-ECB8C9B43031}"/>
               </a:ext>
             </a:extLst>
           </p:cNvPr>
@@ -1529,14 +1529,14 @@
             <a:pPr algn="l">
               <a:defRPr sz="863" b="0">
                 <a:solidFill>
-                  <a:srgbClr val="667084"/>
+                  <a:srgbClr val="63708A"/>
                 </a:solidFill>
               </a:defRPr>
             </a:pPr>
             <a:r>
               <a:rPr sz="863" b="0">
                 <a:solidFill>
-                  <a:srgbClr val="667084"/>
+                  <a:srgbClr val="63708A"/>
                 </a:solidFill>
               </a:rPr>
               <a:t>Northstar Internal Medicine · Sample PPO plan</a:t>
@@ -1549,7 +1549,7 @@
           <p:cNvPr id="10" name="doc-meta">
             <a:extLst xmlns:a="http://schemas.openxmlformats.org/drawingml/2006/main">
               <a:ext uri="{FF2B5EF4-FFF2-40B4-BE49-F238E27FC236}">
-                <a16:creationId xmlns:a16="http://schemas.microsoft.com/office/drawing/2014/main" id="{F4D9909C-8003-4E7D-A49B-9C89A5A95AF1}"/>
+                <a16:creationId xmlns:a16="http://schemas.microsoft.com/office/drawing/2014/main" id="{85449B4B-7887-4AB1-90A6-473FED47094C}"/>
               </a:ext>
             </a:extLst>
           </p:cNvPr>
@@ -1579,14 +1579,14 @@
             <a:pPr algn="r">
               <a:defRPr sz="788" b="0">
                 <a:solidFill>
-                  <a:srgbClr val="667084"/>
+                  <a:srgbClr val="63708A"/>
                 </a:solidFill>
               </a:defRPr>
             </a:pPr>
             <a:r>
               <a:rPr sz="788" b="0">
                 <a:solidFill>
-                  <a:srgbClr val="667084"/>
+                  <a:srgbClr val="63708A"/>
                 </a:solidFill>
               </a:rPr>
               <a:t>Sample member</a:t>
@@ -1596,14 +1596,14 @@
             <a:pPr algn="r">
               <a:defRPr sz="788" b="0">
                 <a:solidFill>
-                  <a:srgbClr val="667084"/>
+                  <a:srgbClr val="63708A"/>
                 </a:solidFill>
               </a:defRPr>
             </a:pPr>
             <a:r>
               <a:rPr sz="788" b="0">
                 <a:solidFill>
-                  <a:srgbClr val="667084"/>
+                  <a:srgbClr val="63708A"/>
                 </a:solidFill>
               </a:rPr>
               <a:t>Apr 10, 2026 service</a:t>
@@ -1613,14 +1613,14 @@
             <a:pPr algn="r">
               <a:defRPr sz="788" b="0">
                 <a:solidFill>
-                  <a:srgbClr val="667084"/>
+                  <a:srgbClr val="63708A"/>
                 </a:solidFill>
               </a:defRPr>
             </a:pPr>
             <a:r>
               <a:rPr sz="788" b="0">
                 <a:solidFill>
-                  <a:srgbClr val="667084"/>
+                  <a:srgbClr val="63708A"/>
                 </a:solidFill>
               </a:rPr>
               <a:t>Apr 18, 2026 processed</a:t>
@@ -1630,14 +1630,14 @@
             <a:pPr algn="r">
               <a:defRPr sz="788" b="0">
                 <a:solidFill>
-                  <a:srgbClr val="667084"/>
+                  <a:srgbClr val="63708A"/>
                 </a:solidFill>
               </a:defRPr>
             </a:pPr>
             <a:r>
               <a:rPr sz="788" b="0">
                 <a:solidFill>
-                  <a:srgbClr val="667084"/>
+                  <a:srgbClr val="63708A"/>
                 </a:solidFill>
               </a:rPr>
               <a:t>Finalized</a:t>
@@ -1650,7 +1650,7 @@
           <p:cNvPr id="11" name="doc-rule-1">
             <a:extLst xmlns:a="http://schemas.openxmlformats.org/drawingml/2006/main">
               <a:ext uri="{FF2B5EF4-FFF2-40B4-BE49-F238E27FC236}">
-                <a16:creationId xmlns:a16="http://schemas.microsoft.com/office/drawing/2014/main" id="{B46F4F3E-AF7C-4890-89F6-B0FF7DA17FDC}"/>
+                <a16:creationId xmlns:a16="http://schemas.microsoft.com/office/drawing/2014/main" id="{2478E03F-ED00-4D0B-AB6D-E7C790243B07}"/>
               </a:ext>
             </a:extLst>
           </p:cNvPr>
@@ -1670,7 +1670,7 @@
           <a:noFill xmlns:a="http://schemas.openxmlformats.org/drawingml/2006/main"/>
           <a:ln xmlns:a="http://schemas.openxmlformats.org/drawingml/2006/main" w="9525">
             <a:solidFill>
-              <a:srgbClr val="C9D0D8"/>
+              <a:srgbClr val="BCC9DA"/>
             </a:solidFill>
             <a:prstDash val="solid"/>
           </a:ln>
@@ -1681,7 +1681,7 @@
           <p:cNvPr id="12" name="summary-0">
             <a:extLst xmlns:a="http://schemas.openxmlformats.org/drawingml/2006/main">
               <a:ext uri="{FF2B5EF4-FFF2-40B4-BE49-F238E27FC236}">
-                <a16:creationId xmlns:a16="http://schemas.microsoft.com/office/drawing/2014/main" id="{FB4C0737-E0D2-4FC1-AEA4-C42993DC045C}"/>
+                <a16:creationId xmlns:a16="http://schemas.microsoft.com/office/drawing/2014/main" id="{A3C321FF-1E97-434B-9B4B-A53EE5B895C3}"/>
               </a:ext>
             </a:extLst>
           </p:cNvPr>
@@ -1699,11 +1699,11 @@
             <a:avLst/>
           </a:prstGeom>
           <a:solidFill xmlns:a="http://schemas.openxmlformats.org/drawingml/2006/main">
-            <a:srgbClr val="EEF0F2"/>
+            <a:srgbClr val="E9EEF5"/>
           </a:solidFill>
           <a:ln xmlns:a="http://schemas.openxmlformats.org/drawingml/2006/main" w="9525">
             <a:solidFill>
-              <a:srgbClr val="C9D0D8"/>
+              <a:srgbClr val="BCC9DA"/>
             </a:solidFill>
             <a:prstDash val="solid"/>
           </a:ln>
@@ -1714,7 +1714,7 @@
           <p:cNvPr id="13" name="summary-label-0">
             <a:extLst xmlns:a="http://schemas.openxmlformats.org/drawingml/2006/main">
               <a:ext uri="{FF2B5EF4-FFF2-40B4-BE49-F238E27FC236}">
-                <a16:creationId xmlns:a16="http://schemas.microsoft.com/office/drawing/2014/main" id="{94ADBEC5-CC74-458D-93B5-C5C017CC379D}"/>
+                <a16:creationId xmlns:a16="http://schemas.microsoft.com/office/drawing/2014/main" id="{A089E27E-E54C-409C-A7A0-A20B5DDC6D7B}"/>
               </a:ext>
             </a:extLst>
           </p:cNvPr>
@@ -1744,14 +1744,14 @@
             <a:pPr algn="l">
               <a:defRPr sz="675" b="1">
                 <a:solidFill>
-                  <a:srgbClr val="667084"/>
+                  <a:srgbClr val="63708A"/>
                 </a:solidFill>
               </a:defRPr>
             </a:pPr>
             <a:r>
               <a:rPr sz="675" b="1">
                 <a:solidFill>
-                  <a:srgbClr val="667084"/>
+                  <a:srgbClr val="63708A"/>
                 </a:solidFill>
               </a:rPr>
               <a:t>PROVIDER BILLED</a:t>
@@ -1764,7 +1764,7 @@
           <p:cNvPr id="14" name="summary-value-0">
             <a:extLst xmlns:a="http://schemas.openxmlformats.org/drawingml/2006/main">
               <a:ext uri="{FF2B5EF4-FFF2-40B4-BE49-F238E27FC236}">
-                <a16:creationId xmlns:a16="http://schemas.microsoft.com/office/drawing/2014/main" id="{0E7EADD4-8F39-4A60-8211-62FB1AF7700B}"/>
+                <a16:creationId xmlns:a16="http://schemas.microsoft.com/office/drawing/2014/main" id="{5F208791-C681-4408-AB01-34A7E5C3AB96}"/>
               </a:ext>
             </a:extLst>
           </p:cNvPr>
@@ -1794,14 +1794,14 @@
             <a:pPr algn="l">
               <a:defRPr sz="1200" b="1">
                 <a:solidFill>
-                  <a:srgbClr val="17243B"/>
+                  <a:srgbClr val="102A56"/>
                 </a:solidFill>
               </a:defRPr>
             </a:pPr>
             <a:r>
               <a:rPr sz="1200" b="1">
                 <a:solidFill>
-                  <a:srgbClr val="17243B"/>
+                  <a:srgbClr val="102A56"/>
                 </a:solidFill>
               </a:rPr>
               <a:t>$593.00</a:t>
@@ -1814,7 +1814,7 @@
           <p:cNvPr id="15" name="summary-1">
             <a:extLst xmlns:a="http://schemas.openxmlformats.org/drawingml/2006/main">
               <a:ext uri="{FF2B5EF4-FFF2-40B4-BE49-F238E27FC236}">
-                <a16:creationId xmlns:a16="http://schemas.microsoft.com/office/drawing/2014/main" id="{1D75100E-ACFD-4F11-A51C-36893773CE2F}"/>
+                <a16:creationId xmlns:a16="http://schemas.microsoft.com/office/drawing/2014/main" id="{24EAA2BF-3C94-4C4B-A38F-D9173BE72B22}"/>
               </a:ext>
             </a:extLst>
           </p:cNvPr>
@@ -1832,11 +1832,11 @@
             <a:avLst/>
           </a:prstGeom>
           <a:solidFill xmlns:a="http://schemas.openxmlformats.org/drawingml/2006/main">
-            <a:srgbClr val="EEF0F2"/>
+            <a:srgbClr val="E9EEF5"/>
           </a:solidFill>
           <a:ln xmlns:a="http://schemas.openxmlformats.org/drawingml/2006/main" w="9525">
             <a:solidFill>
-              <a:srgbClr val="C9D0D8"/>
+              <a:srgbClr val="BCC9DA"/>
             </a:solidFill>
             <a:prstDash val="solid"/>
           </a:ln>
@@ -1847,7 +1847,7 @@
           <p:cNvPr id="16" name="summary-label-1">
             <a:extLst xmlns:a="http://schemas.openxmlformats.org/drawingml/2006/main">
               <a:ext uri="{FF2B5EF4-FFF2-40B4-BE49-F238E27FC236}">
-                <a16:creationId xmlns:a16="http://schemas.microsoft.com/office/drawing/2014/main" id="{AF9507A8-5A3B-4F2D-AE83-A2CB2D8045AE}"/>
+                <a16:creationId xmlns:a16="http://schemas.microsoft.com/office/drawing/2014/main" id="{3B4AC50B-C77E-4EA2-962B-2E71F8B8A781}"/>
               </a:ext>
             </a:extLst>
           </p:cNvPr>
@@ -1877,14 +1877,14 @@
             <a:pPr algn="l">
               <a:defRPr sz="675" b="1">
                 <a:solidFill>
-                  <a:srgbClr val="667084"/>
+                  <a:srgbClr val="63708A"/>
                 </a:solidFill>
               </a:defRPr>
             </a:pPr>
             <a:r>
               <a:rPr sz="675" b="1">
                 <a:solidFill>
-                  <a:srgbClr val="667084"/>
+                  <a:srgbClr val="63708A"/>
                 </a:solidFill>
               </a:rPr>
               <a:t>PLAN DISCOUNTS</a:t>
@@ -1897,7 +1897,7 @@
           <p:cNvPr id="17" name="summary-value-1">
             <a:extLst xmlns:a="http://schemas.openxmlformats.org/drawingml/2006/main">
               <a:ext uri="{FF2B5EF4-FFF2-40B4-BE49-F238E27FC236}">
-                <a16:creationId xmlns:a16="http://schemas.microsoft.com/office/drawing/2014/main" id="{D82C5D95-686F-4CC0-A825-DDAA2AB12251}"/>
+                <a16:creationId xmlns:a16="http://schemas.microsoft.com/office/drawing/2014/main" id="{EF81B20A-E839-4E94-9D3C-651D3B82D916}"/>
               </a:ext>
             </a:extLst>
           </p:cNvPr>
@@ -1927,14 +1927,14 @@
             <a:pPr algn="l">
               <a:defRPr sz="1200" b="1">
                 <a:solidFill>
-                  <a:srgbClr val="17243B"/>
+                  <a:srgbClr val="102A56"/>
                 </a:solidFill>
               </a:defRPr>
             </a:pPr>
             <a:r>
               <a:rPr sz="1200" b="1">
                 <a:solidFill>
-                  <a:srgbClr val="17243B"/>
+                  <a:srgbClr val="102A56"/>
                 </a:solidFill>
               </a:rPr>
               <a:t>−$282.00</a:t>
@@ -1947,7 +1947,7 @@
           <p:cNvPr id="18" name="summary-2">
             <a:extLst xmlns:a="http://schemas.openxmlformats.org/drawingml/2006/main">
               <a:ext uri="{FF2B5EF4-FFF2-40B4-BE49-F238E27FC236}">
-                <a16:creationId xmlns:a16="http://schemas.microsoft.com/office/drawing/2014/main" id="{9895F02C-729F-49CD-8C9C-013F32095621}"/>
+                <a16:creationId xmlns:a16="http://schemas.microsoft.com/office/drawing/2014/main" id="{010C6770-4B88-4DDC-BD36-A6FD0800125B}"/>
               </a:ext>
             </a:extLst>
           </p:cNvPr>
@@ -1965,11 +1965,11 @@
             <a:avLst/>
           </a:prstGeom>
           <a:solidFill xmlns:a="http://schemas.openxmlformats.org/drawingml/2006/main">
-            <a:srgbClr val="EEF0F2"/>
+            <a:srgbClr val="E9EEF5"/>
           </a:solidFill>
           <a:ln xmlns:a="http://schemas.openxmlformats.org/drawingml/2006/main" w="9525">
             <a:solidFill>
-              <a:srgbClr val="C9D0D8"/>
+              <a:srgbClr val="BCC9DA"/>
             </a:solidFill>
             <a:prstDash val="solid"/>
           </a:ln>
@@ -1980,7 +1980,7 @@
           <p:cNvPr id="19" name="summary-label-2">
             <a:extLst xmlns:a="http://schemas.openxmlformats.org/drawingml/2006/main">
               <a:ext uri="{FF2B5EF4-FFF2-40B4-BE49-F238E27FC236}">
-                <a16:creationId xmlns:a16="http://schemas.microsoft.com/office/drawing/2014/main" id="{EA0820C7-4AD0-4C73-B43C-1BE84C3CBCBB}"/>
+                <a16:creationId xmlns:a16="http://schemas.microsoft.com/office/drawing/2014/main" id="{6ED5CD2E-C11D-44BF-BF4E-D1D8AD7BE26B}"/>
               </a:ext>
             </a:extLst>
           </p:cNvPr>
@@ -2010,14 +2010,14 @@
             <a:pPr algn="l">
               <a:defRPr sz="675" b="1">
                 <a:solidFill>
-                  <a:srgbClr val="667084"/>
+                  <a:srgbClr val="63708A"/>
                 </a:solidFill>
               </a:defRPr>
             </a:pPr>
             <a:r>
               <a:rPr sz="675" b="1">
                 <a:solidFill>
-                  <a:srgbClr val="667084"/>
+                  <a:srgbClr val="63708A"/>
                 </a:solidFill>
               </a:rPr>
               <a:t>PLAN PAID</a:t>
@@ -2030,7 +2030,7 @@
           <p:cNvPr id="20" name="summary-value-2">
             <a:extLst xmlns:a="http://schemas.openxmlformats.org/drawingml/2006/main">
               <a:ext uri="{FF2B5EF4-FFF2-40B4-BE49-F238E27FC236}">
-                <a16:creationId xmlns:a16="http://schemas.microsoft.com/office/drawing/2014/main" id="{264DD625-1486-40F1-A09E-5F261BFBB980}"/>
+                <a16:creationId xmlns:a16="http://schemas.microsoft.com/office/drawing/2014/main" id="{63D52F1B-9E09-425C-8B29-74C591D3CDEA}"/>
               </a:ext>
             </a:extLst>
           </p:cNvPr>
@@ -2060,14 +2060,14 @@
             <a:pPr algn="l">
               <a:defRPr sz="1200" b="1">
                 <a:solidFill>
-                  <a:srgbClr val="17243B"/>
+                  <a:srgbClr val="102A56"/>
                 </a:solidFill>
               </a:defRPr>
             </a:pPr>
             <a:r>
               <a:rPr sz="1200" b="1">
                 <a:solidFill>
-                  <a:srgbClr val="17243B"/>
+                  <a:srgbClr val="102A56"/>
                 </a:solidFill>
               </a:rPr>
               <a:t>−$251.00</a:t>
@@ -2080,7 +2080,7 @@
           <p:cNvPr id="21" name="summary-3">
             <a:extLst xmlns:a="http://schemas.openxmlformats.org/drawingml/2006/main">
               <a:ext uri="{FF2B5EF4-FFF2-40B4-BE49-F238E27FC236}">
-                <a16:creationId xmlns:a16="http://schemas.microsoft.com/office/drawing/2014/main" id="{E93FCED6-A772-4C89-A583-D63E60A579F2}"/>
+                <a16:creationId xmlns:a16="http://schemas.microsoft.com/office/drawing/2014/main" id="{9E94388D-42BE-4FEB-88E7-6FE754634046}"/>
               </a:ext>
             </a:extLst>
           </p:cNvPr>
@@ -2098,11 +2098,11 @@
             <a:avLst/>
           </a:prstGeom>
           <a:solidFill xmlns:a="http://schemas.openxmlformats.org/drawingml/2006/main">
-            <a:srgbClr val="FFF0C4"/>
+            <a:srgbClr val="FFF0A8"/>
           </a:solidFill>
           <a:ln xmlns:a="http://schemas.openxmlformats.org/drawingml/2006/main" w="9525">
             <a:solidFill>
-              <a:srgbClr val="A46900"/>
+              <a:srgbClr val="9B6200"/>
             </a:solidFill>
             <a:prstDash val="solid"/>
           </a:ln>
@@ -2113,7 +2113,7 @@
           <p:cNvPr id="22" name="summary-label-3">
             <a:extLst xmlns:a="http://schemas.openxmlformats.org/drawingml/2006/main">
               <a:ext uri="{FF2B5EF4-FFF2-40B4-BE49-F238E27FC236}">
-                <a16:creationId xmlns:a16="http://schemas.microsoft.com/office/drawing/2014/main" id="{DD49B338-18B6-43C7-8133-78FE2FC726B9}"/>
+                <a16:creationId xmlns:a16="http://schemas.microsoft.com/office/drawing/2014/main" id="{E3869414-AE03-4557-B728-644EEB091F67}"/>
               </a:ext>
             </a:extLst>
           </p:cNvPr>
@@ -2143,14 +2143,14 @@
             <a:pPr algn="l">
               <a:defRPr sz="675" b="1">
                 <a:solidFill>
-                  <a:srgbClr val="A46900"/>
+                  <a:srgbClr val="9B6200"/>
                 </a:solidFill>
               </a:defRPr>
             </a:pPr>
             <a:r>
               <a:rPr sz="675" b="1">
                 <a:solidFill>
-                  <a:srgbClr val="A46900"/>
+                  <a:srgbClr val="9B6200"/>
                 </a:solidFill>
               </a:rPr>
               <a:t>YOU MAY OWE</a:t>
@@ -2163,7 +2163,7 @@
           <p:cNvPr id="23" name="summary-value-3">
             <a:extLst xmlns:a="http://schemas.openxmlformats.org/drawingml/2006/main">
               <a:ext uri="{FF2B5EF4-FFF2-40B4-BE49-F238E27FC236}">
-                <a16:creationId xmlns:a16="http://schemas.microsoft.com/office/drawing/2014/main" id="{0EAF2D6A-5DC1-4A42-B9DC-D41F632885C5}"/>
+                <a16:creationId xmlns:a16="http://schemas.microsoft.com/office/drawing/2014/main" id="{A3D4D6E8-1512-45F7-B52C-BBBFD48A7BAE}"/>
               </a:ext>
             </a:extLst>
           </p:cNvPr>
@@ -2193,14 +2193,14 @@
             <a:pPr algn="l">
               <a:defRPr sz="1200" b="1">
                 <a:solidFill>
-                  <a:srgbClr val="A46900"/>
+                  <a:srgbClr val="9B6200"/>
                 </a:solidFill>
               </a:defRPr>
             </a:pPr>
             <a:r>
               <a:rPr sz="1200" b="1">
                 <a:solidFill>
-                  <a:srgbClr val="A46900"/>
+                  <a:srgbClr val="9B6200"/>
                 </a:solidFill>
               </a:rPr>
               <a:t>$60.00</a:t>
@@ -2213,7 +2213,7 @@
           <p:cNvPr id="24" name="service-head">
             <a:extLst xmlns:a="http://schemas.openxmlformats.org/drawingml/2006/main">
               <a:ext uri="{FF2B5EF4-FFF2-40B4-BE49-F238E27FC236}">
-                <a16:creationId xmlns:a16="http://schemas.microsoft.com/office/drawing/2014/main" id="{AC679C07-1C06-4343-B821-0762F1CE8FEA}"/>
+                <a16:creationId xmlns:a16="http://schemas.microsoft.com/office/drawing/2014/main" id="{4273CF98-28BC-494F-8F26-719DCF62B39C}"/>
               </a:ext>
             </a:extLst>
           </p:cNvPr>
@@ -2243,14 +2243,14 @@
             <a:pPr algn="l">
               <a:defRPr sz="675" b="1">
                 <a:solidFill>
-                  <a:srgbClr val="667084"/>
+                  <a:srgbClr val="63708A"/>
                 </a:solidFill>
               </a:defRPr>
             </a:pPr>
             <a:r>
               <a:rPr sz="675" b="1">
                 <a:solidFill>
-                  <a:srgbClr val="667084"/>
+                  <a:srgbClr val="63708A"/>
                 </a:solidFill>
               </a:rPr>
               <a:t>SERVICE</a:t>
@@ -2263,7 +2263,7 @@
           <p:cNvPr id="25" name="billed-head">
             <a:extLst xmlns:a="http://schemas.openxmlformats.org/drawingml/2006/main">
               <a:ext uri="{FF2B5EF4-FFF2-40B4-BE49-F238E27FC236}">
-                <a16:creationId xmlns:a16="http://schemas.microsoft.com/office/drawing/2014/main" id="{FD74C112-CE0B-4292-BCB2-D4082299C24A}"/>
+                <a16:creationId xmlns:a16="http://schemas.microsoft.com/office/drawing/2014/main" id="{F17DF541-95F9-44C5-AD1B-7101F08C74B6}"/>
               </a:ext>
             </a:extLst>
           </p:cNvPr>
@@ -2293,14 +2293,14 @@
             <a:pPr algn="r">
               <a:defRPr sz="675" b="1">
                 <a:solidFill>
-                  <a:srgbClr val="667084"/>
+                  <a:srgbClr val="63708A"/>
                 </a:solidFill>
               </a:defRPr>
             </a:pPr>
             <a:r>
               <a:rPr sz="675" b="1">
                 <a:solidFill>
-                  <a:srgbClr val="667084"/>
+                  <a:srgbClr val="63708A"/>
                 </a:solidFill>
               </a:rPr>
               <a:t>BILLED</a:t>
@@ -2313,7 +2313,7 @@
           <p:cNvPr id="26" name="allowed-head">
             <a:extLst xmlns:a="http://schemas.openxmlformats.org/drawingml/2006/main">
               <a:ext uri="{FF2B5EF4-FFF2-40B4-BE49-F238E27FC236}">
-                <a16:creationId xmlns:a16="http://schemas.microsoft.com/office/drawing/2014/main" id="{B077BE16-DC09-4471-BFAB-0F7DB79E2A0F}"/>
+                <a16:creationId xmlns:a16="http://schemas.microsoft.com/office/drawing/2014/main" id="{7D5AB1BE-F2C4-4B4F-A30F-20586A74BD9C}"/>
               </a:ext>
             </a:extLst>
           </p:cNvPr>
@@ -2343,14 +2343,14 @@
             <a:pPr algn="r">
               <a:defRPr sz="675" b="1">
                 <a:solidFill>
-                  <a:srgbClr val="667084"/>
+                  <a:srgbClr val="63708A"/>
                 </a:solidFill>
               </a:defRPr>
             </a:pPr>
             <a:r>
               <a:rPr sz="675" b="1">
                 <a:solidFill>
-                  <a:srgbClr val="667084"/>
+                  <a:srgbClr val="63708A"/>
                 </a:solidFill>
               </a:rPr>
               <a:t>ALLOWED</a:t>
@@ -2363,7 +2363,7 @@
           <p:cNvPr id="27" name="owe-head">
             <a:extLst xmlns:a="http://schemas.openxmlformats.org/drawingml/2006/main">
               <a:ext uri="{FF2B5EF4-FFF2-40B4-BE49-F238E27FC236}">
-                <a16:creationId xmlns:a16="http://schemas.microsoft.com/office/drawing/2014/main" id="{501FB121-F0AB-4F21-8CC9-73C7173CFA00}"/>
+                <a16:creationId xmlns:a16="http://schemas.microsoft.com/office/drawing/2014/main" id="{1A35CCE0-2EC8-4A7F-B1E1-7CC5DC4CFAAA}"/>
               </a:ext>
             </a:extLst>
           </p:cNvPr>
@@ -2393,14 +2393,14 @@
             <a:pPr algn="r">
               <a:defRPr sz="675" b="1">
                 <a:solidFill>
-                  <a:srgbClr val="667084"/>
+                  <a:srgbClr val="63708A"/>
                 </a:solidFill>
               </a:defRPr>
             </a:pPr>
             <a:r>
               <a:rPr sz="675" b="1">
                 <a:solidFill>
-                  <a:srgbClr val="667084"/>
+                  <a:srgbClr val="63708A"/>
                 </a:solidFill>
               </a:rPr>
               <a:t>YOU OWE</a:t>
@@ -2413,7 +2413,7 @@
           <p:cNvPr id="28" name="row-bg-0">
             <a:extLst xmlns:a="http://schemas.openxmlformats.org/drawingml/2006/main">
               <a:ext uri="{FF2B5EF4-FFF2-40B4-BE49-F238E27FC236}">
-                <a16:creationId xmlns:a16="http://schemas.microsoft.com/office/drawing/2014/main" id="{9817A993-C3E9-46CB-8A9B-B7FB3A8854EC}"/>
+                <a16:creationId xmlns:a16="http://schemas.microsoft.com/office/drawing/2014/main" id="{CB35DD08-A7F2-4150-81A6-76B267F2E3A0}"/>
               </a:ext>
             </a:extLst>
           </p:cNvPr>
@@ -2435,7 +2435,7 @@
           </a:solidFill>
           <a:ln xmlns:a="http://schemas.openxmlformats.org/drawingml/2006/main" w="9525">
             <a:solidFill>
-              <a:srgbClr val="C9D0D8"/>
+              <a:srgbClr val="BCC9DA"/>
             </a:solidFill>
             <a:prstDash val="solid"/>
           </a:ln>
@@ -2446,7 +2446,7 @@
           <p:cNvPr id="29" name="row-code-0">
             <a:extLst xmlns:a="http://schemas.openxmlformats.org/drawingml/2006/main">
               <a:ext uri="{FF2B5EF4-FFF2-40B4-BE49-F238E27FC236}">
-                <a16:creationId xmlns:a16="http://schemas.microsoft.com/office/drawing/2014/main" id="{BBC9DA64-97BE-4488-A1CD-E7C9E23B0283}"/>
+                <a16:creationId xmlns:a16="http://schemas.microsoft.com/office/drawing/2014/main" id="{58BEA502-2972-40C1-82D7-F7F692D12395}"/>
               </a:ext>
             </a:extLst>
           </p:cNvPr>
@@ -2476,14 +2476,14 @@
             <a:pPr algn="l">
               <a:defRPr sz="675" b="1">
                 <a:solidFill>
-                  <a:srgbClr val="295AC8"/>
+                  <a:srgbClr val="165DFF"/>
                 </a:solidFill>
               </a:defRPr>
             </a:pPr>
             <a:r>
               <a:rPr sz="675" b="1">
                 <a:solidFill>
-                  <a:srgbClr val="295AC8"/>
+                  <a:srgbClr val="165DFF"/>
                 </a:solidFill>
               </a:rPr>
               <a:t>99214</a:t>
@@ -2496,7 +2496,7 @@
           <p:cNvPr id="30" name="row-label-0">
             <a:extLst xmlns:a="http://schemas.openxmlformats.org/drawingml/2006/main">
               <a:ext uri="{FF2B5EF4-FFF2-40B4-BE49-F238E27FC236}">
-                <a16:creationId xmlns:a16="http://schemas.microsoft.com/office/drawing/2014/main" id="{199C2B83-8AA2-4B70-A676-45BC83C5D968}"/>
+                <a16:creationId xmlns:a16="http://schemas.microsoft.com/office/drawing/2014/main" id="{2754DF5D-07FF-434B-A872-E6A02C39B489}"/>
               </a:ext>
             </a:extLst>
           </p:cNvPr>
@@ -2526,14 +2526,14 @@
             <a:pPr algn="l">
               <a:defRPr sz="825" b="1">
                 <a:solidFill>
-                  <a:srgbClr val="172033"/>
+                  <a:srgbClr val="15213B"/>
                 </a:solidFill>
               </a:defRPr>
             </a:pPr>
             <a:r>
               <a:rPr sz="825" b="1">
                 <a:solidFill>
-                  <a:srgbClr val="172033"/>
+                  <a:srgbClr val="15213B"/>
                 </a:solidFill>
               </a:rPr>
               <a:t>Office visit, established patient</a:t>
@@ -2546,7 +2546,7 @@
           <p:cNvPr id="31" name="row-billed-0">
             <a:extLst xmlns:a="http://schemas.openxmlformats.org/drawingml/2006/main">
               <a:ext uri="{FF2B5EF4-FFF2-40B4-BE49-F238E27FC236}">
-                <a16:creationId xmlns:a16="http://schemas.microsoft.com/office/drawing/2014/main" id="{F1FC91E9-F293-4E5E-8644-32A002367D90}"/>
+                <a16:creationId xmlns:a16="http://schemas.microsoft.com/office/drawing/2014/main" id="{D2EA8F9A-4E34-4B6A-90C0-1805C7719BBA}"/>
               </a:ext>
             </a:extLst>
           </p:cNvPr>
@@ -2576,14 +2576,14 @@
             <a:pPr algn="r">
               <a:defRPr sz="825" b="0">
                 <a:solidFill>
-                  <a:srgbClr val="172033"/>
+                  <a:srgbClr val="15213B"/>
                 </a:solidFill>
               </a:defRPr>
             </a:pPr>
             <a:r>
               <a:rPr sz="825" b="0">
                 <a:solidFill>
-                  <a:srgbClr val="172033"/>
+                  <a:srgbClr val="15213B"/>
                 </a:solidFill>
               </a:rPr>
               <a:t>$425.00</a:t>
@@ -2596,7 +2596,7 @@
           <p:cNvPr id="32" name="row-allowed-0">
             <a:extLst xmlns:a="http://schemas.openxmlformats.org/drawingml/2006/main">
               <a:ext uri="{FF2B5EF4-FFF2-40B4-BE49-F238E27FC236}">
-                <a16:creationId xmlns:a16="http://schemas.microsoft.com/office/drawing/2014/main" id="{14E73667-1B82-45D5-B597-57DE198B1778}"/>
+                <a16:creationId xmlns:a16="http://schemas.microsoft.com/office/drawing/2014/main" id="{AFA9DD17-F0F7-4316-BBB6-EC75512039E2}"/>
               </a:ext>
             </a:extLst>
           </p:cNvPr>
@@ -2626,14 +2626,14 @@
             <a:pPr algn="r">
               <a:defRPr sz="825" b="0">
                 <a:solidFill>
-                  <a:srgbClr val="172033"/>
+                  <a:srgbClr val="15213B"/>
                 </a:solidFill>
               </a:defRPr>
             </a:pPr>
             <a:r>
               <a:rPr sz="825" b="0">
                 <a:solidFill>
-                  <a:srgbClr val="172033"/>
+                  <a:srgbClr val="15213B"/>
                 </a:solidFill>
               </a:rPr>
               <a:t>$235.00</a:t>
@@ -2646,7 +2646,7 @@
           <p:cNvPr id="33" name="row-owe-0">
             <a:extLst xmlns:a="http://schemas.openxmlformats.org/drawingml/2006/main">
               <a:ext uri="{FF2B5EF4-FFF2-40B4-BE49-F238E27FC236}">
-                <a16:creationId xmlns:a16="http://schemas.microsoft.com/office/drawing/2014/main" id="{737F462E-435D-493A-9713-36BD055B9583}"/>
+                <a16:creationId xmlns:a16="http://schemas.microsoft.com/office/drawing/2014/main" id="{448485A3-351D-4EEA-B60F-5119031B7D0F}"/>
               </a:ext>
             </a:extLst>
           </p:cNvPr>
@@ -2676,14 +2676,14 @@
             <a:pPr algn="r">
               <a:defRPr sz="825" b="0">
                 <a:solidFill>
-                  <a:srgbClr val="172033"/>
+                  <a:srgbClr val="15213B"/>
                 </a:solidFill>
               </a:defRPr>
             </a:pPr>
             <a:r>
               <a:rPr sz="825" b="0">
                 <a:solidFill>
-                  <a:srgbClr val="172033"/>
+                  <a:srgbClr val="15213B"/>
                 </a:solidFill>
               </a:rPr>
               <a:t>$40.00</a:t>
@@ -2696,7 +2696,7 @@
           <p:cNvPr id="34" name="row-bg-1">
             <a:extLst xmlns:a="http://schemas.openxmlformats.org/drawingml/2006/main">
               <a:ext uri="{FF2B5EF4-FFF2-40B4-BE49-F238E27FC236}">
-                <a16:creationId xmlns:a16="http://schemas.microsoft.com/office/drawing/2014/main" id="{2FF388A6-76DE-4519-8256-1C7816657548}"/>
+                <a16:creationId xmlns:a16="http://schemas.microsoft.com/office/drawing/2014/main" id="{3DC06725-C8ED-413C-BC2B-D18B7DE3BB9A}"/>
               </a:ext>
             </a:extLst>
           </p:cNvPr>
@@ -2714,11 +2714,11 @@
             <a:avLst/>
           </a:prstGeom>
           <a:solidFill xmlns:a="http://schemas.openxmlformats.org/drawingml/2006/main">
-            <a:srgbClr val="E8EEFC"/>
+            <a:srgbClr val="E6EEFF"/>
           </a:solidFill>
           <a:ln xmlns:a="http://schemas.openxmlformats.org/drawingml/2006/main" w="13335">
             <a:solidFill>
-              <a:srgbClr val="295AC8"/>
+              <a:srgbClr val="165DFF"/>
             </a:solidFill>
             <a:prstDash val="solid"/>
           </a:ln>
@@ -2729,7 +2729,7 @@
           <p:cNvPr id="35" name="row-code-1">
             <a:extLst xmlns:a="http://schemas.openxmlformats.org/drawingml/2006/main">
               <a:ext uri="{FF2B5EF4-FFF2-40B4-BE49-F238E27FC236}">
-                <a16:creationId xmlns:a16="http://schemas.microsoft.com/office/drawing/2014/main" id="{17F51D4E-B7BB-4D06-9FAF-33C2F75F9704}"/>
+                <a16:creationId xmlns:a16="http://schemas.microsoft.com/office/drawing/2014/main" id="{4D251046-1C2C-43B4-98DC-669B12B42F94}"/>
               </a:ext>
             </a:extLst>
           </p:cNvPr>
@@ -2759,14 +2759,14 @@
             <a:pPr algn="l">
               <a:defRPr sz="675" b="1">
                 <a:solidFill>
-                  <a:srgbClr val="295AC8"/>
+                  <a:srgbClr val="165DFF"/>
                 </a:solidFill>
               </a:defRPr>
             </a:pPr>
             <a:r>
               <a:rPr sz="675" b="1">
                 <a:solidFill>
-                  <a:srgbClr val="295AC8"/>
+                  <a:srgbClr val="165DFF"/>
                 </a:solidFill>
               </a:rPr>
               <a:t>80053</a:t>
@@ -2779,7 +2779,7 @@
           <p:cNvPr id="36" name="row-label-1">
             <a:extLst xmlns:a="http://schemas.openxmlformats.org/drawingml/2006/main">
               <a:ext uri="{FF2B5EF4-FFF2-40B4-BE49-F238E27FC236}">
-                <a16:creationId xmlns:a16="http://schemas.microsoft.com/office/drawing/2014/main" id="{15D1AB47-D3BA-47D5-B361-57C173B8860C}"/>
+                <a16:creationId xmlns:a16="http://schemas.microsoft.com/office/drawing/2014/main" id="{B905CE75-20B9-478A-B4E6-2E128D490FC9}"/>
               </a:ext>
             </a:extLst>
           </p:cNvPr>
@@ -2809,14 +2809,14 @@
             <a:pPr algn="l">
               <a:defRPr sz="825" b="1">
                 <a:solidFill>
-                  <a:srgbClr val="172033"/>
+                  <a:srgbClr val="15213B"/>
                 </a:solidFill>
               </a:defRPr>
             </a:pPr>
             <a:r>
               <a:rPr sz="825" b="1">
                 <a:solidFill>
-                  <a:srgbClr val="172033"/>
+                  <a:srgbClr val="15213B"/>
                 </a:solidFill>
               </a:rPr>
               <a:t>Comprehensive metabolic panel</a:t>
@@ -2829,7 +2829,7 @@
           <p:cNvPr id="37" name="row-billed-1">
             <a:extLst xmlns:a="http://schemas.openxmlformats.org/drawingml/2006/main">
               <a:ext uri="{FF2B5EF4-FFF2-40B4-BE49-F238E27FC236}">
-                <a16:creationId xmlns:a16="http://schemas.microsoft.com/office/drawing/2014/main" id="{E899E800-0B38-440C-AC3A-1D767BBEF838}"/>
+                <a16:creationId xmlns:a16="http://schemas.microsoft.com/office/drawing/2014/main" id="{977F396A-7ACA-4802-8DF8-82B1D5458726}"/>
               </a:ext>
             </a:extLst>
           </p:cNvPr>
@@ -2859,14 +2859,14 @@
             <a:pPr algn="r">
               <a:defRPr sz="825" b="0">
                 <a:solidFill>
-                  <a:srgbClr val="172033"/>
+                  <a:srgbClr val="15213B"/>
                 </a:solidFill>
               </a:defRPr>
             </a:pPr>
             <a:r>
               <a:rPr sz="825" b="0">
                 <a:solidFill>
-                  <a:srgbClr val="172033"/>
+                  <a:srgbClr val="15213B"/>
                 </a:solidFill>
               </a:rPr>
               <a:t>$168.00</a:t>
@@ -2879,7 +2879,7 @@
           <p:cNvPr id="38" name="row-allowed-1">
             <a:extLst xmlns:a="http://schemas.openxmlformats.org/drawingml/2006/main">
               <a:ext uri="{FF2B5EF4-FFF2-40B4-BE49-F238E27FC236}">
-                <a16:creationId xmlns:a16="http://schemas.microsoft.com/office/drawing/2014/main" id="{323EF1C3-9E05-4826-8D6E-D456DA5120F6}"/>
+                <a16:creationId xmlns:a16="http://schemas.microsoft.com/office/drawing/2014/main" id="{0FC37963-0689-4B55-AE9D-450430E7207A}"/>
               </a:ext>
             </a:extLst>
           </p:cNvPr>
@@ -2909,14 +2909,14 @@
             <a:pPr algn="r">
               <a:defRPr sz="825" b="0">
                 <a:solidFill>
-                  <a:srgbClr val="172033"/>
+                  <a:srgbClr val="15213B"/>
                 </a:solidFill>
               </a:defRPr>
             </a:pPr>
             <a:r>
               <a:rPr sz="825" b="0">
                 <a:solidFill>
-                  <a:srgbClr val="172033"/>
+                  <a:srgbClr val="15213B"/>
                 </a:solidFill>
               </a:rPr>
               <a:t>$76.00</a:t>
@@ -2929,7 +2929,7 @@
           <p:cNvPr id="39" name="row-owe-1">
             <a:extLst xmlns:a="http://schemas.openxmlformats.org/drawingml/2006/main">
               <a:ext uri="{FF2B5EF4-FFF2-40B4-BE49-F238E27FC236}">
-                <a16:creationId xmlns:a16="http://schemas.microsoft.com/office/drawing/2014/main" id="{60F34831-E9EA-4000-9F1B-B56E42D56A3A}"/>
+                <a16:creationId xmlns:a16="http://schemas.microsoft.com/office/drawing/2014/main" id="{8CE7CDDE-49C9-4BA1-9615-59CE04C390A9}"/>
               </a:ext>
             </a:extLst>
           </p:cNvPr>
@@ -2959,14 +2959,14 @@
             <a:pPr algn="r">
               <a:defRPr sz="825" b="0">
                 <a:solidFill>
-                  <a:srgbClr val="172033"/>
+                  <a:srgbClr val="15213B"/>
                 </a:solidFill>
               </a:defRPr>
             </a:pPr>
             <a:r>
               <a:rPr sz="825" b="0">
                 <a:solidFill>
-                  <a:srgbClr val="172033"/>
+                  <a:srgbClr val="15213B"/>
                 </a:solidFill>
               </a:rPr>
               <a:t>$20.00</a:t>
@@ -2979,7 +2979,7 @@
           <p:cNvPr id="40" name="row-bg-2">
             <a:extLst xmlns:a="http://schemas.openxmlformats.org/drawingml/2006/main">
               <a:ext uri="{FF2B5EF4-FFF2-40B4-BE49-F238E27FC236}">
-                <a16:creationId xmlns:a16="http://schemas.microsoft.com/office/drawing/2014/main" id="{C642FEE9-7014-4C31-B4F6-ADCA489FDFFF}"/>
+                <a16:creationId xmlns:a16="http://schemas.microsoft.com/office/drawing/2014/main" id="{A22BA0AF-D599-46D5-B07F-3B9FB4988D86}"/>
               </a:ext>
             </a:extLst>
           </p:cNvPr>
@@ -3001,7 +3001,7 @@
           </a:solidFill>
           <a:ln xmlns:a="http://schemas.openxmlformats.org/drawingml/2006/main" w="9525">
             <a:solidFill>
-              <a:srgbClr val="C9D0D8"/>
+              <a:srgbClr val="BCC9DA"/>
             </a:solidFill>
             <a:prstDash val="solid"/>
           </a:ln>
@@ -3012,7 +3012,7 @@
           <p:cNvPr id="41" name="row-code-2">
             <a:extLst xmlns:a="http://schemas.openxmlformats.org/drawingml/2006/main">
               <a:ext uri="{FF2B5EF4-FFF2-40B4-BE49-F238E27FC236}">
-                <a16:creationId xmlns:a16="http://schemas.microsoft.com/office/drawing/2014/main" id="{622F503A-26FC-4DE1-AF96-4541F2D61408}"/>
+                <a16:creationId xmlns:a16="http://schemas.microsoft.com/office/drawing/2014/main" id="{E2F6A1A5-F7E5-480D-95AD-5974B4029931}"/>
               </a:ext>
             </a:extLst>
           </p:cNvPr>
@@ -3042,14 +3042,14 @@
             <a:pPr algn="l">
               <a:defRPr sz="675" b="1">
                 <a:solidFill>
-                  <a:srgbClr val="295AC8"/>
+                  <a:srgbClr val="165DFF"/>
                 </a:solidFill>
               </a:defRPr>
             </a:pPr>
             <a:r>
               <a:rPr sz="675" b="1">
                 <a:solidFill>
-                  <a:srgbClr val="295AC8"/>
+                  <a:srgbClr val="165DFF"/>
                 </a:solidFill>
               </a:rPr>
               <a:t>ADJ</a:t>
@@ -3062,7 +3062,7 @@
           <p:cNvPr id="42" name="row-label-2">
             <a:extLst xmlns:a="http://schemas.openxmlformats.org/drawingml/2006/main">
               <a:ext uri="{FF2B5EF4-FFF2-40B4-BE49-F238E27FC236}">
-                <a16:creationId xmlns:a16="http://schemas.microsoft.com/office/drawing/2014/main" id="{C57C2860-CD3F-4138-A6D9-7A077CA32607}"/>
+                <a16:creationId xmlns:a16="http://schemas.microsoft.com/office/drawing/2014/main" id="{DB12FE4C-F86B-4164-865B-9025C4603EBD}"/>
               </a:ext>
             </a:extLst>
           </p:cNvPr>
@@ -3092,14 +3092,14 @@
             <a:pPr algn="l">
               <a:defRPr sz="825" b="1">
                 <a:solidFill>
-                  <a:srgbClr val="172033"/>
+                  <a:srgbClr val="15213B"/>
                 </a:solidFill>
               </a:defRPr>
             </a:pPr>
             <a:r>
               <a:rPr sz="825" b="1">
                 <a:solidFill>
-                  <a:srgbClr val="172033"/>
+                  <a:srgbClr val="15213B"/>
                 </a:solidFill>
               </a:rPr>
               <a:t>Network discount and plan payment</a:t>
@@ -3112,7 +3112,7 @@
           <p:cNvPr id="43" name="row-billed-2">
             <a:extLst xmlns:a="http://schemas.openxmlformats.org/drawingml/2006/main">
               <a:ext uri="{FF2B5EF4-FFF2-40B4-BE49-F238E27FC236}">
-                <a16:creationId xmlns:a16="http://schemas.microsoft.com/office/drawing/2014/main" id="{53E0627F-2788-41E9-9E79-2AAFE65F7A26}"/>
+                <a16:creationId xmlns:a16="http://schemas.microsoft.com/office/drawing/2014/main" id="{90F5E566-59BA-4A18-B2ED-1280035A1EE7}"/>
               </a:ext>
             </a:extLst>
           </p:cNvPr>
@@ -3142,14 +3142,14 @@
             <a:pPr algn="r">
               <a:defRPr sz="825" b="0">
                 <a:solidFill>
-                  <a:srgbClr val="172033"/>
+                  <a:srgbClr val="15213B"/>
                 </a:solidFill>
               </a:defRPr>
             </a:pPr>
             <a:r>
               <a:rPr sz="825" b="0">
                 <a:solidFill>
-                  <a:srgbClr val="172033"/>
+                  <a:srgbClr val="15213B"/>
                 </a:solidFill>
               </a:rPr>
               <a:t>−$282.00</a:t>
@@ -3162,7 +3162,7 @@
           <p:cNvPr id="44" name="row-allowed-2">
             <a:extLst xmlns:a="http://schemas.openxmlformats.org/drawingml/2006/main">
               <a:ext uri="{FF2B5EF4-FFF2-40B4-BE49-F238E27FC236}">
-                <a16:creationId xmlns:a16="http://schemas.microsoft.com/office/drawing/2014/main" id="{202E6A4B-A5D3-4B7C-88CC-86B2F4273D66}"/>
+                <a16:creationId xmlns:a16="http://schemas.microsoft.com/office/drawing/2014/main" id="{759AD7B7-0911-4647-A8EF-365FB15A5890}"/>
               </a:ext>
             </a:extLst>
           </p:cNvPr>
@@ -3192,14 +3192,14 @@
             <a:pPr algn="r">
               <a:defRPr sz="825" b="0">
                 <a:solidFill>
-                  <a:srgbClr val="172033"/>
+                  <a:srgbClr val="15213B"/>
                 </a:solidFill>
               </a:defRPr>
             </a:pPr>
             <a:r>
               <a:rPr sz="825" b="0">
                 <a:solidFill>
-                  <a:srgbClr val="172033"/>
+                  <a:srgbClr val="15213B"/>
                 </a:solidFill>
               </a:rPr>
               <a:t>Applied</a:t>
@@ -3212,7 +3212,7 @@
           <p:cNvPr id="45" name="row-owe-2">
             <a:extLst xmlns:a="http://schemas.openxmlformats.org/drawingml/2006/main">
               <a:ext uri="{FF2B5EF4-FFF2-40B4-BE49-F238E27FC236}">
-                <a16:creationId xmlns:a16="http://schemas.microsoft.com/office/drawing/2014/main" id="{10E1DBC8-A149-4FCB-B97C-FD42AC987E35}"/>
+                <a16:creationId xmlns:a16="http://schemas.microsoft.com/office/drawing/2014/main" id="{A2904C7C-733E-4853-ACFD-1466AFF63DCD}"/>
               </a:ext>
             </a:extLst>
           </p:cNvPr>
@@ -3242,14 +3242,14 @@
             <a:pPr algn="r">
               <a:defRPr sz="825" b="0">
                 <a:solidFill>
-                  <a:srgbClr val="172033"/>
+                  <a:srgbClr val="15213B"/>
                 </a:solidFill>
               </a:defRPr>
             </a:pPr>
             <a:r>
               <a:rPr sz="825" b="0">
                 <a:solidFill>
-                  <a:srgbClr val="172033"/>
+                  <a:srgbClr val="15213B"/>
                 </a:solidFill>
               </a:rPr>
               <a:t>$0.00</a:t>
@@ -3262,7 +3262,7 @@
           <p:cNvPr id="46" name="not-bill">
             <a:extLst xmlns:a="http://schemas.openxmlformats.org/drawingml/2006/main">
               <a:ext uri="{FF2B5EF4-FFF2-40B4-BE49-F238E27FC236}">
-                <a16:creationId xmlns:a16="http://schemas.microsoft.com/office/drawing/2014/main" id="{D6251799-F7A9-4452-8411-BC5E4BE36C13}"/>
+                <a16:creationId xmlns:a16="http://schemas.microsoft.com/office/drawing/2014/main" id="{4B3974FD-B365-4EF5-AD00-C9A631BD83E2}"/>
               </a:ext>
             </a:extLst>
           </p:cNvPr>
@@ -3282,11 +3282,11 @@
             </a:avLst>
           </a:prstGeom>
           <a:solidFill xmlns:a="http://schemas.openxmlformats.org/drawingml/2006/main">
-            <a:srgbClr val="FFF0C4"/>
+            <a:srgbClr val="FFF0A8"/>
           </a:solidFill>
           <a:ln xmlns:a="http://schemas.openxmlformats.org/drawingml/2006/main" w="9525">
             <a:solidFill>
-              <a:srgbClr val="A46900"/>
+              <a:srgbClr val="9B6200"/>
             </a:solidFill>
             <a:prstDash val="solid"/>
           </a:ln>
@@ -3297,7 +3297,7 @@
           <p:cNvPr id="47" name="not-bill-label">
             <a:extLst xmlns:a="http://schemas.openxmlformats.org/drawingml/2006/main">
               <a:ext uri="{FF2B5EF4-FFF2-40B4-BE49-F238E27FC236}">
-                <a16:creationId xmlns:a16="http://schemas.microsoft.com/office/drawing/2014/main" id="{579A4174-9B22-425D-A654-013204811425}"/>
+                <a16:creationId xmlns:a16="http://schemas.microsoft.com/office/drawing/2014/main" id="{5CAB9754-CEB9-451C-86A0-E667C5F62B66}"/>
               </a:ext>
             </a:extLst>
           </p:cNvPr>
@@ -3327,14 +3327,14 @@
             <a:pPr algn="l">
               <a:defRPr sz="675" b="1">
                 <a:solidFill>
-                  <a:srgbClr val="A46900"/>
+                  <a:srgbClr val="9B6200"/>
                 </a:solidFill>
               </a:defRPr>
             </a:pPr>
             <a:r>
               <a:rPr sz="675" b="1">
                 <a:solidFill>
-                  <a:srgbClr val="A46900"/>
+                  <a:srgbClr val="9B6200"/>
                 </a:solidFill>
               </a:rPr>
               <a:t>NOT A BILL</a:t>
@@ -3347,7 +3347,7 @@
           <p:cNvPr id="48" name="not-bill-copy">
             <a:extLst xmlns:a="http://schemas.openxmlformats.org/drawingml/2006/main">
               <a:ext uri="{FF2B5EF4-FFF2-40B4-BE49-F238E27FC236}">
-                <a16:creationId xmlns:a16="http://schemas.microsoft.com/office/drawing/2014/main" id="{77D5E807-945F-4CE9-9868-E863827AF4CD}"/>
+                <a16:creationId xmlns:a16="http://schemas.microsoft.com/office/drawing/2014/main" id="{EEDA7BE3-0104-4AB0-ABC4-08CB16FFFA13}"/>
               </a:ext>
             </a:extLst>
           </p:cNvPr>
@@ -3377,14 +3377,14 @@
             <a:pPr algn="l">
               <a:defRPr sz="788" b="0">
                 <a:solidFill>
-                  <a:srgbClr val="172033"/>
+                  <a:srgbClr val="15213B"/>
                 </a:solidFill>
               </a:defRPr>
             </a:pPr>
             <a:r>
               <a:rPr sz="788" b="0">
                 <a:solidFill>
-                  <a:srgbClr val="172033"/>
+                  <a:srgbClr val="15213B"/>
                 </a:solidFill>
               </a:rPr>
               <a:t>Compare with the provider invoice before paying; every identity and amount shown is synthetic.</a:t>
@@ -3397,7 +3397,7 @@
           <p:cNvPr id="49" name="document-to-answer">
             <a:extLst xmlns:a="http://schemas.openxmlformats.org/drawingml/2006/main">
               <a:ext uri="{FF2B5EF4-FFF2-40B4-BE49-F238E27FC236}">
-                <a16:creationId xmlns:a16="http://schemas.microsoft.com/office/drawing/2014/main" id="{855ED0CE-4193-4C7B-B3D7-765FF7BFF773}"/>
+                <a16:creationId xmlns:a16="http://schemas.microsoft.com/office/drawing/2014/main" id="{54A7E6B3-883D-4936-9851-3397C4F472E7}"/>
               </a:ext>
             </a:extLst>
           </p:cNvPr>
@@ -3415,11 +3415,11 @@
             <a:avLst/>
           </a:prstGeom>
           <a:solidFill xmlns:a="http://schemas.openxmlformats.org/drawingml/2006/main">
-            <a:srgbClr val="295AC8"/>
+            <a:srgbClr val="165DFF"/>
           </a:solidFill>
           <a:ln xmlns:a="http://schemas.openxmlformats.org/drawingml/2006/main" w="0">
             <a:solidFill>
-              <a:srgbClr val="295AC8"/>
+              <a:srgbClr val="165DFF"/>
             </a:solidFill>
             <a:prstDash val="solid"/>
           </a:ln>
@@ -3430,7 +3430,7 @@
           <p:cNvPr id="50" name="question-label">
             <a:extLst xmlns:a="http://schemas.openxmlformats.org/drawingml/2006/main">
               <a:ext uri="{FF2B5EF4-FFF2-40B4-BE49-F238E27FC236}">
-                <a16:creationId xmlns:a16="http://schemas.microsoft.com/office/drawing/2014/main" id="{B101EDD9-C22F-45D0-841B-8C1EB79377BC}"/>
+                <a16:creationId xmlns:a16="http://schemas.microsoft.com/office/drawing/2014/main" id="{24938B0E-90DC-40B4-AB57-8C6F41ABA0D1}"/>
               </a:ext>
             </a:extLst>
           </p:cNvPr>
@@ -3460,14 +3460,14 @@
             <a:pPr algn="l">
               <a:defRPr sz="900" b="1">
                 <a:solidFill>
-                  <a:srgbClr val="295AC8"/>
+                  <a:srgbClr val="165DFF"/>
                 </a:solidFill>
               </a:defRPr>
             </a:pPr>
             <a:r>
               <a:rPr sz="900" b="1">
                 <a:solidFill>
-                  <a:srgbClr val="295AC8"/>
+                  <a:srgbClr val="165DFF"/>
                 </a:solidFill>
               </a:rPr>
               <a:t>BUNDLED DEMO QUESTION</a:t>
@@ -3480,7 +3480,7 @@
           <p:cNvPr id="51" name="question">
             <a:extLst xmlns:a="http://schemas.openxmlformats.org/drawingml/2006/main">
               <a:ext uri="{FF2B5EF4-FFF2-40B4-BE49-F238E27FC236}">
-                <a16:creationId xmlns:a16="http://schemas.microsoft.com/office/drawing/2014/main" id="{E97CAE71-46FA-480C-A1E9-8DB46A3552A6}"/>
+                <a16:creationId xmlns:a16="http://schemas.microsoft.com/office/drawing/2014/main" id="{461A9C83-45E5-46CD-AD7C-F73BB2E95A87}"/>
               </a:ext>
             </a:extLst>
           </p:cNvPr>
@@ -3500,11 +3500,11 @@
             </a:avLst>
           </a:prstGeom>
           <a:solidFill xmlns:a="http://schemas.openxmlformats.org/drawingml/2006/main">
-            <a:srgbClr val="E8EEFC"/>
+            <a:srgbClr val="E6EEFF"/>
           </a:solidFill>
           <a:ln xmlns:a="http://schemas.openxmlformats.org/drawingml/2006/main" w="11430">
             <a:solidFill>
-              <a:srgbClr val="295AC8"/>
+              <a:srgbClr val="165DFF"/>
             </a:solidFill>
             <a:prstDash val="solid"/>
           </a:ln>
@@ -3515,7 +3515,7 @@
           <p:cNvPr id="52" name="question-copy">
             <a:extLst xmlns:a="http://schemas.openxmlformats.org/drawingml/2006/main">
               <a:ext uri="{FF2B5EF4-FFF2-40B4-BE49-F238E27FC236}">
-                <a16:creationId xmlns:a16="http://schemas.microsoft.com/office/drawing/2014/main" id="{D97A5725-27DD-4222-B43D-02EFDE30CFB4}"/>
+                <a16:creationId xmlns:a16="http://schemas.microsoft.com/office/drawing/2014/main" id="{03E7881A-9B36-49EA-A15C-E165148CAD0A}"/>
               </a:ext>
             </a:extLst>
           </p:cNvPr>
@@ -3545,14 +3545,14 @@
             <a:pPr algn="l">
               <a:defRPr sz="1275" b="1">
                 <a:solidFill>
-                  <a:srgbClr val="17243B"/>
+                  <a:srgbClr val="102A56"/>
                 </a:solidFill>
               </a:defRPr>
             </a:pPr>
             <a:r>
               <a:rPr sz="1275" b="1">
                 <a:solidFill>
-                  <a:srgbClr val="17243B"/>
+                  <a:srgbClr val="102A56"/>
                 </a:solidFill>
               </a:rPr>
               <a:t>What is an Explanation of Benefits?</a:t>
@@ -3565,7 +3565,7 @@
           <p:cNvPr id="53" name="answer-label">
             <a:extLst xmlns:a="http://schemas.openxmlformats.org/drawingml/2006/main">
               <a:ext uri="{FF2B5EF4-FFF2-40B4-BE49-F238E27FC236}">
-                <a16:creationId xmlns:a16="http://schemas.microsoft.com/office/drawing/2014/main" id="{3C98DAD9-C429-441C-8FE0-0A5F4A12B2D9}"/>
+                <a16:creationId xmlns:a16="http://schemas.microsoft.com/office/drawing/2014/main" id="{75492F70-D2CD-4AD2-902D-8AEB913CA02C}"/>
               </a:ext>
             </a:extLst>
           </p:cNvPr>
@@ -3595,14 +3595,14 @@
             <a:pPr algn="l">
               <a:defRPr sz="900" b="1">
                 <a:solidFill>
-                  <a:srgbClr val="147B84"/>
+                  <a:srgbClr val="7137A8"/>
                 </a:solidFill>
               </a:defRPr>
             </a:pPr>
             <a:r>
               <a:rPr sz="900" b="1">
                 <a:solidFill>
-                  <a:srgbClr val="147B84"/>
+                  <a:srgbClr val="7137A8"/>
                 </a:solidFill>
               </a:rPr>
               <a:t>DETERMINISTIC EXPLANATION</a:t>
@@ -3615,7 +3615,7 @@
           <p:cNvPr id="54" name="answer">
             <a:extLst xmlns:a="http://schemas.openxmlformats.org/drawingml/2006/main">
               <a:ext uri="{FF2B5EF4-FFF2-40B4-BE49-F238E27FC236}">
-                <a16:creationId xmlns:a16="http://schemas.microsoft.com/office/drawing/2014/main" id="{EF36E505-D1EA-4D41-AA0D-969448A2FDA6}"/>
+                <a16:creationId xmlns:a16="http://schemas.microsoft.com/office/drawing/2014/main" id="{BE2B3333-7854-4011-98C6-3F95931769CC}"/>
               </a:ext>
             </a:extLst>
           </p:cNvPr>
@@ -3639,7 +3639,7 @@
           </a:solidFill>
           <a:ln xmlns:a="http://schemas.openxmlformats.org/drawingml/2006/main" w="11430">
             <a:solidFill>
-              <a:srgbClr val="147B84"/>
+              <a:srgbClr val="7137A8"/>
             </a:solidFill>
             <a:prstDash val="solid"/>
           </a:ln>
@@ -3650,7 +3650,7 @@
           <p:cNvPr id="55" name="answer-lead">
             <a:extLst xmlns:a="http://schemas.openxmlformats.org/drawingml/2006/main">
               <a:ext uri="{FF2B5EF4-FFF2-40B4-BE49-F238E27FC236}">
-                <a16:creationId xmlns:a16="http://schemas.microsoft.com/office/drawing/2014/main" id="{14D7F157-5434-4110-B837-C0D4A041EE38}"/>
+                <a16:creationId xmlns:a16="http://schemas.microsoft.com/office/drawing/2014/main" id="{46414E18-D1D0-47B0-8425-6C1641A82865}"/>
               </a:ext>
             </a:extLst>
           </p:cNvPr>
@@ -3680,14 +3680,14 @@
             <a:pPr algn="l">
               <a:defRPr sz="1125" b="1">
                 <a:solidFill>
-                  <a:srgbClr val="17243B"/>
+                  <a:srgbClr val="102A56"/>
                 </a:solidFill>
               </a:defRPr>
             </a:pPr>
             <a:r>
               <a:rPr sz="1125" b="1">
                 <a:solidFill>
-                  <a:srgbClr val="17243B"/>
+                  <a:srgbClr val="102A56"/>
                 </a:solidFill>
               </a:rPr>
               <a:t>An EOB is the insurer’s record of how a claim was processed—not a bill.</a:t>
@@ -3700,7 +3700,7 @@
           <p:cNvPr id="56" name="number-0">
             <a:extLst xmlns:a="http://schemas.openxmlformats.org/drawingml/2006/main">
               <a:ext uri="{FF2B5EF4-FFF2-40B4-BE49-F238E27FC236}">
-                <a16:creationId xmlns:a16="http://schemas.microsoft.com/office/drawing/2014/main" id="{998CFA6E-62C9-4F8E-89BD-0F4BF3560467}"/>
+                <a16:creationId xmlns:a16="http://schemas.microsoft.com/office/drawing/2014/main" id="{2B303DC0-12AB-48DC-A673-64E715C47E39}"/>
               </a:ext>
             </a:extLst>
           </p:cNvPr>
@@ -3718,11 +3718,11 @@
             <a:avLst/>
           </a:prstGeom>
           <a:solidFill xmlns:a="http://schemas.openxmlformats.org/drawingml/2006/main">
-            <a:srgbClr val="E6F2F2"/>
+            <a:srgbClr val="F0E8F7"/>
           </a:solidFill>
           <a:ln xmlns:a="http://schemas.openxmlformats.org/drawingml/2006/main" w="9525">
             <a:solidFill>
-              <a:srgbClr val="147B84"/>
+              <a:srgbClr val="7137A8"/>
             </a:solidFill>
             <a:prstDash val="solid"/>
           </a:ln>
@@ -3734,14 +3734,14 @@
             <a:pPr algn="ctr">
               <a:defRPr sz="750" b="1">
                 <a:solidFill>
-                  <a:srgbClr val="147B84"/>
+                  <a:srgbClr val="7137A8"/>
                 </a:solidFill>
               </a:defRPr>
             </a:pPr>
             <a:r>
               <a:rPr sz="750" b="1">
                 <a:solidFill>
-                  <a:srgbClr val="147B84"/>
+                  <a:srgbClr val="7137A8"/>
                 </a:solidFill>
               </a:rPr>
               <a:t>1</a:t>
@@ -3754,7 +3754,7 @@
           <p:cNvPr id="57" name="answer-label-0">
             <a:extLst xmlns:a="http://schemas.openxmlformats.org/drawingml/2006/main">
               <a:ext uri="{FF2B5EF4-FFF2-40B4-BE49-F238E27FC236}">
-                <a16:creationId xmlns:a16="http://schemas.microsoft.com/office/drawing/2014/main" id="{4685BCD2-FD66-45A4-B348-D2AF1873F4E1}"/>
+                <a16:creationId xmlns:a16="http://schemas.microsoft.com/office/drawing/2014/main" id="{888E36E9-0568-48AF-B64C-557E3910AFC5}"/>
               </a:ext>
             </a:extLst>
           </p:cNvPr>
@@ -3784,14 +3784,14 @@
             <a:pPr algn="l">
               <a:defRPr sz="863" b="1">
                 <a:solidFill>
-                  <a:srgbClr val="172033"/>
+                  <a:srgbClr val="15213B"/>
                 </a:solidFill>
               </a:defRPr>
             </a:pPr>
             <a:r>
               <a:rPr sz="863" b="1">
                 <a:solidFill>
-                  <a:srgbClr val="172033"/>
+                  <a:srgbClr val="15213B"/>
                 </a:solidFill>
               </a:rPr>
               <a:t>Amount billed</a:t>
@@ -3804,7 +3804,7 @@
           <p:cNvPr id="58" name="answer-note-0">
             <a:extLst xmlns:a="http://schemas.openxmlformats.org/drawingml/2006/main">
               <a:ext uri="{FF2B5EF4-FFF2-40B4-BE49-F238E27FC236}">
-                <a16:creationId xmlns:a16="http://schemas.microsoft.com/office/drawing/2014/main" id="{57C5B928-FCD6-4E23-AC5B-4E4CDC6E8B9D}"/>
+                <a16:creationId xmlns:a16="http://schemas.microsoft.com/office/drawing/2014/main" id="{49B372DF-84DE-41FB-9AD5-F2119EC5E998}"/>
               </a:ext>
             </a:extLst>
           </p:cNvPr>
@@ -3834,14 +3834,14 @@
             <a:pPr algn="l">
               <a:defRPr sz="788" b="0">
                 <a:solidFill>
-                  <a:srgbClr val="667084"/>
+                  <a:srgbClr val="63708A"/>
                 </a:solidFill>
               </a:defRPr>
             </a:pPr>
             <a:r>
               <a:rPr sz="788" b="0">
                 <a:solidFill>
-                  <a:srgbClr val="667084"/>
+                  <a:srgbClr val="63708A"/>
                 </a:solidFill>
               </a:rPr>
               <a:t>provider submission</a:t>
@@ -3854,7 +3854,7 @@
           <p:cNvPr id="59" name="number-1">
             <a:extLst xmlns:a="http://schemas.openxmlformats.org/drawingml/2006/main">
               <a:ext uri="{FF2B5EF4-FFF2-40B4-BE49-F238E27FC236}">
-                <a16:creationId xmlns:a16="http://schemas.microsoft.com/office/drawing/2014/main" id="{1468ABBC-6677-4A10-B015-7EA814A578CA}"/>
+                <a16:creationId xmlns:a16="http://schemas.microsoft.com/office/drawing/2014/main" id="{14AE64D7-AE13-4186-8787-F896E0E0ECC8}"/>
               </a:ext>
             </a:extLst>
           </p:cNvPr>
@@ -3872,11 +3872,11 @@
             <a:avLst/>
           </a:prstGeom>
           <a:solidFill xmlns:a="http://schemas.openxmlformats.org/drawingml/2006/main">
-            <a:srgbClr val="E6F2F2"/>
+            <a:srgbClr val="F0E8F7"/>
           </a:solidFill>
           <a:ln xmlns:a="http://schemas.openxmlformats.org/drawingml/2006/main" w="9525">
             <a:solidFill>
-              <a:srgbClr val="147B84"/>
+              <a:srgbClr val="7137A8"/>
             </a:solidFill>
             <a:prstDash val="solid"/>
           </a:ln>
@@ -3888,14 +3888,14 @@
             <a:pPr algn="ctr">
               <a:defRPr sz="750" b="1">
                 <a:solidFill>
-                  <a:srgbClr val="147B84"/>
+                  <a:srgbClr val="7137A8"/>
                 </a:solidFill>
               </a:defRPr>
             </a:pPr>
             <a:r>
               <a:rPr sz="750" b="1">
                 <a:solidFill>
-                  <a:srgbClr val="147B84"/>
+                  <a:srgbClr val="7137A8"/>
                 </a:solidFill>
               </a:rPr>
               <a:t>2</a:t>
@@ -3908,7 +3908,7 @@
           <p:cNvPr id="60" name="answer-label-1">
             <a:extLst xmlns:a="http://schemas.openxmlformats.org/drawingml/2006/main">
               <a:ext uri="{FF2B5EF4-FFF2-40B4-BE49-F238E27FC236}">
-                <a16:creationId xmlns:a16="http://schemas.microsoft.com/office/drawing/2014/main" id="{40C7E8D2-9BFB-4BD7-9457-35CFF75988DF}"/>
+                <a16:creationId xmlns:a16="http://schemas.microsoft.com/office/drawing/2014/main" id="{9D36E3C1-5261-46A6-B084-55215BF691A3}"/>
               </a:ext>
             </a:extLst>
           </p:cNvPr>
@@ -3938,14 +3938,14 @@
             <a:pPr algn="l">
               <a:defRPr sz="863" b="1">
                 <a:solidFill>
-                  <a:srgbClr val="172033"/>
+                  <a:srgbClr val="15213B"/>
                 </a:solidFill>
               </a:defRPr>
             </a:pPr>
             <a:r>
               <a:rPr sz="863" b="1">
                 <a:solidFill>
-                  <a:srgbClr val="172033"/>
+                  <a:srgbClr val="15213B"/>
                 </a:solidFill>
               </a:rPr>
               <a:t>Allowed amount</a:t>
@@ -3958,7 +3958,7 @@
           <p:cNvPr id="61" name="answer-note-1">
             <a:extLst xmlns:a="http://schemas.openxmlformats.org/drawingml/2006/main">
               <a:ext uri="{FF2B5EF4-FFF2-40B4-BE49-F238E27FC236}">
-                <a16:creationId xmlns:a16="http://schemas.microsoft.com/office/drawing/2014/main" id="{56267E49-9ABB-4929-A9B8-FBCF907DEA48}"/>
+                <a16:creationId xmlns:a16="http://schemas.microsoft.com/office/drawing/2014/main" id="{3AD62342-AD32-499D-A1FC-99816550B88E}"/>
               </a:ext>
             </a:extLst>
           </p:cNvPr>
@@ -3988,14 +3988,14 @@
             <a:pPr algn="l">
               <a:defRPr sz="788" b="0">
                 <a:solidFill>
-                  <a:srgbClr val="667084"/>
+                  <a:srgbClr val="63708A"/>
                 </a:solidFill>
               </a:defRPr>
             </a:pPr>
             <a:r>
               <a:rPr sz="788" b="0">
                 <a:solidFill>
-                  <a:srgbClr val="667084"/>
+                  <a:srgbClr val="63708A"/>
                 </a:solidFill>
               </a:rPr>
               <a:t>negotiated or recognized price</a:t>
@@ -4008,7 +4008,7 @@
           <p:cNvPr id="62" name="number-2">
             <a:extLst xmlns:a="http://schemas.openxmlformats.org/drawingml/2006/main">
               <a:ext uri="{FF2B5EF4-FFF2-40B4-BE49-F238E27FC236}">
-                <a16:creationId xmlns:a16="http://schemas.microsoft.com/office/drawing/2014/main" id="{D7F5EAB1-E0B8-4858-A330-AE6779A2270C}"/>
+                <a16:creationId xmlns:a16="http://schemas.microsoft.com/office/drawing/2014/main" id="{5E10A86E-817B-4821-936E-023395A86A7E}"/>
               </a:ext>
             </a:extLst>
           </p:cNvPr>
@@ -4026,11 +4026,11 @@
             <a:avLst/>
           </a:prstGeom>
           <a:solidFill xmlns:a="http://schemas.openxmlformats.org/drawingml/2006/main">
-            <a:srgbClr val="E6F2F2"/>
+            <a:srgbClr val="F0E8F7"/>
           </a:solidFill>
           <a:ln xmlns:a="http://schemas.openxmlformats.org/drawingml/2006/main" w="9525">
             <a:solidFill>
-              <a:srgbClr val="147B84"/>
+              <a:srgbClr val="7137A8"/>
             </a:solidFill>
             <a:prstDash val="solid"/>
           </a:ln>
@@ -4042,14 +4042,14 @@
             <a:pPr algn="ctr">
               <a:defRPr sz="750" b="1">
                 <a:solidFill>
-                  <a:srgbClr val="147B84"/>
+                  <a:srgbClr val="7137A8"/>
                 </a:solidFill>
               </a:defRPr>
             </a:pPr>
             <a:r>
               <a:rPr sz="750" b="1">
                 <a:solidFill>
-                  <a:srgbClr val="147B84"/>
+                  <a:srgbClr val="7137A8"/>
                 </a:solidFill>
               </a:rPr>
               <a:t>3</a:t>
@@ -4062,7 +4062,7 @@
           <p:cNvPr id="63" name="answer-label-2">
             <a:extLst xmlns:a="http://schemas.openxmlformats.org/drawingml/2006/main">
               <a:ext uri="{FF2B5EF4-FFF2-40B4-BE49-F238E27FC236}">
-                <a16:creationId xmlns:a16="http://schemas.microsoft.com/office/drawing/2014/main" id="{962567DC-A5FE-4E34-8111-6B3910DEB889}"/>
+                <a16:creationId xmlns:a16="http://schemas.microsoft.com/office/drawing/2014/main" id="{8DA5CAA6-B068-47E8-A6CE-D851213D6C8E}"/>
               </a:ext>
             </a:extLst>
           </p:cNvPr>
@@ -4092,14 +4092,14 @@
             <a:pPr algn="l">
               <a:defRPr sz="863" b="1">
                 <a:solidFill>
-                  <a:srgbClr val="172033"/>
+                  <a:srgbClr val="15213B"/>
                 </a:solidFill>
               </a:defRPr>
             </a:pPr>
             <a:r>
               <a:rPr sz="863" b="1">
                 <a:solidFill>
-                  <a:srgbClr val="172033"/>
+                  <a:srgbClr val="15213B"/>
                 </a:solidFill>
               </a:rPr>
               <a:t>Plan paid</a:t>
@@ -4112,7 +4112,7 @@
           <p:cNvPr id="64" name="answer-note-2">
             <a:extLst xmlns:a="http://schemas.openxmlformats.org/drawingml/2006/main">
               <a:ext uri="{FF2B5EF4-FFF2-40B4-BE49-F238E27FC236}">
-                <a16:creationId xmlns:a16="http://schemas.microsoft.com/office/drawing/2014/main" id="{07F177F9-2F18-4EDD-8372-37BA6FC41D1F}"/>
+                <a16:creationId xmlns:a16="http://schemas.microsoft.com/office/drawing/2014/main" id="{1E2A851E-C4AE-44EB-B3FF-3FD91C4D992E}"/>
               </a:ext>
             </a:extLst>
           </p:cNvPr>
@@ -4142,14 +4142,14 @@
             <a:pPr algn="l">
               <a:defRPr sz="788" b="0">
                 <a:solidFill>
-                  <a:srgbClr val="667084"/>
+                  <a:srgbClr val="63708A"/>
                 </a:solidFill>
               </a:defRPr>
             </a:pPr>
             <a:r>
               <a:rPr sz="788" b="0">
                 <a:solidFill>
-                  <a:srgbClr val="667084"/>
+                  <a:srgbClr val="63708A"/>
                 </a:solidFill>
               </a:rPr>
               <a:t>insurance payment</a:t>
@@ -4162,7 +4162,7 @@
           <p:cNvPr id="65" name="number-3">
             <a:extLst xmlns:a="http://schemas.openxmlformats.org/drawingml/2006/main">
               <a:ext uri="{FF2B5EF4-FFF2-40B4-BE49-F238E27FC236}">
-                <a16:creationId xmlns:a16="http://schemas.microsoft.com/office/drawing/2014/main" id="{F1D20880-62F7-4B79-8830-6DF630632A2D}"/>
+                <a16:creationId xmlns:a16="http://schemas.microsoft.com/office/drawing/2014/main" id="{2B73B88F-BC95-4E16-B28A-CFF2A755BAFE}"/>
               </a:ext>
             </a:extLst>
           </p:cNvPr>
@@ -4180,11 +4180,11 @@
             <a:avLst/>
           </a:prstGeom>
           <a:solidFill xmlns:a="http://schemas.openxmlformats.org/drawingml/2006/main">
-            <a:srgbClr val="E6F2F2"/>
+            <a:srgbClr val="F0E8F7"/>
           </a:solidFill>
           <a:ln xmlns:a="http://schemas.openxmlformats.org/drawingml/2006/main" w="9525">
             <a:solidFill>
-              <a:srgbClr val="147B84"/>
+              <a:srgbClr val="7137A8"/>
             </a:solidFill>
             <a:prstDash val="solid"/>
           </a:ln>
@@ -4196,14 +4196,14 @@
             <a:pPr algn="ctr">
               <a:defRPr sz="750" b="1">
                 <a:solidFill>
-                  <a:srgbClr val="147B84"/>
+                  <a:srgbClr val="7137A8"/>
                 </a:solidFill>
               </a:defRPr>
             </a:pPr>
             <a:r>
               <a:rPr sz="750" b="1">
                 <a:solidFill>
-                  <a:srgbClr val="147B84"/>
+                  <a:srgbClr val="7137A8"/>
                 </a:solidFill>
               </a:rPr>
               <a:t>4</a:t>
@@ -4216,7 +4216,7 @@
           <p:cNvPr id="66" name="answer-label-3">
             <a:extLst xmlns:a="http://schemas.openxmlformats.org/drawingml/2006/main">
               <a:ext uri="{FF2B5EF4-FFF2-40B4-BE49-F238E27FC236}">
-                <a16:creationId xmlns:a16="http://schemas.microsoft.com/office/drawing/2014/main" id="{BD30D216-2EAC-40E4-BB6E-FA028594FAF2}"/>
+                <a16:creationId xmlns:a16="http://schemas.microsoft.com/office/drawing/2014/main" id="{49D32CBC-B473-4298-875D-3CDEE14E8819}"/>
               </a:ext>
             </a:extLst>
           </p:cNvPr>
@@ -4246,14 +4246,14 @@
             <a:pPr algn="l">
               <a:defRPr sz="863" b="1">
                 <a:solidFill>
-                  <a:srgbClr val="172033"/>
+                  <a:srgbClr val="15213B"/>
                 </a:solidFill>
               </a:defRPr>
             </a:pPr>
             <a:r>
               <a:rPr sz="863" b="1">
                 <a:solidFill>
-                  <a:srgbClr val="172033"/>
+                  <a:srgbClr val="15213B"/>
                 </a:solidFill>
               </a:rPr>
               <a:t>You may owe</a:t>
@@ -4266,7 +4266,7 @@
           <p:cNvPr id="67" name="answer-note-3">
             <a:extLst xmlns:a="http://schemas.openxmlformats.org/drawingml/2006/main">
               <a:ext uri="{FF2B5EF4-FFF2-40B4-BE49-F238E27FC236}">
-                <a16:creationId xmlns:a16="http://schemas.microsoft.com/office/drawing/2014/main" id="{9595A9E7-82F8-4D03-AE9D-518036CD9740}"/>
+                <a16:creationId xmlns:a16="http://schemas.microsoft.com/office/drawing/2014/main" id="{7FEFA518-680B-433F-AFE5-AA59BD194C44}"/>
               </a:ext>
             </a:extLst>
           </p:cNvPr>
@@ -4296,14 +4296,14 @@
             <a:pPr algn="l">
               <a:defRPr sz="788" b="0">
                 <a:solidFill>
-                  <a:srgbClr val="667084"/>
+                  <a:srgbClr val="63708A"/>
                 </a:solidFill>
               </a:defRPr>
             </a:pPr>
             <a:r>
               <a:rPr sz="788" b="0">
                 <a:solidFill>
-                  <a:srgbClr val="667084"/>
+                  <a:srgbClr val="63708A"/>
                 </a:solidFill>
               </a:rPr>
               <a:t>deductible, copay, coinsurance, or non-covered amount</a:t>
@@ -4316,7 +4316,7 @@
           <p:cNvPr id="68" name="sources-label">
             <a:extLst xmlns:a="http://schemas.openxmlformats.org/drawingml/2006/main">
               <a:ext uri="{FF2B5EF4-FFF2-40B4-BE49-F238E27FC236}">
-                <a16:creationId xmlns:a16="http://schemas.microsoft.com/office/drawing/2014/main" id="{F62EBC25-3B19-434A-B37B-4CB76E92A4BE}"/>
+                <a16:creationId xmlns:a16="http://schemas.microsoft.com/office/drawing/2014/main" id="{BB065361-152A-47DF-B3CF-747B3DB73A3D}"/>
               </a:ext>
             </a:extLst>
           </p:cNvPr>
@@ -4346,14 +4346,14 @@
             <a:pPr algn="l">
               <a:defRPr sz="900" b="1">
                 <a:solidFill>
-                  <a:srgbClr val="295AC8"/>
+                  <a:srgbClr val="165DFF"/>
                 </a:solidFill>
               </a:defRPr>
             </a:pPr>
             <a:r>
               <a:rPr sz="900" b="1">
                 <a:solidFill>
-                  <a:srgbClr val="295AC8"/>
+                  <a:srgbClr val="165DFF"/>
                 </a:solidFill>
               </a:rPr>
               <a:t>PUBLIC GUIDANCE SHOWN WITH THE ANSWER</a:t>
@@ -4366,7 +4366,7 @@
           <p:cNvPr id="69" name="source-tag-0">
             <a:extLst xmlns:a="http://schemas.openxmlformats.org/drawingml/2006/main">
               <a:ext uri="{FF2B5EF4-FFF2-40B4-BE49-F238E27FC236}">
-                <a16:creationId xmlns:a16="http://schemas.microsoft.com/office/drawing/2014/main" id="{32DFBAC2-85AE-4F55-B31E-D6DC047A2219}"/>
+                <a16:creationId xmlns:a16="http://schemas.microsoft.com/office/drawing/2014/main" id="{CB0D865F-4D19-451B-B8AD-B86BC23305D8}"/>
               </a:ext>
             </a:extLst>
           </p:cNvPr>
@@ -4396,14 +4396,14 @@
             <a:pPr algn="l">
               <a:defRPr sz="788" b="1">
                 <a:solidFill>
-                  <a:srgbClr val="295AC8"/>
+                  <a:srgbClr val="165DFF"/>
                 </a:solidFill>
               </a:defRPr>
             </a:pPr>
             <a:r>
               <a:rPr sz="788" b="1">
                 <a:solidFill>
-                  <a:srgbClr val="295AC8"/>
+                  <a:srgbClr val="165DFF"/>
                 </a:solidFill>
               </a:rPr>
               <a:t>[1]</a:t>
@@ -4416,7 +4416,7 @@
           <p:cNvPr id="70" name="source-publisher-0">
             <a:extLst xmlns:a="http://schemas.openxmlformats.org/drawingml/2006/main">
               <a:ext uri="{FF2B5EF4-FFF2-40B4-BE49-F238E27FC236}">
-                <a16:creationId xmlns:a16="http://schemas.microsoft.com/office/drawing/2014/main" id="{77C5EACF-DBFF-43A2-A576-B794A1B5D340}"/>
+                <a16:creationId xmlns:a16="http://schemas.microsoft.com/office/drawing/2014/main" id="{CF94DD8C-730F-42F0-8E2F-AD3B401EF04F}"/>
               </a:ext>
             </a:extLst>
           </p:cNvPr>
@@ -4446,14 +4446,14 @@
             <a:pPr algn="l">
               <a:defRPr sz="863" b="1">
                 <a:solidFill>
-                  <a:srgbClr val="172033"/>
+                  <a:srgbClr val="15213B"/>
                 </a:solidFill>
               </a:defRPr>
             </a:pPr>
             <a:r>
               <a:rPr sz="863" b="1">
                 <a:solidFill>
-                  <a:srgbClr val="172033"/>
+                  <a:srgbClr val="15213B"/>
                 </a:solidFill>
               </a:rPr>
               <a:t>HealthCare.gov</a:t>
@@ -4466,7 +4466,7 @@
           <p:cNvPr id="71" name="source-topic-0">
             <a:extLst xmlns:a="http://schemas.openxmlformats.org/drawingml/2006/main">
               <a:ext uri="{FF2B5EF4-FFF2-40B4-BE49-F238E27FC236}">
-                <a16:creationId xmlns:a16="http://schemas.microsoft.com/office/drawing/2014/main" id="{AE0FC075-0924-4BE8-BC4B-590EAB223374}"/>
+                <a16:creationId xmlns:a16="http://schemas.microsoft.com/office/drawing/2014/main" id="{86454546-97D6-492D-98DF-8903DEE213A8}"/>
               </a:ext>
             </a:extLst>
           </p:cNvPr>
@@ -4496,14 +4496,14 @@
             <a:pPr algn="l">
               <a:defRPr sz="788" b="0">
                 <a:solidFill>
-                  <a:srgbClr val="667084"/>
+                  <a:srgbClr val="63708A"/>
                 </a:solidFill>
               </a:defRPr>
             </a:pPr>
             <a:r>
               <a:rPr sz="788" b="0">
                 <a:solidFill>
-                  <a:srgbClr val="667084"/>
+                  <a:srgbClr val="63708A"/>
                 </a:solidFill>
               </a:rPr>
               <a:t>understanding an insurance bill</a:t>
@@ -4516,7 +4516,7 @@
           <p:cNvPr id="72" name="source-rule-0">
             <a:extLst xmlns:a="http://schemas.openxmlformats.org/drawingml/2006/main">
               <a:ext uri="{FF2B5EF4-FFF2-40B4-BE49-F238E27FC236}">
-                <a16:creationId xmlns:a16="http://schemas.microsoft.com/office/drawing/2014/main" id="{01535243-A269-4D67-98E4-0D7044C773E8}"/>
+                <a16:creationId xmlns:a16="http://schemas.microsoft.com/office/drawing/2014/main" id="{0723E8A7-DA70-4AD8-9590-DF7CFFDE5E2A}"/>
               </a:ext>
             </a:extLst>
           </p:cNvPr>
@@ -4536,7 +4536,7 @@
           <a:noFill xmlns:a="http://schemas.openxmlformats.org/drawingml/2006/main"/>
           <a:ln xmlns:a="http://schemas.openxmlformats.org/drawingml/2006/main" w="7620">
             <a:solidFill>
-              <a:srgbClr val="C9D0D8"/>
+              <a:srgbClr val="BCC9DA"/>
             </a:solidFill>
             <a:prstDash val="solid"/>
           </a:ln>
@@ -4547,7 +4547,7 @@
           <p:cNvPr id="73" name="source-tag-1">
             <a:extLst xmlns:a="http://schemas.openxmlformats.org/drawingml/2006/main">
               <a:ext uri="{FF2B5EF4-FFF2-40B4-BE49-F238E27FC236}">
-                <a16:creationId xmlns:a16="http://schemas.microsoft.com/office/drawing/2014/main" id="{5A6E6248-51D4-438E-B904-FB2B37FEBF60}"/>
+                <a16:creationId xmlns:a16="http://schemas.microsoft.com/office/drawing/2014/main" id="{7DAD3522-F8E6-401F-B654-1A8CE840886A}"/>
               </a:ext>
             </a:extLst>
           </p:cNvPr>
@@ -4577,14 +4577,14 @@
             <a:pPr algn="l">
               <a:defRPr sz="788" b="1">
                 <a:solidFill>
-                  <a:srgbClr val="295AC8"/>
+                  <a:srgbClr val="165DFF"/>
                 </a:solidFill>
               </a:defRPr>
             </a:pPr>
             <a:r>
               <a:rPr sz="788" b="1">
                 <a:solidFill>
-                  <a:srgbClr val="295AC8"/>
+                  <a:srgbClr val="165DFF"/>
                 </a:solidFill>
               </a:rPr>
               <a:t>[2]</a:t>
@@ -4597,7 +4597,7 @@
           <p:cNvPr id="74" name="source-publisher-1">
             <a:extLst xmlns:a="http://schemas.openxmlformats.org/drawingml/2006/main">
               <a:ext uri="{FF2B5EF4-FFF2-40B4-BE49-F238E27FC236}">
-                <a16:creationId xmlns:a16="http://schemas.microsoft.com/office/drawing/2014/main" id="{EEC163FC-BE28-41BA-B6BD-FA85A1F1F1E9}"/>
+                <a16:creationId xmlns:a16="http://schemas.microsoft.com/office/drawing/2014/main" id="{F58EA623-C822-49D5-8B4E-F3DEE7F5DF09}"/>
               </a:ext>
             </a:extLst>
           </p:cNvPr>
@@ -4627,14 +4627,14 @@
             <a:pPr algn="l">
               <a:defRPr sz="863" b="1">
                 <a:solidFill>
-                  <a:srgbClr val="172033"/>
+                  <a:srgbClr val="15213B"/>
                 </a:solidFill>
               </a:defRPr>
             </a:pPr>
             <a:r>
               <a:rPr sz="863" b="1">
                 <a:solidFill>
-                  <a:srgbClr val="172033"/>
+                  <a:srgbClr val="15213B"/>
                 </a:solidFill>
               </a:rPr>
               <a:t>CMS</a:t>
@@ -4647,7 +4647,7 @@
           <p:cNvPr id="75" name="source-topic-1">
             <a:extLst xmlns:a="http://schemas.openxmlformats.org/drawingml/2006/main">
               <a:ext uri="{FF2B5EF4-FFF2-40B4-BE49-F238E27FC236}">
-                <a16:creationId xmlns:a16="http://schemas.microsoft.com/office/drawing/2014/main" id="{2FCCBE6C-B739-4289-AF90-78FFB4D1E20E}"/>
+                <a16:creationId xmlns:a16="http://schemas.microsoft.com/office/drawing/2014/main" id="{1AA36764-43A9-4901-B5E9-F7F8121D7764}"/>
               </a:ext>
             </a:extLst>
           </p:cNvPr>
@@ -4677,14 +4677,14 @@
             <a:pPr algn="l">
               <a:defRPr sz="788" b="0">
                 <a:solidFill>
-                  <a:srgbClr val="667084"/>
+                  <a:srgbClr val="63708A"/>
                 </a:solidFill>
               </a:defRPr>
             </a:pPr>
             <a:r>
               <a:rPr sz="788" b="0">
                 <a:solidFill>
-                  <a:srgbClr val="667084"/>
+                  <a:srgbClr val="63708A"/>
                 </a:solidFill>
               </a:rPr>
               <a:t>No Surprises Act consumer rights</a:t>
@@ -4697,7 +4697,7 @@
           <p:cNvPr id="76" name="source-rule-1">
             <a:extLst xmlns:a="http://schemas.openxmlformats.org/drawingml/2006/main">
               <a:ext uri="{FF2B5EF4-FFF2-40B4-BE49-F238E27FC236}">
-                <a16:creationId xmlns:a16="http://schemas.microsoft.com/office/drawing/2014/main" id="{3CF24331-BACB-49DF-A148-9209AD7B2089}"/>
+                <a16:creationId xmlns:a16="http://schemas.microsoft.com/office/drawing/2014/main" id="{EC3C0B19-9955-4486-8B57-F8D45F60E906}"/>
               </a:ext>
             </a:extLst>
           </p:cNvPr>
@@ -4717,7 +4717,7 @@
           <a:noFill xmlns:a="http://schemas.openxmlformats.org/drawingml/2006/main"/>
           <a:ln xmlns:a="http://schemas.openxmlformats.org/drawingml/2006/main" w="7620">
             <a:solidFill>
-              <a:srgbClr val="C9D0D8"/>
+              <a:srgbClr val="BCC9DA"/>
             </a:solidFill>
             <a:prstDash val="solid"/>
           </a:ln>
@@ -4728,7 +4728,7 @@
           <p:cNvPr id="77" name="source-tag-2">
             <a:extLst xmlns:a="http://schemas.openxmlformats.org/drawingml/2006/main">
               <a:ext uri="{FF2B5EF4-FFF2-40B4-BE49-F238E27FC236}">
-                <a16:creationId xmlns:a16="http://schemas.microsoft.com/office/drawing/2014/main" id="{2B60B098-5D93-409E-AD98-7D8A3E44F395}"/>
+                <a16:creationId xmlns:a16="http://schemas.microsoft.com/office/drawing/2014/main" id="{3E528BF2-0066-428B-A2D7-C3A7D61503FB}"/>
               </a:ext>
             </a:extLst>
           </p:cNvPr>
@@ -4758,14 +4758,14 @@
             <a:pPr algn="l">
               <a:defRPr sz="788" b="1">
                 <a:solidFill>
-                  <a:srgbClr val="295AC8"/>
+                  <a:srgbClr val="165DFF"/>
                 </a:solidFill>
               </a:defRPr>
             </a:pPr>
             <a:r>
               <a:rPr sz="788" b="1">
                 <a:solidFill>
-                  <a:srgbClr val="295AC8"/>
+                  <a:srgbClr val="165DFF"/>
                 </a:solidFill>
               </a:rPr>
               <a:t>[3]</a:t>
@@ -4778,7 +4778,7 @@
           <p:cNvPr id="78" name="source-publisher-2">
             <a:extLst xmlns:a="http://schemas.openxmlformats.org/drawingml/2006/main">
               <a:ext uri="{FF2B5EF4-FFF2-40B4-BE49-F238E27FC236}">
-                <a16:creationId xmlns:a16="http://schemas.microsoft.com/office/drawing/2014/main" id="{C7FCFDDE-B55C-4541-BC7A-5274E5015BAB}"/>
+                <a16:creationId xmlns:a16="http://schemas.microsoft.com/office/drawing/2014/main" id="{33FDF205-85C6-4D83-9FC2-F43B2E983708}"/>
               </a:ext>
             </a:extLst>
           </p:cNvPr>
@@ -4808,14 +4808,14 @@
             <a:pPr algn="l">
               <a:defRPr sz="863" b="1">
                 <a:solidFill>
-                  <a:srgbClr val="172033"/>
+                  <a:srgbClr val="15213B"/>
                 </a:solidFill>
               </a:defRPr>
             </a:pPr>
             <a:r>
               <a:rPr sz="863" b="1">
                 <a:solidFill>
-                  <a:srgbClr val="172033"/>
+                  <a:srgbClr val="15213B"/>
                 </a:solidFill>
               </a:rPr>
               <a:t>CFPB</a:t>
@@ -4828,7 +4828,7 @@
           <p:cNvPr id="79" name="source-topic-2">
             <a:extLst xmlns:a="http://schemas.openxmlformats.org/drawingml/2006/main">
               <a:ext uri="{FF2B5EF4-FFF2-40B4-BE49-F238E27FC236}">
-                <a16:creationId xmlns:a16="http://schemas.microsoft.com/office/drawing/2014/main" id="{0C8CD354-FBAD-4732-9D67-BDD1C0A537BE}"/>
+                <a16:creationId xmlns:a16="http://schemas.microsoft.com/office/drawing/2014/main" id="{70090882-0904-400B-8B3A-0D62CD78365A}"/>
               </a:ext>
             </a:extLst>
           </p:cNvPr>
@@ -4858,14 +4858,14 @@
             <a:pPr algn="l">
               <a:defRPr sz="788" b="0">
                 <a:solidFill>
-                  <a:srgbClr val="667084"/>
+                  <a:srgbClr val="63708A"/>
                 </a:solidFill>
               </a:defRPr>
             </a:pPr>
             <a:r>
               <a:rPr sz="788" b="0">
                 <a:solidFill>
-                  <a:srgbClr val="667084"/>
+                  <a:srgbClr val="63708A"/>
                 </a:solidFill>
               </a:rPr>
               <a:t>disputing a medical bill</a:t>
@@ -4878,7 +4878,7 @@
           <p:cNvPr id="80" name="source-rule-2">
             <a:extLst xmlns:a="http://schemas.openxmlformats.org/drawingml/2006/main">
               <a:ext uri="{FF2B5EF4-FFF2-40B4-BE49-F238E27FC236}">
-                <a16:creationId xmlns:a16="http://schemas.microsoft.com/office/drawing/2014/main" id="{B9274081-A114-4C8E-B9D2-8387F96B0A09}"/>
+                <a16:creationId xmlns:a16="http://schemas.microsoft.com/office/drawing/2014/main" id="{A5B53757-7AF3-4795-B1DF-9DF1AC1F1B82}"/>
               </a:ext>
             </a:extLst>
           </p:cNvPr>
@@ -4898,7 +4898,7 @@
           <a:noFill xmlns:a="http://schemas.openxmlformats.org/drawingml/2006/main"/>
           <a:ln xmlns:a="http://schemas.openxmlformats.org/drawingml/2006/main" w="7620">
             <a:solidFill>
-              <a:srgbClr val="C9D0D8"/>
+              <a:srgbClr val="BCC9DA"/>
             </a:solidFill>
             <a:prstDash val="solid"/>
           </a:ln>
@@ -4909,7 +4909,7 @@
           <p:cNvPr id="81" name="live-contract">
             <a:extLst xmlns:a="http://schemas.openxmlformats.org/drawingml/2006/main">
               <a:ext uri="{FF2B5EF4-FFF2-40B4-BE49-F238E27FC236}">
-                <a16:creationId xmlns:a16="http://schemas.microsoft.com/office/drawing/2014/main" id="{FD2863FA-14E2-4468-9435-F700A04EFA88}"/>
+                <a16:creationId xmlns:a16="http://schemas.microsoft.com/office/drawing/2014/main" id="{884ED37D-181B-4839-AF06-99B9849D6C8B}"/>
               </a:ext>
             </a:extLst>
           </p:cNvPr>
@@ -4929,11 +4929,11 @@
             </a:avLst>
           </a:prstGeom>
           <a:solidFill xmlns:a="http://schemas.openxmlformats.org/drawingml/2006/main">
-            <a:srgbClr val="E6F2F2"/>
+            <a:srgbClr val="F0E8F7"/>
           </a:solidFill>
           <a:ln xmlns:a="http://schemas.openxmlformats.org/drawingml/2006/main" w="9525">
             <a:solidFill>
-              <a:srgbClr val="147B84"/>
+              <a:srgbClr val="7137A8"/>
             </a:solidFill>
             <a:prstDash val="solid"/>
           </a:ln>
@@ -4944,7 +4944,7 @@
           <p:cNvPr id="82" name="live-title">
             <a:extLst xmlns:a="http://schemas.openxmlformats.org/drawingml/2006/main">
               <a:ext uri="{FF2B5EF4-FFF2-40B4-BE49-F238E27FC236}">
-                <a16:creationId xmlns:a16="http://schemas.microsoft.com/office/drawing/2014/main" id="{4E84760D-5871-4370-9E5F-DEBA0B7BD3DF}"/>
+                <a16:creationId xmlns:a16="http://schemas.microsoft.com/office/drawing/2014/main" id="{08416717-D412-4C1F-AF85-FC2F43EF422F}"/>
               </a:ext>
             </a:extLst>
           </p:cNvPr>
@@ -4974,14 +4974,14 @@
             <a:pPr algn="l">
               <a:defRPr sz="750" b="1">
                 <a:solidFill>
-                  <a:srgbClr val="147B84"/>
+                  <a:srgbClr val="7137A8"/>
                 </a:solidFill>
               </a:defRPr>
             </a:pPr>
             <a:r>
               <a:rPr sz="750" b="1">
                 <a:solidFill>
-                  <a:srgbClr val="147B84"/>
+                  <a:srgbClr val="7137A8"/>
                 </a:solidFill>
               </a:rPr>
               <a:t>LIVE MODE</a:t>
@@ -4994,7 +4994,7 @@
           <p:cNvPr id="83" name="live-copy">
             <a:extLst xmlns:a="http://schemas.openxmlformats.org/drawingml/2006/main">
               <a:ext uri="{FF2B5EF4-FFF2-40B4-BE49-F238E27FC236}">
-                <a16:creationId xmlns:a16="http://schemas.microsoft.com/office/drawing/2014/main" id="{93A3A8F6-ACC6-494D-B241-609EA5718E3B}"/>
+                <a16:creationId xmlns:a16="http://schemas.microsoft.com/office/drawing/2014/main" id="{6EC30ECA-A578-4DA4-A48D-027382FD56EE}"/>
               </a:ext>
             </a:extLst>
           </p:cNvPr>
@@ -5024,14 +5024,14 @@
             <a:pPr algn="l">
               <a:defRPr sz="788" b="1">
                 <a:solidFill>
-                  <a:srgbClr val="172033"/>
+                  <a:srgbClr val="15213B"/>
                 </a:solidFill>
               </a:defRPr>
             </a:pPr>
             <a:r>
               <a:rPr sz="788" b="1">
                 <a:solidFill>
-                  <a:srgbClr val="172033"/>
+                  <a:srgbClr val="15213B"/>
                 </a:solidFill>
               </a:rPr>
               <a:t>retrieve ≤6  →  usable source text  →  context-only answer</a:t>
@@ -5044,7 +5044,7 @@
           <p:cNvPr id="84" name="live-refusal">
             <a:extLst xmlns:a="http://schemas.openxmlformats.org/drawingml/2006/main">
               <a:ext uri="{FF2B5EF4-FFF2-40B4-BE49-F238E27FC236}">
-                <a16:creationId xmlns:a16="http://schemas.microsoft.com/office/drawing/2014/main" id="{F2631693-8FD9-4A3E-973B-11C19CFB1358}"/>
+                <a16:creationId xmlns:a16="http://schemas.microsoft.com/office/drawing/2014/main" id="{ADD7590B-2F15-4353-A324-1333C1634422}"/>
               </a:ext>
             </a:extLst>
           </p:cNvPr>
@@ -5074,14 +5074,14 @@
             <a:pPr algn="l">
               <a:defRPr sz="788" b="1">
                 <a:solidFill>
-                  <a:srgbClr val="B5453A"/>
+                  <a:srgbClr val="C64B38"/>
                 </a:solidFill>
               </a:defRPr>
             </a:pPr>
             <a:r>
               <a:rPr sz="788" b="1">
                 <a:solidFill>
-                  <a:srgbClr val="B5453A"/>
+                  <a:srgbClr val="C64B38"/>
                 </a:solidFill>
               </a:rPr>
               <a:t>no usable text  →  422 response before generation</a:t>
@@ -5094,7 +5094,7 @@
           <p:cNvPr id="85" name="footer-rule">
             <a:extLst xmlns:a="http://schemas.openxmlformats.org/drawingml/2006/main">
               <a:ext uri="{FF2B5EF4-FFF2-40B4-BE49-F238E27FC236}">
-                <a16:creationId xmlns:a16="http://schemas.microsoft.com/office/drawing/2014/main" id="{0695A020-59AA-4EA5-A5CE-283A4D0814A0}"/>
+                <a16:creationId xmlns:a16="http://schemas.microsoft.com/office/drawing/2014/main" id="{790DDE96-D6E1-4BFE-A662-4CCA79BB8677}"/>
               </a:ext>
             </a:extLst>
           </p:cNvPr>
@@ -5114,7 +5114,7 @@
           <a:noFill xmlns:a="http://schemas.openxmlformats.org/drawingml/2006/main"/>
           <a:ln xmlns:a="http://schemas.openxmlformats.org/drawingml/2006/main" w="13335">
             <a:solidFill>
-              <a:srgbClr val="172033"/>
+              <a:srgbClr val="15213B"/>
             </a:solidFill>
             <a:prstDash val="solid"/>
           </a:ln>
@@ -5125,7 +5125,7 @@
           <p:cNvPr id="86" name="boundary">
             <a:extLst xmlns:a="http://schemas.openxmlformats.org/drawingml/2006/main">
               <a:ext uri="{FF2B5EF4-FFF2-40B4-BE49-F238E27FC236}">
-                <a16:creationId xmlns:a16="http://schemas.microsoft.com/office/drawing/2014/main" id="{004D09EB-FC3D-401D-8AE8-49393908D781}"/>
+                <a16:creationId xmlns:a16="http://schemas.microsoft.com/office/drawing/2014/main" id="{9C083845-4960-43D9-9D87-1FF3B830D8D8}"/>
               </a:ext>
             </a:extLst>
           </p:cNvPr>
@@ -5155,14 +5155,14 @@
             <a:pPr algn="l">
               <a:defRPr sz="825" b="1">
                 <a:solidFill>
-                  <a:srgbClr val="B5453A"/>
+                  <a:srgbClr val="C64B38"/>
                 </a:solidFill>
               </a:defRPr>
             </a:pPr>
             <a:r>
               <a:rPr sz="825" b="1">
                 <a:solidFill>
-                  <a:srgbClr val="B5453A"/>
+                  <a:srgbClr val="C64B38"/>
                 </a:solidFill>
               </a:rPr>
               <a:t>EVIDENCE BOUNDARY</a:t>
@@ -5175,7 +5175,7 @@
           <p:cNvPr id="87" name="boundary-copy">
             <a:extLst xmlns:a="http://schemas.openxmlformats.org/drawingml/2006/main">
               <a:ext uri="{FF2B5EF4-FFF2-40B4-BE49-F238E27FC236}">
-                <a16:creationId xmlns:a16="http://schemas.microsoft.com/office/drawing/2014/main" id="{85F1DDC5-B380-4BFD-89BB-DA7FE18BE2E8}"/>
+                <a16:creationId xmlns:a16="http://schemas.microsoft.com/office/drawing/2014/main" id="{B3E94006-1867-4A3F-AF5D-A719475E3005}"/>
               </a:ext>
             </a:extLst>
           </p:cNvPr>
@@ -5205,14 +5205,14 @@
             <a:pPr algn="l">
               <a:defRPr sz="938" b="0">
                 <a:solidFill>
-                  <a:srgbClr val="172033"/>
+                  <a:srgbClr val="15213B"/>
                 </a:solidFill>
               </a:defRPr>
             </a:pPr>
             <a:r>
               <a:rPr sz="938" b="0">
                 <a:solidFill>
-                  <a:srgbClr val="172033"/>
+                  <a:srgbClr val="15213B"/>
                 </a:solidFill>
               </a:rPr>
               <a:t>Fixture answer and sources are deterministic. No coverage, correctness, compliance, retrieval-quality, or financial-outcome claim.</a:t>
@@ -5225,7 +5225,7 @@
           <p:cNvPr id="88" name="sources">
             <a:extLst xmlns:a="http://schemas.openxmlformats.org/drawingml/2006/main">
               <a:ext uri="{FF2B5EF4-FFF2-40B4-BE49-F238E27FC236}">
-                <a16:creationId xmlns:a16="http://schemas.microsoft.com/office/drawing/2014/main" id="{C0EF042A-9CDC-40C0-9F06-03C952348F72}"/>
+                <a16:creationId xmlns:a16="http://schemas.microsoft.com/office/drawing/2014/main" id="{FB510EE3-30C0-4BA9-9C3F-E5E043FE8C3F}"/>
               </a:ext>
             </a:extLst>
           </p:cNvPr>
@@ -5255,14 +5255,14 @@
             <a:pPr algn="ctr">
               <a:defRPr sz="713" b="0">
                 <a:solidFill>
-                  <a:srgbClr val="667084"/>
+                  <a:srgbClr val="63708A"/>
                 </a:solidFill>
               </a:defRPr>
             </a:pPr>
             <a:r>
               <a:rPr sz="713" b="0">
                 <a:solidFill>
-                  <a:srgbClr val="667084"/>
+                  <a:srgbClr val="63708A"/>
                 </a:solidFill>
               </a:rPr>
               <a:t>Sources: app/page.tsx · app/data/demo.ts · app/lib/chat.ts · app/api/chat/route.ts</a:t>
@@ -5273,7 +5273,7 @@
     </p:spTree>
     <p:extLst>
       <p:ext uri="{BB962C8B-B14F-4D97-AF65-F5344CB8AC3E}">
-        <p14:creationId xmlns:p14="http://schemas.microsoft.com/office/powerpoint/2010/main" val="438282160"/>
+        <p14:creationId xmlns:p14="http://schemas.microsoft.com/office/powerpoint/2010/main" val="1323078026"/>
       </p:ext>
     </p:extLst>
   </p:cSld>

</xml_diff>

<commit_message>
Give the evidence figure a distinct clinical palette (#5)
## What changed

- replaced the shared muted treatment with a clinical editorial identity
- uses ultramarine for document linkage, signal yellow for patient
responsibility, violet for explanation, and coral for refusal boundaries
- documented the semantic color roles and retained redundant text labels
- regenerated editable and publication exports plus preflight artifacts

## Why

ClearBill should read like a deliberately designed insurance explainer,
not a generic research pipeline. The new palette borrows from the
product's existing cobalt, yellow, and coral language while adding a
clearer explanatory hierarchy.

## Validation

- npm run check: lint, types, 6 tests, and production build passed
- PowerPoint overflow test: passed
- final-size and grayscale inspection: passed
- PDF preflight: zero raster images
</commit_message>
<xml_diff>
--- a/docs/figures/clearbill-evidence-path/editable/clearbill-evidence-path.pptx
+++ b/docs/figures/clearbill-evidence-path/editable/clearbill-evidence-path.pptx
@@ -2,13 +2,13 @@
 <file path=ppt/presentation.xml><?xml version="1.0" encoding="utf-8"?>
 <p:presentation xmlns:p="http://schemas.openxmlformats.org/presentationml/2006/main">
   <p:sldMasterIdLst>
-    <p:sldMasterId xmlns:r="http://schemas.openxmlformats.org/officeDocument/2006/relationships" id="2147483648" r:id="Rabfe1a2278ce4ecf"/>
+    <p:sldMasterId xmlns:r="http://schemas.openxmlformats.org/officeDocument/2006/relationships" id="2147483648" r:id="Ra6355a825d83480e"/>
   </p:sldMasterIdLst>
   <p:notesMasterIdLst>
-    <p:notesMasterId xmlns:r="http://schemas.openxmlformats.org/officeDocument/2006/relationships" r:id="R2eeded662f0a486a"/>
+    <p:notesMasterId xmlns:r="http://schemas.openxmlformats.org/officeDocument/2006/relationships" r:id="Rf14e2c77280b45ea"/>
   </p:notesMasterIdLst>
   <p:sldIdLst>
-    <p:sldId xmlns:r="http://schemas.openxmlformats.org/officeDocument/2006/relationships" id="256" r:id="R1eff57ebccdd4c6e"/>
+    <p:sldId xmlns:r="http://schemas.openxmlformats.org/officeDocument/2006/relationships" id="256" r:id="Rdb03795d362a45d4"/>
   </p:sldIdLst>
   <p:sldSz cx="12192000" cy="6858000"/>
   <p:notesSz cx="6858000" cy="9144000"/>
@@ -601,7 +601,7 @@
   </p:cSld>
   <p:clrMap bg1="lt1" tx1="dk1" bg2="lt2" tx2="dk2" accent1="accent1" accent2="accent2" accent3="accent3" accent4="accent4" accent5="accent5" accent6="accent6" hlink="hlink" folHlink="folHlink"/>
   <p:sldLayoutIdLst>
-    <p:sldLayoutId xmlns:r="http://schemas.openxmlformats.org/officeDocument/2006/relationships" id="2147483649" r:id="R140e69ada3b9428b"/>
+    <p:sldLayoutId xmlns:r="http://schemas.openxmlformats.org/officeDocument/2006/relationships" id="2147483649" r:id="R950533e171914176"/>
   </p:sldLayoutIdLst>
   <p:txStyles>
     <p:titleStyle>
@@ -1134,7 +1134,7 @@
     <p:bg>
       <p:bgPr>
         <a:solidFill xmlns:a="http://schemas.openxmlformats.org/drawingml/2006/main">
-          <a:srgbClr val="F6F5F0"/>
+          <a:srgbClr val="F2F6FC"/>
         </a:solidFill>
       </p:bgPr>
     </p:bg>
@@ -1152,7 +1152,7 @@
           <p:cNvPr id="89" name="title">
             <a:extLst xmlns:a="http://schemas.openxmlformats.org/drawingml/2006/main">
               <a:ext uri="{FF2B5EF4-FFF2-40B4-BE49-F238E27FC236}">
-                <a16:creationId xmlns:a16="http://schemas.microsoft.com/office/drawing/2014/main" id="{FC198598-ADE2-45DB-B690-431493C34F0D}"/>
+                <a16:creationId xmlns:a16="http://schemas.microsoft.com/office/drawing/2014/main" id="{BD4FA41E-9AB2-4119-90EC-A932AA4AF835}"/>
               </a:ext>
             </a:extLst>
           </p:cNvPr>
@@ -1182,14 +1182,14 @@
             <a:pPr algn="l">
               <a:defRPr sz="2475" b="1">
                 <a:solidFill>
-                  <a:srgbClr val="172033"/>
+                  <a:srgbClr val="15213B"/>
                 </a:solidFill>
               </a:defRPr>
             </a:pPr>
             <a:r>
               <a:rPr sz="2475" b="1">
                 <a:solidFill>
-                  <a:srgbClr val="172033"/>
+                  <a:srgbClr val="15213B"/>
                 </a:solidFill>
               </a:rPr>
               <a:t>ClearBill keeps the explanation attached to the synthetic statement</a:t>
@@ -1202,7 +1202,7 @@
           <p:cNvPr id="2" name="subtitle">
             <a:extLst xmlns:a="http://schemas.openxmlformats.org/drawingml/2006/main">
               <a:ext uri="{FF2B5EF4-FFF2-40B4-BE49-F238E27FC236}">
-                <a16:creationId xmlns:a16="http://schemas.microsoft.com/office/drawing/2014/main" id="{2E1C8167-276F-48B8-BE1C-F028E216F167}"/>
+                <a16:creationId xmlns:a16="http://schemas.microsoft.com/office/drawing/2014/main" id="{EB67E8F7-24DB-4E4E-A19C-76C2D197777B}"/>
               </a:ext>
             </a:extLst>
           </p:cNvPr>
@@ -1232,14 +1232,14 @@
             <a:pPr algn="l">
               <a:defRPr sz="1200" b="0">
                 <a:solidFill>
-                  <a:srgbClr val="667084"/>
+                  <a:srgbClr val="63708A"/>
                 </a:solidFill>
               </a:defRPr>
             </a:pPr>
             <a:r>
               <a:rPr sz="1200" b="0">
                 <a:solidFill>
-                  <a:srgbClr val="667084"/>
+                  <a:srgbClr val="63708A"/>
                 </a:solidFill>
               </a:rPr>
               <a:t>One EOB is annotated in place: the answer names the fields to compare, cites public guidance, and keeps live refusal separate from the fixture.</a:t>
@@ -1252,7 +1252,7 @@
           <p:cNvPr id="3" name="header-rule">
             <a:extLst xmlns:a="http://schemas.openxmlformats.org/drawingml/2006/main">
               <a:ext uri="{FF2B5EF4-FFF2-40B4-BE49-F238E27FC236}">
-                <a16:creationId xmlns:a16="http://schemas.microsoft.com/office/drawing/2014/main" id="{96EF8707-7F8E-4A65-AA31-0C6653D9579D}"/>
+                <a16:creationId xmlns:a16="http://schemas.microsoft.com/office/drawing/2014/main" id="{0F344A6D-9953-421D-917D-9E2333D1E8F1}"/>
               </a:ext>
             </a:extLst>
           </p:cNvPr>
@@ -1272,7 +1272,7 @@
           <a:noFill xmlns:a="http://schemas.openxmlformats.org/drawingml/2006/main"/>
           <a:ln xmlns:a="http://schemas.openxmlformats.org/drawingml/2006/main" w="14288">
             <a:solidFill>
-              <a:srgbClr val="172033"/>
+              <a:srgbClr val="15213B"/>
             </a:solidFill>
             <a:prstDash val="solid"/>
           </a:ln>
@@ -1283,7 +1283,7 @@
           <p:cNvPr id="4" name="document-label">
             <a:extLst xmlns:a="http://schemas.openxmlformats.org/drawingml/2006/main">
               <a:ext uri="{FF2B5EF4-FFF2-40B4-BE49-F238E27FC236}">
-                <a16:creationId xmlns:a16="http://schemas.microsoft.com/office/drawing/2014/main" id="{EB7240B2-F354-4718-A586-4040F2C21E85}"/>
+                <a16:creationId xmlns:a16="http://schemas.microsoft.com/office/drawing/2014/main" id="{24A746B7-AFC0-467F-BB33-08AEF2246851}"/>
               </a:ext>
             </a:extLst>
           </p:cNvPr>
@@ -1313,14 +1313,14 @@
             <a:pPr algn="l">
               <a:defRPr sz="900" b="1">
                 <a:solidFill>
-                  <a:srgbClr val="295AC8"/>
+                  <a:srgbClr val="165DFF"/>
                 </a:solidFill>
               </a:defRPr>
             </a:pPr>
             <a:r>
               <a:rPr sz="900" b="1">
                 <a:solidFill>
-                  <a:srgbClr val="295AC8"/>
+                  <a:srgbClr val="165DFF"/>
                 </a:solidFill>
               </a:rPr>
               <a:t>SYNTHETIC EXPLANATION OF BENEFITS</a:t>
@@ -1333,7 +1333,7 @@
           <p:cNvPr id="5" name="document">
             <a:extLst xmlns:a="http://schemas.openxmlformats.org/drawingml/2006/main">
               <a:ext uri="{FF2B5EF4-FFF2-40B4-BE49-F238E27FC236}">
-                <a16:creationId xmlns:a16="http://schemas.microsoft.com/office/drawing/2014/main" id="{6B597B15-DEF8-49C6-AFDD-F0420A983C24}"/>
+                <a16:creationId xmlns:a16="http://schemas.microsoft.com/office/drawing/2014/main" id="{14B29E59-9192-4B0D-98A6-02C918A40CDA}"/>
               </a:ext>
             </a:extLst>
           </p:cNvPr>
@@ -1355,7 +1355,7 @@
           </a:solidFill>
           <a:ln xmlns:a="http://schemas.openxmlformats.org/drawingml/2006/main" w="12383">
             <a:solidFill>
-              <a:srgbClr val="17243B"/>
+              <a:srgbClr val="102A56"/>
             </a:solidFill>
             <a:prstDash val="solid"/>
           </a:ln>
@@ -1366,7 +1366,7 @@
           <p:cNvPr id="6" name="document-accent">
             <a:extLst xmlns:a="http://schemas.openxmlformats.org/drawingml/2006/main">
               <a:ext uri="{FF2B5EF4-FFF2-40B4-BE49-F238E27FC236}">
-                <a16:creationId xmlns:a16="http://schemas.microsoft.com/office/drawing/2014/main" id="{3291621A-A571-41BC-9E4C-48FDDFD66353}"/>
+                <a16:creationId xmlns:a16="http://schemas.microsoft.com/office/drawing/2014/main" id="{4B1B4C43-B7EE-46E5-84A0-D74FEE90165A}"/>
               </a:ext>
             </a:extLst>
           </p:cNvPr>
@@ -1384,11 +1384,11 @@
             <a:avLst/>
           </a:prstGeom>
           <a:solidFill xmlns:a="http://schemas.openxmlformats.org/drawingml/2006/main">
-            <a:srgbClr val="295AC8"/>
+            <a:srgbClr val="165DFF"/>
           </a:solidFill>
           <a:ln xmlns:a="http://schemas.openxmlformats.org/drawingml/2006/main" w="0">
             <a:solidFill>
-              <a:srgbClr val="295AC8"/>
+              <a:srgbClr val="165DFF"/>
             </a:solidFill>
             <a:prstDash val="solid"/>
           </a:ln>
@@ -1399,7 +1399,7 @@
           <p:cNvPr id="7" name="doc-eyebrow">
             <a:extLst xmlns:a="http://schemas.openxmlformats.org/drawingml/2006/main">
               <a:ext uri="{FF2B5EF4-FFF2-40B4-BE49-F238E27FC236}">
-                <a16:creationId xmlns:a16="http://schemas.microsoft.com/office/drawing/2014/main" id="{6C145B1A-3DE3-4F30-B2D8-EDBE34EA0985}"/>
+                <a16:creationId xmlns:a16="http://schemas.microsoft.com/office/drawing/2014/main" id="{D9D29C14-6F93-4BEE-90BB-1CEF70258A87}"/>
               </a:ext>
             </a:extLst>
           </p:cNvPr>
@@ -1429,14 +1429,14 @@
             <a:pPr algn="l">
               <a:defRPr sz="750" b="1">
                 <a:solidFill>
-                  <a:srgbClr val="295AC8"/>
+                  <a:srgbClr val="165DFF"/>
                 </a:solidFill>
               </a:defRPr>
             </a:pPr>
             <a:r>
               <a:rPr sz="750" b="1">
                 <a:solidFill>
-                  <a:srgbClr val="295AC8"/>
+                  <a:srgbClr val="165DFF"/>
                 </a:solidFill>
               </a:rPr>
               <a:t>EXPLANATION OF BENEFITS</a:t>
@@ -1449,7 +1449,7 @@
           <p:cNvPr id="8" name="doc-title">
             <a:extLst xmlns:a="http://schemas.openxmlformats.org/drawingml/2006/main">
               <a:ext uri="{FF2B5EF4-FFF2-40B4-BE49-F238E27FC236}">
-                <a16:creationId xmlns:a16="http://schemas.microsoft.com/office/drawing/2014/main" id="{386545C2-DFF0-41DD-8453-4D1AE7BF59A4}"/>
+                <a16:creationId xmlns:a16="http://schemas.microsoft.com/office/drawing/2014/main" id="{5F54ADF5-98CD-4C32-82BB-8E4E5D84E97A}"/>
               </a:ext>
             </a:extLst>
           </p:cNvPr>
@@ -1479,14 +1479,14 @@
             <a:pPr algn="l">
               <a:defRPr sz="1575" b="1">
                 <a:solidFill>
-                  <a:srgbClr val="17243B"/>
+                  <a:srgbClr val="102A56"/>
                 </a:solidFill>
               </a:defRPr>
             </a:pPr>
             <a:r>
               <a:rPr sz="1575" b="1">
                 <a:solidFill>
-                  <a:srgbClr val="17243B"/>
+                  <a:srgbClr val="102A56"/>
                 </a:solidFill>
               </a:rPr>
               <a:t>Claim 04-2719</a:t>
@@ -1499,7 +1499,7 @@
           <p:cNvPr id="9" name="doc-subtitle">
             <a:extLst xmlns:a="http://schemas.openxmlformats.org/drawingml/2006/main">
               <a:ext uri="{FF2B5EF4-FFF2-40B4-BE49-F238E27FC236}">
-                <a16:creationId xmlns:a16="http://schemas.microsoft.com/office/drawing/2014/main" id="{93778D9D-CA7A-4F22-83C0-B489F505E550}"/>
+                <a16:creationId xmlns:a16="http://schemas.microsoft.com/office/drawing/2014/main" id="{107EA676-3709-41A6-B6FE-ECB8C9B43031}"/>
               </a:ext>
             </a:extLst>
           </p:cNvPr>
@@ -1529,14 +1529,14 @@
             <a:pPr algn="l">
               <a:defRPr sz="863" b="0">
                 <a:solidFill>
-                  <a:srgbClr val="667084"/>
+                  <a:srgbClr val="63708A"/>
                 </a:solidFill>
               </a:defRPr>
             </a:pPr>
             <a:r>
               <a:rPr sz="863" b="0">
                 <a:solidFill>
-                  <a:srgbClr val="667084"/>
+                  <a:srgbClr val="63708A"/>
                 </a:solidFill>
               </a:rPr>
               <a:t>Northstar Internal Medicine · Sample PPO plan</a:t>
@@ -1549,7 +1549,7 @@
           <p:cNvPr id="10" name="doc-meta">
             <a:extLst xmlns:a="http://schemas.openxmlformats.org/drawingml/2006/main">
               <a:ext uri="{FF2B5EF4-FFF2-40B4-BE49-F238E27FC236}">
-                <a16:creationId xmlns:a16="http://schemas.microsoft.com/office/drawing/2014/main" id="{F4D9909C-8003-4E7D-A49B-9C89A5A95AF1}"/>
+                <a16:creationId xmlns:a16="http://schemas.microsoft.com/office/drawing/2014/main" id="{85449B4B-7887-4AB1-90A6-473FED47094C}"/>
               </a:ext>
             </a:extLst>
           </p:cNvPr>
@@ -1579,14 +1579,14 @@
             <a:pPr algn="r">
               <a:defRPr sz="788" b="0">
                 <a:solidFill>
-                  <a:srgbClr val="667084"/>
+                  <a:srgbClr val="63708A"/>
                 </a:solidFill>
               </a:defRPr>
             </a:pPr>
             <a:r>
               <a:rPr sz="788" b="0">
                 <a:solidFill>
-                  <a:srgbClr val="667084"/>
+                  <a:srgbClr val="63708A"/>
                 </a:solidFill>
               </a:rPr>
               <a:t>Sample member</a:t>
@@ -1596,14 +1596,14 @@
             <a:pPr algn="r">
               <a:defRPr sz="788" b="0">
                 <a:solidFill>
-                  <a:srgbClr val="667084"/>
+                  <a:srgbClr val="63708A"/>
                 </a:solidFill>
               </a:defRPr>
             </a:pPr>
             <a:r>
               <a:rPr sz="788" b="0">
                 <a:solidFill>
-                  <a:srgbClr val="667084"/>
+                  <a:srgbClr val="63708A"/>
                 </a:solidFill>
               </a:rPr>
               <a:t>Apr 10, 2026 service</a:t>
@@ -1613,14 +1613,14 @@
             <a:pPr algn="r">
               <a:defRPr sz="788" b="0">
                 <a:solidFill>
-                  <a:srgbClr val="667084"/>
+                  <a:srgbClr val="63708A"/>
                 </a:solidFill>
               </a:defRPr>
             </a:pPr>
             <a:r>
               <a:rPr sz="788" b="0">
                 <a:solidFill>
-                  <a:srgbClr val="667084"/>
+                  <a:srgbClr val="63708A"/>
                 </a:solidFill>
               </a:rPr>
               <a:t>Apr 18, 2026 processed</a:t>
@@ -1630,14 +1630,14 @@
             <a:pPr algn="r">
               <a:defRPr sz="788" b="0">
                 <a:solidFill>
-                  <a:srgbClr val="667084"/>
+                  <a:srgbClr val="63708A"/>
                 </a:solidFill>
               </a:defRPr>
             </a:pPr>
             <a:r>
               <a:rPr sz="788" b="0">
                 <a:solidFill>
-                  <a:srgbClr val="667084"/>
+                  <a:srgbClr val="63708A"/>
                 </a:solidFill>
               </a:rPr>
               <a:t>Finalized</a:t>
@@ -1650,7 +1650,7 @@
           <p:cNvPr id="11" name="doc-rule-1">
             <a:extLst xmlns:a="http://schemas.openxmlformats.org/drawingml/2006/main">
               <a:ext uri="{FF2B5EF4-FFF2-40B4-BE49-F238E27FC236}">
-                <a16:creationId xmlns:a16="http://schemas.microsoft.com/office/drawing/2014/main" id="{B46F4F3E-AF7C-4890-89F6-B0FF7DA17FDC}"/>
+                <a16:creationId xmlns:a16="http://schemas.microsoft.com/office/drawing/2014/main" id="{2478E03F-ED00-4D0B-AB6D-E7C790243B07}"/>
               </a:ext>
             </a:extLst>
           </p:cNvPr>
@@ -1670,7 +1670,7 @@
           <a:noFill xmlns:a="http://schemas.openxmlformats.org/drawingml/2006/main"/>
           <a:ln xmlns:a="http://schemas.openxmlformats.org/drawingml/2006/main" w="9525">
             <a:solidFill>
-              <a:srgbClr val="C9D0D8"/>
+              <a:srgbClr val="BCC9DA"/>
             </a:solidFill>
             <a:prstDash val="solid"/>
           </a:ln>
@@ -1681,7 +1681,7 @@
           <p:cNvPr id="12" name="summary-0">
             <a:extLst xmlns:a="http://schemas.openxmlformats.org/drawingml/2006/main">
               <a:ext uri="{FF2B5EF4-FFF2-40B4-BE49-F238E27FC236}">
-                <a16:creationId xmlns:a16="http://schemas.microsoft.com/office/drawing/2014/main" id="{FB4C0737-E0D2-4FC1-AEA4-C42993DC045C}"/>
+                <a16:creationId xmlns:a16="http://schemas.microsoft.com/office/drawing/2014/main" id="{A3C321FF-1E97-434B-9B4B-A53EE5B895C3}"/>
               </a:ext>
             </a:extLst>
           </p:cNvPr>
@@ -1699,11 +1699,11 @@
             <a:avLst/>
           </a:prstGeom>
           <a:solidFill xmlns:a="http://schemas.openxmlformats.org/drawingml/2006/main">
-            <a:srgbClr val="EEF0F2"/>
+            <a:srgbClr val="E9EEF5"/>
           </a:solidFill>
           <a:ln xmlns:a="http://schemas.openxmlformats.org/drawingml/2006/main" w="9525">
             <a:solidFill>
-              <a:srgbClr val="C9D0D8"/>
+              <a:srgbClr val="BCC9DA"/>
             </a:solidFill>
             <a:prstDash val="solid"/>
           </a:ln>
@@ -1714,7 +1714,7 @@
           <p:cNvPr id="13" name="summary-label-0">
             <a:extLst xmlns:a="http://schemas.openxmlformats.org/drawingml/2006/main">
               <a:ext uri="{FF2B5EF4-FFF2-40B4-BE49-F238E27FC236}">
-                <a16:creationId xmlns:a16="http://schemas.microsoft.com/office/drawing/2014/main" id="{94ADBEC5-CC74-458D-93B5-C5C017CC379D}"/>
+                <a16:creationId xmlns:a16="http://schemas.microsoft.com/office/drawing/2014/main" id="{A089E27E-E54C-409C-A7A0-A20B5DDC6D7B}"/>
               </a:ext>
             </a:extLst>
           </p:cNvPr>
@@ -1744,14 +1744,14 @@
             <a:pPr algn="l">
               <a:defRPr sz="675" b="1">
                 <a:solidFill>
-                  <a:srgbClr val="667084"/>
+                  <a:srgbClr val="63708A"/>
                 </a:solidFill>
               </a:defRPr>
             </a:pPr>
             <a:r>
               <a:rPr sz="675" b="1">
                 <a:solidFill>
-                  <a:srgbClr val="667084"/>
+                  <a:srgbClr val="63708A"/>
                 </a:solidFill>
               </a:rPr>
               <a:t>PROVIDER BILLED</a:t>
@@ -1764,7 +1764,7 @@
           <p:cNvPr id="14" name="summary-value-0">
             <a:extLst xmlns:a="http://schemas.openxmlformats.org/drawingml/2006/main">
               <a:ext uri="{FF2B5EF4-FFF2-40B4-BE49-F238E27FC236}">
-                <a16:creationId xmlns:a16="http://schemas.microsoft.com/office/drawing/2014/main" id="{0E7EADD4-8F39-4A60-8211-62FB1AF7700B}"/>
+                <a16:creationId xmlns:a16="http://schemas.microsoft.com/office/drawing/2014/main" id="{5F208791-C681-4408-AB01-34A7E5C3AB96}"/>
               </a:ext>
             </a:extLst>
           </p:cNvPr>
@@ -1794,14 +1794,14 @@
             <a:pPr algn="l">
               <a:defRPr sz="1200" b="1">
                 <a:solidFill>
-                  <a:srgbClr val="17243B"/>
+                  <a:srgbClr val="102A56"/>
                 </a:solidFill>
               </a:defRPr>
             </a:pPr>
             <a:r>
               <a:rPr sz="1200" b="1">
                 <a:solidFill>
-                  <a:srgbClr val="17243B"/>
+                  <a:srgbClr val="102A56"/>
                 </a:solidFill>
               </a:rPr>
               <a:t>$593.00</a:t>
@@ -1814,7 +1814,7 @@
           <p:cNvPr id="15" name="summary-1">
             <a:extLst xmlns:a="http://schemas.openxmlformats.org/drawingml/2006/main">
               <a:ext uri="{FF2B5EF4-FFF2-40B4-BE49-F238E27FC236}">
-                <a16:creationId xmlns:a16="http://schemas.microsoft.com/office/drawing/2014/main" id="{1D75100E-ACFD-4F11-A51C-36893773CE2F}"/>
+                <a16:creationId xmlns:a16="http://schemas.microsoft.com/office/drawing/2014/main" id="{24EAA2BF-3C94-4C4B-A38F-D9173BE72B22}"/>
               </a:ext>
             </a:extLst>
           </p:cNvPr>
@@ -1832,11 +1832,11 @@
             <a:avLst/>
           </a:prstGeom>
           <a:solidFill xmlns:a="http://schemas.openxmlformats.org/drawingml/2006/main">
-            <a:srgbClr val="EEF0F2"/>
+            <a:srgbClr val="E9EEF5"/>
           </a:solidFill>
           <a:ln xmlns:a="http://schemas.openxmlformats.org/drawingml/2006/main" w="9525">
             <a:solidFill>
-              <a:srgbClr val="C9D0D8"/>
+              <a:srgbClr val="BCC9DA"/>
             </a:solidFill>
             <a:prstDash val="solid"/>
           </a:ln>
@@ -1847,7 +1847,7 @@
           <p:cNvPr id="16" name="summary-label-1">
             <a:extLst xmlns:a="http://schemas.openxmlformats.org/drawingml/2006/main">
               <a:ext uri="{FF2B5EF4-FFF2-40B4-BE49-F238E27FC236}">
-                <a16:creationId xmlns:a16="http://schemas.microsoft.com/office/drawing/2014/main" id="{AF9507A8-5A3B-4F2D-AE83-A2CB2D8045AE}"/>
+                <a16:creationId xmlns:a16="http://schemas.microsoft.com/office/drawing/2014/main" id="{3B4AC50B-C77E-4EA2-962B-2E71F8B8A781}"/>
               </a:ext>
             </a:extLst>
           </p:cNvPr>
@@ -1877,14 +1877,14 @@
             <a:pPr algn="l">
               <a:defRPr sz="675" b="1">
                 <a:solidFill>
-                  <a:srgbClr val="667084"/>
+                  <a:srgbClr val="63708A"/>
                 </a:solidFill>
               </a:defRPr>
             </a:pPr>
             <a:r>
               <a:rPr sz="675" b="1">
                 <a:solidFill>
-                  <a:srgbClr val="667084"/>
+                  <a:srgbClr val="63708A"/>
                 </a:solidFill>
               </a:rPr>
               <a:t>PLAN DISCOUNTS</a:t>
@@ -1897,7 +1897,7 @@
           <p:cNvPr id="17" name="summary-value-1">
             <a:extLst xmlns:a="http://schemas.openxmlformats.org/drawingml/2006/main">
               <a:ext uri="{FF2B5EF4-FFF2-40B4-BE49-F238E27FC236}">
-                <a16:creationId xmlns:a16="http://schemas.microsoft.com/office/drawing/2014/main" id="{D82C5D95-686F-4CC0-A825-DDAA2AB12251}"/>
+                <a16:creationId xmlns:a16="http://schemas.microsoft.com/office/drawing/2014/main" id="{EF81B20A-E839-4E94-9D3C-651D3B82D916}"/>
               </a:ext>
             </a:extLst>
           </p:cNvPr>
@@ -1927,14 +1927,14 @@
             <a:pPr algn="l">
               <a:defRPr sz="1200" b="1">
                 <a:solidFill>
-                  <a:srgbClr val="17243B"/>
+                  <a:srgbClr val="102A56"/>
                 </a:solidFill>
               </a:defRPr>
             </a:pPr>
             <a:r>
               <a:rPr sz="1200" b="1">
                 <a:solidFill>
-                  <a:srgbClr val="17243B"/>
+                  <a:srgbClr val="102A56"/>
                 </a:solidFill>
               </a:rPr>
               <a:t>−$282.00</a:t>
@@ -1947,7 +1947,7 @@
           <p:cNvPr id="18" name="summary-2">
             <a:extLst xmlns:a="http://schemas.openxmlformats.org/drawingml/2006/main">
               <a:ext uri="{FF2B5EF4-FFF2-40B4-BE49-F238E27FC236}">
-                <a16:creationId xmlns:a16="http://schemas.microsoft.com/office/drawing/2014/main" id="{9895F02C-729F-49CD-8C9C-013F32095621}"/>
+                <a16:creationId xmlns:a16="http://schemas.microsoft.com/office/drawing/2014/main" id="{010C6770-4B88-4DDC-BD36-A6FD0800125B}"/>
               </a:ext>
             </a:extLst>
           </p:cNvPr>
@@ -1965,11 +1965,11 @@
             <a:avLst/>
           </a:prstGeom>
           <a:solidFill xmlns:a="http://schemas.openxmlformats.org/drawingml/2006/main">
-            <a:srgbClr val="EEF0F2"/>
+            <a:srgbClr val="E9EEF5"/>
           </a:solidFill>
           <a:ln xmlns:a="http://schemas.openxmlformats.org/drawingml/2006/main" w="9525">
             <a:solidFill>
-              <a:srgbClr val="C9D0D8"/>
+              <a:srgbClr val="BCC9DA"/>
             </a:solidFill>
             <a:prstDash val="solid"/>
           </a:ln>
@@ -1980,7 +1980,7 @@
           <p:cNvPr id="19" name="summary-label-2">
             <a:extLst xmlns:a="http://schemas.openxmlformats.org/drawingml/2006/main">
               <a:ext uri="{FF2B5EF4-FFF2-40B4-BE49-F238E27FC236}">
-                <a16:creationId xmlns:a16="http://schemas.microsoft.com/office/drawing/2014/main" id="{EA0820C7-4AD0-4C73-B43C-1BE84C3CBCBB}"/>
+                <a16:creationId xmlns:a16="http://schemas.microsoft.com/office/drawing/2014/main" id="{6ED5CD2E-C11D-44BF-BF4E-D1D8AD7BE26B}"/>
               </a:ext>
             </a:extLst>
           </p:cNvPr>
@@ -2010,14 +2010,14 @@
             <a:pPr algn="l">
               <a:defRPr sz="675" b="1">
                 <a:solidFill>
-                  <a:srgbClr val="667084"/>
+                  <a:srgbClr val="63708A"/>
                 </a:solidFill>
               </a:defRPr>
             </a:pPr>
             <a:r>
               <a:rPr sz="675" b="1">
                 <a:solidFill>
-                  <a:srgbClr val="667084"/>
+                  <a:srgbClr val="63708A"/>
                 </a:solidFill>
               </a:rPr>
               <a:t>PLAN PAID</a:t>
@@ -2030,7 +2030,7 @@
           <p:cNvPr id="20" name="summary-value-2">
             <a:extLst xmlns:a="http://schemas.openxmlformats.org/drawingml/2006/main">
               <a:ext uri="{FF2B5EF4-FFF2-40B4-BE49-F238E27FC236}">
-                <a16:creationId xmlns:a16="http://schemas.microsoft.com/office/drawing/2014/main" id="{264DD625-1486-40F1-A09E-5F261BFBB980}"/>
+                <a16:creationId xmlns:a16="http://schemas.microsoft.com/office/drawing/2014/main" id="{63D52F1B-9E09-425C-8B29-74C591D3CDEA}"/>
               </a:ext>
             </a:extLst>
           </p:cNvPr>
@@ -2060,14 +2060,14 @@
             <a:pPr algn="l">
               <a:defRPr sz="1200" b="1">
                 <a:solidFill>
-                  <a:srgbClr val="17243B"/>
+                  <a:srgbClr val="102A56"/>
                 </a:solidFill>
               </a:defRPr>
             </a:pPr>
             <a:r>
               <a:rPr sz="1200" b="1">
                 <a:solidFill>
-                  <a:srgbClr val="17243B"/>
+                  <a:srgbClr val="102A56"/>
                 </a:solidFill>
               </a:rPr>
               <a:t>−$251.00</a:t>
@@ -2080,7 +2080,7 @@
           <p:cNvPr id="21" name="summary-3">
             <a:extLst xmlns:a="http://schemas.openxmlformats.org/drawingml/2006/main">
               <a:ext uri="{FF2B5EF4-FFF2-40B4-BE49-F238E27FC236}">
-                <a16:creationId xmlns:a16="http://schemas.microsoft.com/office/drawing/2014/main" id="{E93FCED6-A772-4C89-A583-D63E60A579F2}"/>
+                <a16:creationId xmlns:a16="http://schemas.microsoft.com/office/drawing/2014/main" id="{9E94388D-42BE-4FEB-88E7-6FE754634046}"/>
               </a:ext>
             </a:extLst>
           </p:cNvPr>
@@ -2098,11 +2098,11 @@
             <a:avLst/>
           </a:prstGeom>
           <a:solidFill xmlns:a="http://schemas.openxmlformats.org/drawingml/2006/main">
-            <a:srgbClr val="FFF0C4"/>
+            <a:srgbClr val="FFF0A8"/>
           </a:solidFill>
           <a:ln xmlns:a="http://schemas.openxmlformats.org/drawingml/2006/main" w="9525">
             <a:solidFill>
-              <a:srgbClr val="A46900"/>
+              <a:srgbClr val="9B6200"/>
             </a:solidFill>
             <a:prstDash val="solid"/>
           </a:ln>
@@ -2113,7 +2113,7 @@
           <p:cNvPr id="22" name="summary-label-3">
             <a:extLst xmlns:a="http://schemas.openxmlformats.org/drawingml/2006/main">
               <a:ext uri="{FF2B5EF4-FFF2-40B4-BE49-F238E27FC236}">
-                <a16:creationId xmlns:a16="http://schemas.microsoft.com/office/drawing/2014/main" id="{DD49B338-18B6-43C7-8133-78FE2FC726B9}"/>
+                <a16:creationId xmlns:a16="http://schemas.microsoft.com/office/drawing/2014/main" id="{E3869414-AE03-4557-B728-644EEB091F67}"/>
               </a:ext>
             </a:extLst>
           </p:cNvPr>
@@ -2143,14 +2143,14 @@
             <a:pPr algn="l">
               <a:defRPr sz="675" b="1">
                 <a:solidFill>
-                  <a:srgbClr val="A46900"/>
+                  <a:srgbClr val="9B6200"/>
                 </a:solidFill>
               </a:defRPr>
             </a:pPr>
             <a:r>
               <a:rPr sz="675" b="1">
                 <a:solidFill>
-                  <a:srgbClr val="A46900"/>
+                  <a:srgbClr val="9B6200"/>
                 </a:solidFill>
               </a:rPr>
               <a:t>YOU MAY OWE</a:t>
@@ -2163,7 +2163,7 @@
           <p:cNvPr id="23" name="summary-value-3">
             <a:extLst xmlns:a="http://schemas.openxmlformats.org/drawingml/2006/main">
               <a:ext uri="{FF2B5EF4-FFF2-40B4-BE49-F238E27FC236}">
-                <a16:creationId xmlns:a16="http://schemas.microsoft.com/office/drawing/2014/main" id="{0EAF2D6A-5DC1-4A42-B9DC-D41F632885C5}"/>
+                <a16:creationId xmlns:a16="http://schemas.microsoft.com/office/drawing/2014/main" id="{A3D4D6E8-1512-45F7-B52C-BBBFD48A7BAE}"/>
               </a:ext>
             </a:extLst>
           </p:cNvPr>
@@ -2193,14 +2193,14 @@
             <a:pPr algn="l">
               <a:defRPr sz="1200" b="1">
                 <a:solidFill>
-                  <a:srgbClr val="A46900"/>
+                  <a:srgbClr val="9B6200"/>
                 </a:solidFill>
               </a:defRPr>
             </a:pPr>
             <a:r>
               <a:rPr sz="1200" b="1">
                 <a:solidFill>
-                  <a:srgbClr val="A46900"/>
+                  <a:srgbClr val="9B6200"/>
                 </a:solidFill>
               </a:rPr>
               <a:t>$60.00</a:t>
@@ -2213,7 +2213,7 @@
           <p:cNvPr id="24" name="service-head">
             <a:extLst xmlns:a="http://schemas.openxmlformats.org/drawingml/2006/main">
               <a:ext uri="{FF2B5EF4-FFF2-40B4-BE49-F238E27FC236}">
-                <a16:creationId xmlns:a16="http://schemas.microsoft.com/office/drawing/2014/main" id="{AC679C07-1C06-4343-B821-0762F1CE8FEA}"/>
+                <a16:creationId xmlns:a16="http://schemas.microsoft.com/office/drawing/2014/main" id="{4273CF98-28BC-494F-8F26-719DCF62B39C}"/>
               </a:ext>
             </a:extLst>
           </p:cNvPr>
@@ -2243,14 +2243,14 @@
             <a:pPr algn="l">
               <a:defRPr sz="675" b="1">
                 <a:solidFill>
-                  <a:srgbClr val="667084"/>
+                  <a:srgbClr val="63708A"/>
                 </a:solidFill>
               </a:defRPr>
             </a:pPr>
             <a:r>
               <a:rPr sz="675" b="1">
                 <a:solidFill>
-                  <a:srgbClr val="667084"/>
+                  <a:srgbClr val="63708A"/>
                 </a:solidFill>
               </a:rPr>
               <a:t>SERVICE</a:t>
@@ -2263,7 +2263,7 @@
           <p:cNvPr id="25" name="billed-head">
             <a:extLst xmlns:a="http://schemas.openxmlformats.org/drawingml/2006/main">
               <a:ext uri="{FF2B5EF4-FFF2-40B4-BE49-F238E27FC236}">
-                <a16:creationId xmlns:a16="http://schemas.microsoft.com/office/drawing/2014/main" id="{FD74C112-CE0B-4292-BCB2-D4082299C24A}"/>
+                <a16:creationId xmlns:a16="http://schemas.microsoft.com/office/drawing/2014/main" id="{F17DF541-95F9-44C5-AD1B-7101F08C74B6}"/>
               </a:ext>
             </a:extLst>
           </p:cNvPr>
@@ -2293,14 +2293,14 @@
             <a:pPr algn="r">
               <a:defRPr sz="675" b="1">
                 <a:solidFill>
-                  <a:srgbClr val="667084"/>
+                  <a:srgbClr val="63708A"/>
                 </a:solidFill>
               </a:defRPr>
             </a:pPr>
             <a:r>
               <a:rPr sz="675" b="1">
                 <a:solidFill>
-                  <a:srgbClr val="667084"/>
+                  <a:srgbClr val="63708A"/>
                 </a:solidFill>
               </a:rPr>
               <a:t>BILLED</a:t>
@@ -2313,7 +2313,7 @@
           <p:cNvPr id="26" name="allowed-head">
             <a:extLst xmlns:a="http://schemas.openxmlformats.org/drawingml/2006/main">
               <a:ext uri="{FF2B5EF4-FFF2-40B4-BE49-F238E27FC236}">
-                <a16:creationId xmlns:a16="http://schemas.microsoft.com/office/drawing/2014/main" id="{B077BE16-DC09-4471-BFAB-0F7DB79E2A0F}"/>
+                <a16:creationId xmlns:a16="http://schemas.microsoft.com/office/drawing/2014/main" id="{7D5AB1BE-F2C4-4B4F-A30F-20586A74BD9C}"/>
               </a:ext>
             </a:extLst>
           </p:cNvPr>
@@ -2343,14 +2343,14 @@
             <a:pPr algn="r">
               <a:defRPr sz="675" b="1">
                 <a:solidFill>
-                  <a:srgbClr val="667084"/>
+                  <a:srgbClr val="63708A"/>
                 </a:solidFill>
               </a:defRPr>
             </a:pPr>
             <a:r>
               <a:rPr sz="675" b="1">
                 <a:solidFill>
-                  <a:srgbClr val="667084"/>
+                  <a:srgbClr val="63708A"/>
                 </a:solidFill>
               </a:rPr>
               <a:t>ALLOWED</a:t>
@@ -2363,7 +2363,7 @@
           <p:cNvPr id="27" name="owe-head">
             <a:extLst xmlns:a="http://schemas.openxmlformats.org/drawingml/2006/main">
               <a:ext uri="{FF2B5EF4-FFF2-40B4-BE49-F238E27FC236}">
-                <a16:creationId xmlns:a16="http://schemas.microsoft.com/office/drawing/2014/main" id="{501FB121-F0AB-4F21-8CC9-73C7173CFA00}"/>
+                <a16:creationId xmlns:a16="http://schemas.microsoft.com/office/drawing/2014/main" id="{1A35CCE0-2EC8-4A7F-B1E1-7CC5DC4CFAAA}"/>
               </a:ext>
             </a:extLst>
           </p:cNvPr>
@@ -2393,14 +2393,14 @@
             <a:pPr algn="r">
               <a:defRPr sz="675" b="1">
                 <a:solidFill>
-                  <a:srgbClr val="667084"/>
+                  <a:srgbClr val="63708A"/>
                 </a:solidFill>
               </a:defRPr>
             </a:pPr>
             <a:r>
               <a:rPr sz="675" b="1">
                 <a:solidFill>
-                  <a:srgbClr val="667084"/>
+                  <a:srgbClr val="63708A"/>
                 </a:solidFill>
               </a:rPr>
               <a:t>YOU OWE</a:t>
@@ -2413,7 +2413,7 @@
           <p:cNvPr id="28" name="row-bg-0">
             <a:extLst xmlns:a="http://schemas.openxmlformats.org/drawingml/2006/main">
               <a:ext uri="{FF2B5EF4-FFF2-40B4-BE49-F238E27FC236}">
-                <a16:creationId xmlns:a16="http://schemas.microsoft.com/office/drawing/2014/main" id="{9817A993-C3E9-46CB-8A9B-B7FB3A8854EC}"/>
+                <a16:creationId xmlns:a16="http://schemas.microsoft.com/office/drawing/2014/main" id="{CB35DD08-A7F2-4150-81A6-76B267F2E3A0}"/>
               </a:ext>
             </a:extLst>
           </p:cNvPr>
@@ -2435,7 +2435,7 @@
           </a:solidFill>
           <a:ln xmlns:a="http://schemas.openxmlformats.org/drawingml/2006/main" w="9525">
             <a:solidFill>
-              <a:srgbClr val="C9D0D8"/>
+              <a:srgbClr val="BCC9DA"/>
             </a:solidFill>
             <a:prstDash val="solid"/>
           </a:ln>
@@ -2446,7 +2446,7 @@
           <p:cNvPr id="29" name="row-code-0">
             <a:extLst xmlns:a="http://schemas.openxmlformats.org/drawingml/2006/main">
               <a:ext uri="{FF2B5EF4-FFF2-40B4-BE49-F238E27FC236}">
-                <a16:creationId xmlns:a16="http://schemas.microsoft.com/office/drawing/2014/main" id="{BBC9DA64-97BE-4488-A1CD-E7C9E23B0283}"/>
+                <a16:creationId xmlns:a16="http://schemas.microsoft.com/office/drawing/2014/main" id="{58BEA502-2972-40C1-82D7-F7F692D12395}"/>
               </a:ext>
             </a:extLst>
           </p:cNvPr>
@@ -2476,14 +2476,14 @@
             <a:pPr algn="l">
               <a:defRPr sz="675" b="1">
                 <a:solidFill>
-                  <a:srgbClr val="295AC8"/>
+                  <a:srgbClr val="165DFF"/>
                 </a:solidFill>
               </a:defRPr>
             </a:pPr>
             <a:r>
               <a:rPr sz="675" b="1">
                 <a:solidFill>
-                  <a:srgbClr val="295AC8"/>
+                  <a:srgbClr val="165DFF"/>
                 </a:solidFill>
               </a:rPr>
               <a:t>99214</a:t>
@@ -2496,7 +2496,7 @@
           <p:cNvPr id="30" name="row-label-0">
             <a:extLst xmlns:a="http://schemas.openxmlformats.org/drawingml/2006/main">
               <a:ext uri="{FF2B5EF4-FFF2-40B4-BE49-F238E27FC236}">
-                <a16:creationId xmlns:a16="http://schemas.microsoft.com/office/drawing/2014/main" id="{199C2B83-8AA2-4B70-A676-45BC83C5D968}"/>
+                <a16:creationId xmlns:a16="http://schemas.microsoft.com/office/drawing/2014/main" id="{2754DF5D-07FF-434B-A872-E6A02C39B489}"/>
               </a:ext>
             </a:extLst>
           </p:cNvPr>
@@ -2526,14 +2526,14 @@
             <a:pPr algn="l">
               <a:defRPr sz="825" b="1">
                 <a:solidFill>
-                  <a:srgbClr val="172033"/>
+                  <a:srgbClr val="15213B"/>
                 </a:solidFill>
               </a:defRPr>
             </a:pPr>
             <a:r>
               <a:rPr sz="825" b="1">
                 <a:solidFill>
-                  <a:srgbClr val="172033"/>
+                  <a:srgbClr val="15213B"/>
                 </a:solidFill>
               </a:rPr>
               <a:t>Office visit, established patient</a:t>
@@ -2546,7 +2546,7 @@
           <p:cNvPr id="31" name="row-billed-0">
             <a:extLst xmlns:a="http://schemas.openxmlformats.org/drawingml/2006/main">
               <a:ext uri="{FF2B5EF4-FFF2-40B4-BE49-F238E27FC236}">
-                <a16:creationId xmlns:a16="http://schemas.microsoft.com/office/drawing/2014/main" id="{F1FC91E9-F293-4E5E-8644-32A002367D90}"/>
+                <a16:creationId xmlns:a16="http://schemas.microsoft.com/office/drawing/2014/main" id="{D2EA8F9A-4E34-4B6A-90C0-1805C7719BBA}"/>
               </a:ext>
             </a:extLst>
           </p:cNvPr>
@@ -2576,14 +2576,14 @@
             <a:pPr algn="r">
               <a:defRPr sz="825" b="0">
                 <a:solidFill>
-                  <a:srgbClr val="172033"/>
+                  <a:srgbClr val="15213B"/>
                 </a:solidFill>
               </a:defRPr>
             </a:pPr>
             <a:r>
               <a:rPr sz="825" b="0">
                 <a:solidFill>
-                  <a:srgbClr val="172033"/>
+                  <a:srgbClr val="15213B"/>
                 </a:solidFill>
               </a:rPr>
               <a:t>$425.00</a:t>
@@ -2596,7 +2596,7 @@
           <p:cNvPr id="32" name="row-allowed-0">
             <a:extLst xmlns:a="http://schemas.openxmlformats.org/drawingml/2006/main">
               <a:ext uri="{FF2B5EF4-FFF2-40B4-BE49-F238E27FC236}">
-                <a16:creationId xmlns:a16="http://schemas.microsoft.com/office/drawing/2014/main" id="{14E73667-1B82-45D5-B597-57DE198B1778}"/>
+                <a16:creationId xmlns:a16="http://schemas.microsoft.com/office/drawing/2014/main" id="{AFA9DD17-F0F7-4316-BBB6-EC75512039E2}"/>
               </a:ext>
             </a:extLst>
           </p:cNvPr>
@@ -2626,14 +2626,14 @@
             <a:pPr algn="r">
               <a:defRPr sz="825" b="0">
                 <a:solidFill>
-                  <a:srgbClr val="172033"/>
+                  <a:srgbClr val="15213B"/>
                 </a:solidFill>
               </a:defRPr>
             </a:pPr>
             <a:r>
               <a:rPr sz="825" b="0">
                 <a:solidFill>
-                  <a:srgbClr val="172033"/>
+                  <a:srgbClr val="15213B"/>
                 </a:solidFill>
               </a:rPr>
               <a:t>$235.00</a:t>
@@ -2646,7 +2646,7 @@
           <p:cNvPr id="33" name="row-owe-0">
             <a:extLst xmlns:a="http://schemas.openxmlformats.org/drawingml/2006/main">
               <a:ext uri="{FF2B5EF4-FFF2-40B4-BE49-F238E27FC236}">
-                <a16:creationId xmlns:a16="http://schemas.microsoft.com/office/drawing/2014/main" id="{737F462E-435D-493A-9713-36BD055B9583}"/>
+                <a16:creationId xmlns:a16="http://schemas.microsoft.com/office/drawing/2014/main" id="{448485A3-351D-4EEA-B60F-5119031B7D0F}"/>
               </a:ext>
             </a:extLst>
           </p:cNvPr>
@@ -2676,14 +2676,14 @@
             <a:pPr algn="r">
               <a:defRPr sz="825" b="0">
                 <a:solidFill>
-                  <a:srgbClr val="172033"/>
+                  <a:srgbClr val="15213B"/>
                 </a:solidFill>
               </a:defRPr>
             </a:pPr>
             <a:r>
               <a:rPr sz="825" b="0">
                 <a:solidFill>
-                  <a:srgbClr val="172033"/>
+                  <a:srgbClr val="15213B"/>
                 </a:solidFill>
               </a:rPr>
               <a:t>$40.00</a:t>
@@ -2696,7 +2696,7 @@
           <p:cNvPr id="34" name="row-bg-1">
             <a:extLst xmlns:a="http://schemas.openxmlformats.org/drawingml/2006/main">
               <a:ext uri="{FF2B5EF4-FFF2-40B4-BE49-F238E27FC236}">
-                <a16:creationId xmlns:a16="http://schemas.microsoft.com/office/drawing/2014/main" id="{2FF388A6-76DE-4519-8256-1C7816657548}"/>
+                <a16:creationId xmlns:a16="http://schemas.microsoft.com/office/drawing/2014/main" id="{3DC06725-C8ED-413C-BC2B-D18B7DE3BB9A}"/>
               </a:ext>
             </a:extLst>
           </p:cNvPr>
@@ -2714,11 +2714,11 @@
             <a:avLst/>
           </a:prstGeom>
           <a:solidFill xmlns:a="http://schemas.openxmlformats.org/drawingml/2006/main">
-            <a:srgbClr val="E8EEFC"/>
+            <a:srgbClr val="E6EEFF"/>
           </a:solidFill>
           <a:ln xmlns:a="http://schemas.openxmlformats.org/drawingml/2006/main" w="13335">
             <a:solidFill>
-              <a:srgbClr val="295AC8"/>
+              <a:srgbClr val="165DFF"/>
             </a:solidFill>
             <a:prstDash val="solid"/>
           </a:ln>
@@ -2729,7 +2729,7 @@
           <p:cNvPr id="35" name="row-code-1">
             <a:extLst xmlns:a="http://schemas.openxmlformats.org/drawingml/2006/main">
               <a:ext uri="{FF2B5EF4-FFF2-40B4-BE49-F238E27FC236}">
-                <a16:creationId xmlns:a16="http://schemas.microsoft.com/office/drawing/2014/main" id="{17F51D4E-B7BB-4D06-9FAF-33C2F75F9704}"/>
+                <a16:creationId xmlns:a16="http://schemas.microsoft.com/office/drawing/2014/main" id="{4D251046-1C2C-43B4-98DC-669B12B42F94}"/>
               </a:ext>
             </a:extLst>
           </p:cNvPr>
@@ -2759,14 +2759,14 @@
             <a:pPr algn="l">
               <a:defRPr sz="675" b="1">
                 <a:solidFill>
-                  <a:srgbClr val="295AC8"/>
+                  <a:srgbClr val="165DFF"/>
                 </a:solidFill>
               </a:defRPr>
             </a:pPr>
             <a:r>
               <a:rPr sz="675" b="1">
                 <a:solidFill>
-                  <a:srgbClr val="295AC8"/>
+                  <a:srgbClr val="165DFF"/>
                 </a:solidFill>
               </a:rPr>
               <a:t>80053</a:t>
@@ -2779,7 +2779,7 @@
           <p:cNvPr id="36" name="row-label-1">
             <a:extLst xmlns:a="http://schemas.openxmlformats.org/drawingml/2006/main">
               <a:ext uri="{FF2B5EF4-FFF2-40B4-BE49-F238E27FC236}">
-                <a16:creationId xmlns:a16="http://schemas.microsoft.com/office/drawing/2014/main" id="{15D1AB47-D3BA-47D5-B361-57C173B8860C}"/>
+                <a16:creationId xmlns:a16="http://schemas.microsoft.com/office/drawing/2014/main" id="{B905CE75-20B9-478A-B4E6-2E128D490FC9}"/>
               </a:ext>
             </a:extLst>
           </p:cNvPr>
@@ -2809,14 +2809,14 @@
             <a:pPr algn="l">
               <a:defRPr sz="825" b="1">
                 <a:solidFill>
-                  <a:srgbClr val="172033"/>
+                  <a:srgbClr val="15213B"/>
                 </a:solidFill>
               </a:defRPr>
             </a:pPr>
             <a:r>
               <a:rPr sz="825" b="1">
                 <a:solidFill>
-                  <a:srgbClr val="172033"/>
+                  <a:srgbClr val="15213B"/>
                 </a:solidFill>
               </a:rPr>
               <a:t>Comprehensive metabolic panel</a:t>
@@ -2829,7 +2829,7 @@
           <p:cNvPr id="37" name="row-billed-1">
             <a:extLst xmlns:a="http://schemas.openxmlformats.org/drawingml/2006/main">
               <a:ext uri="{FF2B5EF4-FFF2-40B4-BE49-F238E27FC236}">
-                <a16:creationId xmlns:a16="http://schemas.microsoft.com/office/drawing/2014/main" id="{E899E800-0B38-440C-AC3A-1D767BBEF838}"/>
+                <a16:creationId xmlns:a16="http://schemas.microsoft.com/office/drawing/2014/main" id="{977F396A-7ACA-4802-8DF8-82B1D5458726}"/>
               </a:ext>
             </a:extLst>
           </p:cNvPr>
@@ -2859,14 +2859,14 @@
             <a:pPr algn="r">
               <a:defRPr sz="825" b="0">
                 <a:solidFill>
-                  <a:srgbClr val="172033"/>
+                  <a:srgbClr val="15213B"/>
                 </a:solidFill>
               </a:defRPr>
             </a:pPr>
             <a:r>
               <a:rPr sz="825" b="0">
                 <a:solidFill>
-                  <a:srgbClr val="172033"/>
+                  <a:srgbClr val="15213B"/>
                 </a:solidFill>
               </a:rPr>
               <a:t>$168.00</a:t>
@@ -2879,7 +2879,7 @@
           <p:cNvPr id="38" name="row-allowed-1">
             <a:extLst xmlns:a="http://schemas.openxmlformats.org/drawingml/2006/main">
               <a:ext uri="{FF2B5EF4-FFF2-40B4-BE49-F238E27FC236}">
-                <a16:creationId xmlns:a16="http://schemas.microsoft.com/office/drawing/2014/main" id="{323EF1C3-9E05-4826-8D6E-D456DA5120F6}"/>
+                <a16:creationId xmlns:a16="http://schemas.microsoft.com/office/drawing/2014/main" id="{0FC37963-0689-4B55-AE9D-450430E7207A}"/>
               </a:ext>
             </a:extLst>
           </p:cNvPr>
@@ -2909,14 +2909,14 @@
             <a:pPr algn="r">
               <a:defRPr sz="825" b="0">
                 <a:solidFill>
-                  <a:srgbClr val="172033"/>
+                  <a:srgbClr val="15213B"/>
                 </a:solidFill>
               </a:defRPr>
             </a:pPr>
             <a:r>
               <a:rPr sz="825" b="0">
                 <a:solidFill>
-                  <a:srgbClr val="172033"/>
+                  <a:srgbClr val="15213B"/>
                 </a:solidFill>
               </a:rPr>
               <a:t>$76.00</a:t>
@@ -2929,7 +2929,7 @@
           <p:cNvPr id="39" name="row-owe-1">
             <a:extLst xmlns:a="http://schemas.openxmlformats.org/drawingml/2006/main">
               <a:ext uri="{FF2B5EF4-FFF2-40B4-BE49-F238E27FC236}">
-                <a16:creationId xmlns:a16="http://schemas.microsoft.com/office/drawing/2014/main" id="{60F34831-E9EA-4000-9F1B-B56E42D56A3A}"/>
+                <a16:creationId xmlns:a16="http://schemas.microsoft.com/office/drawing/2014/main" id="{8CE7CDDE-49C9-4BA1-9615-59CE04C390A9}"/>
               </a:ext>
             </a:extLst>
           </p:cNvPr>
@@ -2959,14 +2959,14 @@
             <a:pPr algn="r">
               <a:defRPr sz="825" b="0">
                 <a:solidFill>
-                  <a:srgbClr val="172033"/>
+                  <a:srgbClr val="15213B"/>
                 </a:solidFill>
               </a:defRPr>
             </a:pPr>
             <a:r>
               <a:rPr sz="825" b="0">
                 <a:solidFill>
-                  <a:srgbClr val="172033"/>
+                  <a:srgbClr val="15213B"/>
                 </a:solidFill>
               </a:rPr>
               <a:t>$20.00</a:t>
@@ -2979,7 +2979,7 @@
           <p:cNvPr id="40" name="row-bg-2">
             <a:extLst xmlns:a="http://schemas.openxmlformats.org/drawingml/2006/main">
               <a:ext uri="{FF2B5EF4-FFF2-40B4-BE49-F238E27FC236}">
-                <a16:creationId xmlns:a16="http://schemas.microsoft.com/office/drawing/2014/main" id="{C642FEE9-7014-4C31-B4F6-ADCA489FDFFF}"/>
+                <a16:creationId xmlns:a16="http://schemas.microsoft.com/office/drawing/2014/main" id="{A22BA0AF-D599-46D5-B07F-3B9FB4988D86}"/>
               </a:ext>
             </a:extLst>
           </p:cNvPr>
@@ -3001,7 +3001,7 @@
           </a:solidFill>
           <a:ln xmlns:a="http://schemas.openxmlformats.org/drawingml/2006/main" w="9525">
             <a:solidFill>
-              <a:srgbClr val="C9D0D8"/>
+              <a:srgbClr val="BCC9DA"/>
             </a:solidFill>
             <a:prstDash val="solid"/>
           </a:ln>
@@ -3012,7 +3012,7 @@
           <p:cNvPr id="41" name="row-code-2">
             <a:extLst xmlns:a="http://schemas.openxmlformats.org/drawingml/2006/main">
               <a:ext uri="{FF2B5EF4-FFF2-40B4-BE49-F238E27FC236}">
-                <a16:creationId xmlns:a16="http://schemas.microsoft.com/office/drawing/2014/main" id="{622F503A-26FC-4DE1-AF96-4541F2D61408}"/>
+                <a16:creationId xmlns:a16="http://schemas.microsoft.com/office/drawing/2014/main" id="{E2F6A1A5-F7E5-480D-95AD-5974B4029931}"/>
               </a:ext>
             </a:extLst>
           </p:cNvPr>
@@ -3042,14 +3042,14 @@
             <a:pPr algn="l">
               <a:defRPr sz="675" b="1">
                 <a:solidFill>
-                  <a:srgbClr val="295AC8"/>
+                  <a:srgbClr val="165DFF"/>
                 </a:solidFill>
               </a:defRPr>
             </a:pPr>
             <a:r>
               <a:rPr sz="675" b="1">
                 <a:solidFill>
-                  <a:srgbClr val="295AC8"/>
+                  <a:srgbClr val="165DFF"/>
                 </a:solidFill>
               </a:rPr>
               <a:t>ADJ</a:t>
@@ -3062,7 +3062,7 @@
           <p:cNvPr id="42" name="row-label-2">
             <a:extLst xmlns:a="http://schemas.openxmlformats.org/drawingml/2006/main">
               <a:ext uri="{FF2B5EF4-FFF2-40B4-BE49-F238E27FC236}">
-                <a16:creationId xmlns:a16="http://schemas.microsoft.com/office/drawing/2014/main" id="{C57C2860-CD3F-4138-A6D9-7A077CA32607}"/>
+                <a16:creationId xmlns:a16="http://schemas.microsoft.com/office/drawing/2014/main" id="{DB12FE4C-F86B-4164-865B-9025C4603EBD}"/>
               </a:ext>
             </a:extLst>
           </p:cNvPr>
@@ -3092,14 +3092,14 @@
             <a:pPr algn="l">
               <a:defRPr sz="825" b="1">
                 <a:solidFill>
-                  <a:srgbClr val="172033"/>
+                  <a:srgbClr val="15213B"/>
                 </a:solidFill>
               </a:defRPr>
             </a:pPr>
             <a:r>
               <a:rPr sz="825" b="1">
                 <a:solidFill>
-                  <a:srgbClr val="172033"/>
+                  <a:srgbClr val="15213B"/>
                 </a:solidFill>
               </a:rPr>
               <a:t>Network discount and plan payment</a:t>
@@ -3112,7 +3112,7 @@
           <p:cNvPr id="43" name="row-billed-2">
             <a:extLst xmlns:a="http://schemas.openxmlformats.org/drawingml/2006/main">
               <a:ext uri="{FF2B5EF4-FFF2-40B4-BE49-F238E27FC236}">
-                <a16:creationId xmlns:a16="http://schemas.microsoft.com/office/drawing/2014/main" id="{53E0627F-2788-41E9-9E79-2AAFE65F7A26}"/>
+                <a16:creationId xmlns:a16="http://schemas.microsoft.com/office/drawing/2014/main" id="{90F5E566-59BA-4A18-B2ED-1280035A1EE7}"/>
               </a:ext>
             </a:extLst>
           </p:cNvPr>
@@ -3142,14 +3142,14 @@
             <a:pPr algn="r">
               <a:defRPr sz="825" b="0">
                 <a:solidFill>
-                  <a:srgbClr val="172033"/>
+                  <a:srgbClr val="15213B"/>
                 </a:solidFill>
               </a:defRPr>
             </a:pPr>
             <a:r>
               <a:rPr sz="825" b="0">
                 <a:solidFill>
-                  <a:srgbClr val="172033"/>
+                  <a:srgbClr val="15213B"/>
                 </a:solidFill>
               </a:rPr>
               <a:t>−$282.00</a:t>
@@ -3162,7 +3162,7 @@
           <p:cNvPr id="44" name="row-allowed-2">
             <a:extLst xmlns:a="http://schemas.openxmlformats.org/drawingml/2006/main">
               <a:ext uri="{FF2B5EF4-FFF2-40B4-BE49-F238E27FC236}">
-                <a16:creationId xmlns:a16="http://schemas.microsoft.com/office/drawing/2014/main" id="{202E6A4B-A5D3-4B7C-88CC-86B2F4273D66}"/>
+                <a16:creationId xmlns:a16="http://schemas.microsoft.com/office/drawing/2014/main" id="{759AD7B7-0911-4647-A8EF-365FB15A5890}"/>
               </a:ext>
             </a:extLst>
           </p:cNvPr>
@@ -3192,14 +3192,14 @@
             <a:pPr algn="r">
               <a:defRPr sz="825" b="0">
                 <a:solidFill>
-                  <a:srgbClr val="172033"/>
+                  <a:srgbClr val="15213B"/>
                 </a:solidFill>
               </a:defRPr>
             </a:pPr>
             <a:r>
               <a:rPr sz="825" b="0">
                 <a:solidFill>
-                  <a:srgbClr val="172033"/>
+                  <a:srgbClr val="15213B"/>
                 </a:solidFill>
               </a:rPr>
               <a:t>Applied</a:t>
@@ -3212,7 +3212,7 @@
           <p:cNvPr id="45" name="row-owe-2">
             <a:extLst xmlns:a="http://schemas.openxmlformats.org/drawingml/2006/main">
               <a:ext uri="{FF2B5EF4-FFF2-40B4-BE49-F238E27FC236}">
-                <a16:creationId xmlns:a16="http://schemas.microsoft.com/office/drawing/2014/main" id="{10E1DBC8-A149-4FCB-B97C-FD42AC987E35}"/>
+                <a16:creationId xmlns:a16="http://schemas.microsoft.com/office/drawing/2014/main" id="{A2904C7C-733E-4853-ACFD-1466AFF63DCD}"/>
               </a:ext>
             </a:extLst>
           </p:cNvPr>
@@ -3242,14 +3242,14 @@
             <a:pPr algn="r">
               <a:defRPr sz="825" b="0">
                 <a:solidFill>
-                  <a:srgbClr val="172033"/>
+                  <a:srgbClr val="15213B"/>
                 </a:solidFill>
               </a:defRPr>
             </a:pPr>
             <a:r>
               <a:rPr sz="825" b="0">
                 <a:solidFill>
-                  <a:srgbClr val="172033"/>
+                  <a:srgbClr val="15213B"/>
                 </a:solidFill>
               </a:rPr>
               <a:t>$0.00</a:t>
@@ -3262,7 +3262,7 @@
           <p:cNvPr id="46" name="not-bill">
             <a:extLst xmlns:a="http://schemas.openxmlformats.org/drawingml/2006/main">
               <a:ext uri="{FF2B5EF4-FFF2-40B4-BE49-F238E27FC236}">
-                <a16:creationId xmlns:a16="http://schemas.microsoft.com/office/drawing/2014/main" id="{D6251799-F7A9-4452-8411-BC5E4BE36C13}"/>
+                <a16:creationId xmlns:a16="http://schemas.microsoft.com/office/drawing/2014/main" id="{4B3974FD-B365-4EF5-AD00-C9A631BD83E2}"/>
               </a:ext>
             </a:extLst>
           </p:cNvPr>
@@ -3282,11 +3282,11 @@
             </a:avLst>
           </a:prstGeom>
           <a:solidFill xmlns:a="http://schemas.openxmlformats.org/drawingml/2006/main">
-            <a:srgbClr val="FFF0C4"/>
+            <a:srgbClr val="FFF0A8"/>
           </a:solidFill>
           <a:ln xmlns:a="http://schemas.openxmlformats.org/drawingml/2006/main" w="9525">
             <a:solidFill>
-              <a:srgbClr val="A46900"/>
+              <a:srgbClr val="9B6200"/>
             </a:solidFill>
             <a:prstDash val="solid"/>
           </a:ln>
@@ -3297,7 +3297,7 @@
           <p:cNvPr id="47" name="not-bill-label">
             <a:extLst xmlns:a="http://schemas.openxmlformats.org/drawingml/2006/main">
               <a:ext uri="{FF2B5EF4-FFF2-40B4-BE49-F238E27FC236}">
-                <a16:creationId xmlns:a16="http://schemas.microsoft.com/office/drawing/2014/main" id="{579A4174-9B22-425D-A654-013204811425}"/>
+                <a16:creationId xmlns:a16="http://schemas.microsoft.com/office/drawing/2014/main" id="{5CAB9754-CEB9-451C-86A0-E667C5F62B66}"/>
               </a:ext>
             </a:extLst>
           </p:cNvPr>
@@ -3327,14 +3327,14 @@
             <a:pPr algn="l">
               <a:defRPr sz="675" b="1">
                 <a:solidFill>
-                  <a:srgbClr val="A46900"/>
+                  <a:srgbClr val="9B6200"/>
                 </a:solidFill>
               </a:defRPr>
             </a:pPr>
             <a:r>
               <a:rPr sz="675" b="1">
                 <a:solidFill>
-                  <a:srgbClr val="A46900"/>
+                  <a:srgbClr val="9B6200"/>
                 </a:solidFill>
               </a:rPr>
               <a:t>NOT A BILL</a:t>
@@ -3347,7 +3347,7 @@
           <p:cNvPr id="48" name="not-bill-copy">
             <a:extLst xmlns:a="http://schemas.openxmlformats.org/drawingml/2006/main">
               <a:ext uri="{FF2B5EF4-FFF2-40B4-BE49-F238E27FC236}">
-                <a16:creationId xmlns:a16="http://schemas.microsoft.com/office/drawing/2014/main" id="{77D5E807-945F-4CE9-9868-E863827AF4CD}"/>
+                <a16:creationId xmlns:a16="http://schemas.microsoft.com/office/drawing/2014/main" id="{EEDA7BE3-0104-4AB0-ABC4-08CB16FFFA13}"/>
               </a:ext>
             </a:extLst>
           </p:cNvPr>
@@ -3377,14 +3377,14 @@
             <a:pPr algn="l">
               <a:defRPr sz="788" b="0">
                 <a:solidFill>
-                  <a:srgbClr val="172033"/>
+                  <a:srgbClr val="15213B"/>
                 </a:solidFill>
               </a:defRPr>
             </a:pPr>
             <a:r>
               <a:rPr sz="788" b="0">
                 <a:solidFill>
-                  <a:srgbClr val="172033"/>
+                  <a:srgbClr val="15213B"/>
                 </a:solidFill>
               </a:rPr>
               <a:t>Compare with the provider invoice before paying; every identity and amount shown is synthetic.</a:t>
@@ -3397,7 +3397,7 @@
           <p:cNvPr id="49" name="document-to-answer">
             <a:extLst xmlns:a="http://schemas.openxmlformats.org/drawingml/2006/main">
               <a:ext uri="{FF2B5EF4-FFF2-40B4-BE49-F238E27FC236}">
-                <a16:creationId xmlns:a16="http://schemas.microsoft.com/office/drawing/2014/main" id="{855ED0CE-4193-4C7B-B3D7-765FF7BFF773}"/>
+                <a16:creationId xmlns:a16="http://schemas.microsoft.com/office/drawing/2014/main" id="{54A7E6B3-883D-4936-9851-3397C4F472E7}"/>
               </a:ext>
             </a:extLst>
           </p:cNvPr>
@@ -3415,11 +3415,11 @@
             <a:avLst/>
           </a:prstGeom>
           <a:solidFill xmlns:a="http://schemas.openxmlformats.org/drawingml/2006/main">
-            <a:srgbClr val="295AC8"/>
+            <a:srgbClr val="165DFF"/>
           </a:solidFill>
           <a:ln xmlns:a="http://schemas.openxmlformats.org/drawingml/2006/main" w="0">
             <a:solidFill>
-              <a:srgbClr val="295AC8"/>
+              <a:srgbClr val="165DFF"/>
             </a:solidFill>
             <a:prstDash val="solid"/>
           </a:ln>
@@ -3430,7 +3430,7 @@
           <p:cNvPr id="50" name="question-label">
             <a:extLst xmlns:a="http://schemas.openxmlformats.org/drawingml/2006/main">
               <a:ext uri="{FF2B5EF4-FFF2-40B4-BE49-F238E27FC236}">
-                <a16:creationId xmlns:a16="http://schemas.microsoft.com/office/drawing/2014/main" id="{B101EDD9-C22F-45D0-841B-8C1EB79377BC}"/>
+                <a16:creationId xmlns:a16="http://schemas.microsoft.com/office/drawing/2014/main" id="{24938B0E-90DC-40B4-AB57-8C6F41ABA0D1}"/>
               </a:ext>
             </a:extLst>
           </p:cNvPr>
@@ -3460,14 +3460,14 @@
             <a:pPr algn="l">
               <a:defRPr sz="900" b="1">
                 <a:solidFill>
-                  <a:srgbClr val="295AC8"/>
+                  <a:srgbClr val="165DFF"/>
                 </a:solidFill>
               </a:defRPr>
             </a:pPr>
             <a:r>
               <a:rPr sz="900" b="1">
                 <a:solidFill>
-                  <a:srgbClr val="295AC8"/>
+                  <a:srgbClr val="165DFF"/>
                 </a:solidFill>
               </a:rPr>
               <a:t>BUNDLED DEMO QUESTION</a:t>
@@ -3480,7 +3480,7 @@
           <p:cNvPr id="51" name="question">
             <a:extLst xmlns:a="http://schemas.openxmlformats.org/drawingml/2006/main">
               <a:ext uri="{FF2B5EF4-FFF2-40B4-BE49-F238E27FC236}">
-                <a16:creationId xmlns:a16="http://schemas.microsoft.com/office/drawing/2014/main" id="{E97CAE71-46FA-480C-A1E9-8DB46A3552A6}"/>
+                <a16:creationId xmlns:a16="http://schemas.microsoft.com/office/drawing/2014/main" id="{461A9C83-45E5-46CD-AD7C-F73BB2E95A87}"/>
               </a:ext>
             </a:extLst>
           </p:cNvPr>
@@ -3500,11 +3500,11 @@
             </a:avLst>
           </a:prstGeom>
           <a:solidFill xmlns:a="http://schemas.openxmlformats.org/drawingml/2006/main">
-            <a:srgbClr val="E8EEFC"/>
+            <a:srgbClr val="E6EEFF"/>
           </a:solidFill>
           <a:ln xmlns:a="http://schemas.openxmlformats.org/drawingml/2006/main" w="11430">
             <a:solidFill>
-              <a:srgbClr val="295AC8"/>
+              <a:srgbClr val="165DFF"/>
             </a:solidFill>
             <a:prstDash val="solid"/>
           </a:ln>
@@ -3515,7 +3515,7 @@
           <p:cNvPr id="52" name="question-copy">
             <a:extLst xmlns:a="http://schemas.openxmlformats.org/drawingml/2006/main">
               <a:ext uri="{FF2B5EF4-FFF2-40B4-BE49-F238E27FC236}">
-                <a16:creationId xmlns:a16="http://schemas.microsoft.com/office/drawing/2014/main" id="{D97A5725-27DD-4222-B43D-02EFDE30CFB4}"/>
+                <a16:creationId xmlns:a16="http://schemas.microsoft.com/office/drawing/2014/main" id="{03E7881A-9B36-49EA-A15C-E165148CAD0A}"/>
               </a:ext>
             </a:extLst>
           </p:cNvPr>
@@ -3545,14 +3545,14 @@
             <a:pPr algn="l">
               <a:defRPr sz="1275" b="1">
                 <a:solidFill>
-                  <a:srgbClr val="17243B"/>
+                  <a:srgbClr val="102A56"/>
                 </a:solidFill>
               </a:defRPr>
             </a:pPr>
             <a:r>
               <a:rPr sz="1275" b="1">
                 <a:solidFill>
-                  <a:srgbClr val="17243B"/>
+                  <a:srgbClr val="102A56"/>
                 </a:solidFill>
               </a:rPr>
               <a:t>What is an Explanation of Benefits?</a:t>
@@ -3565,7 +3565,7 @@
           <p:cNvPr id="53" name="answer-label">
             <a:extLst xmlns:a="http://schemas.openxmlformats.org/drawingml/2006/main">
               <a:ext uri="{FF2B5EF4-FFF2-40B4-BE49-F238E27FC236}">
-                <a16:creationId xmlns:a16="http://schemas.microsoft.com/office/drawing/2014/main" id="{3C98DAD9-C429-441C-8FE0-0A5F4A12B2D9}"/>
+                <a16:creationId xmlns:a16="http://schemas.microsoft.com/office/drawing/2014/main" id="{75492F70-D2CD-4AD2-902D-8AEB913CA02C}"/>
               </a:ext>
             </a:extLst>
           </p:cNvPr>
@@ -3595,14 +3595,14 @@
             <a:pPr algn="l">
               <a:defRPr sz="900" b="1">
                 <a:solidFill>
-                  <a:srgbClr val="147B84"/>
+                  <a:srgbClr val="7137A8"/>
                 </a:solidFill>
               </a:defRPr>
             </a:pPr>
             <a:r>
               <a:rPr sz="900" b="1">
                 <a:solidFill>
-                  <a:srgbClr val="147B84"/>
+                  <a:srgbClr val="7137A8"/>
                 </a:solidFill>
               </a:rPr>
               <a:t>DETERMINISTIC EXPLANATION</a:t>
@@ -3615,7 +3615,7 @@
           <p:cNvPr id="54" name="answer">
             <a:extLst xmlns:a="http://schemas.openxmlformats.org/drawingml/2006/main">
               <a:ext uri="{FF2B5EF4-FFF2-40B4-BE49-F238E27FC236}">
-                <a16:creationId xmlns:a16="http://schemas.microsoft.com/office/drawing/2014/main" id="{EF36E505-D1EA-4D41-AA0D-969448A2FDA6}"/>
+                <a16:creationId xmlns:a16="http://schemas.microsoft.com/office/drawing/2014/main" id="{BE2B3333-7854-4011-98C6-3F95931769CC}"/>
               </a:ext>
             </a:extLst>
           </p:cNvPr>
@@ -3639,7 +3639,7 @@
           </a:solidFill>
           <a:ln xmlns:a="http://schemas.openxmlformats.org/drawingml/2006/main" w="11430">
             <a:solidFill>
-              <a:srgbClr val="147B84"/>
+              <a:srgbClr val="7137A8"/>
             </a:solidFill>
             <a:prstDash val="solid"/>
           </a:ln>
@@ -3650,7 +3650,7 @@
           <p:cNvPr id="55" name="answer-lead">
             <a:extLst xmlns:a="http://schemas.openxmlformats.org/drawingml/2006/main">
               <a:ext uri="{FF2B5EF4-FFF2-40B4-BE49-F238E27FC236}">
-                <a16:creationId xmlns:a16="http://schemas.microsoft.com/office/drawing/2014/main" id="{14D7F157-5434-4110-B837-C0D4A041EE38}"/>
+                <a16:creationId xmlns:a16="http://schemas.microsoft.com/office/drawing/2014/main" id="{46414E18-D1D0-47B0-8425-6C1641A82865}"/>
               </a:ext>
             </a:extLst>
           </p:cNvPr>
@@ -3680,14 +3680,14 @@
             <a:pPr algn="l">
               <a:defRPr sz="1125" b="1">
                 <a:solidFill>
-                  <a:srgbClr val="17243B"/>
+                  <a:srgbClr val="102A56"/>
                 </a:solidFill>
               </a:defRPr>
             </a:pPr>
             <a:r>
               <a:rPr sz="1125" b="1">
                 <a:solidFill>
-                  <a:srgbClr val="17243B"/>
+                  <a:srgbClr val="102A56"/>
                 </a:solidFill>
               </a:rPr>
               <a:t>An EOB is the insurer’s record of how a claim was processed—not a bill.</a:t>
@@ -3700,7 +3700,7 @@
           <p:cNvPr id="56" name="number-0">
             <a:extLst xmlns:a="http://schemas.openxmlformats.org/drawingml/2006/main">
               <a:ext uri="{FF2B5EF4-FFF2-40B4-BE49-F238E27FC236}">
-                <a16:creationId xmlns:a16="http://schemas.microsoft.com/office/drawing/2014/main" id="{998CFA6E-62C9-4F8E-89BD-0F4BF3560467}"/>
+                <a16:creationId xmlns:a16="http://schemas.microsoft.com/office/drawing/2014/main" id="{2B303DC0-12AB-48DC-A673-64E715C47E39}"/>
               </a:ext>
             </a:extLst>
           </p:cNvPr>
@@ -3718,11 +3718,11 @@
             <a:avLst/>
           </a:prstGeom>
           <a:solidFill xmlns:a="http://schemas.openxmlformats.org/drawingml/2006/main">
-            <a:srgbClr val="E6F2F2"/>
+            <a:srgbClr val="F0E8F7"/>
           </a:solidFill>
           <a:ln xmlns:a="http://schemas.openxmlformats.org/drawingml/2006/main" w="9525">
             <a:solidFill>
-              <a:srgbClr val="147B84"/>
+              <a:srgbClr val="7137A8"/>
             </a:solidFill>
             <a:prstDash val="solid"/>
           </a:ln>
@@ -3734,14 +3734,14 @@
             <a:pPr algn="ctr">
               <a:defRPr sz="750" b="1">
                 <a:solidFill>
-                  <a:srgbClr val="147B84"/>
+                  <a:srgbClr val="7137A8"/>
                 </a:solidFill>
               </a:defRPr>
             </a:pPr>
             <a:r>
               <a:rPr sz="750" b="1">
                 <a:solidFill>
-                  <a:srgbClr val="147B84"/>
+                  <a:srgbClr val="7137A8"/>
                 </a:solidFill>
               </a:rPr>
               <a:t>1</a:t>
@@ -3754,7 +3754,7 @@
           <p:cNvPr id="57" name="answer-label-0">
             <a:extLst xmlns:a="http://schemas.openxmlformats.org/drawingml/2006/main">
               <a:ext uri="{FF2B5EF4-FFF2-40B4-BE49-F238E27FC236}">
-                <a16:creationId xmlns:a16="http://schemas.microsoft.com/office/drawing/2014/main" id="{4685BCD2-FD66-45A4-B348-D2AF1873F4E1}"/>
+                <a16:creationId xmlns:a16="http://schemas.microsoft.com/office/drawing/2014/main" id="{888E36E9-0568-48AF-B64C-557E3910AFC5}"/>
               </a:ext>
             </a:extLst>
           </p:cNvPr>
@@ -3784,14 +3784,14 @@
             <a:pPr algn="l">
               <a:defRPr sz="863" b="1">
                 <a:solidFill>
-                  <a:srgbClr val="172033"/>
+                  <a:srgbClr val="15213B"/>
                 </a:solidFill>
               </a:defRPr>
             </a:pPr>
             <a:r>
               <a:rPr sz="863" b="1">
                 <a:solidFill>
-                  <a:srgbClr val="172033"/>
+                  <a:srgbClr val="15213B"/>
                 </a:solidFill>
               </a:rPr>
               <a:t>Amount billed</a:t>
@@ -3804,7 +3804,7 @@
           <p:cNvPr id="58" name="answer-note-0">
             <a:extLst xmlns:a="http://schemas.openxmlformats.org/drawingml/2006/main">
               <a:ext uri="{FF2B5EF4-FFF2-40B4-BE49-F238E27FC236}">
-                <a16:creationId xmlns:a16="http://schemas.microsoft.com/office/drawing/2014/main" id="{57C5B928-FCD6-4E23-AC5B-4E4CDC6E8B9D}"/>
+                <a16:creationId xmlns:a16="http://schemas.microsoft.com/office/drawing/2014/main" id="{49B372DF-84DE-41FB-9AD5-F2119EC5E998}"/>
               </a:ext>
             </a:extLst>
           </p:cNvPr>
@@ -3834,14 +3834,14 @@
             <a:pPr algn="l">
               <a:defRPr sz="788" b="0">
                 <a:solidFill>
-                  <a:srgbClr val="667084"/>
+                  <a:srgbClr val="63708A"/>
                 </a:solidFill>
               </a:defRPr>
             </a:pPr>
             <a:r>
               <a:rPr sz="788" b="0">
                 <a:solidFill>
-                  <a:srgbClr val="667084"/>
+                  <a:srgbClr val="63708A"/>
                 </a:solidFill>
               </a:rPr>
               <a:t>provider submission</a:t>
@@ -3854,7 +3854,7 @@
           <p:cNvPr id="59" name="number-1">
             <a:extLst xmlns:a="http://schemas.openxmlformats.org/drawingml/2006/main">
               <a:ext uri="{FF2B5EF4-FFF2-40B4-BE49-F238E27FC236}">
-                <a16:creationId xmlns:a16="http://schemas.microsoft.com/office/drawing/2014/main" id="{1468ABBC-6677-4A10-B015-7EA814A578CA}"/>
+                <a16:creationId xmlns:a16="http://schemas.microsoft.com/office/drawing/2014/main" id="{14AE64D7-AE13-4186-8787-F896E0E0ECC8}"/>
               </a:ext>
             </a:extLst>
           </p:cNvPr>
@@ -3872,11 +3872,11 @@
             <a:avLst/>
           </a:prstGeom>
           <a:solidFill xmlns:a="http://schemas.openxmlformats.org/drawingml/2006/main">
-            <a:srgbClr val="E6F2F2"/>
+            <a:srgbClr val="F0E8F7"/>
           </a:solidFill>
           <a:ln xmlns:a="http://schemas.openxmlformats.org/drawingml/2006/main" w="9525">
             <a:solidFill>
-              <a:srgbClr val="147B84"/>
+              <a:srgbClr val="7137A8"/>
             </a:solidFill>
             <a:prstDash val="solid"/>
           </a:ln>
@@ -3888,14 +3888,14 @@
             <a:pPr algn="ctr">
               <a:defRPr sz="750" b="1">
                 <a:solidFill>
-                  <a:srgbClr val="147B84"/>
+                  <a:srgbClr val="7137A8"/>
                 </a:solidFill>
               </a:defRPr>
             </a:pPr>
             <a:r>
               <a:rPr sz="750" b="1">
                 <a:solidFill>
-                  <a:srgbClr val="147B84"/>
+                  <a:srgbClr val="7137A8"/>
                 </a:solidFill>
               </a:rPr>
               <a:t>2</a:t>
@@ -3908,7 +3908,7 @@
           <p:cNvPr id="60" name="answer-label-1">
             <a:extLst xmlns:a="http://schemas.openxmlformats.org/drawingml/2006/main">
               <a:ext uri="{FF2B5EF4-FFF2-40B4-BE49-F238E27FC236}">
-                <a16:creationId xmlns:a16="http://schemas.microsoft.com/office/drawing/2014/main" id="{40C7E8D2-9BFB-4BD7-9457-35CFF75988DF}"/>
+                <a16:creationId xmlns:a16="http://schemas.microsoft.com/office/drawing/2014/main" id="{9D36E3C1-5261-46A6-B084-55215BF691A3}"/>
               </a:ext>
             </a:extLst>
           </p:cNvPr>
@@ -3938,14 +3938,14 @@
             <a:pPr algn="l">
               <a:defRPr sz="863" b="1">
                 <a:solidFill>
-                  <a:srgbClr val="172033"/>
+                  <a:srgbClr val="15213B"/>
                 </a:solidFill>
               </a:defRPr>
             </a:pPr>
             <a:r>
               <a:rPr sz="863" b="1">
                 <a:solidFill>
-                  <a:srgbClr val="172033"/>
+                  <a:srgbClr val="15213B"/>
                 </a:solidFill>
               </a:rPr>
               <a:t>Allowed amount</a:t>
@@ -3958,7 +3958,7 @@
           <p:cNvPr id="61" name="answer-note-1">
             <a:extLst xmlns:a="http://schemas.openxmlformats.org/drawingml/2006/main">
               <a:ext uri="{FF2B5EF4-FFF2-40B4-BE49-F238E27FC236}">
-                <a16:creationId xmlns:a16="http://schemas.microsoft.com/office/drawing/2014/main" id="{56267E49-9ABB-4929-A9B8-FBCF907DEA48}"/>
+                <a16:creationId xmlns:a16="http://schemas.microsoft.com/office/drawing/2014/main" id="{3AD62342-AD32-499D-A1FC-99816550B88E}"/>
               </a:ext>
             </a:extLst>
           </p:cNvPr>
@@ -3988,14 +3988,14 @@
             <a:pPr algn="l">
               <a:defRPr sz="788" b="0">
                 <a:solidFill>
-                  <a:srgbClr val="667084"/>
+                  <a:srgbClr val="63708A"/>
                 </a:solidFill>
               </a:defRPr>
             </a:pPr>
             <a:r>
               <a:rPr sz="788" b="0">
                 <a:solidFill>
-                  <a:srgbClr val="667084"/>
+                  <a:srgbClr val="63708A"/>
                 </a:solidFill>
               </a:rPr>
               <a:t>negotiated or recognized price</a:t>
@@ -4008,7 +4008,7 @@
           <p:cNvPr id="62" name="number-2">
             <a:extLst xmlns:a="http://schemas.openxmlformats.org/drawingml/2006/main">
               <a:ext uri="{FF2B5EF4-FFF2-40B4-BE49-F238E27FC236}">
-                <a16:creationId xmlns:a16="http://schemas.microsoft.com/office/drawing/2014/main" id="{D7F5EAB1-E0B8-4858-A330-AE6779A2270C}"/>
+                <a16:creationId xmlns:a16="http://schemas.microsoft.com/office/drawing/2014/main" id="{5E10A86E-817B-4821-936E-023395A86A7E}"/>
               </a:ext>
             </a:extLst>
           </p:cNvPr>
@@ -4026,11 +4026,11 @@
             <a:avLst/>
           </a:prstGeom>
           <a:solidFill xmlns:a="http://schemas.openxmlformats.org/drawingml/2006/main">
-            <a:srgbClr val="E6F2F2"/>
+            <a:srgbClr val="F0E8F7"/>
           </a:solidFill>
           <a:ln xmlns:a="http://schemas.openxmlformats.org/drawingml/2006/main" w="9525">
             <a:solidFill>
-              <a:srgbClr val="147B84"/>
+              <a:srgbClr val="7137A8"/>
             </a:solidFill>
             <a:prstDash val="solid"/>
           </a:ln>
@@ -4042,14 +4042,14 @@
             <a:pPr algn="ctr">
               <a:defRPr sz="750" b="1">
                 <a:solidFill>
-                  <a:srgbClr val="147B84"/>
+                  <a:srgbClr val="7137A8"/>
                 </a:solidFill>
               </a:defRPr>
             </a:pPr>
             <a:r>
               <a:rPr sz="750" b="1">
                 <a:solidFill>
-                  <a:srgbClr val="147B84"/>
+                  <a:srgbClr val="7137A8"/>
                 </a:solidFill>
               </a:rPr>
               <a:t>3</a:t>
@@ -4062,7 +4062,7 @@
           <p:cNvPr id="63" name="answer-label-2">
             <a:extLst xmlns:a="http://schemas.openxmlformats.org/drawingml/2006/main">
               <a:ext uri="{FF2B5EF4-FFF2-40B4-BE49-F238E27FC236}">
-                <a16:creationId xmlns:a16="http://schemas.microsoft.com/office/drawing/2014/main" id="{962567DC-A5FE-4E34-8111-6B3910DEB889}"/>
+                <a16:creationId xmlns:a16="http://schemas.microsoft.com/office/drawing/2014/main" id="{8DA5CAA6-B068-47E8-A6CE-D851213D6C8E}"/>
               </a:ext>
             </a:extLst>
           </p:cNvPr>
@@ -4092,14 +4092,14 @@
             <a:pPr algn="l">
               <a:defRPr sz="863" b="1">
                 <a:solidFill>
-                  <a:srgbClr val="172033"/>
+                  <a:srgbClr val="15213B"/>
                 </a:solidFill>
               </a:defRPr>
             </a:pPr>
             <a:r>
               <a:rPr sz="863" b="1">
                 <a:solidFill>
-                  <a:srgbClr val="172033"/>
+                  <a:srgbClr val="15213B"/>
                 </a:solidFill>
               </a:rPr>
               <a:t>Plan paid</a:t>
@@ -4112,7 +4112,7 @@
           <p:cNvPr id="64" name="answer-note-2">
             <a:extLst xmlns:a="http://schemas.openxmlformats.org/drawingml/2006/main">
               <a:ext uri="{FF2B5EF4-FFF2-40B4-BE49-F238E27FC236}">
-                <a16:creationId xmlns:a16="http://schemas.microsoft.com/office/drawing/2014/main" id="{07F177F9-2F18-4EDD-8372-37BA6FC41D1F}"/>
+                <a16:creationId xmlns:a16="http://schemas.microsoft.com/office/drawing/2014/main" id="{1E2A851E-C4AE-44EB-B3FF-3FD91C4D992E}"/>
               </a:ext>
             </a:extLst>
           </p:cNvPr>
@@ -4142,14 +4142,14 @@
             <a:pPr algn="l">
               <a:defRPr sz="788" b="0">
                 <a:solidFill>
-                  <a:srgbClr val="667084"/>
+                  <a:srgbClr val="63708A"/>
                 </a:solidFill>
               </a:defRPr>
             </a:pPr>
             <a:r>
               <a:rPr sz="788" b="0">
                 <a:solidFill>
-                  <a:srgbClr val="667084"/>
+                  <a:srgbClr val="63708A"/>
                 </a:solidFill>
               </a:rPr>
               <a:t>insurance payment</a:t>
@@ -4162,7 +4162,7 @@
           <p:cNvPr id="65" name="number-3">
             <a:extLst xmlns:a="http://schemas.openxmlformats.org/drawingml/2006/main">
               <a:ext uri="{FF2B5EF4-FFF2-40B4-BE49-F238E27FC236}">
-                <a16:creationId xmlns:a16="http://schemas.microsoft.com/office/drawing/2014/main" id="{F1D20880-62F7-4B79-8830-6DF630632A2D}"/>
+                <a16:creationId xmlns:a16="http://schemas.microsoft.com/office/drawing/2014/main" id="{2B73B88F-BC95-4E16-B28A-CFF2A755BAFE}"/>
               </a:ext>
             </a:extLst>
           </p:cNvPr>
@@ -4180,11 +4180,11 @@
             <a:avLst/>
           </a:prstGeom>
           <a:solidFill xmlns:a="http://schemas.openxmlformats.org/drawingml/2006/main">
-            <a:srgbClr val="E6F2F2"/>
+            <a:srgbClr val="F0E8F7"/>
           </a:solidFill>
           <a:ln xmlns:a="http://schemas.openxmlformats.org/drawingml/2006/main" w="9525">
             <a:solidFill>
-              <a:srgbClr val="147B84"/>
+              <a:srgbClr val="7137A8"/>
             </a:solidFill>
             <a:prstDash val="solid"/>
           </a:ln>
@@ -4196,14 +4196,14 @@
             <a:pPr algn="ctr">
               <a:defRPr sz="750" b="1">
                 <a:solidFill>
-                  <a:srgbClr val="147B84"/>
+                  <a:srgbClr val="7137A8"/>
                 </a:solidFill>
               </a:defRPr>
             </a:pPr>
             <a:r>
               <a:rPr sz="750" b="1">
                 <a:solidFill>
-                  <a:srgbClr val="147B84"/>
+                  <a:srgbClr val="7137A8"/>
                 </a:solidFill>
               </a:rPr>
               <a:t>4</a:t>
@@ -4216,7 +4216,7 @@
           <p:cNvPr id="66" name="answer-label-3">
             <a:extLst xmlns:a="http://schemas.openxmlformats.org/drawingml/2006/main">
               <a:ext uri="{FF2B5EF4-FFF2-40B4-BE49-F238E27FC236}">
-                <a16:creationId xmlns:a16="http://schemas.microsoft.com/office/drawing/2014/main" id="{BD30D216-2EAC-40E4-BB6E-FA028594FAF2}"/>
+                <a16:creationId xmlns:a16="http://schemas.microsoft.com/office/drawing/2014/main" id="{49D32CBC-B473-4298-875D-3CDEE14E8819}"/>
               </a:ext>
             </a:extLst>
           </p:cNvPr>
@@ -4246,14 +4246,14 @@
             <a:pPr algn="l">
               <a:defRPr sz="863" b="1">
                 <a:solidFill>
-                  <a:srgbClr val="172033"/>
+                  <a:srgbClr val="15213B"/>
                 </a:solidFill>
               </a:defRPr>
             </a:pPr>
             <a:r>
               <a:rPr sz="863" b="1">
                 <a:solidFill>
-                  <a:srgbClr val="172033"/>
+                  <a:srgbClr val="15213B"/>
                 </a:solidFill>
               </a:rPr>
               <a:t>You may owe</a:t>
@@ -4266,7 +4266,7 @@
           <p:cNvPr id="67" name="answer-note-3">
             <a:extLst xmlns:a="http://schemas.openxmlformats.org/drawingml/2006/main">
               <a:ext uri="{FF2B5EF4-FFF2-40B4-BE49-F238E27FC236}">
-                <a16:creationId xmlns:a16="http://schemas.microsoft.com/office/drawing/2014/main" id="{9595A9E7-82F8-4D03-AE9D-518036CD9740}"/>
+                <a16:creationId xmlns:a16="http://schemas.microsoft.com/office/drawing/2014/main" id="{7FEFA518-680B-433F-AFE5-AA59BD194C44}"/>
               </a:ext>
             </a:extLst>
           </p:cNvPr>
@@ -4296,14 +4296,14 @@
             <a:pPr algn="l">
               <a:defRPr sz="788" b="0">
                 <a:solidFill>
-                  <a:srgbClr val="667084"/>
+                  <a:srgbClr val="63708A"/>
                 </a:solidFill>
               </a:defRPr>
             </a:pPr>
             <a:r>
               <a:rPr sz="788" b="0">
                 <a:solidFill>
-                  <a:srgbClr val="667084"/>
+                  <a:srgbClr val="63708A"/>
                 </a:solidFill>
               </a:rPr>
               <a:t>deductible, copay, coinsurance, or non-covered amount</a:t>
@@ -4316,7 +4316,7 @@
           <p:cNvPr id="68" name="sources-label">
             <a:extLst xmlns:a="http://schemas.openxmlformats.org/drawingml/2006/main">
               <a:ext uri="{FF2B5EF4-FFF2-40B4-BE49-F238E27FC236}">
-                <a16:creationId xmlns:a16="http://schemas.microsoft.com/office/drawing/2014/main" id="{F62EBC25-3B19-434A-B37B-4CB76E92A4BE}"/>
+                <a16:creationId xmlns:a16="http://schemas.microsoft.com/office/drawing/2014/main" id="{BB065361-152A-47DF-B3CF-747B3DB73A3D}"/>
               </a:ext>
             </a:extLst>
           </p:cNvPr>
@@ -4346,14 +4346,14 @@
             <a:pPr algn="l">
               <a:defRPr sz="900" b="1">
                 <a:solidFill>
-                  <a:srgbClr val="295AC8"/>
+                  <a:srgbClr val="165DFF"/>
                 </a:solidFill>
               </a:defRPr>
             </a:pPr>
             <a:r>
               <a:rPr sz="900" b="1">
                 <a:solidFill>
-                  <a:srgbClr val="295AC8"/>
+                  <a:srgbClr val="165DFF"/>
                 </a:solidFill>
               </a:rPr>
               <a:t>PUBLIC GUIDANCE SHOWN WITH THE ANSWER</a:t>
@@ -4366,7 +4366,7 @@
           <p:cNvPr id="69" name="source-tag-0">
             <a:extLst xmlns:a="http://schemas.openxmlformats.org/drawingml/2006/main">
               <a:ext uri="{FF2B5EF4-FFF2-40B4-BE49-F238E27FC236}">
-                <a16:creationId xmlns:a16="http://schemas.microsoft.com/office/drawing/2014/main" id="{32DFBAC2-85AE-4F55-B31E-D6DC047A2219}"/>
+                <a16:creationId xmlns:a16="http://schemas.microsoft.com/office/drawing/2014/main" id="{CB0D865F-4D19-451B-B8AD-B86BC23305D8}"/>
               </a:ext>
             </a:extLst>
           </p:cNvPr>
@@ -4396,14 +4396,14 @@
             <a:pPr algn="l">
               <a:defRPr sz="788" b="1">
                 <a:solidFill>
-                  <a:srgbClr val="295AC8"/>
+                  <a:srgbClr val="165DFF"/>
                 </a:solidFill>
               </a:defRPr>
             </a:pPr>
             <a:r>
               <a:rPr sz="788" b="1">
                 <a:solidFill>
-                  <a:srgbClr val="295AC8"/>
+                  <a:srgbClr val="165DFF"/>
                 </a:solidFill>
               </a:rPr>
               <a:t>[1]</a:t>
@@ -4416,7 +4416,7 @@
           <p:cNvPr id="70" name="source-publisher-0">
             <a:extLst xmlns:a="http://schemas.openxmlformats.org/drawingml/2006/main">
               <a:ext uri="{FF2B5EF4-FFF2-40B4-BE49-F238E27FC236}">
-                <a16:creationId xmlns:a16="http://schemas.microsoft.com/office/drawing/2014/main" id="{77C5EACF-DBFF-43A2-A576-B794A1B5D340}"/>
+                <a16:creationId xmlns:a16="http://schemas.microsoft.com/office/drawing/2014/main" id="{CF94DD8C-730F-42F0-8E2F-AD3B401EF04F}"/>
               </a:ext>
             </a:extLst>
           </p:cNvPr>
@@ -4446,14 +4446,14 @@
             <a:pPr algn="l">
               <a:defRPr sz="863" b="1">
                 <a:solidFill>
-                  <a:srgbClr val="172033"/>
+                  <a:srgbClr val="15213B"/>
                 </a:solidFill>
               </a:defRPr>
             </a:pPr>
             <a:r>
               <a:rPr sz="863" b="1">
                 <a:solidFill>
-                  <a:srgbClr val="172033"/>
+                  <a:srgbClr val="15213B"/>
                 </a:solidFill>
               </a:rPr>
               <a:t>HealthCare.gov</a:t>
@@ -4466,7 +4466,7 @@
           <p:cNvPr id="71" name="source-topic-0">
             <a:extLst xmlns:a="http://schemas.openxmlformats.org/drawingml/2006/main">
               <a:ext uri="{FF2B5EF4-FFF2-40B4-BE49-F238E27FC236}">
-                <a16:creationId xmlns:a16="http://schemas.microsoft.com/office/drawing/2014/main" id="{AE0FC075-0924-4BE8-BC4B-590EAB223374}"/>
+                <a16:creationId xmlns:a16="http://schemas.microsoft.com/office/drawing/2014/main" id="{86454546-97D6-492D-98DF-8903DEE213A8}"/>
               </a:ext>
             </a:extLst>
           </p:cNvPr>
@@ -4496,14 +4496,14 @@
             <a:pPr algn="l">
               <a:defRPr sz="788" b="0">
                 <a:solidFill>
-                  <a:srgbClr val="667084"/>
+                  <a:srgbClr val="63708A"/>
                 </a:solidFill>
               </a:defRPr>
             </a:pPr>
             <a:r>
               <a:rPr sz="788" b="0">
                 <a:solidFill>
-                  <a:srgbClr val="667084"/>
+                  <a:srgbClr val="63708A"/>
                 </a:solidFill>
               </a:rPr>
               <a:t>understanding an insurance bill</a:t>
@@ -4516,7 +4516,7 @@
           <p:cNvPr id="72" name="source-rule-0">
             <a:extLst xmlns:a="http://schemas.openxmlformats.org/drawingml/2006/main">
               <a:ext uri="{FF2B5EF4-FFF2-40B4-BE49-F238E27FC236}">
-                <a16:creationId xmlns:a16="http://schemas.microsoft.com/office/drawing/2014/main" id="{01535243-A269-4D67-98E4-0D7044C773E8}"/>
+                <a16:creationId xmlns:a16="http://schemas.microsoft.com/office/drawing/2014/main" id="{0723E8A7-DA70-4AD8-9590-DF7CFFDE5E2A}"/>
               </a:ext>
             </a:extLst>
           </p:cNvPr>
@@ -4536,7 +4536,7 @@
           <a:noFill xmlns:a="http://schemas.openxmlformats.org/drawingml/2006/main"/>
           <a:ln xmlns:a="http://schemas.openxmlformats.org/drawingml/2006/main" w="7620">
             <a:solidFill>
-              <a:srgbClr val="C9D0D8"/>
+              <a:srgbClr val="BCC9DA"/>
             </a:solidFill>
             <a:prstDash val="solid"/>
           </a:ln>
@@ -4547,7 +4547,7 @@
           <p:cNvPr id="73" name="source-tag-1">
             <a:extLst xmlns:a="http://schemas.openxmlformats.org/drawingml/2006/main">
               <a:ext uri="{FF2B5EF4-FFF2-40B4-BE49-F238E27FC236}">
-                <a16:creationId xmlns:a16="http://schemas.microsoft.com/office/drawing/2014/main" id="{5A6E6248-51D4-438E-B904-FB2B37FEBF60}"/>
+                <a16:creationId xmlns:a16="http://schemas.microsoft.com/office/drawing/2014/main" id="{7DAD3522-F8E6-401F-B654-1A8CE840886A}"/>
               </a:ext>
             </a:extLst>
           </p:cNvPr>
@@ -4577,14 +4577,14 @@
             <a:pPr algn="l">
               <a:defRPr sz="788" b="1">
                 <a:solidFill>
-                  <a:srgbClr val="295AC8"/>
+                  <a:srgbClr val="165DFF"/>
                 </a:solidFill>
               </a:defRPr>
             </a:pPr>
             <a:r>
               <a:rPr sz="788" b="1">
                 <a:solidFill>
-                  <a:srgbClr val="295AC8"/>
+                  <a:srgbClr val="165DFF"/>
                 </a:solidFill>
               </a:rPr>
               <a:t>[2]</a:t>
@@ -4597,7 +4597,7 @@
           <p:cNvPr id="74" name="source-publisher-1">
             <a:extLst xmlns:a="http://schemas.openxmlformats.org/drawingml/2006/main">
               <a:ext uri="{FF2B5EF4-FFF2-40B4-BE49-F238E27FC236}">
-                <a16:creationId xmlns:a16="http://schemas.microsoft.com/office/drawing/2014/main" id="{EEC163FC-BE28-41BA-B6BD-FA85A1F1F1E9}"/>
+                <a16:creationId xmlns:a16="http://schemas.microsoft.com/office/drawing/2014/main" id="{F58EA623-C822-49D5-8B4E-F3DEE7F5DF09}"/>
               </a:ext>
             </a:extLst>
           </p:cNvPr>
@@ -4627,14 +4627,14 @@
             <a:pPr algn="l">
               <a:defRPr sz="863" b="1">
                 <a:solidFill>
-                  <a:srgbClr val="172033"/>
+                  <a:srgbClr val="15213B"/>
                 </a:solidFill>
               </a:defRPr>
             </a:pPr>
             <a:r>
               <a:rPr sz="863" b="1">
                 <a:solidFill>
-                  <a:srgbClr val="172033"/>
+                  <a:srgbClr val="15213B"/>
                 </a:solidFill>
               </a:rPr>
               <a:t>CMS</a:t>
@@ -4647,7 +4647,7 @@
           <p:cNvPr id="75" name="source-topic-1">
             <a:extLst xmlns:a="http://schemas.openxmlformats.org/drawingml/2006/main">
               <a:ext uri="{FF2B5EF4-FFF2-40B4-BE49-F238E27FC236}">
-                <a16:creationId xmlns:a16="http://schemas.microsoft.com/office/drawing/2014/main" id="{2FCCBE6C-B739-4289-AF90-78FFB4D1E20E}"/>
+                <a16:creationId xmlns:a16="http://schemas.microsoft.com/office/drawing/2014/main" id="{1AA36764-43A9-4901-B5E9-F7F8121D7764}"/>
               </a:ext>
             </a:extLst>
           </p:cNvPr>
@@ -4677,14 +4677,14 @@
             <a:pPr algn="l">
               <a:defRPr sz="788" b="0">
                 <a:solidFill>
-                  <a:srgbClr val="667084"/>
+                  <a:srgbClr val="63708A"/>
                 </a:solidFill>
               </a:defRPr>
             </a:pPr>
             <a:r>
               <a:rPr sz="788" b="0">
                 <a:solidFill>
-                  <a:srgbClr val="667084"/>
+                  <a:srgbClr val="63708A"/>
                 </a:solidFill>
               </a:rPr>
               <a:t>No Surprises Act consumer rights</a:t>
@@ -4697,7 +4697,7 @@
           <p:cNvPr id="76" name="source-rule-1">
             <a:extLst xmlns:a="http://schemas.openxmlformats.org/drawingml/2006/main">
               <a:ext uri="{FF2B5EF4-FFF2-40B4-BE49-F238E27FC236}">
-                <a16:creationId xmlns:a16="http://schemas.microsoft.com/office/drawing/2014/main" id="{3CF24331-BACB-49DF-A148-9209AD7B2089}"/>
+                <a16:creationId xmlns:a16="http://schemas.microsoft.com/office/drawing/2014/main" id="{EC3C0B19-9955-4486-8B57-F8D45F60E906}"/>
               </a:ext>
             </a:extLst>
           </p:cNvPr>
@@ -4717,7 +4717,7 @@
           <a:noFill xmlns:a="http://schemas.openxmlformats.org/drawingml/2006/main"/>
           <a:ln xmlns:a="http://schemas.openxmlformats.org/drawingml/2006/main" w="7620">
             <a:solidFill>
-              <a:srgbClr val="C9D0D8"/>
+              <a:srgbClr val="BCC9DA"/>
             </a:solidFill>
             <a:prstDash val="solid"/>
           </a:ln>
@@ -4728,7 +4728,7 @@
           <p:cNvPr id="77" name="source-tag-2">
             <a:extLst xmlns:a="http://schemas.openxmlformats.org/drawingml/2006/main">
               <a:ext uri="{FF2B5EF4-FFF2-40B4-BE49-F238E27FC236}">
-                <a16:creationId xmlns:a16="http://schemas.microsoft.com/office/drawing/2014/main" id="{2B60B098-5D93-409E-AD98-7D8A3E44F395}"/>
+                <a16:creationId xmlns:a16="http://schemas.microsoft.com/office/drawing/2014/main" id="{3E528BF2-0066-428B-A2D7-C3A7D61503FB}"/>
               </a:ext>
             </a:extLst>
           </p:cNvPr>
@@ -4758,14 +4758,14 @@
             <a:pPr algn="l">
               <a:defRPr sz="788" b="1">
                 <a:solidFill>
-                  <a:srgbClr val="295AC8"/>
+                  <a:srgbClr val="165DFF"/>
                 </a:solidFill>
               </a:defRPr>
             </a:pPr>
             <a:r>
               <a:rPr sz="788" b="1">
                 <a:solidFill>
-                  <a:srgbClr val="295AC8"/>
+                  <a:srgbClr val="165DFF"/>
                 </a:solidFill>
               </a:rPr>
               <a:t>[3]</a:t>
@@ -4778,7 +4778,7 @@
           <p:cNvPr id="78" name="source-publisher-2">
             <a:extLst xmlns:a="http://schemas.openxmlformats.org/drawingml/2006/main">
               <a:ext uri="{FF2B5EF4-FFF2-40B4-BE49-F238E27FC236}">
-                <a16:creationId xmlns:a16="http://schemas.microsoft.com/office/drawing/2014/main" id="{C7FCFDDE-B55C-4541-BC7A-5274E5015BAB}"/>
+                <a16:creationId xmlns:a16="http://schemas.microsoft.com/office/drawing/2014/main" id="{33FDF205-85C6-4D83-9FC2-F43B2E983708}"/>
               </a:ext>
             </a:extLst>
           </p:cNvPr>
@@ -4808,14 +4808,14 @@
             <a:pPr algn="l">
               <a:defRPr sz="863" b="1">
                 <a:solidFill>
-                  <a:srgbClr val="172033"/>
+                  <a:srgbClr val="15213B"/>
                 </a:solidFill>
               </a:defRPr>
             </a:pPr>
             <a:r>
               <a:rPr sz="863" b="1">
                 <a:solidFill>
-                  <a:srgbClr val="172033"/>
+                  <a:srgbClr val="15213B"/>
                 </a:solidFill>
               </a:rPr>
               <a:t>CFPB</a:t>
@@ -4828,7 +4828,7 @@
           <p:cNvPr id="79" name="source-topic-2">
             <a:extLst xmlns:a="http://schemas.openxmlformats.org/drawingml/2006/main">
               <a:ext uri="{FF2B5EF4-FFF2-40B4-BE49-F238E27FC236}">
-                <a16:creationId xmlns:a16="http://schemas.microsoft.com/office/drawing/2014/main" id="{0C8CD354-FBAD-4732-9D67-BDD1C0A537BE}"/>
+                <a16:creationId xmlns:a16="http://schemas.microsoft.com/office/drawing/2014/main" id="{70090882-0904-400B-8B3A-0D62CD78365A}"/>
               </a:ext>
             </a:extLst>
           </p:cNvPr>
@@ -4858,14 +4858,14 @@
             <a:pPr algn="l">
               <a:defRPr sz="788" b="0">
                 <a:solidFill>
-                  <a:srgbClr val="667084"/>
+                  <a:srgbClr val="63708A"/>
                 </a:solidFill>
               </a:defRPr>
             </a:pPr>
             <a:r>
               <a:rPr sz="788" b="0">
                 <a:solidFill>
-                  <a:srgbClr val="667084"/>
+                  <a:srgbClr val="63708A"/>
                 </a:solidFill>
               </a:rPr>
               <a:t>disputing a medical bill</a:t>
@@ -4878,7 +4878,7 @@
           <p:cNvPr id="80" name="source-rule-2">
             <a:extLst xmlns:a="http://schemas.openxmlformats.org/drawingml/2006/main">
               <a:ext uri="{FF2B5EF4-FFF2-40B4-BE49-F238E27FC236}">
-                <a16:creationId xmlns:a16="http://schemas.microsoft.com/office/drawing/2014/main" id="{B9274081-A114-4C8E-B9D2-8387F96B0A09}"/>
+                <a16:creationId xmlns:a16="http://schemas.microsoft.com/office/drawing/2014/main" id="{A5B53757-7AF3-4795-B1DF-9DF1AC1F1B82}"/>
               </a:ext>
             </a:extLst>
           </p:cNvPr>
@@ -4898,7 +4898,7 @@
           <a:noFill xmlns:a="http://schemas.openxmlformats.org/drawingml/2006/main"/>
           <a:ln xmlns:a="http://schemas.openxmlformats.org/drawingml/2006/main" w="7620">
             <a:solidFill>
-              <a:srgbClr val="C9D0D8"/>
+              <a:srgbClr val="BCC9DA"/>
             </a:solidFill>
             <a:prstDash val="solid"/>
           </a:ln>
@@ -4909,7 +4909,7 @@
           <p:cNvPr id="81" name="live-contract">
             <a:extLst xmlns:a="http://schemas.openxmlformats.org/drawingml/2006/main">
               <a:ext uri="{FF2B5EF4-FFF2-40B4-BE49-F238E27FC236}">
-                <a16:creationId xmlns:a16="http://schemas.microsoft.com/office/drawing/2014/main" id="{FD2863FA-14E2-4468-9435-F700A04EFA88}"/>
+                <a16:creationId xmlns:a16="http://schemas.microsoft.com/office/drawing/2014/main" id="{884ED37D-181B-4839-AF06-99B9849D6C8B}"/>
               </a:ext>
             </a:extLst>
           </p:cNvPr>
@@ -4929,11 +4929,11 @@
             </a:avLst>
           </a:prstGeom>
           <a:solidFill xmlns:a="http://schemas.openxmlformats.org/drawingml/2006/main">
-            <a:srgbClr val="E6F2F2"/>
+            <a:srgbClr val="F0E8F7"/>
           </a:solidFill>
           <a:ln xmlns:a="http://schemas.openxmlformats.org/drawingml/2006/main" w="9525">
             <a:solidFill>
-              <a:srgbClr val="147B84"/>
+              <a:srgbClr val="7137A8"/>
             </a:solidFill>
             <a:prstDash val="solid"/>
           </a:ln>
@@ -4944,7 +4944,7 @@
           <p:cNvPr id="82" name="live-title">
             <a:extLst xmlns:a="http://schemas.openxmlformats.org/drawingml/2006/main">
               <a:ext uri="{FF2B5EF4-FFF2-40B4-BE49-F238E27FC236}">
-                <a16:creationId xmlns:a16="http://schemas.microsoft.com/office/drawing/2014/main" id="{4E84760D-5871-4370-9E5F-DEBA0B7BD3DF}"/>
+                <a16:creationId xmlns:a16="http://schemas.microsoft.com/office/drawing/2014/main" id="{08416717-D412-4C1F-AF85-FC2F43EF422F}"/>
               </a:ext>
             </a:extLst>
           </p:cNvPr>
@@ -4974,14 +4974,14 @@
             <a:pPr algn="l">
               <a:defRPr sz="750" b="1">
                 <a:solidFill>
-                  <a:srgbClr val="147B84"/>
+                  <a:srgbClr val="7137A8"/>
                 </a:solidFill>
               </a:defRPr>
             </a:pPr>
             <a:r>
               <a:rPr sz="750" b="1">
                 <a:solidFill>
-                  <a:srgbClr val="147B84"/>
+                  <a:srgbClr val="7137A8"/>
                 </a:solidFill>
               </a:rPr>
               <a:t>LIVE MODE</a:t>
@@ -4994,7 +4994,7 @@
           <p:cNvPr id="83" name="live-copy">
             <a:extLst xmlns:a="http://schemas.openxmlformats.org/drawingml/2006/main">
               <a:ext uri="{FF2B5EF4-FFF2-40B4-BE49-F238E27FC236}">
-                <a16:creationId xmlns:a16="http://schemas.microsoft.com/office/drawing/2014/main" id="{93A3A8F6-ACC6-494D-B241-609EA5718E3B}"/>
+                <a16:creationId xmlns:a16="http://schemas.microsoft.com/office/drawing/2014/main" id="{6EC30ECA-A578-4DA4-A48D-027382FD56EE}"/>
               </a:ext>
             </a:extLst>
           </p:cNvPr>
@@ -5024,14 +5024,14 @@
             <a:pPr algn="l">
               <a:defRPr sz="788" b="1">
                 <a:solidFill>
-                  <a:srgbClr val="172033"/>
+                  <a:srgbClr val="15213B"/>
                 </a:solidFill>
               </a:defRPr>
             </a:pPr>
             <a:r>
               <a:rPr sz="788" b="1">
                 <a:solidFill>
-                  <a:srgbClr val="172033"/>
+                  <a:srgbClr val="15213B"/>
                 </a:solidFill>
               </a:rPr>
               <a:t>retrieve ≤6  →  usable source text  →  context-only answer</a:t>
@@ -5044,7 +5044,7 @@
           <p:cNvPr id="84" name="live-refusal">
             <a:extLst xmlns:a="http://schemas.openxmlformats.org/drawingml/2006/main">
               <a:ext uri="{FF2B5EF4-FFF2-40B4-BE49-F238E27FC236}">
-                <a16:creationId xmlns:a16="http://schemas.microsoft.com/office/drawing/2014/main" id="{F2631693-8FD9-4A3E-973B-11C19CFB1358}"/>
+                <a16:creationId xmlns:a16="http://schemas.microsoft.com/office/drawing/2014/main" id="{ADD7590B-2F15-4353-A324-1333C1634422}"/>
               </a:ext>
             </a:extLst>
           </p:cNvPr>
@@ -5074,14 +5074,14 @@
             <a:pPr algn="l">
               <a:defRPr sz="788" b="1">
                 <a:solidFill>
-                  <a:srgbClr val="B5453A"/>
+                  <a:srgbClr val="C64B38"/>
                 </a:solidFill>
               </a:defRPr>
             </a:pPr>
             <a:r>
               <a:rPr sz="788" b="1">
                 <a:solidFill>
-                  <a:srgbClr val="B5453A"/>
+                  <a:srgbClr val="C64B38"/>
                 </a:solidFill>
               </a:rPr>
               <a:t>no usable text  →  422 response before generation</a:t>
@@ -5094,7 +5094,7 @@
           <p:cNvPr id="85" name="footer-rule">
             <a:extLst xmlns:a="http://schemas.openxmlformats.org/drawingml/2006/main">
               <a:ext uri="{FF2B5EF4-FFF2-40B4-BE49-F238E27FC236}">
-                <a16:creationId xmlns:a16="http://schemas.microsoft.com/office/drawing/2014/main" id="{0695A020-59AA-4EA5-A5CE-283A4D0814A0}"/>
+                <a16:creationId xmlns:a16="http://schemas.microsoft.com/office/drawing/2014/main" id="{790DDE96-D6E1-4BFE-A662-4CCA79BB8677}"/>
               </a:ext>
             </a:extLst>
           </p:cNvPr>
@@ -5114,7 +5114,7 @@
           <a:noFill xmlns:a="http://schemas.openxmlformats.org/drawingml/2006/main"/>
           <a:ln xmlns:a="http://schemas.openxmlformats.org/drawingml/2006/main" w="13335">
             <a:solidFill>
-              <a:srgbClr val="172033"/>
+              <a:srgbClr val="15213B"/>
             </a:solidFill>
             <a:prstDash val="solid"/>
           </a:ln>
@@ -5125,7 +5125,7 @@
           <p:cNvPr id="86" name="boundary">
             <a:extLst xmlns:a="http://schemas.openxmlformats.org/drawingml/2006/main">
               <a:ext uri="{FF2B5EF4-FFF2-40B4-BE49-F238E27FC236}">
-                <a16:creationId xmlns:a16="http://schemas.microsoft.com/office/drawing/2014/main" id="{004D09EB-FC3D-401D-8AE8-49393908D781}"/>
+                <a16:creationId xmlns:a16="http://schemas.microsoft.com/office/drawing/2014/main" id="{9C083845-4960-43D9-9D87-1FF3B830D8D8}"/>
               </a:ext>
             </a:extLst>
           </p:cNvPr>
@@ -5155,14 +5155,14 @@
             <a:pPr algn="l">
               <a:defRPr sz="825" b="1">
                 <a:solidFill>
-                  <a:srgbClr val="B5453A"/>
+                  <a:srgbClr val="C64B38"/>
                 </a:solidFill>
               </a:defRPr>
             </a:pPr>
             <a:r>
               <a:rPr sz="825" b="1">
                 <a:solidFill>
-                  <a:srgbClr val="B5453A"/>
+                  <a:srgbClr val="C64B38"/>
                 </a:solidFill>
               </a:rPr>
               <a:t>EVIDENCE BOUNDARY</a:t>
@@ -5175,7 +5175,7 @@
           <p:cNvPr id="87" name="boundary-copy">
             <a:extLst xmlns:a="http://schemas.openxmlformats.org/drawingml/2006/main">
               <a:ext uri="{FF2B5EF4-FFF2-40B4-BE49-F238E27FC236}">
-                <a16:creationId xmlns:a16="http://schemas.microsoft.com/office/drawing/2014/main" id="{85F1DDC5-B380-4BFD-89BB-DA7FE18BE2E8}"/>
+                <a16:creationId xmlns:a16="http://schemas.microsoft.com/office/drawing/2014/main" id="{B3E94006-1867-4A3F-AF5D-A719475E3005}"/>
               </a:ext>
             </a:extLst>
           </p:cNvPr>
@@ -5205,14 +5205,14 @@
             <a:pPr algn="l">
               <a:defRPr sz="938" b="0">
                 <a:solidFill>
-                  <a:srgbClr val="172033"/>
+                  <a:srgbClr val="15213B"/>
                 </a:solidFill>
               </a:defRPr>
             </a:pPr>
             <a:r>
               <a:rPr sz="938" b="0">
                 <a:solidFill>
-                  <a:srgbClr val="172033"/>
+                  <a:srgbClr val="15213B"/>
                 </a:solidFill>
               </a:rPr>
               <a:t>Fixture answer and sources are deterministic. No coverage, correctness, compliance, retrieval-quality, or financial-outcome claim.</a:t>
@@ -5225,7 +5225,7 @@
           <p:cNvPr id="88" name="sources">
             <a:extLst xmlns:a="http://schemas.openxmlformats.org/drawingml/2006/main">
               <a:ext uri="{FF2B5EF4-FFF2-40B4-BE49-F238E27FC236}">
-                <a16:creationId xmlns:a16="http://schemas.microsoft.com/office/drawing/2014/main" id="{C0EF042A-9CDC-40C0-9F06-03C952348F72}"/>
+                <a16:creationId xmlns:a16="http://schemas.microsoft.com/office/drawing/2014/main" id="{FB510EE3-30C0-4BA9-9C3F-E5E043FE8C3F}"/>
               </a:ext>
             </a:extLst>
           </p:cNvPr>
@@ -5255,14 +5255,14 @@
             <a:pPr algn="ctr">
               <a:defRPr sz="713" b="0">
                 <a:solidFill>
-                  <a:srgbClr val="667084"/>
+                  <a:srgbClr val="63708A"/>
                 </a:solidFill>
               </a:defRPr>
             </a:pPr>
             <a:r>
               <a:rPr sz="713" b="0">
                 <a:solidFill>
-                  <a:srgbClr val="667084"/>
+                  <a:srgbClr val="63708A"/>
                 </a:solidFill>
               </a:rPr>
               <a:t>Sources: app/page.tsx · app/data/demo.ts · app/lib/chat.ts · app/api/chat/route.ts</a:t>
@@ -5273,7 +5273,7 @@
     </p:spTree>
     <p:extLst>
       <p:ext uri="{BB962C8B-B14F-4D97-AF65-F5344CB8AC3E}">
-        <p14:creationId xmlns:p14="http://schemas.microsoft.com/office/powerpoint/2010/main" val="438282160"/>
+        <p14:creationId xmlns:p14="http://schemas.microsoft.com/office/powerpoint/2010/main" val="1323078026"/>
       </p:ext>
     </p:extLst>
   </p:cSld>

</xml_diff>

<commit_message>
Align architecture figure with the product theme
</commit_message>
<xml_diff>
--- a/docs/figures/clearbill-evidence-path/editable/clearbill-evidence-path.pptx
+++ b/docs/figures/clearbill-evidence-path/editable/clearbill-evidence-path.pptx
@@ -2,13 +2,13 @@
 <file path=ppt/presentation.xml><?xml version="1.0" encoding="utf-8"?>
 <p:presentation xmlns:p="http://schemas.openxmlformats.org/presentationml/2006/main">
   <p:sldMasterIdLst>
-    <p:sldMasterId xmlns:r="http://schemas.openxmlformats.org/officeDocument/2006/relationships" id="2147483648" r:id="R6d4d202a6e4a426e"/>
+    <p:sldMasterId xmlns:r="http://schemas.openxmlformats.org/officeDocument/2006/relationships" id="2147483648" r:id="R525e4c50e99a42d4"/>
   </p:sldMasterIdLst>
   <p:notesMasterIdLst>
-    <p:notesMasterId xmlns:r="http://schemas.openxmlformats.org/officeDocument/2006/relationships" r:id="R86ed7fd047a941ac"/>
+    <p:notesMasterId xmlns:r="http://schemas.openxmlformats.org/officeDocument/2006/relationships" r:id="R763a299058a3481f"/>
   </p:notesMasterIdLst>
   <p:sldIdLst>
-    <p:sldId xmlns:r="http://schemas.openxmlformats.org/officeDocument/2006/relationships" id="256" r:id="R5a5eca8f255b4b01"/>
+    <p:sldId xmlns:r="http://schemas.openxmlformats.org/officeDocument/2006/relationships" id="256" r:id="Rbea5f6fc9c0c4edc"/>
   </p:sldIdLst>
   <p:sldSz cx="12192000" cy="6858000"/>
   <p:notesSz cx="6858000" cy="9144000"/>
@@ -601,7 +601,7 @@
   </p:cSld>
   <p:clrMap bg1="lt1" tx1="dk1" bg2="lt2" tx2="dk2" accent1="accent1" accent2="accent2" accent3="accent3" accent4="accent4" accent5="accent5" accent6="accent6" hlink="hlink" folHlink="folHlink"/>
   <p:sldLayoutIdLst>
-    <p:sldLayoutId xmlns:r="http://schemas.openxmlformats.org/officeDocument/2006/relationships" id="2147483649" r:id="Rff6f979ecaea4c84"/>
+    <p:sldLayoutId xmlns:r="http://schemas.openxmlformats.org/officeDocument/2006/relationships" id="2147483649" r:id="Rb7c72c4b7fb64177"/>
   </p:sldLayoutIdLst>
   <p:txStyles>
     <p:titleStyle>
@@ -1134,7 +1134,7 @@
     <p:bg>
       <p:bgPr>
         <a:solidFill xmlns:a="http://schemas.openxmlformats.org/drawingml/2006/main">
-          <a:srgbClr val="F7FAFC"/>
+          <a:srgbClr val="FFFDF8"/>
         </a:solidFill>
       </p:bgPr>
     </p:bg>
@@ -1152,7 +1152,7 @@
           <p:cNvPr id="84" name="title">
             <a:extLst xmlns:a="http://schemas.openxmlformats.org/drawingml/2006/main">
               <a:ext uri="{FF2B5EF4-FFF2-40B4-BE49-F238E27FC236}">
-                <a16:creationId xmlns:a16="http://schemas.microsoft.com/office/drawing/2014/main" id="{2432F6A2-8A26-480C-9B79-A0E3EE4C0EC6}"/>
+                <a16:creationId xmlns:a16="http://schemas.microsoft.com/office/drawing/2014/main" id="{7EE3C346-8437-40E8-B17B-21F7B871EFDB}"/>
               </a:ext>
             </a:extLst>
           </p:cNvPr>
@@ -1182,14 +1182,14 @@
             <a:pPr algn="l">
               <a:defRPr sz="2175" b="1">
                 <a:solidFill>
-                  <a:srgbClr val="15365F"/>
+                  <a:srgbClr val="172033"/>
                 </a:solidFill>
               </a:defRPr>
             </a:pPr>
             <a:r>
               <a:rPr sz="2175" b="1">
                 <a:solidFill>
-                  <a:srgbClr val="15365F"/>
+                  <a:srgbClr val="172033"/>
                 </a:solidFill>
               </a:rPr>
               <a:t>ClearBill has one shared evidence plane</a:t>
@@ -1202,7 +1202,7 @@
           <p:cNvPr id="2" name="subtitle">
             <a:extLst xmlns:a="http://schemas.openxmlformats.org/drawingml/2006/main">
               <a:ext uri="{FF2B5EF4-FFF2-40B4-BE49-F238E27FC236}">
-                <a16:creationId xmlns:a16="http://schemas.microsoft.com/office/drawing/2014/main" id="{4C43002D-4A45-470A-BDBD-9A58CAA292A3}"/>
+                <a16:creationId xmlns:a16="http://schemas.microsoft.com/office/drawing/2014/main" id="{9C52249E-99C1-40D7-9C71-152334634C19}"/>
               </a:ext>
             </a:extLst>
           </p:cNvPr>
@@ -1232,14 +1232,14 @@
             <a:pPr algn="l">
               <a:defRPr sz="1088" b="0">
                 <a:solidFill>
-                  <a:srgbClr val="64748B"/>
+                  <a:srgbClr val="667085"/>
                 </a:solidFill>
               </a:defRPr>
             </a:pPr>
             <a:r>
               <a:rPr sz="1088" b="0">
                 <a:solidFill>
-                  <a:srgbClr val="64748B"/>
+                  <a:srgbClr val="667085"/>
                 </a:solidFill>
               </a:rPr>
               <a:t>Public guidance enters from the corpus path; questions leave through a guarded answer path.</a:t>
@@ -1252,7 +1252,7 @@
           <p:cNvPr id="3" name="route">
             <a:extLst xmlns:a="http://schemas.openxmlformats.org/drawingml/2006/main">
               <a:ext uri="{FF2B5EF4-FFF2-40B4-BE49-F238E27FC236}">
-                <a16:creationId xmlns:a16="http://schemas.microsoft.com/office/drawing/2014/main" id="{274EAC72-70B4-4531-B148-B36C56F73F39}"/>
+                <a16:creationId xmlns:a16="http://schemas.microsoft.com/office/drawing/2014/main" id="{C4FE0E0D-1FCF-4849-89F5-7FE373FFE6A3}"/>
               </a:ext>
             </a:extLst>
           </p:cNvPr>
@@ -1282,14 +1282,14 @@
             <a:pPr algn="r">
               <a:defRPr sz="863" b="1">
                 <a:solidFill>
-                  <a:srgbClr val="7451B9"/>
+                  <a:srgbClr val="205BE5"/>
                 </a:solidFill>
               </a:defRPr>
             </a:pPr>
             <a:r>
               <a:rPr sz="863" b="1">
                 <a:solidFill>
-                  <a:srgbClr val="7451B9"/>
+                  <a:srgbClr val="205BE5"/>
                 </a:solidFill>
               </a:rPr>
               <a:t>POST /api/chat</a:t>
@@ -1302,7 +1302,7 @@
           <p:cNvPr id="4" name="header-rule">
             <a:extLst xmlns:a="http://schemas.openxmlformats.org/drawingml/2006/main">
               <a:ext uri="{FF2B5EF4-FFF2-40B4-BE49-F238E27FC236}">
-                <a16:creationId xmlns:a16="http://schemas.microsoft.com/office/drawing/2014/main" id="{337F3561-1C7A-4C6F-8427-4A2F3E25F433}"/>
+                <a16:creationId xmlns:a16="http://schemas.microsoft.com/office/drawing/2014/main" id="{6430BCFD-CD47-4415-85FA-5E2254AA65B3}"/>
               </a:ext>
             </a:extLst>
           </p:cNvPr>
@@ -1322,7 +1322,7 @@
           <a:noFill xmlns:a="http://schemas.openxmlformats.org/drawingml/2006/main"/>
           <a:ln xmlns:a="http://schemas.openxmlformats.org/drawingml/2006/main" w="12383">
             <a:solidFill>
-              <a:srgbClr val="15365F"/>
+              <a:srgbClr val="172033"/>
             </a:solidFill>
             <a:prstDash val="solid"/>
           </a:ln>
@@ -1333,7 +1333,7 @@
           <p:cNvPr id="5" name="docs-browser">
             <a:extLst xmlns:a="http://schemas.openxmlformats.org/drawingml/2006/main">
               <a:ext uri="{FF2B5EF4-FFF2-40B4-BE49-F238E27FC236}">
-                <a16:creationId xmlns:a16="http://schemas.microsoft.com/office/drawing/2014/main" id="{AE7C76C7-3EE0-436D-B799-0DA66AB58992}"/>
+                <a16:creationId xmlns:a16="http://schemas.microsoft.com/office/drawing/2014/main" id="{9807CB1E-C780-476E-B4F5-13B14DEA164D}"/>
               </a:ext>
             </a:extLst>
           </p:cNvPr>
@@ -1351,11 +1351,11 @@
             <a:avLst/>
           </a:prstGeom>
           <a:solidFill xmlns:a="http://schemas.openxmlformats.org/drawingml/2006/main">
-            <a:srgbClr val="1769E0"/>
+            <a:srgbClr val="205BE5"/>
           </a:solidFill>
           <a:ln xmlns:a="http://schemas.openxmlformats.org/drawingml/2006/main" w="0">
             <a:solidFill>
-              <a:srgbClr val="1769E0"/>
+              <a:srgbClr val="205BE5"/>
             </a:solidFill>
             <a:prstDash val="solid"/>
           </a:ln>
@@ -1366,7 +1366,7 @@
           <p:cNvPr id="6" name="browser-chunk">
             <a:extLst xmlns:a="http://schemas.openxmlformats.org/drawingml/2006/main">
               <a:ext uri="{FF2B5EF4-FFF2-40B4-BE49-F238E27FC236}">
-                <a16:creationId xmlns:a16="http://schemas.microsoft.com/office/drawing/2014/main" id="{756A8706-871E-4A3A-92F4-CC1191B6BD8D}"/>
+                <a16:creationId xmlns:a16="http://schemas.microsoft.com/office/drawing/2014/main" id="{97BDC3DE-AB38-4869-85A3-605E42E5717E}"/>
               </a:ext>
             </a:extLst>
           </p:cNvPr>
@@ -1384,11 +1384,11 @@
             <a:avLst/>
           </a:prstGeom>
           <a:solidFill xmlns:a="http://schemas.openxmlformats.org/drawingml/2006/main">
-            <a:srgbClr val="1769E0"/>
+            <a:srgbClr val="205BE5"/>
           </a:solidFill>
           <a:ln xmlns:a="http://schemas.openxmlformats.org/drawingml/2006/main" w="0">
             <a:solidFill>
-              <a:srgbClr val="1769E0"/>
+              <a:srgbClr val="205BE5"/>
             </a:solidFill>
             <a:prstDash val="solid"/>
           </a:ln>
@@ -1399,7 +1399,7 @@
           <p:cNvPr id="7" name="chunk-embed">
             <a:extLst xmlns:a="http://schemas.openxmlformats.org/drawingml/2006/main">
               <a:ext uri="{FF2B5EF4-FFF2-40B4-BE49-F238E27FC236}">
-                <a16:creationId xmlns:a16="http://schemas.microsoft.com/office/drawing/2014/main" id="{29839290-4B30-4AFC-A4FA-791A369646DE}"/>
+                <a16:creationId xmlns:a16="http://schemas.microsoft.com/office/drawing/2014/main" id="{1F313AC8-F491-4071-9572-9D3E52E4A1D8}"/>
               </a:ext>
             </a:extLst>
           </p:cNvPr>
@@ -1417,11 +1417,11 @@
             <a:avLst/>
           </a:prstGeom>
           <a:solidFill xmlns:a="http://schemas.openxmlformats.org/drawingml/2006/main">
-            <a:srgbClr val="1769E0"/>
+            <a:srgbClr val="205BE5"/>
           </a:solidFill>
           <a:ln xmlns:a="http://schemas.openxmlformats.org/drawingml/2006/main" w="0">
             <a:solidFill>
-              <a:srgbClr val="1769E0"/>
+              <a:srgbClr val="205BE5"/>
             </a:solidFill>
             <a:prstDash val="solid"/>
           </a:ln>
@@ -1432,7 +1432,7 @@
           <p:cNvPr id="8" name="embed-store">
             <a:extLst xmlns:a="http://schemas.openxmlformats.org/drawingml/2006/main">
               <a:ext uri="{FF2B5EF4-FFF2-40B4-BE49-F238E27FC236}">
-                <a16:creationId xmlns:a16="http://schemas.microsoft.com/office/drawing/2014/main" id="{B6A4376D-4A88-406E-BD29-F73076FEBC49}"/>
+                <a16:creationId xmlns:a16="http://schemas.microsoft.com/office/drawing/2014/main" id="{4BAF83E7-79D9-4B1A-B9C4-F63EB9684E6A}"/>
               </a:ext>
             </a:extLst>
           </p:cNvPr>
@@ -1450,11 +1450,11 @@
             <a:avLst/>
           </a:prstGeom>
           <a:solidFill xmlns:a="http://schemas.openxmlformats.org/drawingml/2006/main">
-            <a:srgbClr val="1896A8"/>
+            <a:srgbClr val="127B78"/>
           </a:solidFill>
           <a:ln xmlns:a="http://schemas.openxmlformats.org/drawingml/2006/main" w="0">
             <a:solidFill>
-              <a:srgbClr val="1896A8"/>
+              <a:srgbClr val="127B78"/>
             </a:solidFill>
             <a:prstDash val="solid"/>
           </a:ln>
@@ -1465,7 +1465,7 @@
           <p:cNvPr id="9" name="question-validate">
             <a:extLst xmlns:a="http://schemas.openxmlformats.org/drawingml/2006/main">
               <a:ext uri="{FF2B5EF4-FFF2-40B4-BE49-F238E27FC236}">
-                <a16:creationId xmlns:a16="http://schemas.microsoft.com/office/drawing/2014/main" id="{B0A87F0D-BD71-48C6-9D52-7C1A01508F38}"/>
+                <a16:creationId xmlns:a16="http://schemas.microsoft.com/office/drawing/2014/main" id="{5AEEA287-1C81-45F8-8751-9C2C35ADE210}"/>
               </a:ext>
             </a:extLst>
           </p:cNvPr>
@@ -1483,11 +1483,11 @@
             <a:avLst/>
           </a:prstGeom>
           <a:solidFill xmlns:a="http://schemas.openxmlformats.org/drawingml/2006/main">
-            <a:srgbClr val="7451B9"/>
+            <a:srgbClr val="1743A6"/>
           </a:solidFill>
           <a:ln xmlns:a="http://schemas.openxmlformats.org/drawingml/2006/main" w="0">
             <a:solidFill>
-              <a:srgbClr val="7451B9"/>
+              <a:srgbClr val="1743A6"/>
             </a:solidFill>
             <a:prstDash val="solid"/>
           </a:ln>
@@ -1498,7 +1498,7 @@
           <p:cNvPr id="10" name="validate-embed">
             <a:extLst xmlns:a="http://schemas.openxmlformats.org/drawingml/2006/main">
               <a:ext uri="{FF2B5EF4-FFF2-40B4-BE49-F238E27FC236}">
-                <a16:creationId xmlns:a16="http://schemas.microsoft.com/office/drawing/2014/main" id="{732594C6-2886-430E-B743-91209D9B914C}"/>
+                <a16:creationId xmlns:a16="http://schemas.microsoft.com/office/drawing/2014/main" id="{5907E15B-1888-4C56-B178-EB9ACE9C664B}"/>
               </a:ext>
             </a:extLst>
           </p:cNvPr>
@@ -1516,11 +1516,11 @@
             <a:avLst/>
           </a:prstGeom>
           <a:solidFill xmlns:a="http://schemas.openxmlformats.org/drawingml/2006/main">
-            <a:srgbClr val="7451B9"/>
+            <a:srgbClr val="1743A6"/>
           </a:solidFill>
           <a:ln xmlns:a="http://schemas.openxmlformats.org/drawingml/2006/main" w="0">
             <a:solidFill>
-              <a:srgbClr val="7451B9"/>
+              <a:srgbClr val="1743A6"/>
             </a:solidFill>
             <a:prstDash val="solid"/>
           </a:ln>
@@ -1531,7 +1531,7 @@
           <p:cNvPr id="11" name="query-store">
             <a:extLst xmlns:a="http://schemas.openxmlformats.org/drawingml/2006/main">
               <a:ext uri="{FF2B5EF4-FFF2-40B4-BE49-F238E27FC236}">
-                <a16:creationId xmlns:a16="http://schemas.microsoft.com/office/drawing/2014/main" id="{301C40A9-0302-496E-B9CF-33657DCF3E62}"/>
+                <a16:creationId xmlns:a16="http://schemas.microsoft.com/office/drawing/2014/main" id="{74E20F1D-1668-4C04-AECA-37F815922229}"/>
               </a:ext>
             </a:extLst>
           </p:cNvPr>
@@ -1549,11 +1549,11 @@
             <a:avLst/>
           </a:prstGeom>
           <a:solidFill xmlns:a="http://schemas.openxmlformats.org/drawingml/2006/main">
-            <a:srgbClr val="7451B9"/>
+            <a:srgbClr val="1743A6"/>
           </a:solidFill>
           <a:ln xmlns:a="http://schemas.openxmlformats.org/drawingml/2006/main" w="0">
             <a:solidFill>
-              <a:srgbClr val="7451B9"/>
+              <a:srgbClr val="1743A6"/>
             </a:solidFill>
             <a:prstDash val="solid"/>
           </a:ln>
@@ -1564,7 +1564,7 @@
           <p:cNvPr id="12" name="store-retrieve">
             <a:extLst xmlns:a="http://schemas.openxmlformats.org/drawingml/2006/main">
               <a:ext uri="{FF2B5EF4-FFF2-40B4-BE49-F238E27FC236}">
-                <a16:creationId xmlns:a16="http://schemas.microsoft.com/office/drawing/2014/main" id="{63E91FB1-034C-48C3-9B6F-76A98D9D9015}"/>
+                <a16:creationId xmlns:a16="http://schemas.microsoft.com/office/drawing/2014/main" id="{441FCC58-5E2B-4C2E-BB7E-9BF52AA6033A}"/>
               </a:ext>
             </a:extLst>
           </p:cNvPr>
@@ -1582,11 +1582,11 @@
             <a:avLst/>
           </a:prstGeom>
           <a:solidFill xmlns:a="http://schemas.openxmlformats.org/drawingml/2006/main">
-            <a:srgbClr val="7451B9"/>
+            <a:srgbClr val="1743A6"/>
           </a:solidFill>
           <a:ln xmlns:a="http://schemas.openxmlformats.org/drawingml/2006/main" w="0">
             <a:solidFill>
-              <a:srgbClr val="7451B9"/>
+              <a:srgbClr val="1743A6"/>
             </a:solidFill>
             <a:prstDash val="solid"/>
           </a:ln>
@@ -1597,7 +1597,7 @@
           <p:cNvPr id="13" name="retrieve-decision">
             <a:extLst xmlns:a="http://schemas.openxmlformats.org/drawingml/2006/main">
               <a:ext uri="{FF2B5EF4-FFF2-40B4-BE49-F238E27FC236}">
-                <a16:creationId xmlns:a16="http://schemas.microsoft.com/office/drawing/2014/main" id="{67FDEC4F-8957-46D6-9EF4-C3F69E4BE46C}"/>
+                <a16:creationId xmlns:a16="http://schemas.microsoft.com/office/drawing/2014/main" id="{A7FB2E51-8A32-4000-8F95-3071E7332536}"/>
               </a:ext>
             </a:extLst>
           </p:cNvPr>
@@ -1615,11 +1615,11 @@
             <a:avLst/>
           </a:prstGeom>
           <a:solidFill xmlns:a="http://schemas.openxmlformats.org/drawingml/2006/main">
-            <a:srgbClr val="7451B9"/>
+            <a:srgbClr val="1743A6"/>
           </a:solidFill>
           <a:ln xmlns:a="http://schemas.openxmlformats.org/drawingml/2006/main" w="0">
             <a:solidFill>
-              <a:srgbClr val="7451B9"/>
+              <a:srgbClr val="1743A6"/>
             </a:solidFill>
             <a:prstDash val="solid"/>
           </a:ln>
@@ -1630,7 +1630,7 @@
           <p:cNvPr id="14" name="decision-refuse">
             <a:extLst xmlns:a="http://schemas.openxmlformats.org/drawingml/2006/main">
               <a:ext uri="{FF2B5EF4-FFF2-40B4-BE49-F238E27FC236}">
-                <a16:creationId xmlns:a16="http://schemas.microsoft.com/office/drawing/2014/main" id="{2CE3B3AE-CB8B-4FE0-A9D4-FC0B230E617C}"/>
+                <a16:creationId xmlns:a16="http://schemas.microsoft.com/office/drawing/2014/main" id="{F5E5215B-0BF1-4A6A-89F7-AC97434D6BFF}"/>
               </a:ext>
             </a:extLst>
           </p:cNvPr>
@@ -1648,11 +1648,11 @@
             <a:avLst/>
           </a:prstGeom>
           <a:solidFill xmlns:a="http://schemas.openxmlformats.org/drawingml/2006/main">
-            <a:srgbClr val="CC4B3E"/>
+            <a:srgbClr val="C85440"/>
           </a:solidFill>
           <a:ln xmlns:a="http://schemas.openxmlformats.org/drawingml/2006/main" w="0">
             <a:solidFill>
-              <a:srgbClr val="CC4B3E"/>
+              <a:srgbClr val="C85440"/>
             </a:solidFill>
             <a:prstDash val="solid"/>
           </a:ln>
@@ -1663,7 +1663,7 @@
           <p:cNvPr id="15" name="decision-prompt-a">
             <a:extLst xmlns:a="http://schemas.openxmlformats.org/drawingml/2006/main">
               <a:ext uri="{FF2B5EF4-FFF2-40B4-BE49-F238E27FC236}">
-                <a16:creationId xmlns:a16="http://schemas.microsoft.com/office/drawing/2014/main" id="{DF336E09-055F-4DCD-A3FF-D0B70B509A1E}"/>
+                <a16:creationId xmlns:a16="http://schemas.microsoft.com/office/drawing/2014/main" id="{69726E3F-B9B2-42A9-BF7C-8D6DB5E2E8F9}"/>
               </a:ext>
             </a:extLst>
           </p:cNvPr>
@@ -1683,7 +1683,7 @@
           <a:noFill xmlns:a="http://schemas.openxmlformats.org/drawingml/2006/main"/>
           <a:ln xmlns:a="http://schemas.openxmlformats.org/drawingml/2006/main" w="19050">
             <a:solidFill>
-              <a:srgbClr val="7451B9"/>
+              <a:srgbClr val="1743A6"/>
             </a:solidFill>
             <a:prstDash val="solid"/>
           </a:ln>
@@ -1694,7 +1694,7 @@
           <p:cNvPr id="16" name="decision-prompt-b">
             <a:extLst xmlns:a="http://schemas.openxmlformats.org/drawingml/2006/main">
               <a:ext uri="{FF2B5EF4-FFF2-40B4-BE49-F238E27FC236}">
-                <a16:creationId xmlns:a16="http://schemas.microsoft.com/office/drawing/2014/main" id="{A83015E5-3FA7-4E9F-9F97-A75AA9ACE6FA}"/>
+                <a16:creationId xmlns:a16="http://schemas.microsoft.com/office/drawing/2014/main" id="{364E1FC9-354C-4DFA-8C55-86F8D1674ACB}"/>
               </a:ext>
             </a:extLst>
           </p:cNvPr>
@@ -1714,7 +1714,7 @@
           <a:noFill xmlns:a="http://schemas.openxmlformats.org/drawingml/2006/main"/>
           <a:ln xmlns:a="http://schemas.openxmlformats.org/drawingml/2006/main" w="19050">
             <a:solidFill>
-              <a:srgbClr val="7451B9"/>
+              <a:srgbClr val="1743A6"/>
             </a:solidFill>
             <a:prstDash val="solid"/>
           </a:ln>
@@ -1725,7 +1725,7 @@
           <p:cNvPr id="17" name="decision-prompt-c">
             <a:extLst xmlns:a="http://schemas.openxmlformats.org/drawingml/2006/main">
               <a:ext uri="{FF2B5EF4-FFF2-40B4-BE49-F238E27FC236}">
-                <a16:creationId xmlns:a16="http://schemas.microsoft.com/office/drawing/2014/main" id="{588B20B6-481B-4BB9-81DC-04433FAFC7EC}"/>
+                <a16:creationId xmlns:a16="http://schemas.microsoft.com/office/drawing/2014/main" id="{66888487-43C6-4221-A0A2-137C53676953}"/>
               </a:ext>
             </a:extLst>
           </p:cNvPr>
@@ -1743,11 +1743,11 @@
             <a:avLst/>
           </a:prstGeom>
           <a:solidFill xmlns:a="http://schemas.openxmlformats.org/drawingml/2006/main">
-            <a:srgbClr val="7451B9"/>
+            <a:srgbClr val="1743A6"/>
           </a:solidFill>
           <a:ln xmlns:a="http://schemas.openxmlformats.org/drawingml/2006/main" w="0">
             <a:solidFill>
-              <a:srgbClr val="7451B9"/>
+              <a:srgbClr val="1743A6"/>
             </a:solidFill>
             <a:prstDash val="solid"/>
           </a:ln>
@@ -1758,7 +1758,7 @@
           <p:cNvPr id="18" name="prompt-model">
             <a:extLst xmlns:a="http://schemas.openxmlformats.org/drawingml/2006/main">
               <a:ext uri="{FF2B5EF4-FFF2-40B4-BE49-F238E27FC236}">
-                <a16:creationId xmlns:a16="http://schemas.microsoft.com/office/drawing/2014/main" id="{16E9B34C-90DB-4748-BDA1-790EDF1B66E4}"/>
+                <a16:creationId xmlns:a16="http://schemas.microsoft.com/office/drawing/2014/main" id="{1407D16F-C5BE-461F-9AE5-248984BB9C9D}"/>
               </a:ext>
             </a:extLst>
           </p:cNvPr>
@@ -1776,11 +1776,11 @@
             <a:avLst/>
           </a:prstGeom>
           <a:solidFill xmlns:a="http://schemas.openxmlformats.org/drawingml/2006/main">
-            <a:srgbClr val="7451B9"/>
+            <a:srgbClr val="1743A6"/>
           </a:solidFill>
           <a:ln xmlns:a="http://schemas.openxmlformats.org/drawingml/2006/main" w="0">
             <a:solidFill>
-              <a:srgbClr val="7451B9"/>
+              <a:srgbClr val="1743A6"/>
             </a:solidFill>
             <a:prstDash val="solid"/>
           </a:ln>
@@ -1791,7 +1791,7 @@
           <p:cNvPr id="19" name="model-response">
             <a:extLst xmlns:a="http://schemas.openxmlformats.org/drawingml/2006/main">
               <a:ext uri="{FF2B5EF4-FFF2-40B4-BE49-F238E27FC236}">
-                <a16:creationId xmlns:a16="http://schemas.microsoft.com/office/drawing/2014/main" id="{2ED0DDF7-6F3F-4500-A651-740DF17D7039}"/>
+                <a16:creationId xmlns:a16="http://schemas.microsoft.com/office/drawing/2014/main" id="{B3D5B2F3-2EDE-483C-A9C5-0BE9B3A28396}"/>
               </a:ext>
             </a:extLst>
           </p:cNvPr>
@@ -1809,11 +1809,11 @@
             <a:avLst/>
           </a:prstGeom>
           <a:solidFill xmlns:a="http://schemas.openxmlformats.org/drawingml/2006/main">
-            <a:srgbClr val="1769E0"/>
+            <a:srgbClr val="205BE5"/>
           </a:solidFill>
           <a:ln xmlns:a="http://schemas.openxmlformats.org/drawingml/2006/main" w="0">
             <a:solidFill>
-              <a:srgbClr val="1769E0"/>
+              <a:srgbClr val="205BE5"/>
             </a:solidFill>
             <a:prstDash val="solid"/>
           </a:ln>
@@ -1824,7 +1824,7 @@
           <p:cNvPr id="20" name="corpus-label">
             <a:extLst xmlns:a="http://schemas.openxmlformats.org/drawingml/2006/main">
               <a:ext uri="{FF2B5EF4-FFF2-40B4-BE49-F238E27FC236}">
-                <a16:creationId xmlns:a16="http://schemas.microsoft.com/office/drawing/2014/main" id="{78DA1FE1-7229-4D60-961D-21105956688A}"/>
+                <a16:creationId xmlns:a16="http://schemas.microsoft.com/office/drawing/2014/main" id="{C022BC14-4252-425C-932F-5A67DFB23584}"/>
               </a:ext>
             </a:extLst>
           </p:cNvPr>
@@ -1854,14 +1854,14 @@
             <a:pPr algn="l">
               <a:defRPr sz="900" b="1">
                 <a:solidFill>
-                  <a:srgbClr val="1769E0"/>
+                  <a:srgbClr val="205BE5"/>
                 </a:solidFill>
               </a:defRPr>
             </a:pPr>
             <a:r>
               <a:rPr sz="900" b="1">
                 <a:solidFill>
-                  <a:srgbClr val="1769E0"/>
+                  <a:srgbClr val="205BE5"/>
                 </a:solidFill>
               </a:rPr>
               <a:t>01 · BUILD THE CORPUS</a:t>
@@ -1874,7 +1874,7 @@
           <p:cNvPr id="21" name="corpus-copy">
             <a:extLst xmlns:a="http://schemas.openxmlformats.org/drawingml/2006/main">
               <a:ext uri="{FF2B5EF4-FFF2-40B4-BE49-F238E27FC236}">
-                <a16:creationId xmlns:a16="http://schemas.microsoft.com/office/drawing/2014/main" id="{B206BED3-ADCE-4DD5-B882-2019068BBFA2}"/>
+                <a16:creationId xmlns:a16="http://schemas.microsoft.com/office/drawing/2014/main" id="{AFB233D2-7E23-4BF4-80AD-800F65D66B72}"/>
               </a:ext>
             </a:extLst>
           </p:cNvPr>
@@ -1904,14 +1904,14 @@
             <a:pPr algn="l">
               <a:defRPr sz="863" b="0">
                 <a:solidFill>
-                  <a:srgbClr val="64748B"/>
+                  <a:srgbClr val="667085"/>
                 </a:solidFill>
               </a:defRPr>
             </a:pPr>
             <a:r>
               <a:rPr sz="863" b="0">
                 <a:solidFill>
-                  <a:srgbClr val="64748B"/>
+                  <a:srgbClr val="667085"/>
                 </a:solidFill>
               </a:rPr>
               <a:t>18 maintained public guidance URLs</a:t>
@@ -1924,7 +1924,7 @@
           <p:cNvPr id="22" name="doc-back-2">
             <a:extLst xmlns:a="http://schemas.openxmlformats.org/drawingml/2006/main">
               <a:ext uri="{FF2B5EF4-FFF2-40B4-BE49-F238E27FC236}">
-                <a16:creationId xmlns:a16="http://schemas.microsoft.com/office/drawing/2014/main" id="{72BC3583-A070-46F0-90CE-900320AA4F92}"/>
+                <a16:creationId xmlns:a16="http://schemas.microsoft.com/office/drawing/2014/main" id="{E7F7E3E3-391A-47D5-BD3A-A9D404766DE9}"/>
               </a:ext>
             </a:extLst>
           </p:cNvPr>
@@ -1942,11 +1942,11 @@
             <a:avLst/>
           </a:prstGeom>
           <a:solidFill xmlns:a="http://schemas.openxmlformats.org/drawingml/2006/main">
-            <a:srgbClr val="E5F0FF"/>
+            <a:srgbClr val="EAF1FF"/>
           </a:solidFill>
           <a:ln xmlns:a="http://schemas.openxmlformats.org/drawingml/2006/main" w="9525">
             <a:solidFill>
-              <a:srgbClr val="1769E0"/>
+              <a:srgbClr val="205BE5"/>
             </a:solidFill>
             <a:prstDash val="solid"/>
           </a:ln>
@@ -1957,7 +1957,7 @@
           <p:cNvPr id="23" name="doc-back-1">
             <a:extLst xmlns:a="http://schemas.openxmlformats.org/drawingml/2006/main">
               <a:ext uri="{FF2B5EF4-FFF2-40B4-BE49-F238E27FC236}">
-                <a16:creationId xmlns:a16="http://schemas.microsoft.com/office/drawing/2014/main" id="{561936C9-820A-4165-B16C-3011C0245BDA}"/>
+                <a16:creationId xmlns:a16="http://schemas.microsoft.com/office/drawing/2014/main" id="{C71F22D6-5423-43F4-80EA-ABFC8CC1102C}"/>
               </a:ext>
             </a:extLst>
           </p:cNvPr>
@@ -1979,7 +1979,7 @@
           </a:solidFill>
           <a:ln xmlns:a="http://schemas.openxmlformats.org/drawingml/2006/main" w="9525">
             <a:solidFill>
-              <a:srgbClr val="1769E0"/>
+              <a:srgbClr val="205BE5"/>
             </a:solidFill>
             <a:prstDash val="solid"/>
           </a:ln>
@@ -1990,7 +1990,7 @@
           <p:cNvPr id="24" name="doc-front">
             <a:extLst xmlns:a="http://schemas.openxmlformats.org/drawingml/2006/main">
               <a:ext uri="{FF2B5EF4-FFF2-40B4-BE49-F238E27FC236}">
-                <a16:creationId xmlns:a16="http://schemas.microsoft.com/office/drawing/2014/main" id="{898606C2-2D90-45D0-BBC8-4E7EC4C71D8F}"/>
+                <a16:creationId xmlns:a16="http://schemas.microsoft.com/office/drawing/2014/main" id="{4A0FE6EA-2B0F-42CD-8273-E6FD1191018A}"/>
               </a:ext>
             </a:extLst>
           </p:cNvPr>
@@ -2012,7 +2012,7 @@
           </a:solidFill>
           <a:ln xmlns:a="http://schemas.openxmlformats.org/drawingml/2006/main" w="12383">
             <a:solidFill>
-              <a:srgbClr val="1769E0"/>
+              <a:srgbClr val="205BE5"/>
             </a:solidFill>
             <a:prstDash val="solid"/>
           </a:ln>
@@ -2023,7 +2023,7 @@
           <p:cNvPr id="25" name="doc-count">
             <a:extLst xmlns:a="http://schemas.openxmlformats.org/drawingml/2006/main">
               <a:ext uri="{FF2B5EF4-FFF2-40B4-BE49-F238E27FC236}">
-                <a16:creationId xmlns:a16="http://schemas.microsoft.com/office/drawing/2014/main" id="{09CDA344-094C-4AD4-BF55-8501A2E61AF5}"/>
+                <a16:creationId xmlns:a16="http://schemas.microsoft.com/office/drawing/2014/main" id="{B74B195E-2E86-42EF-888D-2E582A5A0E7E}"/>
               </a:ext>
             </a:extLst>
           </p:cNvPr>
@@ -2053,14 +2053,14 @@
             <a:pPr algn="ctr">
               <a:defRPr sz="1800" b="1">
                 <a:solidFill>
-                  <a:srgbClr val="1769E0"/>
+                  <a:srgbClr val="205BE5"/>
                 </a:solidFill>
               </a:defRPr>
             </a:pPr>
             <a:r>
               <a:rPr sz="1800" b="1">
                 <a:solidFill>
-                  <a:srgbClr val="1769E0"/>
+                  <a:srgbClr val="205BE5"/>
                 </a:solidFill>
               </a:rPr>
               <a:t>18</a:t>
@@ -2073,7 +2073,7 @@
           <p:cNvPr id="26" name="doc-label">
             <a:extLst xmlns:a="http://schemas.openxmlformats.org/drawingml/2006/main">
               <a:ext uri="{FF2B5EF4-FFF2-40B4-BE49-F238E27FC236}">
-                <a16:creationId xmlns:a16="http://schemas.microsoft.com/office/drawing/2014/main" id="{8C36C0AB-376B-4313-AEDD-176DB48F645C}"/>
+                <a16:creationId xmlns:a16="http://schemas.microsoft.com/office/drawing/2014/main" id="{61447E3A-3824-4D35-97CD-DBC354523CF9}"/>
               </a:ext>
             </a:extLst>
           </p:cNvPr>
@@ -2103,14 +2103,14 @@
             <a:pPr algn="ctr">
               <a:defRPr sz="825" b="1">
                 <a:solidFill>
-                  <a:srgbClr val="15365F"/>
+                  <a:srgbClr val="172033"/>
                 </a:solidFill>
               </a:defRPr>
             </a:pPr>
             <a:r>
               <a:rPr sz="825" b="1">
                 <a:solidFill>
-                  <a:srgbClr val="15365F"/>
+                  <a:srgbClr val="172033"/>
                 </a:solidFill>
               </a:rPr>
               <a:t>public</a:t>
@@ -2120,14 +2120,14 @@
             <a:pPr algn="ctr">
               <a:defRPr sz="825" b="1">
                 <a:solidFill>
-                  <a:srgbClr val="15365F"/>
+                  <a:srgbClr val="172033"/>
                 </a:solidFill>
               </a:defRPr>
             </a:pPr>
             <a:r>
               <a:rPr sz="825" b="1">
                 <a:solidFill>
-                  <a:srgbClr val="15365F"/>
+                  <a:srgbClr val="172033"/>
                 </a:solidFill>
               </a:rPr>
               <a:t>guides</a:t>
@@ -2140,7 +2140,7 @@
           <p:cNvPr id="27" name="browser-circle">
             <a:extLst xmlns:a="http://schemas.openxmlformats.org/drawingml/2006/main">
               <a:ext uri="{FF2B5EF4-FFF2-40B4-BE49-F238E27FC236}">
-                <a16:creationId xmlns:a16="http://schemas.microsoft.com/office/drawing/2014/main" id="{A552CA10-5A50-4127-BB49-10AF1FADDF2B}"/>
+                <a16:creationId xmlns:a16="http://schemas.microsoft.com/office/drawing/2014/main" id="{D5C42CEB-B671-44FA-BFD7-7C3354458A97}"/>
               </a:ext>
             </a:extLst>
           </p:cNvPr>
@@ -2158,11 +2158,11 @@
             <a:avLst/>
           </a:prstGeom>
           <a:solidFill xmlns:a="http://schemas.openxmlformats.org/drawingml/2006/main">
-            <a:srgbClr val="E5F0FF"/>
+            <a:srgbClr val="EAF1FF"/>
           </a:solidFill>
           <a:ln xmlns:a="http://schemas.openxmlformats.org/drawingml/2006/main" w="14288">
             <a:solidFill>
-              <a:srgbClr val="1769E0"/>
+              <a:srgbClr val="205BE5"/>
             </a:solidFill>
             <a:prstDash val="solid"/>
           </a:ln>
@@ -2173,7 +2173,7 @@
           <p:cNvPr id="28" name="browser-label">
             <a:extLst xmlns:a="http://schemas.openxmlformats.org/drawingml/2006/main">
               <a:ext uri="{FF2B5EF4-FFF2-40B4-BE49-F238E27FC236}">
-                <a16:creationId xmlns:a16="http://schemas.microsoft.com/office/drawing/2014/main" id="{2E10FCDB-6567-41F0-9565-F006F8D11B63}"/>
+                <a16:creationId xmlns:a16="http://schemas.microsoft.com/office/drawing/2014/main" id="{C21E813F-BE5B-456F-895B-426B505D791D}"/>
               </a:ext>
             </a:extLst>
           </p:cNvPr>
@@ -2203,14 +2203,14 @@
             <a:pPr algn="ctr">
               <a:defRPr sz="938" b="1">
                 <a:solidFill>
-                  <a:srgbClr val="1769E0"/>
+                  <a:srgbClr val="205BE5"/>
                 </a:solidFill>
               </a:defRPr>
             </a:pPr>
             <a:r>
               <a:rPr sz="938" b="1">
                 <a:solidFill>
-                  <a:srgbClr val="1769E0"/>
+                  <a:srgbClr val="205BE5"/>
                 </a:solidFill>
               </a:rPr>
               <a:t>Extract</a:t>
@@ -2223,7 +2223,7 @@
           <p:cNvPr id="29" name="browser-detail">
             <a:extLst xmlns:a="http://schemas.openxmlformats.org/drawingml/2006/main">
               <a:ext uri="{FF2B5EF4-FFF2-40B4-BE49-F238E27FC236}">
-                <a16:creationId xmlns:a16="http://schemas.microsoft.com/office/drawing/2014/main" id="{D53D8B05-1F8D-430A-ADED-9899FA7B1285}"/>
+                <a16:creationId xmlns:a16="http://schemas.microsoft.com/office/drawing/2014/main" id="{4FB7D413-D341-4702-BCB5-B93C55A4CC4D}"/>
               </a:ext>
             </a:extLst>
           </p:cNvPr>
@@ -2253,14 +2253,14 @@
             <a:pPr algn="ctr">
               <a:defRPr sz="713" b="0">
                 <a:solidFill>
-                  <a:srgbClr val="64748B"/>
+                  <a:srgbClr val="667085"/>
                 </a:solidFill>
               </a:defRPr>
             </a:pPr>
             <a:r>
               <a:rPr sz="713" b="0">
                 <a:solidFill>
-                  <a:srgbClr val="64748B"/>
+                  <a:srgbClr val="667085"/>
                 </a:solidFill>
               </a:rPr>
               <a:t>Puppeteer</a:t>
@@ -2270,14 +2270,14 @@
             <a:pPr algn="ctr">
               <a:defRPr sz="713" b="0">
                 <a:solidFill>
-                  <a:srgbClr val="64748B"/>
+                  <a:srgbClr val="667085"/>
                 </a:solidFill>
               </a:defRPr>
             </a:pPr>
             <a:r>
               <a:rPr sz="713" b="0">
                 <a:solidFill>
-                  <a:srgbClr val="64748B"/>
+                  <a:srgbClr val="667085"/>
                 </a:solidFill>
               </a:rPr>
               <a:t>one browser</a:t>
@@ -2290,7 +2290,7 @@
           <p:cNvPr id="30" name="chunk-circle">
             <a:extLst xmlns:a="http://schemas.openxmlformats.org/drawingml/2006/main">
               <a:ext uri="{FF2B5EF4-FFF2-40B4-BE49-F238E27FC236}">
-                <a16:creationId xmlns:a16="http://schemas.microsoft.com/office/drawing/2014/main" id="{4D9E15AC-1783-4195-BB1C-D1A1A36E5E58}"/>
+                <a16:creationId xmlns:a16="http://schemas.microsoft.com/office/drawing/2014/main" id="{7F4E8BA4-81C9-4FCB-96A3-57372041063E}"/>
               </a:ext>
             </a:extLst>
           </p:cNvPr>
@@ -2312,7 +2312,7 @@
           </a:solidFill>
           <a:ln xmlns:a="http://schemas.openxmlformats.org/drawingml/2006/main" w="14288">
             <a:solidFill>
-              <a:srgbClr val="15365F"/>
+              <a:srgbClr val="172033"/>
             </a:solidFill>
             <a:prstDash val="solid"/>
           </a:ln>
@@ -2323,7 +2323,7 @@
           <p:cNvPr id="31" name="chunk-label">
             <a:extLst xmlns:a="http://schemas.openxmlformats.org/drawingml/2006/main">
               <a:ext uri="{FF2B5EF4-FFF2-40B4-BE49-F238E27FC236}">
-                <a16:creationId xmlns:a16="http://schemas.microsoft.com/office/drawing/2014/main" id="{012D81EE-4B6E-4C76-BA37-2E818C52678F}"/>
+                <a16:creationId xmlns:a16="http://schemas.microsoft.com/office/drawing/2014/main" id="{C8A56533-2625-44C6-BEEA-821FEAFBF3E3}"/>
               </a:ext>
             </a:extLst>
           </p:cNvPr>
@@ -2353,14 +2353,14 @@
             <a:pPr algn="ctr">
               <a:defRPr sz="938" b="1">
                 <a:solidFill>
-                  <a:srgbClr val="15365F"/>
+                  <a:srgbClr val="172033"/>
                 </a:solidFill>
               </a:defRPr>
             </a:pPr>
             <a:r>
               <a:rPr sz="938" b="1">
                 <a:solidFill>
-                  <a:srgbClr val="15365F"/>
+                  <a:srgbClr val="172033"/>
                 </a:solidFill>
               </a:rPr>
               <a:t>Chunk</a:t>
@@ -2373,7 +2373,7 @@
           <p:cNvPr id="32" name="chunk-detail">
             <a:extLst xmlns:a="http://schemas.openxmlformats.org/drawingml/2006/main">
               <a:ext uri="{FF2B5EF4-FFF2-40B4-BE49-F238E27FC236}">
-                <a16:creationId xmlns:a16="http://schemas.microsoft.com/office/drawing/2014/main" id="{BB730A5B-2313-4998-B4F0-7F0311F45178}"/>
+                <a16:creationId xmlns:a16="http://schemas.microsoft.com/office/drawing/2014/main" id="{92CD90A1-B8EE-4EC6-826B-0E39CCF0E540}"/>
               </a:ext>
             </a:extLst>
           </p:cNvPr>
@@ -2403,14 +2403,14 @@
             <a:pPr algn="ctr">
               <a:defRPr sz="713" b="0">
                 <a:solidFill>
-                  <a:srgbClr val="64748B"/>
+                  <a:srgbClr val="667085"/>
                 </a:solidFill>
               </a:defRPr>
             </a:pPr>
             <a:r>
               <a:rPr sz="713" b="0">
                 <a:solidFill>
-                  <a:srgbClr val="64748B"/>
+                  <a:srgbClr val="667085"/>
                 </a:solidFill>
               </a:rPr>
               <a:t>normalize</a:t>
@@ -2420,14 +2420,14 @@
             <a:pPr algn="ctr">
               <a:defRPr sz="713" b="0">
                 <a:solidFill>
-                  <a:srgbClr val="64748B"/>
+                  <a:srgbClr val="667085"/>
                 </a:solidFill>
               </a:defRPr>
             </a:pPr>
             <a:r>
               <a:rPr sz="713" b="0">
                 <a:solidFill>
-                  <a:srgbClr val="64748B"/>
+                  <a:srgbClr val="667085"/>
                 </a:solidFill>
               </a:rPr>
               <a:t>512 / overlap 100</a:t>
@@ -2440,7 +2440,7 @@
           <p:cNvPr id="33" name="corpus-embed-circle">
             <a:extLst xmlns:a="http://schemas.openxmlformats.org/drawingml/2006/main">
               <a:ext uri="{FF2B5EF4-FFF2-40B4-BE49-F238E27FC236}">
-                <a16:creationId xmlns:a16="http://schemas.microsoft.com/office/drawing/2014/main" id="{067B5AB1-C4AB-4919-B2BC-A0957B9EC865}"/>
+                <a16:creationId xmlns:a16="http://schemas.microsoft.com/office/drawing/2014/main" id="{3A49DD60-8B2B-4580-8976-64D958585487}"/>
               </a:ext>
             </a:extLst>
           </p:cNvPr>
@@ -2458,11 +2458,11 @@
             <a:avLst/>
           </a:prstGeom>
           <a:solidFill xmlns:a="http://schemas.openxmlformats.org/drawingml/2006/main">
-            <a:srgbClr val="E2F4F6"/>
+            <a:srgbClr val="E6F3F2"/>
           </a:solidFill>
           <a:ln xmlns:a="http://schemas.openxmlformats.org/drawingml/2006/main" w="14288">
             <a:solidFill>
-              <a:srgbClr val="1896A8"/>
+              <a:srgbClr val="127B78"/>
             </a:solidFill>
             <a:prstDash val="solid"/>
           </a:ln>
@@ -2473,7 +2473,7 @@
           <p:cNvPr id="34" name="corpus-embed-label">
             <a:extLst xmlns:a="http://schemas.openxmlformats.org/drawingml/2006/main">
               <a:ext uri="{FF2B5EF4-FFF2-40B4-BE49-F238E27FC236}">
-                <a16:creationId xmlns:a16="http://schemas.microsoft.com/office/drawing/2014/main" id="{483F1CC4-A5C1-426E-B0BD-5692E67262E9}"/>
+                <a16:creationId xmlns:a16="http://schemas.microsoft.com/office/drawing/2014/main" id="{E4395439-FAED-462E-A32F-60E64F572637}"/>
               </a:ext>
             </a:extLst>
           </p:cNvPr>
@@ -2503,14 +2503,14 @@
             <a:pPr algn="ctr">
               <a:defRPr sz="938" b="1">
                 <a:solidFill>
-                  <a:srgbClr val="1896A8"/>
+                  <a:srgbClr val="127B78"/>
                 </a:solidFill>
               </a:defRPr>
             </a:pPr>
             <a:r>
               <a:rPr sz="938" b="1">
                 <a:solidFill>
-                  <a:srgbClr val="1896A8"/>
+                  <a:srgbClr val="127B78"/>
                 </a:solidFill>
               </a:rPr>
               <a:t>Embed</a:t>
@@ -2523,7 +2523,7 @@
           <p:cNvPr id="35" name="corpus-embed-detail">
             <a:extLst xmlns:a="http://schemas.openxmlformats.org/drawingml/2006/main">
               <a:ext uri="{FF2B5EF4-FFF2-40B4-BE49-F238E27FC236}">
-                <a16:creationId xmlns:a16="http://schemas.microsoft.com/office/drawing/2014/main" id="{25F998E6-0AED-4D24-B30B-E01D941F3759}"/>
+                <a16:creationId xmlns:a16="http://schemas.microsoft.com/office/drawing/2014/main" id="{6A9185DE-A436-4B8D-B261-79B1C594B478}"/>
               </a:ext>
             </a:extLst>
           </p:cNvPr>
@@ -2553,14 +2553,14 @@
             <a:pPr algn="ctr">
               <a:defRPr sz="713" b="0">
                 <a:solidFill>
-                  <a:srgbClr val="64748B"/>
+                  <a:srgbClr val="667085"/>
                 </a:solidFill>
               </a:defRPr>
             </a:pPr>
             <a:r>
               <a:rPr sz="713" b="0">
                 <a:solidFill>
-                  <a:srgbClr val="64748B"/>
+                  <a:srgbClr val="667085"/>
                 </a:solidFill>
               </a:rPr>
               <a:t>MiniLM-L6-v2</a:t>
@@ -2570,14 +2570,14 @@
             <a:pPr algn="ctr">
               <a:defRPr sz="713" b="0">
                 <a:solidFill>
-                  <a:srgbClr val="64748B"/>
+                  <a:srgbClr val="667085"/>
                 </a:solidFill>
               </a:defRPr>
             </a:pPr>
             <a:r>
               <a:rPr sz="713" b="0">
                 <a:solidFill>
-                  <a:srgbClr val="64748B"/>
+                  <a:srgbClr val="667085"/>
                 </a:solidFill>
               </a:rPr>
               <a:t>384-D normalized</a:t>
@@ -2590,7 +2590,7 @@
           <p:cNvPr id="36" name="astra-outer">
             <a:extLst xmlns:a="http://schemas.openxmlformats.org/drawingml/2006/main">
               <a:ext uri="{FF2B5EF4-FFF2-40B4-BE49-F238E27FC236}">
-                <a16:creationId xmlns:a16="http://schemas.microsoft.com/office/drawing/2014/main" id="{5D6807EB-E060-42DE-A802-9D337B4B2FC1}"/>
+                <a16:creationId xmlns:a16="http://schemas.microsoft.com/office/drawing/2014/main" id="{844B8957-1736-483D-BEC0-FDC1B993FA62}"/>
               </a:ext>
             </a:extLst>
           </p:cNvPr>
@@ -2608,11 +2608,11 @@
             <a:avLst/>
           </a:prstGeom>
           <a:solidFill xmlns:a="http://schemas.openxmlformats.org/drawingml/2006/main">
-            <a:srgbClr val="FFF1B8"/>
+            <a:srgbClr val="FFF1AE"/>
           </a:solidFill>
           <a:ln xmlns:a="http://schemas.openxmlformats.org/drawingml/2006/main" w="17145">
             <a:solidFill>
-              <a:srgbClr val="B77A00"/>
+              <a:srgbClr val="9A6A00"/>
             </a:solidFill>
             <a:prstDash val="solid"/>
           </a:ln>
@@ -2623,7 +2623,7 @@
           <p:cNvPr id="37" name="astra-top">
             <a:extLst xmlns:a="http://schemas.openxmlformats.org/drawingml/2006/main">
               <a:ext uri="{FF2B5EF4-FFF2-40B4-BE49-F238E27FC236}">
-                <a16:creationId xmlns:a16="http://schemas.microsoft.com/office/drawing/2014/main" id="{D7DF7B04-171E-4E14-A693-5A077CD5C67C}"/>
+                <a16:creationId xmlns:a16="http://schemas.microsoft.com/office/drawing/2014/main" id="{F035988A-62CB-463F-AEC2-3DDD49EAA900}"/>
               </a:ext>
             </a:extLst>
           </p:cNvPr>
@@ -2645,7 +2645,7 @@
           </a:solidFill>
           <a:ln xmlns:a="http://schemas.openxmlformats.org/drawingml/2006/main" w="17145">
             <a:solidFill>
-              <a:srgbClr val="B77A00"/>
+              <a:srgbClr val="9A6A00"/>
             </a:solidFill>
             <a:prstDash val="solid"/>
           </a:ln>
@@ -2656,7 +2656,7 @@
           <p:cNvPr id="38" name="astra-bottom">
             <a:extLst xmlns:a="http://schemas.openxmlformats.org/drawingml/2006/main">
               <a:ext uri="{FF2B5EF4-FFF2-40B4-BE49-F238E27FC236}">
-                <a16:creationId xmlns:a16="http://schemas.microsoft.com/office/drawing/2014/main" id="{9AD09C5A-428A-4A94-AE47-D6CAD37298E3}"/>
+                <a16:creationId xmlns:a16="http://schemas.microsoft.com/office/drawing/2014/main" id="{39598258-A47F-4AB5-8429-73CE1CEECE43}"/>
               </a:ext>
             </a:extLst>
           </p:cNvPr>
@@ -2678,7 +2678,7 @@
           </a:solidFill>
           <a:ln xmlns:a="http://schemas.openxmlformats.org/drawingml/2006/main" w="17145">
             <a:solidFill>
-              <a:srgbClr val="B77A00"/>
+              <a:srgbClr val="9A6A00"/>
             </a:solidFill>
             <a:prstDash val="solid"/>
           </a:ln>
@@ -2689,7 +2689,7 @@
           <p:cNvPr id="39" name="astra-kicker">
             <a:extLst xmlns:a="http://schemas.openxmlformats.org/drawingml/2006/main">
               <a:ext uri="{FF2B5EF4-FFF2-40B4-BE49-F238E27FC236}">
-                <a16:creationId xmlns:a16="http://schemas.microsoft.com/office/drawing/2014/main" id="{DB5806FC-BDA4-4A1B-A62D-B481A416CBE9}"/>
+                <a16:creationId xmlns:a16="http://schemas.microsoft.com/office/drawing/2014/main" id="{FDAD84BC-EF98-45A9-91E0-7BCB67DD6819}"/>
               </a:ext>
             </a:extLst>
           </p:cNvPr>
@@ -2719,14 +2719,14 @@
             <a:pPr algn="ctr">
               <a:defRPr sz="750" b="1">
                 <a:solidFill>
-                  <a:srgbClr val="B77A00"/>
+                  <a:srgbClr val="9A6A00"/>
                 </a:solidFill>
               </a:defRPr>
             </a:pPr>
             <a:r>
               <a:rPr sz="750" b="1">
                 <a:solidFill>
-                  <a:srgbClr val="B77A00"/>
+                  <a:srgbClr val="9A6A00"/>
                 </a:solidFill>
               </a:rPr>
               <a:t>SHARED STATE</a:t>
@@ -2739,7 +2739,7 @@
           <p:cNvPr id="40" name="astra-title">
             <a:extLst xmlns:a="http://schemas.openxmlformats.org/drawingml/2006/main">
               <a:ext uri="{FF2B5EF4-FFF2-40B4-BE49-F238E27FC236}">
-                <a16:creationId xmlns:a16="http://schemas.microsoft.com/office/drawing/2014/main" id="{6F728A02-06A7-43E5-867B-2542C0AC5B0D}"/>
+                <a16:creationId xmlns:a16="http://schemas.microsoft.com/office/drawing/2014/main" id="{3F73DF59-9C7B-4D4B-A754-91576E324011}"/>
               </a:ext>
             </a:extLst>
           </p:cNvPr>
@@ -2769,14 +2769,14 @@
             <a:pPr algn="ctr">
               <a:defRPr sz="1500" b="1">
                 <a:solidFill>
-                  <a:srgbClr val="15365F"/>
+                  <a:srgbClr val="172033"/>
                 </a:solidFill>
               </a:defRPr>
             </a:pPr>
             <a:r>
               <a:rPr sz="1500" b="1">
                 <a:solidFill>
-                  <a:srgbClr val="15365F"/>
+                  <a:srgbClr val="172033"/>
                 </a:solidFill>
               </a:rPr>
               <a:t>Astra DB</a:t>
@@ -2789,7 +2789,7 @@
           <p:cNvPr id="41" name="astra-copy">
             <a:extLst xmlns:a="http://schemas.openxmlformats.org/drawingml/2006/main">
               <a:ext uri="{FF2B5EF4-FFF2-40B4-BE49-F238E27FC236}">
-                <a16:creationId xmlns:a16="http://schemas.microsoft.com/office/drawing/2014/main" id="{35402E9C-8EB5-4ADD-AF68-D11EA240E821}"/>
+                <a16:creationId xmlns:a16="http://schemas.microsoft.com/office/drawing/2014/main" id="{44ED77ED-9BD4-4EDF-918A-A31766A5EC0D}"/>
               </a:ext>
             </a:extLst>
           </p:cNvPr>
@@ -2819,14 +2819,14 @@
             <a:pPr algn="ctr">
               <a:defRPr sz="825" b="0">
                 <a:solidFill>
-                  <a:srgbClr val="12223D"/>
+                  <a:srgbClr val="172033"/>
                 </a:solidFill>
               </a:defRPr>
             </a:pPr>
             <a:r>
               <a:rPr sz="825" b="0">
                 <a:solidFill>
-                  <a:srgbClr val="12223D"/>
+                  <a:srgbClr val="172033"/>
                 </a:solidFill>
               </a:rPr>
               <a:t>vector collection</a:t>
@@ -2836,14 +2836,14 @@
             <a:pPr algn="ctr">
               <a:defRPr sz="825" b="0">
                 <a:solidFill>
-                  <a:srgbClr val="12223D"/>
+                  <a:srgbClr val="172033"/>
                 </a:solidFill>
               </a:defRPr>
             </a:pPr>
             <a:r>
               <a:rPr sz="825" b="0">
                 <a:solidFill>
-                  <a:srgbClr val="12223D"/>
+                  <a:srgbClr val="172033"/>
                 </a:solidFill>
               </a:rPr>
               <a:t>source metadata</a:t>
@@ -2853,14 +2853,14 @@
             <a:pPr algn="ctr">
               <a:defRPr sz="825" b="0">
                 <a:solidFill>
-                  <a:srgbClr val="12223D"/>
+                  <a:srgbClr val="172033"/>
                 </a:solidFill>
               </a:defRPr>
             </a:pPr>
             <a:r>
               <a:rPr sz="825" b="0">
                 <a:solidFill>
-                  <a:srgbClr val="12223D"/>
+                  <a:srgbClr val="172033"/>
                 </a:solidFill>
               </a:rPr>
               <a:t>dot-product search</a:t>
@@ -2873,7 +2873,7 @@
           <p:cNvPr id="42" name="astra-divider">
             <a:extLst xmlns:a="http://schemas.openxmlformats.org/drawingml/2006/main">
               <a:ext uri="{FF2B5EF4-FFF2-40B4-BE49-F238E27FC236}">
-                <a16:creationId xmlns:a16="http://schemas.microsoft.com/office/drawing/2014/main" id="{6E4FA402-464E-44E2-A9A3-BD13E158C0E2}"/>
+                <a16:creationId xmlns:a16="http://schemas.microsoft.com/office/drawing/2014/main" id="{91FFD754-F126-4ED4-B256-4725A57080C6}"/>
               </a:ext>
             </a:extLst>
           </p:cNvPr>
@@ -2893,7 +2893,7 @@
           <a:noFill xmlns:a="http://schemas.openxmlformats.org/drawingml/2006/main"/>
           <a:ln xmlns:a="http://schemas.openxmlformats.org/drawingml/2006/main" w="10478">
             <a:solidFill>
-              <a:srgbClr val="B77A00"/>
+              <a:srgbClr val="9A6A00"/>
             </a:solidFill>
             <a:prstDash val="solid"/>
           </a:ln>
@@ -2904,7 +2904,7 @@
           <p:cNvPr id="43" name="astra-secret">
             <a:extLst xmlns:a="http://schemas.openxmlformats.org/drawingml/2006/main">
               <a:ext uri="{FF2B5EF4-FFF2-40B4-BE49-F238E27FC236}">
-                <a16:creationId xmlns:a16="http://schemas.microsoft.com/office/drawing/2014/main" id="{FC4CFD0A-518D-44BB-9448-DB7D289F91F6}"/>
+                <a16:creationId xmlns:a16="http://schemas.microsoft.com/office/drawing/2014/main" id="{5257BA0B-191B-4EB1-A366-308F6D0E279C}"/>
               </a:ext>
             </a:extLst>
           </p:cNvPr>
@@ -2934,14 +2934,14 @@
             <a:pPr algn="ctr">
               <a:defRPr sz="713" b="0">
                 <a:solidFill>
-                  <a:srgbClr val="64748B"/>
+                  <a:srgbClr val="667085"/>
                 </a:solidFill>
               </a:defRPr>
             </a:pPr>
             <a:r>
               <a:rPr sz="713" b="0">
                 <a:solidFill>
-                  <a:srgbClr val="64748B"/>
+                  <a:srgbClr val="667085"/>
                 </a:solidFill>
               </a:rPr>
               <a:t>server-side token</a:t>
@@ -2954,7 +2954,7 @@
           <p:cNvPr id="44" name="query-label">
             <a:extLst xmlns:a="http://schemas.openxmlformats.org/drawingml/2006/main">
               <a:ext uri="{FF2B5EF4-FFF2-40B4-BE49-F238E27FC236}">
-                <a16:creationId xmlns:a16="http://schemas.microsoft.com/office/drawing/2014/main" id="{F5D23464-2B1B-45E4-9F8E-5876CF7DC804}"/>
+                <a16:creationId xmlns:a16="http://schemas.microsoft.com/office/drawing/2014/main" id="{8097A3EC-15E4-4E43-A89A-B05C67ED4439}"/>
               </a:ext>
             </a:extLst>
           </p:cNvPr>
@@ -2984,14 +2984,14 @@
             <a:pPr algn="l">
               <a:defRPr sz="900" b="1">
                 <a:solidFill>
-                  <a:srgbClr val="7451B9"/>
+                  <a:srgbClr val="1743A6"/>
                 </a:solidFill>
               </a:defRPr>
             </a:pPr>
             <a:r>
               <a:rPr sz="900" b="1">
                 <a:solidFill>
-                  <a:srgbClr val="7451B9"/>
+                  <a:srgbClr val="1743A6"/>
                 </a:solidFill>
               </a:rPr>
               <a:t>02 · ANSWER A QUESTION</a:t>
@@ -3004,7 +3004,7 @@
           <p:cNvPr id="45" name="query-copy">
             <a:extLst xmlns:a="http://schemas.openxmlformats.org/drawingml/2006/main">
               <a:ext uri="{FF2B5EF4-FFF2-40B4-BE49-F238E27FC236}">
-                <a16:creationId xmlns:a16="http://schemas.microsoft.com/office/drawing/2014/main" id="{9460E42D-2C00-417E-A358-00B923E51E59}"/>
+                <a16:creationId xmlns:a16="http://schemas.microsoft.com/office/drawing/2014/main" id="{C6150592-AECC-40EA-BB3D-1B3E79E7DDA0}"/>
               </a:ext>
             </a:extLst>
           </p:cNvPr>
@@ -3034,14 +3034,14 @@
             <a:pPr algn="l">
               <a:defRPr sz="863" b="0">
                 <a:solidFill>
-                  <a:srgbClr val="64748B"/>
+                  <a:srgbClr val="667085"/>
                 </a:solidFill>
               </a:defRPr>
             </a:pPr>
             <a:r>
               <a:rPr sz="863" b="0">
                 <a:solidFill>
-                  <a:srgbClr val="64748B"/>
+                  <a:srgbClr val="667085"/>
                 </a:solidFill>
               </a:rPr>
               <a:t>The latest user message enters the same vector space.</a:t>
@@ -3054,7 +3054,7 @@
           <p:cNvPr id="46" name="question">
             <a:extLst xmlns:a="http://schemas.openxmlformats.org/drawingml/2006/main">
               <a:ext uri="{FF2B5EF4-FFF2-40B4-BE49-F238E27FC236}">
-                <a16:creationId xmlns:a16="http://schemas.microsoft.com/office/drawing/2014/main" id="{119F3DBA-36B8-463A-BC22-6EEF0E841216}"/>
+                <a16:creationId xmlns:a16="http://schemas.microsoft.com/office/drawing/2014/main" id="{A7B59697-5B79-4883-83F7-1E206BF46CCD}"/>
               </a:ext>
             </a:extLst>
           </p:cNvPr>
@@ -3074,11 +3074,11 @@
             </a:avLst>
           </a:prstGeom>
           <a:solidFill xmlns:a="http://schemas.openxmlformats.org/drawingml/2006/main">
-            <a:srgbClr val="EEE8FA"/>
+            <a:srgbClr val="EAF1FF"/>
           </a:solidFill>
           <a:ln xmlns:a="http://schemas.openxmlformats.org/drawingml/2006/main" w="12383">
             <a:solidFill>
-              <a:srgbClr val="7451B9"/>
+              <a:srgbClr val="1743A6"/>
             </a:solidFill>
             <a:prstDash val="solid"/>
           </a:ln>
@@ -3089,7 +3089,7 @@
           <p:cNvPr id="47" name="question-title">
             <a:extLst xmlns:a="http://schemas.openxmlformats.org/drawingml/2006/main">
               <a:ext uri="{FF2B5EF4-FFF2-40B4-BE49-F238E27FC236}">
-                <a16:creationId xmlns:a16="http://schemas.microsoft.com/office/drawing/2014/main" id="{F79165DB-159B-491B-B05B-DD7FD0FBAF74}"/>
+                <a16:creationId xmlns:a16="http://schemas.microsoft.com/office/drawing/2014/main" id="{61C4B6C4-4772-432B-A995-BFD814C45E88}"/>
               </a:ext>
             </a:extLst>
           </p:cNvPr>
@@ -3119,14 +3119,14 @@
             <a:pPr algn="ctr">
               <a:defRPr sz="975" b="1">
                 <a:solidFill>
-                  <a:srgbClr val="7451B9"/>
+                  <a:srgbClr val="1743A6"/>
                 </a:solidFill>
               </a:defRPr>
             </a:pPr>
             <a:r>
               <a:rPr sz="975" b="1">
                 <a:solidFill>
-                  <a:srgbClr val="7451B9"/>
+                  <a:srgbClr val="1743A6"/>
                 </a:solidFill>
               </a:rPr>
               <a:t>Question</a:t>
@@ -3139,7 +3139,7 @@
           <p:cNvPr id="48" name="question-copy">
             <a:extLst xmlns:a="http://schemas.openxmlformats.org/drawingml/2006/main">
               <a:ext uri="{FF2B5EF4-FFF2-40B4-BE49-F238E27FC236}">
-                <a16:creationId xmlns:a16="http://schemas.microsoft.com/office/drawing/2014/main" id="{8F5C530F-CAEB-48B1-B9A0-D12BFC119724}"/>
+                <a16:creationId xmlns:a16="http://schemas.microsoft.com/office/drawing/2014/main" id="{1C4C6838-8B59-4C86-AA66-1CBAF23F634C}"/>
               </a:ext>
             </a:extLst>
           </p:cNvPr>
@@ -3169,14 +3169,14 @@
             <a:pPr algn="ctr">
               <a:defRPr sz="713" b="0">
                 <a:solidFill>
-                  <a:srgbClr val="64748B"/>
+                  <a:srgbClr val="667085"/>
                 </a:solidFill>
               </a:defRPr>
             </a:pPr>
             <a:r>
               <a:rPr sz="713" b="0">
                 <a:solidFill>
-                  <a:srgbClr val="64748B"/>
+                  <a:srgbClr val="667085"/>
                 </a:solidFill>
               </a:rPr>
               <a:t>latest turn</a:t>
@@ -3189,7 +3189,7 @@
           <p:cNvPr id="49" name="validate-circle">
             <a:extLst xmlns:a="http://schemas.openxmlformats.org/drawingml/2006/main">
               <a:ext uri="{FF2B5EF4-FFF2-40B4-BE49-F238E27FC236}">
-                <a16:creationId xmlns:a16="http://schemas.microsoft.com/office/drawing/2014/main" id="{16776A50-8272-4C93-86CF-E31F8E161EC0}"/>
+                <a16:creationId xmlns:a16="http://schemas.microsoft.com/office/drawing/2014/main" id="{14A64111-00EB-498D-9050-80A032DEFAA7}"/>
               </a:ext>
             </a:extLst>
           </p:cNvPr>
@@ -3211,7 +3211,7 @@
           </a:solidFill>
           <a:ln xmlns:a="http://schemas.openxmlformats.org/drawingml/2006/main" w="14288">
             <a:solidFill>
-              <a:srgbClr val="15365F"/>
+              <a:srgbClr val="172033"/>
             </a:solidFill>
             <a:prstDash val="solid"/>
           </a:ln>
@@ -3222,7 +3222,7 @@
           <p:cNvPr id="50" name="validate-label">
             <a:extLst xmlns:a="http://schemas.openxmlformats.org/drawingml/2006/main">
               <a:ext uri="{FF2B5EF4-FFF2-40B4-BE49-F238E27FC236}">
-                <a16:creationId xmlns:a16="http://schemas.microsoft.com/office/drawing/2014/main" id="{9E95D48C-0125-43B9-B1FF-1E419EA1EF1F}"/>
+                <a16:creationId xmlns:a16="http://schemas.microsoft.com/office/drawing/2014/main" id="{65B46CAF-1F88-451B-9BE8-0A7F367DEC69}"/>
               </a:ext>
             </a:extLst>
           </p:cNvPr>
@@ -3252,14 +3252,14 @@
             <a:pPr algn="ctr">
               <a:defRPr sz="938" b="1">
                 <a:solidFill>
-                  <a:srgbClr val="15365F"/>
+                  <a:srgbClr val="172033"/>
                 </a:solidFill>
               </a:defRPr>
             </a:pPr>
             <a:r>
               <a:rPr sz="938" b="1">
                 <a:solidFill>
-                  <a:srgbClr val="15365F"/>
+                  <a:srgbClr val="172033"/>
                 </a:solidFill>
               </a:rPr>
               <a:t>Validate</a:t>
@@ -3272,7 +3272,7 @@
           <p:cNvPr id="51" name="validate-detail">
             <a:extLst xmlns:a="http://schemas.openxmlformats.org/drawingml/2006/main">
               <a:ext uri="{FF2B5EF4-FFF2-40B4-BE49-F238E27FC236}">
-                <a16:creationId xmlns:a16="http://schemas.microsoft.com/office/drawing/2014/main" id="{7093C7E6-001E-4127-85BE-E71A0B20C34C}"/>
+                <a16:creationId xmlns:a16="http://schemas.microsoft.com/office/drawing/2014/main" id="{F3E9E68A-723C-4A0B-BA7E-AD32289905CE}"/>
               </a:ext>
             </a:extLst>
           </p:cNvPr>
@@ -3302,14 +3302,14 @@
             <a:pPr algn="ctr">
               <a:defRPr sz="713" b="0">
                 <a:solidFill>
-                  <a:srgbClr val="64748B"/>
+                  <a:srgbClr val="667085"/>
                 </a:solidFill>
               </a:defRPr>
             </a:pPr>
             <a:r>
               <a:rPr sz="713" b="0">
                 <a:solidFill>
-                  <a:srgbClr val="64748B"/>
+                  <a:srgbClr val="667085"/>
                 </a:solidFill>
               </a:rPr>
               <a:t>1–20 messages</a:t>
@@ -3319,14 +3319,14 @@
             <a:pPr algn="ctr">
               <a:defRPr sz="713" b="0">
                 <a:solidFill>
-                  <a:srgbClr val="64748B"/>
+                  <a:srgbClr val="667085"/>
                 </a:solidFill>
               </a:defRPr>
             </a:pPr>
             <a:r>
               <a:rPr sz="713" b="0">
                 <a:solidFill>
-                  <a:srgbClr val="64748B"/>
+                  <a:srgbClr val="667085"/>
                 </a:solidFill>
               </a:rPr>
               <a:t>≤2,000 chars</a:t>
@@ -3339,7 +3339,7 @@
           <p:cNvPr id="52" name="query-embed-circle">
             <a:extLst xmlns:a="http://schemas.openxmlformats.org/drawingml/2006/main">
               <a:ext uri="{FF2B5EF4-FFF2-40B4-BE49-F238E27FC236}">
-                <a16:creationId xmlns:a16="http://schemas.microsoft.com/office/drawing/2014/main" id="{1A16CA10-A3A7-45B5-8921-9647B74F1D2D}"/>
+                <a16:creationId xmlns:a16="http://schemas.microsoft.com/office/drawing/2014/main" id="{24D8B786-43BB-4FAF-8302-C83DAE9829E7}"/>
               </a:ext>
             </a:extLst>
           </p:cNvPr>
@@ -3357,11 +3357,11 @@
             <a:avLst/>
           </a:prstGeom>
           <a:solidFill xmlns:a="http://schemas.openxmlformats.org/drawingml/2006/main">
-            <a:srgbClr val="E2F4F6"/>
+            <a:srgbClr val="E6F3F2"/>
           </a:solidFill>
           <a:ln xmlns:a="http://schemas.openxmlformats.org/drawingml/2006/main" w="14288">
             <a:solidFill>
-              <a:srgbClr val="1896A8"/>
+              <a:srgbClr val="127B78"/>
             </a:solidFill>
             <a:prstDash val="solid"/>
           </a:ln>
@@ -3372,7 +3372,7 @@
           <p:cNvPr id="53" name="query-embed-label">
             <a:extLst xmlns:a="http://schemas.openxmlformats.org/drawingml/2006/main">
               <a:ext uri="{FF2B5EF4-FFF2-40B4-BE49-F238E27FC236}">
-                <a16:creationId xmlns:a16="http://schemas.microsoft.com/office/drawing/2014/main" id="{CD0F6C30-0641-47AF-AD92-91D5094438F4}"/>
+                <a16:creationId xmlns:a16="http://schemas.microsoft.com/office/drawing/2014/main" id="{E4EE4067-0B3A-4474-813E-B2D272920430}"/>
               </a:ext>
             </a:extLst>
           </p:cNvPr>
@@ -3402,14 +3402,14 @@
             <a:pPr algn="ctr">
               <a:defRPr sz="938" b="1">
                 <a:solidFill>
-                  <a:srgbClr val="1896A8"/>
+                  <a:srgbClr val="127B78"/>
                 </a:solidFill>
               </a:defRPr>
             </a:pPr>
             <a:r>
               <a:rPr sz="938" b="1">
                 <a:solidFill>
-                  <a:srgbClr val="1896A8"/>
+                  <a:srgbClr val="127B78"/>
                 </a:solidFill>
               </a:rPr>
               <a:t>Embed</a:t>
@@ -3422,7 +3422,7 @@
           <p:cNvPr id="54" name="query-embed-detail">
             <a:extLst xmlns:a="http://schemas.openxmlformats.org/drawingml/2006/main">
               <a:ext uri="{FF2B5EF4-FFF2-40B4-BE49-F238E27FC236}">
-                <a16:creationId xmlns:a16="http://schemas.microsoft.com/office/drawing/2014/main" id="{E4DA9E3F-7863-46C5-BC19-505261641F92}"/>
+                <a16:creationId xmlns:a16="http://schemas.microsoft.com/office/drawing/2014/main" id="{3D1B7711-87E6-48FC-A56D-33FA62CF9A0B}"/>
               </a:ext>
             </a:extLst>
           </p:cNvPr>
@@ -3452,14 +3452,14 @@
             <a:pPr algn="ctr">
               <a:defRPr sz="713" b="0">
                 <a:solidFill>
-                  <a:srgbClr val="64748B"/>
+                  <a:srgbClr val="667085"/>
                 </a:solidFill>
               </a:defRPr>
             </a:pPr>
             <a:r>
               <a:rPr sz="713" b="0">
                 <a:solidFill>
-                  <a:srgbClr val="64748B"/>
+                  <a:srgbClr val="667085"/>
                 </a:solidFill>
               </a:rPr>
               <a:t>same MiniLM</a:t>
@@ -3469,14 +3469,14 @@
             <a:pPr algn="ctr">
               <a:defRPr sz="713" b="0">
                 <a:solidFill>
-                  <a:srgbClr val="64748B"/>
+                  <a:srgbClr val="667085"/>
                 </a:solidFill>
               </a:defRPr>
             </a:pPr>
             <a:r>
               <a:rPr sz="713" b="0">
                 <a:solidFill>
-                  <a:srgbClr val="64748B"/>
+                  <a:srgbClr val="667085"/>
                 </a:solidFill>
               </a:rPr>
               <a:t>vector space</a:t>
@@ -3489,7 +3489,7 @@
           <p:cNvPr id="55" name="retrieve-circle">
             <a:extLst xmlns:a="http://schemas.openxmlformats.org/drawingml/2006/main">
               <a:ext uri="{FF2B5EF4-FFF2-40B4-BE49-F238E27FC236}">
-                <a16:creationId xmlns:a16="http://schemas.microsoft.com/office/drawing/2014/main" id="{7AF78818-3199-48B7-BB21-542D663DE2E8}"/>
+                <a16:creationId xmlns:a16="http://schemas.microsoft.com/office/drawing/2014/main" id="{8B01347F-4981-4015-ACDC-D7FBDE5BCC96}"/>
               </a:ext>
             </a:extLst>
           </p:cNvPr>
@@ -3507,11 +3507,11 @@
             <a:avLst/>
           </a:prstGeom>
           <a:solidFill xmlns:a="http://schemas.openxmlformats.org/drawingml/2006/main">
-            <a:srgbClr val="EEE8FA"/>
+            <a:srgbClr val="EAF1FF"/>
           </a:solidFill>
           <a:ln xmlns:a="http://schemas.openxmlformats.org/drawingml/2006/main" w="14288">
             <a:solidFill>
-              <a:srgbClr val="7451B9"/>
+              <a:srgbClr val="1743A6"/>
             </a:solidFill>
             <a:prstDash val="solid"/>
           </a:ln>
@@ -3522,7 +3522,7 @@
           <p:cNvPr id="56" name="retrieve-label">
             <a:extLst xmlns:a="http://schemas.openxmlformats.org/drawingml/2006/main">
               <a:ext uri="{FF2B5EF4-FFF2-40B4-BE49-F238E27FC236}">
-                <a16:creationId xmlns:a16="http://schemas.microsoft.com/office/drawing/2014/main" id="{14DC8F86-862E-43C3-A7FF-160577534E05}"/>
+                <a16:creationId xmlns:a16="http://schemas.microsoft.com/office/drawing/2014/main" id="{298DD323-4956-435B-B818-929239565D9B}"/>
               </a:ext>
             </a:extLst>
           </p:cNvPr>
@@ -3552,14 +3552,14 @@
             <a:pPr algn="ctr">
               <a:defRPr sz="938" b="1">
                 <a:solidFill>
-                  <a:srgbClr val="7451B9"/>
+                  <a:srgbClr val="1743A6"/>
                 </a:solidFill>
               </a:defRPr>
             </a:pPr>
             <a:r>
               <a:rPr sz="938" b="1">
                 <a:solidFill>
-                  <a:srgbClr val="7451B9"/>
+                  <a:srgbClr val="1743A6"/>
                 </a:solidFill>
               </a:rPr>
               <a:t>Top 6</a:t>
@@ -3572,7 +3572,7 @@
           <p:cNvPr id="57" name="retrieve-detail">
             <a:extLst xmlns:a="http://schemas.openxmlformats.org/drawingml/2006/main">
               <a:ext uri="{FF2B5EF4-FFF2-40B4-BE49-F238E27FC236}">
-                <a16:creationId xmlns:a16="http://schemas.microsoft.com/office/drawing/2014/main" id="{A0AA64F9-2C59-4683-A434-B7919BDF4107}"/>
+                <a16:creationId xmlns:a16="http://schemas.microsoft.com/office/drawing/2014/main" id="{B2B0D33D-C1FA-440B-AB5D-F5B6981FB2A7}"/>
               </a:ext>
             </a:extLst>
           </p:cNvPr>
@@ -3602,14 +3602,14 @@
             <a:pPr algn="ctr">
               <a:defRPr sz="713" b="0">
                 <a:solidFill>
-                  <a:srgbClr val="64748B"/>
+                  <a:srgbClr val="667085"/>
                 </a:solidFill>
               </a:defRPr>
             </a:pPr>
             <a:r>
               <a:rPr sz="713" b="0">
                 <a:solidFill>
-                  <a:srgbClr val="64748B"/>
+                  <a:srgbClr val="667085"/>
                 </a:solidFill>
               </a:rPr>
               <a:t>usable text</a:t>
@@ -3619,14 +3619,14 @@
             <a:pPr algn="ctr">
               <a:defRPr sz="713" b="0">
                 <a:solidFill>
-                  <a:srgbClr val="64748B"/>
+                  <a:srgbClr val="667085"/>
                 </a:solidFill>
               </a:defRPr>
             </a:pPr>
             <a:r>
               <a:rPr sz="713" b="0">
                 <a:solidFill>
-                  <a:srgbClr val="64748B"/>
+                  <a:srgbClr val="667085"/>
                 </a:solidFill>
               </a:rPr>
               <a:t>only</a:t>
@@ -3639,7 +3639,7 @@
           <p:cNvPr id="58" name="evidence-gate">
             <a:extLst xmlns:a="http://schemas.openxmlformats.org/drawingml/2006/main">
               <a:ext uri="{FF2B5EF4-FFF2-40B4-BE49-F238E27FC236}">
-                <a16:creationId xmlns:a16="http://schemas.microsoft.com/office/drawing/2014/main" id="{52BF2E34-90A8-42AA-BA06-92F43EB5FBCC}"/>
+                <a16:creationId xmlns:a16="http://schemas.microsoft.com/office/drawing/2014/main" id="{868E0AE6-4EFD-4077-B73A-2F6671F4F329}"/>
               </a:ext>
             </a:extLst>
           </p:cNvPr>
@@ -3657,11 +3657,11 @@
             <a:avLst/>
           </a:prstGeom>
           <a:solidFill xmlns:a="http://schemas.openxmlformats.org/drawingml/2006/main">
-            <a:srgbClr val="FFFFFF"/>
+            <a:srgbClr val="FFF1AE"/>
           </a:solidFill>
           <a:ln xmlns:a="http://schemas.openxmlformats.org/drawingml/2006/main" w="14288">
             <a:solidFill>
-              <a:srgbClr val="7451B9"/>
+              <a:srgbClr val="9A6A00"/>
             </a:solidFill>
             <a:prstDash val="solid"/>
           </a:ln>
@@ -3672,7 +3672,7 @@
           <p:cNvPr id="59" name="gate-text">
             <a:extLst xmlns:a="http://schemas.openxmlformats.org/drawingml/2006/main">
               <a:ext uri="{FF2B5EF4-FFF2-40B4-BE49-F238E27FC236}">
-                <a16:creationId xmlns:a16="http://schemas.microsoft.com/office/drawing/2014/main" id="{E2A18170-72A3-4B56-982B-6BF89CEFDDA2}"/>
+                <a16:creationId xmlns:a16="http://schemas.microsoft.com/office/drawing/2014/main" id="{6AFAA394-A57F-4A01-B217-F4BC7AD2FDC5}"/>
               </a:ext>
             </a:extLst>
           </p:cNvPr>
@@ -3702,14 +3702,14 @@
             <a:pPr algn="ctr">
               <a:defRPr sz="788" b="1">
                 <a:solidFill>
-                  <a:srgbClr val="7451B9"/>
+                  <a:srgbClr val="9A6A00"/>
                 </a:solidFill>
               </a:defRPr>
             </a:pPr>
             <a:r>
               <a:rPr sz="788" b="1">
                 <a:solidFill>
-                  <a:srgbClr val="7451B9"/>
+                  <a:srgbClr val="9A6A00"/>
                 </a:solidFill>
               </a:rPr>
               <a:t>text?</a:t>
@@ -3722,7 +3722,7 @@
           <p:cNvPr id="60" name="prompt">
             <a:extLst xmlns:a="http://schemas.openxmlformats.org/drawingml/2006/main">
               <a:ext uri="{FF2B5EF4-FFF2-40B4-BE49-F238E27FC236}">
-                <a16:creationId xmlns:a16="http://schemas.microsoft.com/office/drawing/2014/main" id="{AFE11DD7-33FC-480A-A2BE-BF9BCB6AE5F0}"/>
+                <a16:creationId xmlns:a16="http://schemas.microsoft.com/office/drawing/2014/main" id="{5F5E6A4A-FCA4-4A11-BA31-C1347C7B925E}"/>
               </a:ext>
             </a:extLst>
           </p:cNvPr>
@@ -3742,11 +3742,11 @@
             </a:avLst>
           </a:prstGeom>
           <a:solidFill xmlns:a="http://schemas.openxmlformats.org/drawingml/2006/main">
-            <a:srgbClr val="EEE8FA"/>
+            <a:srgbClr val="E6F3F2"/>
           </a:solidFill>
           <a:ln xmlns:a="http://schemas.openxmlformats.org/drawingml/2006/main" w="12383">
             <a:solidFill>
-              <a:srgbClr val="7451B9"/>
+              <a:srgbClr val="127B78"/>
             </a:solidFill>
             <a:prstDash val="solid"/>
           </a:ln>
@@ -3757,7 +3757,7 @@
           <p:cNvPr id="61" name="prompt-title">
             <a:extLst xmlns:a="http://schemas.openxmlformats.org/drawingml/2006/main">
               <a:ext uri="{FF2B5EF4-FFF2-40B4-BE49-F238E27FC236}">
-                <a16:creationId xmlns:a16="http://schemas.microsoft.com/office/drawing/2014/main" id="{F68C61C5-1A61-49AA-9FA7-EC85DA0BE6BD}"/>
+                <a16:creationId xmlns:a16="http://schemas.microsoft.com/office/drawing/2014/main" id="{08636C55-5AD2-4615-BCA5-A08A8CF89255}"/>
               </a:ext>
             </a:extLst>
           </p:cNvPr>
@@ -3787,14 +3787,14 @@
             <a:pPr algn="ctr">
               <a:defRPr sz="863" b="1">
                 <a:solidFill>
-                  <a:srgbClr val="7451B9"/>
+                  <a:srgbClr val="127B78"/>
                 </a:solidFill>
               </a:defRPr>
             </a:pPr>
             <a:r>
               <a:rPr sz="863" b="1">
                 <a:solidFill>
-                  <a:srgbClr val="7451B9"/>
+                  <a:srgbClr val="127B78"/>
                 </a:solidFill>
               </a:rPr>
               <a:t>Grounded prompt</a:t>
@@ -3807,7 +3807,7 @@
           <p:cNvPr id="62" name="prompt-note">
             <a:extLst xmlns:a="http://schemas.openxmlformats.org/drawingml/2006/main">
               <a:ext uri="{FF2B5EF4-FFF2-40B4-BE49-F238E27FC236}">
-                <a16:creationId xmlns:a16="http://schemas.microsoft.com/office/drawing/2014/main" id="{F81DCACE-C6AA-481E-94FC-54FD9C40BF1A}"/>
+                <a16:creationId xmlns:a16="http://schemas.microsoft.com/office/drawing/2014/main" id="{57248EAA-DA18-4ACA-B398-022CA1E0C984}"/>
               </a:ext>
             </a:extLst>
           </p:cNvPr>
@@ -3837,14 +3837,14 @@
             <a:pPr algn="ctr">
               <a:defRPr sz="660" b="0">
                 <a:solidFill>
-                  <a:srgbClr val="64748B"/>
+                  <a:srgbClr val="667085"/>
                 </a:solidFill>
               </a:defRPr>
             </a:pPr>
             <a:r>
               <a:rPr sz="660" b="0">
                 <a:solidFill>
-                  <a:srgbClr val="64748B"/>
+                  <a:srgbClr val="667085"/>
                 </a:solidFill>
               </a:rPr>
               <a:t>context only</a:t>
@@ -3857,7 +3857,7 @@
           <p:cNvPr id="63" name="model">
             <a:extLst xmlns:a="http://schemas.openxmlformats.org/drawingml/2006/main">
               <a:ext uri="{FF2B5EF4-FFF2-40B4-BE49-F238E27FC236}">
-                <a16:creationId xmlns:a16="http://schemas.microsoft.com/office/drawing/2014/main" id="{91DE846B-07F8-4E33-80BC-329EE137A5A4}"/>
+                <a16:creationId xmlns:a16="http://schemas.microsoft.com/office/drawing/2014/main" id="{DE0A77B6-28B0-45FF-99CF-DFDA4DB222D6}"/>
               </a:ext>
             </a:extLst>
           </p:cNvPr>
@@ -3875,11 +3875,11 @@
             <a:avLst/>
           </a:prstGeom>
           <a:solidFill xmlns:a="http://schemas.openxmlformats.org/drawingml/2006/main">
-            <a:srgbClr val="E5F0FF"/>
+            <a:srgbClr val="EAF1FF"/>
           </a:solidFill>
           <a:ln xmlns:a="http://schemas.openxmlformats.org/drawingml/2006/main" w="14288">
             <a:solidFill>
-              <a:srgbClr val="1769E0"/>
+              <a:srgbClr val="205BE5"/>
             </a:solidFill>
             <a:prstDash val="solid"/>
           </a:ln>
@@ -3890,7 +3890,7 @@
           <p:cNvPr id="64" name="model-title">
             <a:extLst xmlns:a="http://schemas.openxmlformats.org/drawingml/2006/main">
               <a:ext uri="{FF2B5EF4-FFF2-40B4-BE49-F238E27FC236}">
-                <a16:creationId xmlns:a16="http://schemas.microsoft.com/office/drawing/2014/main" id="{CE5EA8F7-FD32-4771-A4C3-424BAEF2D08C}"/>
+                <a16:creationId xmlns:a16="http://schemas.microsoft.com/office/drawing/2014/main" id="{F8876177-04BB-496C-85F2-57FB2BCF0EDE}"/>
               </a:ext>
             </a:extLst>
           </p:cNvPr>
@@ -3920,14 +3920,14 @@
             <a:pPr algn="ctr">
               <a:defRPr sz="900" b="1">
                 <a:solidFill>
-                  <a:srgbClr val="1769E0"/>
+                  <a:srgbClr val="205BE5"/>
                 </a:solidFill>
               </a:defRPr>
             </a:pPr>
             <a:r>
               <a:rPr sz="900" b="1">
                 <a:solidFill>
-                  <a:srgbClr val="1769E0"/>
+                  <a:srgbClr val="205BE5"/>
                 </a:solidFill>
               </a:rPr>
               <a:t>HF router</a:t>
@@ -3940,7 +3940,7 @@
           <p:cNvPr id="65" name="model-note">
             <a:extLst xmlns:a="http://schemas.openxmlformats.org/drawingml/2006/main">
               <a:ext uri="{FF2B5EF4-FFF2-40B4-BE49-F238E27FC236}">
-                <a16:creationId xmlns:a16="http://schemas.microsoft.com/office/drawing/2014/main" id="{6BB2FB2F-0104-41FD-94F7-DE70F798D0FD}"/>
+                <a16:creationId xmlns:a16="http://schemas.microsoft.com/office/drawing/2014/main" id="{EE55DB7B-E6A2-4AFE-91F3-99042CA66037}"/>
               </a:ext>
             </a:extLst>
           </p:cNvPr>
@@ -3970,14 +3970,14 @@
             <a:pPr algn="ctr">
               <a:defRPr sz="690" b="0">
                 <a:solidFill>
-                  <a:srgbClr val="64748B"/>
+                  <a:srgbClr val="667085"/>
                 </a:solidFill>
               </a:defRPr>
             </a:pPr>
             <a:r>
               <a:rPr sz="690" b="0">
                 <a:solidFill>
-                  <a:srgbClr val="64748B"/>
+                  <a:srgbClr val="667085"/>
                 </a:solidFill>
               </a:rPr>
               <a:t>temp 0.2</a:t>
@@ -3987,14 +3987,14 @@
             <a:pPr algn="ctr">
               <a:defRPr sz="690" b="0">
                 <a:solidFill>
-                  <a:srgbClr val="64748B"/>
+                  <a:srgbClr val="667085"/>
                 </a:solidFill>
               </a:defRPr>
             </a:pPr>
             <a:r>
               <a:rPr sz="690" b="0">
                 <a:solidFill>
-                  <a:srgbClr val="64748B"/>
+                  <a:srgbClr val="667085"/>
                 </a:solidFill>
               </a:rPr>
               <a:t>25 s timeout</a:t>
@@ -4007,7 +4007,7 @@
           <p:cNvPr id="66" name="refusal">
             <a:extLst xmlns:a="http://schemas.openxmlformats.org/drawingml/2006/main">
               <a:ext uri="{FF2B5EF4-FFF2-40B4-BE49-F238E27FC236}">
-                <a16:creationId xmlns:a16="http://schemas.microsoft.com/office/drawing/2014/main" id="{888F1DE0-3D67-49DB-A28F-3C9F26CB23B5}"/>
+                <a16:creationId xmlns:a16="http://schemas.microsoft.com/office/drawing/2014/main" id="{8CACE831-09AD-4A3D-8352-51B6BD25509F}"/>
               </a:ext>
             </a:extLst>
           </p:cNvPr>
@@ -4027,11 +4027,11 @@
             </a:avLst>
           </a:prstGeom>
           <a:solidFill xmlns:a="http://schemas.openxmlformats.org/drawingml/2006/main">
-            <a:srgbClr val="FCE8E4"/>
+            <a:srgbClr val="F8E9E5"/>
           </a:solidFill>
           <a:ln xmlns:a="http://schemas.openxmlformats.org/drawingml/2006/main" w="12383">
             <a:solidFill>
-              <a:srgbClr val="CC4B3E"/>
+              <a:srgbClr val="C85440"/>
             </a:solidFill>
             <a:prstDash val="solid"/>
           </a:ln>
@@ -4042,7 +4042,7 @@
           <p:cNvPr id="67" name="refusal-copy">
             <a:extLst xmlns:a="http://schemas.openxmlformats.org/drawingml/2006/main">
               <a:ext uri="{FF2B5EF4-FFF2-40B4-BE49-F238E27FC236}">
-                <a16:creationId xmlns:a16="http://schemas.microsoft.com/office/drawing/2014/main" id="{1F5F79EC-C379-4BA7-B3D9-D464CBCCAA15}"/>
+                <a16:creationId xmlns:a16="http://schemas.microsoft.com/office/drawing/2014/main" id="{06DD625E-1CC1-4A9B-8D2A-89FBD6BF2341}"/>
               </a:ext>
             </a:extLst>
           </p:cNvPr>
@@ -4072,14 +4072,14 @@
             <a:pPr algn="ctr">
               <a:defRPr sz="788" b="1">
                 <a:solidFill>
-                  <a:srgbClr val="CC4B3E"/>
+                  <a:srgbClr val="C85440"/>
                 </a:solidFill>
               </a:defRPr>
             </a:pPr>
             <a:r>
               <a:rPr sz="788" b="1">
                 <a:solidFill>
-                  <a:srgbClr val="CC4B3E"/>
+                  <a:srgbClr val="C85440"/>
                 </a:solidFill>
               </a:rPr>
               <a:t>422 · refuse</a:t>
@@ -4089,14 +4089,14 @@
             <a:pPr algn="ctr">
               <a:defRPr sz="788" b="1">
                 <a:solidFill>
-                  <a:srgbClr val="CC4B3E"/>
+                  <a:srgbClr val="C85440"/>
                 </a:solidFill>
               </a:defRPr>
             </a:pPr>
             <a:r>
               <a:rPr sz="788" b="1">
                 <a:solidFill>
-                  <a:srgbClr val="CC4B3E"/>
+                  <a:srgbClr val="C85440"/>
                 </a:solidFill>
               </a:rPr>
               <a:t>no generation</a:t>
@@ -4109,7 +4109,7 @@
           <p:cNvPr id="68" name="response">
             <a:extLst xmlns:a="http://schemas.openxmlformats.org/drawingml/2006/main">
               <a:ext uri="{FF2B5EF4-FFF2-40B4-BE49-F238E27FC236}">
-                <a16:creationId xmlns:a16="http://schemas.microsoft.com/office/drawing/2014/main" id="{7317162E-3D76-46E6-8AF3-29C18CAE96F1}"/>
+                <a16:creationId xmlns:a16="http://schemas.microsoft.com/office/drawing/2014/main" id="{DC10C4A5-2CFB-4A0D-B291-624E65A20E81}"/>
               </a:ext>
             </a:extLst>
           </p:cNvPr>
@@ -4129,11 +4129,11 @@
             </a:avLst>
           </a:prstGeom>
           <a:solidFill xmlns:a="http://schemas.openxmlformats.org/drawingml/2006/main">
-            <a:srgbClr val="E5F0FF"/>
+            <a:srgbClr val="EAF1FF"/>
           </a:solidFill>
           <a:ln xmlns:a="http://schemas.openxmlformats.org/drawingml/2006/main" w="12383">
             <a:solidFill>
-              <a:srgbClr val="1769E0"/>
+              <a:srgbClr val="205BE5"/>
             </a:solidFill>
             <a:prstDash val="solid"/>
           </a:ln>
@@ -4144,7 +4144,7 @@
           <p:cNvPr id="69" name="response-copy">
             <a:extLst xmlns:a="http://schemas.openxmlformats.org/drawingml/2006/main">
               <a:ext uri="{FF2B5EF4-FFF2-40B4-BE49-F238E27FC236}">
-                <a16:creationId xmlns:a16="http://schemas.microsoft.com/office/drawing/2014/main" id="{8FC9BEA8-F1A9-4431-9A9F-DC9E54641252}"/>
+                <a16:creationId xmlns:a16="http://schemas.microsoft.com/office/drawing/2014/main" id="{5FC31A9B-4BA5-40DC-BDED-9AD9352A5A84}"/>
               </a:ext>
             </a:extLst>
           </p:cNvPr>
@@ -4174,14 +4174,14 @@
             <a:pPr algn="ctr">
               <a:defRPr sz="750" b="1">
                 <a:solidFill>
-                  <a:srgbClr val="1769E0"/>
+                  <a:srgbClr val="205BE5"/>
                 </a:solidFill>
               </a:defRPr>
             </a:pPr>
             <a:r>
               <a:rPr sz="750" b="1">
                 <a:solidFill>
-                  <a:srgbClr val="1769E0"/>
+                  <a:srgbClr val="205BE5"/>
                 </a:solidFill>
               </a:rPr>
               <a:t>answer +</a:t>
@@ -4191,14 +4191,14 @@
             <a:pPr algn="ctr">
               <a:defRPr sz="750" b="1">
                 <a:solidFill>
-                  <a:srgbClr val="1769E0"/>
+                  <a:srgbClr val="205BE5"/>
                 </a:solidFill>
               </a:defRPr>
             </a:pPr>
             <a:r>
               <a:rPr sz="750" b="1">
                 <a:solidFill>
-                  <a:srgbClr val="1769E0"/>
+                  <a:srgbClr val="205BE5"/>
                 </a:solidFill>
               </a:rPr>
               <a:t>≤4 sources</a:t>
@@ -4211,7 +4211,7 @@
           <p:cNvPr id="70" name="bound-browser-num">
             <a:extLst xmlns:a="http://schemas.openxmlformats.org/drawingml/2006/main">
               <a:ext uri="{FF2B5EF4-FFF2-40B4-BE49-F238E27FC236}">
-                <a16:creationId xmlns:a16="http://schemas.microsoft.com/office/drawing/2014/main" id="{B513D161-3D1B-4BF7-8274-EE4074339C35}"/>
+                <a16:creationId xmlns:a16="http://schemas.microsoft.com/office/drawing/2014/main" id="{36908B72-8A30-4B71-99E8-7C7E42F8351F}"/>
               </a:ext>
             </a:extLst>
           </p:cNvPr>
@@ -4229,11 +4229,11 @@
             <a:avLst/>
           </a:prstGeom>
           <a:solidFill xmlns:a="http://schemas.openxmlformats.org/drawingml/2006/main">
-            <a:srgbClr val="15365F"/>
+            <a:srgbClr val="172033"/>
           </a:solidFill>
           <a:ln xmlns:a="http://schemas.openxmlformats.org/drawingml/2006/main" w="0">
             <a:solidFill>
-              <a:srgbClr val="15365F"/>
+              <a:srgbClr val="172033"/>
             </a:solidFill>
             <a:prstDash val="solid"/>
           </a:ln>
@@ -4244,7 +4244,7 @@
           <p:cNvPr id="71" name="bound-browser-n">
             <a:extLst xmlns:a="http://schemas.openxmlformats.org/drawingml/2006/main">
               <a:ext uri="{FF2B5EF4-FFF2-40B4-BE49-F238E27FC236}">
-                <a16:creationId xmlns:a16="http://schemas.microsoft.com/office/drawing/2014/main" id="{80F53CC5-BD65-46DE-96BD-F2583F75EA12}"/>
+                <a16:creationId xmlns:a16="http://schemas.microsoft.com/office/drawing/2014/main" id="{753C39D2-86B1-48ED-893F-E8185DD4C8A0}"/>
               </a:ext>
             </a:extLst>
           </p:cNvPr>
@@ -4294,7 +4294,7 @@
           <p:cNvPr id="72" name="bound-browser-title">
             <a:extLst xmlns:a="http://schemas.openxmlformats.org/drawingml/2006/main">
               <a:ext uri="{FF2B5EF4-FFF2-40B4-BE49-F238E27FC236}">
-                <a16:creationId xmlns:a16="http://schemas.microsoft.com/office/drawing/2014/main" id="{3E7177B5-52CC-44DF-814A-29E379BC3BA6}"/>
+                <a16:creationId xmlns:a16="http://schemas.microsoft.com/office/drawing/2014/main" id="{B5AE3119-ABBE-4B9D-8BE0-E95227895E2B}"/>
               </a:ext>
             </a:extLst>
           </p:cNvPr>
@@ -4324,14 +4324,14 @@
             <a:pPr algn="l">
               <a:defRPr sz="750" b="1">
                 <a:solidFill>
-                  <a:srgbClr val="15365F"/>
+                  <a:srgbClr val="172033"/>
                 </a:solidFill>
               </a:defRPr>
             </a:pPr>
             <a:r>
               <a:rPr sz="750" b="1">
                 <a:solidFill>
-                  <a:srgbClr val="15365F"/>
+                  <a:srgbClr val="172033"/>
                 </a:solidFill>
               </a:rPr>
               <a:t>SERVER BOUNDARY</a:t>
@@ -4344,7 +4344,7 @@
           <p:cNvPr id="73" name="bound-browser-body">
             <a:extLst xmlns:a="http://schemas.openxmlformats.org/drawingml/2006/main">
               <a:ext uri="{FF2B5EF4-FFF2-40B4-BE49-F238E27FC236}">
-                <a16:creationId xmlns:a16="http://schemas.microsoft.com/office/drawing/2014/main" id="{61B77D91-5CB2-4481-B252-F1DCAD8CDD25}"/>
+                <a16:creationId xmlns:a16="http://schemas.microsoft.com/office/drawing/2014/main" id="{99CC8252-CF4E-4485-BB2B-E5B810B80763}"/>
               </a:ext>
             </a:extLst>
           </p:cNvPr>
@@ -4374,14 +4374,14 @@
             <a:pPr algn="l">
               <a:defRPr sz="713" b="0">
                 <a:solidFill>
-                  <a:srgbClr val="64748B"/>
+                  <a:srgbClr val="667085"/>
                 </a:solidFill>
               </a:defRPr>
             </a:pPr>
             <a:r>
               <a:rPr sz="713" b="0">
                 <a:solidFill>
-                  <a:srgbClr val="64748B"/>
+                  <a:srgbClr val="667085"/>
                 </a:solidFill>
               </a:rPr>
               <a:t>Astra and model credentials never enter the browser.</a:t>
@@ -4394,7 +4394,7 @@
           <p:cNvPr id="74" name="bound-empty-num">
             <a:extLst xmlns:a="http://schemas.openxmlformats.org/drawingml/2006/main">
               <a:ext uri="{FF2B5EF4-FFF2-40B4-BE49-F238E27FC236}">
-                <a16:creationId xmlns:a16="http://schemas.microsoft.com/office/drawing/2014/main" id="{9BC44C7A-2C03-45C7-A978-0F3F9F8191AF}"/>
+                <a16:creationId xmlns:a16="http://schemas.microsoft.com/office/drawing/2014/main" id="{04B9A81A-3876-43FE-A2C4-0C7CCBD7ED3D}"/>
               </a:ext>
             </a:extLst>
           </p:cNvPr>
@@ -4412,11 +4412,11 @@
             <a:avLst/>
           </a:prstGeom>
           <a:solidFill xmlns:a="http://schemas.openxmlformats.org/drawingml/2006/main">
-            <a:srgbClr val="CC4B3E"/>
+            <a:srgbClr val="C85440"/>
           </a:solidFill>
           <a:ln xmlns:a="http://schemas.openxmlformats.org/drawingml/2006/main" w="0">
             <a:solidFill>
-              <a:srgbClr val="CC4B3E"/>
+              <a:srgbClr val="C85440"/>
             </a:solidFill>
             <a:prstDash val="solid"/>
           </a:ln>
@@ -4427,7 +4427,7 @@
           <p:cNvPr id="75" name="bound-empty-n">
             <a:extLst xmlns:a="http://schemas.openxmlformats.org/drawingml/2006/main">
               <a:ext uri="{FF2B5EF4-FFF2-40B4-BE49-F238E27FC236}">
-                <a16:creationId xmlns:a16="http://schemas.microsoft.com/office/drawing/2014/main" id="{DFCCEBB4-2E39-4686-8DA9-6FC797C9B9C7}"/>
+                <a16:creationId xmlns:a16="http://schemas.microsoft.com/office/drawing/2014/main" id="{3BA8D041-121E-4F13-8895-6547F543AFBF}"/>
               </a:ext>
             </a:extLst>
           </p:cNvPr>
@@ -4477,7 +4477,7 @@
           <p:cNvPr id="76" name="bound-empty-title">
             <a:extLst xmlns:a="http://schemas.openxmlformats.org/drawingml/2006/main">
               <a:ext uri="{FF2B5EF4-FFF2-40B4-BE49-F238E27FC236}">
-                <a16:creationId xmlns:a16="http://schemas.microsoft.com/office/drawing/2014/main" id="{71C121A2-A426-4392-B500-6ABF0F6EDD27}"/>
+                <a16:creationId xmlns:a16="http://schemas.microsoft.com/office/drawing/2014/main" id="{377F0D9E-83F2-4DD8-99DD-447A5E8026FF}"/>
               </a:ext>
             </a:extLst>
           </p:cNvPr>
@@ -4507,14 +4507,14 @@
             <a:pPr algn="l">
               <a:defRPr sz="750" b="1">
                 <a:solidFill>
-                  <a:srgbClr val="CC4B3E"/>
+                  <a:srgbClr val="C85440"/>
                 </a:solidFill>
               </a:defRPr>
             </a:pPr>
             <a:r>
               <a:rPr sz="750" b="1">
                 <a:solidFill>
-                  <a:srgbClr val="CC4B3E"/>
+                  <a:srgbClr val="C85440"/>
                 </a:solidFill>
               </a:rPr>
               <a:t>EMPTY RETRIEVAL</a:t>
@@ -4527,7 +4527,7 @@
           <p:cNvPr id="77" name="bound-empty-body">
             <a:extLst xmlns:a="http://schemas.openxmlformats.org/drawingml/2006/main">
               <a:ext uri="{FF2B5EF4-FFF2-40B4-BE49-F238E27FC236}">
-                <a16:creationId xmlns:a16="http://schemas.microsoft.com/office/drawing/2014/main" id="{75B3AC31-AAF9-425C-A4B6-64DBFCB1B2A8}"/>
+                <a16:creationId xmlns:a16="http://schemas.microsoft.com/office/drawing/2014/main" id="{FA542278-EC00-4747-8126-12BA688BA309}"/>
               </a:ext>
             </a:extLst>
           </p:cNvPr>
@@ -4557,14 +4557,14 @@
             <a:pPr algn="l">
               <a:defRPr sz="713" b="0">
                 <a:solidFill>
-                  <a:srgbClr val="64748B"/>
+                  <a:srgbClr val="667085"/>
                 </a:solidFill>
               </a:defRPr>
             </a:pPr>
             <a:r>
               <a:rPr sz="713" b="0">
                 <a:solidFill>
-                  <a:srgbClr val="64748B"/>
+                  <a:srgbClr val="667085"/>
                 </a:solidFill>
               </a:rPr>
               <a:t>The route refuses before generation—no general-knowledge fallback.</a:t>
@@ -4577,7 +4577,7 @@
           <p:cNvPr id="78" name="bound-scope-num">
             <a:extLst xmlns:a="http://schemas.openxmlformats.org/drawingml/2006/main">
               <a:ext uri="{FF2B5EF4-FFF2-40B4-BE49-F238E27FC236}">
-                <a16:creationId xmlns:a16="http://schemas.microsoft.com/office/drawing/2014/main" id="{BB8C4F66-155A-4920-9962-C57049BE836A}"/>
+                <a16:creationId xmlns:a16="http://schemas.microsoft.com/office/drawing/2014/main" id="{F99BB6BE-1803-45B7-94B3-B57778D887E7}"/>
               </a:ext>
             </a:extLst>
           </p:cNvPr>
@@ -4595,11 +4595,11 @@
             <a:avLst/>
           </a:prstGeom>
           <a:solidFill xmlns:a="http://schemas.openxmlformats.org/drawingml/2006/main">
-            <a:srgbClr val="1F8065"/>
+            <a:srgbClr val="127B78"/>
           </a:solidFill>
           <a:ln xmlns:a="http://schemas.openxmlformats.org/drawingml/2006/main" w="0">
             <a:solidFill>
-              <a:srgbClr val="1F8065"/>
+              <a:srgbClr val="127B78"/>
             </a:solidFill>
             <a:prstDash val="solid"/>
           </a:ln>
@@ -4610,7 +4610,7 @@
           <p:cNvPr id="79" name="bound-scope-n">
             <a:extLst xmlns:a="http://schemas.openxmlformats.org/drawingml/2006/main">
               <a:ext uri="{FF2B5EF4-FFF2-40B4-BE49-F238E27FC236}">
-                <a16:creationId xmlns:a16="http://schemas.microsoft.com/office/drawing/2014/main" id="{3AE74B03-69BB-4D65-9013-C6C068497BEF}"/>
+                <a16:creationId xmlns:a16="http://schemas.microsoft.com/office/drawing/2014/main" id="{2D8400D0-CACA-40C3-82C4-AB517F5660B3}"/>
               </a:ext>
             </a:extLst>
           </p:cNvPr>
@@ -4660,7 +4660,7 @@
           <p:cNvPr id="80" name="bound-scope-title">
             <a:extLst xmlns:a="http://schemas.openxmlformats.org/drawingml/2006/main">
               <a:ext uri="{FF2B5EF4-FFF2-40B4-BE49-F238E27FC236}">
-                <a16:creationId xmlns:a16="http://schemas.microsoft.com/office/drawing/2014/main" id="{726EA682-D1E0-4001-9280-E53E87E61A64}"/>
+                <a16:creationId xmlns:a16="http://schemas.microsoft.com/office/drawing/2014/main" id="{B3A7C7D7-AC6D-4A40-B270-FF565FF988F8}"/>
               </a:ext>
             </a:extLst>
           </p:cNvPr>
@@ -4690,14 +4690,14 @@
             <a:pPr algn="l">
               <a:defRPr sz="750" b="1">
                 <a:solidFill>
-                  <a:srgbClr val="1F8065"/>
+                  <a:srgbClr val="127B78"/>
                 </a:solidFill>
               </a:defRPr>
             </a:pPr>
             <a:r>
               <a:rPr sz="750" b="1">
                 <a:solidFill>
-                  <a:srgbClr val="1F8065"/>
+                  <a:srgbClr val="127B78"/>
                 </a:solidFill>
               </a:rPr>
               <a:t>SCOPE</a:t>
@@ -4710,7 +4710,7 @@
           <p:cNvPr id="81" name="bound-scope-body">
             <a:extLst xmlns:a="http://schemas.openxmlformats.org/drawingml/2006/main">
               <a:ext uri="{FF2B5EF4-FFF2-40B4-BE49-F238E27FC236}">
-                <a16:creationId xmlns:a16="http://schemas.microsoft.com/office/drawing/2014/main" id="{23E6DF64-82CA-40AC-A61F-E72E6BDB2AB9}"/>
+                <a16:creationId xmlns:a16="http://schemas.microsoft.com/office/drawing/2014/main" id="{F5D94EBF-94B5-4A2D-B261-4E9B8F4E459B}"/>
               </a:ext>
             </a:extLst>
           </p:cNvPr>
@@ -4740,14 +4740,14 @@
             <a:pPr algn="l">
               <a:defRPr sz="713" b="0">
                 <a:solidFill>
-                  <a:srgbClr val="64748B"/>
+                  <a:srgbClr val="667085"/>
                 </a:solidFill>
               </a:defRPr>
             </a:pPr>
             <a:r>
               <a:rPr sz="713" b="0">
                 <a:solidFill>
-                  <a:srgbClr val="64748B"/>
+                  <a:srgbClr val="667085"/>
                 </a:solidFill>
               </a:rPr>
               <a:t>Educational guidance only; no PHI, coverage, or amount-owed decision.</a:t>
@@ -4760,7 +4760,7 @@
           <p:cNvPr id="82" name="caption">
             <a:extLst xmlns:a="http://schemas.openxmlformats.org/drawingml/2006/main">
               <a:ext uri="{FF2B5EF4-FFF2-40B4-BE49-F238E27FC236}">
-                <a16:creationId xmlns:a16="http://schemas.microsoft.com/office/drawing/2014/main" id="{D1CE6787-F246-432D-9E7B-0A3FADA70FC4}"/>
+                <a16:creationId xmlns:a16="http://schemas.microsoft.com/office/drawing/2014/main" id="{F7FB6CA2-E2DC-4587-A412-E66EAEAA89E2}"/>
               </a:ext>
             </a:extLst>
           </p:cNvPr>
@@ -4790,14 +4790,14 @@
             <a:pPr algn="l">
               <a:defRPr sz="938" b="0">
                 <a:solidFill>
-                  <a:srgbClr val="12223D"/>
+                  <a:srgbClr val="172033"/>
                 </a:solidFill>
               </a:defRPr>
             </a:pPr>
             <a:r>
               <a:rPr sz="938" b="0">
                 <a:solidFill>
-                  <a:srgbClr val="12223D"/>
+                  <a:srgbClr val="172033"/>
                 </a:solidFill>
               </a:rPr>
               <a:t>The offline and online paths share only the embedding space and vector collection; the evidence gate decides whether generation is allowed.</a:t>
@@ -4810,7 +4810,7 @@
           <p:cNvPr id="83" name="sources">
             <a:extLst xmlns:a="http://schemas.openxmlformats.org/drawingml/2006/main">
               <a:ext uri="{FF2B5EF4-FFF2-40B4-BE49-F238E27FC236}">
-                <a16:creationId xmlns:a16="http://schemas.microsoft.com/office/drawing/2014/main" id="{13ADBAAF-8328-4F84-8A69-B62389256EE9}"/>
+                <a16:creationId xmlns:a16="http://schemas.microsoft.com/office/drawing/2014/main" id="{61B88C7F-8B6E-493F-8DCB-5728B5947836}"/>
               </a:ext>
             </a:extLst>
           </p:cNvPr>
@@ -4840,14 +4840,14 @@
             <a:pPr algn="l">
               <a:defRPr sz="690" b="0">
                 <a:solidFill>
-                  <a:srgbClr val="64748B"/>
+                  <a:srgbClr val="667085"/>
                 </a:solidFill>
               </a:defRPr>
             </a:pPr>
             <a:r>
               <a:rPr sz="690" b="0">
                 <a:solidFill>
-                  <a:srgbClr val="64748B"/>
+                  <a:srgbClr val="667085"/>
                 </a:solidFill>
               </a:rPr>
               <a:t>scripts/loadDB.ts · app/api/chat/route.ts · app/lib/chat.ts · app/types.ts</a:t>
@@ -4858,7 +4858,7 @@
     </p:spTree>
     <p:extLst>
       <p:ext uri="{BB962C8B-B14F-4D97-AF65-F5344CB8AC3E}">
-        <p14:creationId xmlns:p14="http://schemas.microsoft.com/office/powerpoint/2010/main" val="330265552"/>
+        <p14:creationId xmlns:p14="http://schemas.microsoft.com/office/powerpoint/2010/main" val="1766284720"/>
       </p:ext>
     </p:extLst>
   </p:cSld>

</xml_diff>

<commit_message>
Align ClearBill figure with the product theme (#8)
## What changed

- aligned the architecture figure with ClearBill's actual paper, navy,
blue, yellow, teal, and coral design tokens
- removed the unrelated purple visual language
- preserved the shared evidence-plane composition and refuse-or-generate
gate
- regenerated editable, vector, raster, provenance, and preflight
artifacts

## Why

The architecture figure should feel native to the product while
retaining the restrained hierarchy of a research-paper system diagram.

## Validation

- PowerPoint overflow check
- 716 px final-size and grayscale review
- vector-only PDF preflight
- provenance checksums verified
</commit_message>
<xml_diff>
--- a/docs/figures/clearbill-evidence-path/editable/clearbill-evidence-path.pptx
+++ b/docs/figures/clearbill-evidence-path/editable/clearbill-evidence-path.pptx
@@ -2,13 +2,13 @@
 <file path=ppt/presentation.xml><?xml version="1.0" encoding="utf-8"?>
 <p:presentation xmlns:p="http://schemas.openxmlformats.org/presentationml/2006/main">
   <p:sldMasterIdLst>
-    <p:sldMasterId xmlns:r="http://schemas.openxmlformats.org/officeDocument/2006/relationships" id="2147483648" r:id="R6d4d202a6e4a426e"/>
+    <p:sldMasterId xmlns:r="http://schemas.openxmlformats.org/officeDocument/2006/relationships" id="2147483648" r:id="R525e4c50e99a42d4"/>
   </p:sldMasterIdLst>
   <p:notesMasterIdLst>
-    <p:notesMasterId xmlns:r="http://schemas.openxmlformats.org/officeDocument/2006/relationships" r:id="R86ed7fd047a941ac"/>
+    <p:notesMasterId xmlns:r="http://schemas.openxmlformats.org/officeDocument/2006/relationships" r:id="R763a299058a3481f"/>
   </p:notesMasterIdLst>
   <p:sldIdLst>
-    <p:sldId xmlns:r="http://schemas.openxmlformats.org/officeDocument/2006/relationships" id="256" r:id="R5a5eca8f255b4b01"/>
+    <p:sldId xmlns:r="http://schemas.openxmlformats.org/officeDocument/2006/relationships" id="256" r:id="Rbea5f6fc9c0c4edc"/>
   </p:sldIdLst>
   <p:sldSz cx="12192000" cy="6858000"/>
   <p:notesSz cx="6858000" cy="9144000"/>
@@ -601,7 +601,7 @@
   </p:cSld>
   <p:clrMap bg1="lt1" tx1="dk1" bg2="lt2" tx2="dk2" accent1="accent1" accent2="accent2" accent3="accent3" accent4="accent4" accent5="accent5" accent6="accent6" hlink="hlink" folHlink="folHlink"/>
   <p:sldLayoutIdLst>
-    <p:sldLayoutId xmlns:r="http://schemas.openxmlformats.org/officeDocument/2006/relationships" id="2147483649" r:id="Rff6f979ecaea4c84"/>
+    <p:sldLayoutId xmlns:r="http://schemas.openxmlformats.org/officeDocument/2006/relationships" id="2147483649" r:id="Rb7c72c4b7fb64177"/>
   </p:sldLayoutIdLst>
   <p:txStyles>
     <p:titleStyle>
@@ -1134,7 +1134,7 @@
     <p:bg>
       <p:bgPr>
         <a:solidFill xmlns:a="http://schemas.openxmlformats.org/drawingml/2006/main">
-          <a:srgbClr val="F7FAFC"/>
+          <a:srgbClr val="FFFDF8"/>
         </a:solidFill>
       </p:bgPr>
     </p:bg>
@@ -1152,7 +1152,7 @@
           <p:cNvPr id="84" name="title">
             <a:extLst xmlns:a="http://schemas.openxmlformats.org/drawingml/2006/main">
               <a:ext uri="{FF2B5EF4-FFF2-40B4-BE49-F238E27FC236}">
-                <a16:creationId xmlns:a16="http://schemas.microsoft.com/office/drawing/2014/main" id="{2432F6A2-8A26-480C-9B79-A0E3EE4C0EC6}"/>
+                <a16:creationId xmlns:a16="http://schemas.microsoft.com/office/drawing/2014/main" id="{7EE3C346-8437-40E8-B17B-21F7B871EFDB}"/>
               </a:ext>
             </a:extLst>
           </p:cNvPr>
@@ -1182,14 +1182,14 @@
             <a:pPr algn="l">
               <a:defRPr sz="2175" b="1">
                 <a:solidFill>
-                  <a:srgbClr val="15365F"/>
+                  <a:srgbClr val="172033"/>
                 </a:solidFill>
               </a:defRPr>
             </a:pPr>
             <a:r>
               <a:rPr sz="2175" b="1">
                 <a:solidFill>
-                  <a:srgbClr val="15365F"/>
+                  <a:srgbClr val="172033"/>
                 </a:solidFill>
               </a:rPr>
               <a:t>ClearBill has one shared evidence plane</a:t>
@@ -1202,7 +1202,7 @@
           <p:cNvPr id="2" name="subtitle">
             <a:extLst xmlns:a="http://schemas.openxmlformats.org/drawingml/2006/main">
               <a:ext uri="{FF2B5EF4-FFF2-40B4-BE49-F238E27FC236}">
-                <a16:creationId xmlns:a16="http://schemas.microsoft.com/office/drawing/2014/main" id="{4C43002D-4A45-470A-BDBD-9A58CAA292A3}"/>
+                <a16:creationId xmlns:a16="http://schemas.microsoft.com/office/drawing/2014/main" id="{9C52249E-99C1-40D7-9C71-152334634C19}"/>
               </a:ext>
             </a:extLst>
           </p:cNvPr>
@@ -1232,14 +1232,14 @@
             <a:pPr algn="l">
               <a:defRPr sz="1088" b="0">
                 <a:solidFill>
-                  <a:srgbClr val="64748B"/>
+                  <a:srgbClr val="667085"/>
                 </a:solidFill>
               </a:defRPr>
             </a:pPr>
             <a:r>
               <a:rPr sz="1088" b="0">
                 <a:solidFill>
-                  <a:srgbClr val="64748B"/>
+                  <a:srgbClr val="667085"/>
                 </a:solidFill>
               </a:rPr>
               <a:t>Public guidance enters from the corpus path; questions leave through a guarded answer path.</a:t>
@@ -1252,7 +1252,7 @@
           <p:cNvPr id="3" name="route">
             <a:extLst xmlns:a="http://schemas.openxmlformats.org/drawingml/2006/main">
               <a:ext uri="{FF2B5EF4-FFF2-40B4-BE49-F238E27FC236}">
-                <a16:creationId xmlns:a16="http://schemas.microsoft.com/office/drawing/2014/main" id="{274EAC72-70B4-4531-B148-B36C56F73F39}"/>
+                <a16:creationId xmlns:a16="http://schemas.microsoft.com/office/drawing/2014/main" id="{C4FE0E0D-1FCF-4849-89F5-7FE373FFE6A3}"/>
               </a:ext>
             </a:extLst>
           </p:cNvPr>
@@ -1282,14 +1282,14 @@
             <a:pPr algn="r">
               <a:defRPr sz="863" b="1">
                 <a:solidFill>
-                  <a:srgbClr val="7451B9"/>
+                  <a:srgbClr val="205BE5"/>
                 </a:solidFill>
               </a:defRPr>
             </a:pPr>
             <a:r>
               <a:rPr sz="863" b="1">
                 <a:solidFill>
-                  <a:srgbClr val="7451B9"/>
+                  <a:srgbClr val="205BE5"/>
                 </a:solidFill>
               </a:rPr>
               <a:t>POST /api/chat</a:t>
@@ -1302,7 +1302,7 @@
           <p:cNvPr id="4" name="header-rule">
             <a:extLst xmlns:a="http://schemas.openxmlformats.org/drawingml/2006/main">
               <a:ext uri="{FF2B5EF4-FFF2-40B4-BE49-F238E27FC236}">
-                <a16:creationId xmlns:a16="http://schemas.microsoft.com/office/drawing/2014/main" id="{337F3561-1C7A-4C6F-8427-4A2F3E25F433}"/>
+                <a16:creationId xmlns:a16="http://schemas.microsoft.com/office/drawing/2014/main" id="{6430BCFD-CD47-4415-85FA-5E2254AA65B3}"/>
               </a:ext>
             </a:extLst>
           </p:cNvPr>
@@ -1322,7 +1322,7 @@
           <a:noFill xmlns:a="http://schemas.openxmlformats.org/drawingml/2006/main"/>
           <a:ln xmlns:a="http://schemas.openxmlformats.org/drawingml/2006/main" w="12383">
             <a:solidFill>
-              <a:srgbClr val="15365F"/>
+              <a:srgbClr val="172033"/>
             </a:solidFill>
             <a:prstDash val="solid"/>
           </a:ln>
@@ -1333,7 +1333,7 @@
           <p:cNvPr id="5" name="docs-browser">
             <a:extLst xmlns:a="http://schemas.openxmlformats.org/drawingml/2006/main">
               <a:ext uri="{FF2B5EF4-FFF2-40B4-BE49-F238E27FC236}">
-                <a16:creationId xmlns:a16="http://schemas.microsoft.com/office/drawing/2014/main" id="{AE7C76C7-3EE0-436D-B799-0DA66AB58992}"/>
+                <a16:creationId xmlns:a16="http://schemas.microsoft.com/office/drawing/2014/main" id="{9807CB1E-C780-476E-B4F5-13B14DEA164D}"/>
               </a:ext>
             </a:extLst>
           </p:cNvPr>
@@ -1351,11 +1351,11 @@
             <a:avLst/>
           </a:prstGeom>
           <a:solidFill xmlns:a="http://schemas.openxmlformats.org/drawingml/2006/main">
-            <a:srgbClr val="1769E0"/>
+            <a:srgbClr val="205BE5"/>
           </a:solidFill>
           <a:ln xmlns:a="http://schemas.openxmlformats.org/drawingml/2006/main" w="0">
             <a:solidFill>
-              <a:srgbClr val="1769E0"/>
+              <a:srgbClr val="205BE5"/>
             </a:solidFill>
             <a:prstDash val="solid"/>
           </a:ln>
@@ -1366,7 +1366,7 @@
           <p:cNvPr id="6" name="browser-chunk">
             <a:extLst xmlns:a="http://schemas.openxmlformats.org/drawingml/2006/main">
               <a:ext uri="{FF2B5EF4-FFF2-40B4-BE49-F238E27FC236}">
-                <a16:creationId xmlns:a16="http://schemas.microsoft.com/office/drawing/2014/main" id="{756A8706-871E-4A3A-92F4-CC1191B6BD8D}"/>
+                <a16:creationId xmlns:a16="http://schemas.microsoft.com/office/drawing/2014/main" id="{97BDC3DE-AB38-4869-85A3-605E42E5717E}"/>
               </a:ext>
             </a:extLst>
           </p:cNvPr>
@@ -1384,11 +1384,11 @@
             <a:avLst/>
           </a:prstGeom>
           <a:solidFill xmlns:a="http://schemas.openxmlformats.org/drawingml/2006/main">
-            <a:srgbClr val="1769E0"/>
+            <a:srgbClr val="205BE5"/>
           </a:solidFill>
           <a:ln xmlns:a="http://schemas.openxmlformats.org/drawingml/2006/main" w="0">
             <a:solidFill>
-              <a:srgbClr val="1769E0"/>
+              <a:srgbClr val="205BE5"/>
             </a:solidFill>
             <a:prstDash val="solid"/>
           </a:ln>
@@ -1399,7 +1399,7 @@
           <p:cNvPr id="7" name="chunk-embed">
             <a:extLst xmlns:a="http://schemas.openxmlformats.org/drawingml/2006/main">
               <a:ext uri="{FF2B5EF4-FFF2-40B4-BE49-F238E27FC236}">
-                <a16:creationId xmlns:a16="http://schemas.microsoft.com/office/drawing/2014/main" id="{29839290-4B30-4AFC-A4FA-791A369646DE}"/>
+                <a16:creationId xmlns:a16="http://schemas.microsoft.com/office/drawing/2014/main" id="{1F313AC8-F491-4071-9572-9D3E52E4A1D8}"/>
               </a:ext>
             </a:extLst>
           </p:cNvPr>
@@ -1417,11 +1417,11 @@
             <a:avLst/>
           </a:prstGeom>
           <a:solidFill xmlns:a="http://schemas.openxmlformats.org/drawingml/2006/main">
-            <a:srgbClr val="1769E0"/>
+            <a:srgbClr val="205BE5"/>
           </a:solidFill>
           <a:ln xmlns:a="http://schemas.openxmlformats.org/drawingml/2006/main" w="0">
             <a:solidFill>
-              <a:srgbClr val="1769E0"/>
+              <a:srgbClr val="205BE5"/>
             </a:solidFill>
             <a:prstDash val="solid"/>
           </a:ln>
@@ -1432,7 +1432,7 @@
           <p:cNvPr id="8" name="embed-store">
             <a:extLst xmlns:a="http://schemas.openxmlformats.org/drawingml/2006/main">
               <a:ext uri="{FF2B5EF4-FFF2-40B4-BE49-F238E27FC236}">
-                <a16:creationId xmlns:a16="http://schemas.microsoft.com/office/drawing/2014/main" id="{B6A4376D-4A88-406E-BD29-F73076FEBC49}"/>
+                <a16:creationId xmlns:a16="http://schemas.microsoft.com/office/drawing/2014/main" id="{4BAF83E7-79D9-4B1A-B9C4-F63EB9684E6A}"/>
               </a:ext>
             </a:extLst>
           </p:cNvPr>
@@ -1450,11 +1450,11 @@
             <a:avLst/>
           </a:prstGeom>
           <a:solidFill xmlns:a="http://schemas.openxmlformats.org/drawingml/2006/main">
-            <a:srgbClr val="1896A8"/>
+            <a:srgbClr val="127B78"/>
           </a:solidFill>
           <a:ln xmlns:a="http://schemas.openxmlformats.org/drawingml/2006/main" w="0">
             <a:solidFill>
-              <a:srgbClr val="1896A8"/>
+              <a:srgbClr val="127B78"/>
             </a:solidFill>
             <a:prstDash val="solid"/>
           </a:ln>
@@ -1465,7 +1465,7 @@
           <p:cNvPr id="9" name="question-validate">
             <a:extLst xmlns:a="http://schemas.openxmlformats.org/drawingml/2006/main">
               <a:ext uri="{FF2B5EF4-FFF2-40B4-BE49-F238E27FC236}">
-                <a16:creationId xmlns:a16="http://schemas.microsoft.com/office/drawing/2014/main" id="{B0A87F0D-BD71-48C6-9D52-7C1A01508F38}"/>
+                <a16:creationId xmlns:a16="http://schemas.microsoft.com/office/drawing/2014/main" id="{5AEEA287-1C81-45F8-8751-9C2C35ADE210}"/>
               </a:ext>
             </a:extLst>
           </p:cNvPr>
@@ -1483,11 +1483,11 @@
             <a:avLst/>
           </a:prstGeom>
           <a:solidFill xmlns:a="http://schemas.openxmlformats.org/drawingml/2006/main">
-            <a:srgbClr val="7451B9"/>
+            <a:srgbClr val="1743A6"/>
           </a:solidFill>
           <a:ln xmlns:a="http://schemas.openxmlformats.org/drawingml/2006/main" w="0">
             <a:solidFill>
-              <a:srgbClr val="7451B9"/>
+              <a:srgbClr val="1743A6"/>
             </a:solidFill>
             <a:prstDash val="solid"/>
           </a:ln>
@@ -1498,7 +1498,7 @@
           <p:cNvPr id="10" name="validate-embed">
             <a:extLst xmlns:a="http://schemas.openxmlformats.org/drawingml/2006/main">
               <a:ext uri="{FF2B5EF4-FFF2-40B4-BE49-F238E27FC236}">
-                <a16:creationId xmlns:a16="http://schemas.microsoft.com/office/drawing/2014/main" id="{732594C6-2886-430E-B743-91209D9B914C}"/>
+                <a16:creationId xmlns:a16="http://schemas.microsoft.com/office/drawing/2014/main" id="{5907E15B-1888-4C56-B178-EB9ACE9C664B}"/>
               </a:ext>
             </a:extLst>
           </p:cNvPr>
@@ -1516,11 +1516,11 @@
             <a:avLst/>
           </a:prstGeom>
           <a:solidFill xmlns:a="http://schemas.openxmlformats.org/drawingml/2006/main">
-            <a:srgbClr val="7451B9"/>
+            <a:srgbClr val="1743A6"/>
           </a:solidFill>
           <a:ln xmlns:a="http://schemas.openxmlformats.org/drawingml/2006/main" w="0">
             <a:solidFill>
-              <a:srgbClr val="7451B9"/>
+              <a:srgbClr val="1743A6"/>
             </a:solidFill>
             <a:prstDash val="solid"/>
           </a:ln>
@@ -1531,7 +1531,7 @@
           <p:cNvPr id="11" name="query-store">
             <a:extLst xmlns:a="http://schemas.openxmlformats.org/drawingml/2006/main">
               <a:ext uri="{FF2B5EF4-FFF2-40B4-BE49-F238E27FC236}">
-                <a16:creationId xmlns:a16="http://schemas.microsoft.com/office/drawing/2014/main" id="{301C40A9-0302-496E-B9CF-33657DCF3E62}"/>
+                <a16:creationId xmlns:a16="http://schemas.microsoft.com/office/drawing/2014/main" id="{74E20F1D-1668-4C04-AECA-37F815922229}"/>
               </a:ext>
             </a:extLst>
           </p:cNvPr>
@@ -1549,11 +1549,11 @@
             <a:avLst/>
           </a:prstGeom>
           <a:solidFill xmlns:a="http://schemas.openxmlformats.org/drawingml/2006/main">
-            <a:srgbClr val="7451B9"/>
+            <a:srgbClr val="1743A6"/>
           </a:solidFill>
           <a:ln xmlns:a="http://schemas.openxmlformats.org/drawingml/2006/main" w="0">
             <a:solidFill>
-              <a:srgbClr val="7451B9"/>
+              <a:srgbClr val="1743A6"/>
             </a:solidFill>
             <a:prstDash val="solid"/>
           </a:ln>
@@ -1564,7 +1564,7 @@
           <p:cNvPr id="12" name="store-retrieve">
             <a:extLst xmlns:a="http://schemas.openxmlformats.org/drawingml/2006/main">
               <a:ext uri="{FF2B5EF4-FFF2-40B4-BE49-F238E27FC236}">
-                <a16:creationId xmlns:a16="http://schemas.microsoft.com/office/drawing/2014/main" id="{63E91FB1-034C-48C3-9B6F-76A98D9D9015}"/>
+                <a16:creationId xmlns:a16="http://schemas.microsoft.com/office/drawing/2014/main" id="{441FCC58-5E2B-4C2E-BB7E-9BF52AA6033A}"/>
               </a:ext>
             </a:extLst>
           </p:cNvPr>
@@ -1582,11 +1582,11 @@
             <a:avLst/>
           </a:prstGeom>
           <a:solidFill xmlns:a="http://schemas.openxmlformats.org/drawingml/2006/main">
-            <a:srgbClr val="7451B9"/>
+            <a:srgbClr val="1743A6"/>
           </a:solidFill>
           <a:ln xmlns:a="http://schemas.openxmlformats.org/drawingml/2006/main" w="0">
             <a:solidFill>
-              <a:srgbClr val="7451B9"/>
+              <a:srgbClr val="1743A6"/>
             </a:solidFill>
             <a:prstDash val="solid"/>
           </a:ln>
@@ -1597,7 +1597,7 @@
           <p:cNvPr id="13" name="retrieve-decision">
             <a:extLst xmlns:a="http://schemas.openxmlformats.org/drawingml/2006/main">
               <a:ext uri="{FF2B5EF4-FFF2-40B4-BE49-F238E27FC236}">
-                <a16:creationId xmlns:a16="http://schemas.microsoft.com/office/drawing/2014/main" id="{67FDEC4F-8957-46D6-9EF4-C3F69E4BE46C}"/>
+                <a16:creationId xmlns:a16="http://schemas.microsoft.com/office/drawing/2014/main" id="{A7FB2E51-8A32-4000-8F95-3071E7332536}"/>
               </a:ext>
             </a:extLst>
           </p:cNvPr>
@@ -1615,11 +1615,11 @@
             <a:avLst/>
           </a:prstGeom>
           <a:solidFill xmlns:a="http://schemas.openxmlformats.org/drawingml/2006/main">
-            <a:srgbClr val="7451B9"/>
+            <a:srgbClr val="1743A6"/>
           </a:solidFill>
           <a:ln xmlns:a="http://schemas.openxmlformats.org/drawingml/2006/main" w="0">
             <a:solidFill>
-              <a:srgbClr val="7451B9"/>
+              <a:srgbClr val="1743A6"/>
             </a:solidFill>
             <a:prstDash val="solid"/>
           </a:ln>
@@ -1630,7 +1630,7 @@
           <p:cNvPr id="14" name="decision-refuse">
             <a:extLst xmlns:a="http://schemas.openxmlformats.org/drawingml/2006/main">
               <a:ext uri="{FF2B5EF4-FFF2-40B4-BE49-F238E27FC236}">
-                <a16:creationId xmlns:a16="http://schemas.microsoft.com/office/drawing/2014/main" id="{2CE3B3AE-CB8B-4FE0-A9D4-FC0B230E617C}"/>
+                <a16:creationId xmlns:a16="http://schemas.microsoft.com/office/drawing/2014/main" id="{F5E5215B-0BF1-4A6A-89F7-AC97434D6BFF}"/>
               </a:ext>
             </a:extLst>
           </p:cNvPr>
@@ -1648,11 +1648,11 @@
             <a:avLst/>
           </a:prstGeom>
           <a:solidFill xmlns:a="http://schemas.openxmlformats.org/drawingml/2006/main">
-            <a:srgbClr val="CC4B3E"/>
+            <a:srgbClr val="C85440"/>
           </a:solidFill>
           <a:ln xmlns:a="http://schemas.openxmlformats.org/drawingml/2006/main" w="0">
             <a:solidFill>
-              <a:srgbClr val="CC4B3E"/>
+              <a:srgbClr val="C85440"/>
             </a:solidFill>
             <a:prstDash val="solid"/>
           </a:ln>
@@ -1663,7 +1663,7 @@
           <p:cNvPr id="15" name="decision-prompt-a">
             <a:extLst xmlns:a="http://schemas.openxmlformats.org/drawingml/2006/main">
               <a:ext uri="{FF2B5EF4-FFF2-40B4-BE49-F238E27FC236}">
-                <a16:creationId xmlns:a16="http://schemas.microsoft.com/office/drawing/2014/main" id="{DF336E09-055F-4DCD-A3FF-D0B70B509A1E}"/>
+                <a16:creationId xmlns:a16="http://schemas.microsoft.com/office/drawing/2014/main" id="{69726E3F-B9B2-42A9-BF7C-8D6DB5E2E8F9}"/>
               </a:ext>
             </a:extLst>
           </p:cNvPr>
@@ -1683,7 +1683,7 @@
           <a:noFill xmlns:a="http://schemas.openxmlformats.org/drawingml/2006/main"/>
           <a:ln xmlns:a="http://schemas.openxmlformats.org/drawingml/2006/main" w="19050">
             <a:solidFill>
-              <a:srgbClr val="7451B9"/>
+              <a:srgbClr val="1743A6"/>
             </a:solidFill>
             <a:prstDash val="solid"/>
           </a:ln>
@@ -1694,7 +1694,7 @@
           <p:cNvPr id="16" name="decision-prompt-b">
             <a:extLst xmlns:a="http://schemas.openxmlformats.org/drawingml/2006/main">
               <a:ext uri="{FF2B5EF4-FFF2-40B4-BE49-F238E27FC236}">
-                <a16:creationId xmlns:a16="http://schemas.microsoft.com/office/drawing/2014/main" id="{A83015E5-3FA7-4E9F-9F97-A75AA9ACE6FA}"/>
+                <a16:creationId xmlns:a16="http://schemas.microsoft.com/office/drawing/2014/main" id="{364E1FC9-354C-4DFA-8C55-86F8D1674ACB}"/>
               </a:ext>
             </a:extLst>
           </p:cNvPr>
@@ -1714,7 +1714,7 @@
           <a:noFill xmlns:a="http://schemas.openxmlformats.org/drawingml/2006/main"/>
           <a:ln xmlns:a="http://schemas.openxmlformats.org/drawingml/2006/main" w="19050">
             <a:solidFill>
-              <a:srgbClr val="7451B9"/>
+              <a:srgbClr val="1743A6"/>
             </a:solidFill>
             <a:prstDash val="solid"/>
           </a:ln>
@@ -1725,7 +1725,7 @@
           <p:cNvPr id="17" name="decision-prompt-c">
             <a:extLst xmlns:a="http://schemas.openxmlformats.org/drawingml/2006/main">
               <a:ext uri="{FF2B5EF4-FFF2-40B4-BE49-F238E27FC236}">
-                <a16:creationId xmlns:a16="http://schemas.microsoft.com/office/drawing/2014/main" id="{588B20B6-481B-4BB9-81DC-04433FAFC7EC}"/>
+                <a16:creationId xmlns:a16="http://schemas.microsoft.com/office/drawing/2014/main" id="{66888487-43C6-4221-A0A2-137C53676953}"/>
               </a:ext>
             </a:extLst>
           </p:cNvPr>
@@ -1743,11 +1743,11 @@
             <a:avLst/>
           </a:prstGeom>
           <a:solidFill xmlns:a="http://schemas.openxmlformats.org/drawingml/2006/main">
-            <a:srgbClr val="7451B9"/>
+            <a:srgbClr val="1743A6"/>
           </a:solidFill>
           <a:ln xmlns:a="http://schemas.openxmlformats.org/drawingml/2006/main" w="0">
             <a:solidFill>
-              <a:srgbClr val="7451B9"/>
+              <a:srgbClr val="1743A6"/>
             </a:solidFill>
             <a:prstDash val="solid"/>
           </a:ln>
@@ -1758,7 +1758,7 @@
           <p:cNvPr id="18" name="prompt-model">
             <a:extLst xmlns:a="http://schemas.openxmlformats.org/drawingml/2006/main">
               <a:ext uri="{FF2B5EF4-FFF2-40B4-BE49-F238E27FC236}">
-                <a16:creationId xmlns:a16="http://schemas.microsoft.com/office/drawing/2014/main" id="{16E9B34C-90DB-4748-BDA1-790EDF1B66E4}"/>
+                <a16:creationId xmlns:a16="http://schemas.microsoft.com/office/drawing/2014/main" id="{1407D16F-C5BE-461F-9AE5-248984BB9C9D}"/>
               </a:ext>
             </a:extLst>
           </p:cNvPr>
@@ -1776,11 +1776,11 @@
             <a:avLst/>
           </a:prstGeom>
           <a:solidFill xmlns:a="http://schemas.openxmlformats.org/drawingml/2006/main">
-            <a:srgbClr val="7451B9"/>
+            <a:srgbClr val="1743A6"/>
           </a:solidFill>
           <a:ln xmlns:a="http://schemas.openxmlformats.org/drawingml/2006/main" w="0">
             <a:solidFill>
-              <a:srgbClr val="7451B9"/>
+              <a:srgbClr val="1743A6"/>
             </a:solidFill>
             <a:prstDash val="solid"/>
           </a:ln>
@@ -1791,7 +1791,7 @@
           <p:cNvPr id="19" name="model-response">
             <a:extLst xmlns:a="http://schemas.openxmlformats.org/drawingml/2006/main">
               <a:ext uri="{FF2B5EF4-FFF2-40B4-BE49-F238E27FC236}">
-                <a16:creationId xmlns:a16="http://schemas.microsoft.com/office/drawing/2014/main" id="{2ED0DDF7-6F3F-4500-A651-740DF17D7039}"/>
+                <a16:creationId xmlns:a16="http://schemas.microsoft.com/office/drawing/2014/main" id="{B3D5B2F3-2EDE-483C-A9C5-0BE9B3A28396}"/>
               </a:ext>
             </a:extLst>
           </p:cNvPr>
@@ -1809,11 +1809,11 @@
             <a:avLst/>
           </a:prstGeom>
           <a:solidFill xmlns:a="http://schemas.openxmlformats.org/drawingml/2006/main">
-            <a:srgbClr val="1769E0"/>
+            <a:srgbClr val="205BE5"/>
           </a:solidFill>
           <a:ln xmlns:a="http://schemas.openxmlformats.org/drawingml/2006/main" w="0">
             <a:solidFill>
-              <a:srgbClr val="1769E0"/>
+              <a:srgbClr val="205BE5"/>
             </a:solidFill>
             <a:prstDash val="solid"/>
           </a:ln>
@@ -1824,7 +1824,7 @@
           <p:cNvPr id="20" name="corpus-label">
             <a:extLst xmlns:a="http://schemas.openxmlformats.org/drawingml/2006/main">
               <a:ext uri="{FF2B5EF4-FFF2-40B4-BE49-F238E27FC236}">
-                <a16:creationId xmlns:a16="http://schemas.microsoft.com/office/drawing/2014/main" id="{78DA1FE1-7229-4D60-961D-21105956688A}"/>
+                <a16:creationId xmlns:a16="http://schemas.microsoft.com/office/drawing/2014/main" id="{C022BC14-4252-425C-932F-5A67DFB23584}"/>
               </a:ext>
             </a:extLst>
           </p:cNvPr>
@@ -1854,14 +1854,14 @@
             <a:pPr algn="l">
               <a:defRPr sz="900" b="1">
                 <a:solidFill>
-                  <a:srgbClr val="1769E0"/>
+                  <a:srgbClr val="205BE5"/>
                 </a:solidFill>
               </a:defRPr>
             </a:pPr>
             <a:r>
               <a:rPr sz="900" b="1">
                 <a:solidFill>
-                  <a:srgbClr val="1769E0"/>
+                  <a:srgbClr val="205BE5"/>
                 </a:solidFill>
               </a:rPr>
               <a:t>01 · BUILD THE CORPUS</a:t>
@@ -1874,7 +1874,7 @@
           <p:cNvPr id="21" name="corpus-copy">
             <a:extLst xmlns:a="http://schemas.openxmlformats.org/drawingml/2006/main">
               <a:ext uri="{FF2B5EF4-FFF2-40B4-BE49-F238E27FC236}">
-                <a16:creationId xmlns:a16="http://schemas.microsoft.com/office/drawing/2014/main" id="{B206BED3-ADCE-4DD5-B882-2019068BBFA2}"/>
+                <a16:creationId xmlns:a16="http://schemas.microsoft.com/office/drawing/2014/main" id="{AFB233D2-7E23-4BF4-80AD-800F65D66B72}"/>
               </a:ext>
             </a:extLst>
           </p:cNvPr>
@@ -1904,14 +1904,14 @@
             <a:pPr algn="l">
               <a:defRPr sz="863" b="0">
                 <a:solidFill>
-                  <a:srgbClr val="64748B"/>
+                  <a:srgbClr val="667085"/>
                 </a:solidFill>
               </a:defRPr>
             </a:pPr>
             <a:r>
               <a:rPr sz="863" b="0">
                 <a:solidFill>
-                  <a:srgbClr val="64748B"/>
+                  <a:srgbClr val="667085"/>
                 </a:solidFill>
               </a:rPr>
               <a:t>18 maintained public guidance URLs</a:t>
@@ -1924,7 +1924,7 @@
           <p:cNvPr id="22" name="doc-back-2">
             <a:extLst xmlns:a="http://schemas.openxmlformats.org/drawingml/2006/main">
               <a:ext uri="{FF2B5EF4-FFF2-40B4-BE49-F238E27FC236}">
-                <a16:creationId xmlns:a16="http://schemas.microsoft.com/office/drawing/2014/main" id="{72BC3583-A070-46F0-90CE-900320AA4F92}"/>
+                <a16:creationId xmlns:a16="http://schemas.microsoft.com/office/drawing/2014/main" id="{E7F7E3E3-391A-47D5-BD3A-A9D404766DE9}"/>
               </a:ext>
             </a:extLst>
           </p:cNvPr>
@@ -1942,11 +1942,11 @@
             <a:avLst/>
           </a:prstGeom>
           <a:solidFill xmlns:a="http://schemas.openxmlformats.org/drawingml/2006/main">
-            <a:srgbClr val="E5F0FF"/>
+            <a:srgbClr val="EAF1FF"/>
           </a:solidFill>
           <a:ln xmlns:a="http://schemas.openxmlformats.org/drawingml/2006/main" w="9525">
             <a:solidFill>
-              <a:srgbClr val="1769E0"/>
+              <a:srgbClr val="205BE5"/>
             </a:solidFill>
             <a:prstDash val="solid"/>
           </a:ln>
@@ -1957,7 +1957,7 @@
           <p:cNvPr id="23" name="doc-back-1">
             <a:extLst xmlns:a="http://schemas.openxmlformats.org/drawingml/2006/main">
               <a:ext uri="{FF2B5EF4-FFF2-40B4-BE49-F238E27FC236}">
-                <a16:creationId xmlns:a16="http://schemas.microsoft.com/office/drawing/2014/main" id="{561936C9-820A-4165-B16C-3011C0245BDA}"/>
+                <a16:creationId xmlns:a16="http://schemas.microsoft.com/office/drawing/2014/main" id="{C71F22D6-5423-43F4-80EA-ABFC8CC1102C}"/>
               </a:ext>
             </a:extLst>
           </p:cNvPr>
@@ -1979,7 +1979,7 @@
           </a:solidFill>
           <a:ln xmlns:a="http://schemas.openxmlformats.org/drawingml/2006/main" w="9525">
             <a:solidFill>
-              <a:srgbClr val="1769E0"/>
+              <a:srgbClr val="205BE5"/>
             </a:solidFill>
             <a:prstDash val="solid"/>
           </a:ln>
@@ -1990,7 +1990,7 @@
           <p:cNvPr id="24" name="doc-front">
             <a:extLst xmlns:a="http://schemas.openxmlformats.org/drawingml/2006/main">
               <a:ext uri="{FF2B5EF4-FFF2-40B4-BE49-F238E27FC236}">
-                <a16:creationId xmlns:a16="http://schemas.microsoft.com/office/drawing/2014/main" id="{898606C2-2D90-45D0-BBC8-4E7EC4C71D8F}"/>
+                <a16:creationId xmlns:a16="http://schemas.microsoft.com/office/drawing/2014/main" id="{4A0FE6EA-2B0F-42CD-8273-E6FD1191018A}"/>
               </a:ext>
             </a:extLst>
           </p:cNvPr>
@@ -2012,7 +2012,7 @@
           </a:solidFill>
           <a:ln xmlns:a="http://schemas.openxmlformats.org/drawingml/2006/main" w="12383">
             <a:solidFill>
-              <a:srgbClr val="1769E0"/>
+              <a:srgbClr val="205BE5"/>
             </a:solidFill>
             <a:prstDash val="solid"/>
           </a:ln>
@@ -2023,7 +2023,7 @@
           <p:cNvPr id="25" name="doc-count">
             <a:extLst xmlns:a="http://schemas.openxmlformats.org/drawingml/2006/main">
               <a:ext uri="{FF2B5EF4-FFF2-40B4-BE49-F238E27FC236}">
-                <a16:creationId xmlns:a16="http://schemas.microsoft.com/office/drawing/2014/main" id="{09CDA344-094C-4AD4-BF55-8501A2E61AF5}"/>
+                <a16:creationId xmlns:a16="http://schemas.microsoft.com/office/drawing/2014/main" id="{B74B195E-2E86-42EF-888D-2E582A5A0E7E}"/>
               </a:ext>
             </a:extLst>
           </p:cNvPr>
@@ -2053,14 +2053,14 @@
             <a:pPr algn="ctr">
               <a:defRPr sz="1800" b="1">
                 <a:solidFill>
-                  <a:srgbClr val="1769E0"/>
+                  <a:srgbClr val="205BE5"/>
                 </a:solidFill>
               </a:defRPr>
             </a:pPr>
             <a:r>
               <a:rPr sz="1800" b="1">
                 <a:solidFill>
-                  <a:srgbClr val="1769E0"/>
+                  <a:srgbClr val="205BE5"/>
                 </a:solidFill>
               </a:rPr>
               <a:t>18</a:t>
@@ -2073,7 +2073,7 @@
           <p:cNvPr id="26" name="doc-label">
             <a:extLst xmlns:a="http://schemas.openxmlformats.org/drawingml/2006/main">
               <a:ext uri="{FF2B5EF4-FFF2-40B4-BE49-F238E27FC236}">
-                <a16:creationId xmlns:a16="http://schemas.microsoft.com/office/drawing/2014/main" id="{8C36C0AB-376B-4313-AEDD-176DB48F645C}"/>
+                <a16:creationId xmlns:a16="http://schemas.microsoft.com/office/drawing/2014/main" id="{61447E3A-3824-4D35-97CD-DBC354523CF9}"/>
               </a:ext>
             </a:extLst>
           </p:cNvPr>
@@ -2103,14 +2103,14 @@
             <a:pPr algn="ctr">
               <a:defRPr sz="825" b="1">
                 <a:solidFill>
-                  <a:srgbClr val="15365F"/>
+                  <a:srgbClr val="172033"/>
                 </a:solidFill>
               </a:defRPr>
             </a:pPr>
             <a:r>
               <a:rPr sz="825" b="1">
                 <a:solidFill>
-                  <a:srgbClr val="15365F"/>
+                  <a:srgbClr val="172033"/>
                 </a:solidFill>
               </a:rPr>
               <a:t>public</a:t>
@@ -2120,14 +2120,14 @@
             <a:pPr algn="ctr">
               <a:defRPr sz="825" b="1">
                 <a:solidFill>
-                  <a:srgbClr val="15365F"/>
+                  <a:srgbClr val="172033"/>
                 </a:solidFill>
               </a:defRPr>
             </a:pPr>
             <a:r>
               <a:rPr sz="825" b="1">
                 <a:solidFill>
-                  <a:srgbClr val="15365F"/>
+                  <a:srgbClr val="172033"/>
                 </a:solidFill>
               </a:rPr>
               <a:t>guides</a:t>
@@ -2140,7 +2140,7 @@
           <p:cNvPr id="27" name="browser-circle">
             <a:extLst xmlns:a="http://schemas.openxmlformats.org/drawingml/2006/main">
               <a:ext uri="{FF2B5EF4-FFF2-40B4-BE49-F238E27FC236}">
-                <a16:creationId xmlns:a16="http://schemas.microsoft.com/office/drawing/2014/main" id="{A552CA10-5A50-4127-BB49-10AF1FADDF2B}"/>
+                <a16:creationId xmlns:a16="http://schemas.microsoft.com/office/drawing/2014/main" id="{D5C42CEB-B671-44FA-BFD7-7C3354458A97}"/>
               </a:ext>
             </a:extLst>
           </p:cNvPr>
@@ -2158,11 +2158,11 @@
             <a:avLst/>
           </a:prstGeom>
           <a:solidFill xmlns:a="http://schemas.openxmlformats.org/drawingml/2006/main">
-            <a:srgbClr val="E5F0FF"/>
+            <a:srgbClr val="EAF1FF"/>
           </a:solidFill>
           <a:ln xmlns:a="http://schemas.openxmlformats.org/drawingml/2006/main" w="14288">
             <a:solidFill>
-              <a:srgbClr val="1769E0"/>
+              <a:srgbClr val="205BE5"/>
             </a:solidFill>
             <a:prstDash val="solid"/>
           </a:ln>
@@ -2173,7 +2173,7 @@
           <p:cNvPr id="28" name="browser-label">
             <a:extLst xmlns:a="http://schemas.openxmlformats.org/drawingml/2006/main">
               <a:ext uri="{FF2B5EF4-FFF2-40B4-BE49-F238E27FC236}">
-                <a16:creationId xmlns:a16="http://schemas.microsoft.com/office/drawing/2014/main" id="{2E10FCDB-6567-41F0-9565-F006F8D11B63}"/>
+                <a16:creationId xmlns:a16="http://schemas.microsoft.com/office/drawing/2014/main" id="{C21E813F-BE5B-456F-895B-426B505D791D}"/>
               </a:ext>
             </a:extLst>
           </p:cNvPr>
@@ -2203,14 +2203,14 @@
             <a:pPr algn="ctr">
               <a:defRPr sz="938" b="1">
                 <a:solidFill>
-                  <a:srgbClr val="1769E0"/>
+                  <a:srgbClr val="205BE5"/>
                 </a:solidFill>
               </a:defRPr>
             </a:pPr>
             <a:r>
               <a:rPr sz="938" b="1">
                 <a:solidFill>
-                  <a:srgbClr val="1769E0"/>
+                  <a:srgbClr val="205BE5"/>
                 </a:solidFill>
               </a:rPr>
               <a:t>Extract</a:t>
@@ -2223,7 +2223,7 @@
           <p:cNvPr id="29" name="browser-detail">
             <a:extLst xmlns:a="http://schemas.openxmlformats.org/drawingml/2006/main">
               <a:ext uri="{FF2B5EF4-FFF2-40B4-BE49-F238E27FC236}">
-                <a16:creationId xmlns:a16="http://schemas.microsoft.com/office/drawing/2014/main" id="{D53D8B05-1F8D-430A-ADED-9899FA7B1285}"/>
+                <a16:creationId xmlns:a16="http://schemas.microsoft.com/office/drawing/2014/main" id="{4FB7D413-D341-4702-BCB5-B93C55A4CC4D}"/>
               </a:ext>
             </a:extLst>
           </p:cNvPr>
@@ -2253,14 +2253,14 @@
             <a:pPr algn="ctr">
               <a:defRPr sz="713" b="0">
                 <a:solidFill>
-                  <a:srgbClr val="64748B"/>
+                  <a:srgbClr val="667085"/>
                 </a:solidFill>
               </a:defRPr>
             </a:pPr>
             <a:r>
               <a:rPr sz="713" b="0">
                 <a:solidFill>
-                  <a:srgbClr val="64748B"/>
+                  <a:srgbClr val="667085"/>
                 </a:solidFill>
               </a:rPr>
               <a:t>Puppeteer</a:t>
@@ -2270,14 +2270,14 @@
             <a:pPr algn="ctr">
               <a:defRPr sz="713" b="0">
                 <a:solidFill>
-                  <a:srgbClr val="64748B"/>
+                  <a:srgbClr val="667085"/>
                 </a:solidFill>
               </a:defRPr>
             </a:pPr>
             <a:r>
               <a:rPr sz="713" b="0">
                 <a:solidFill>
-                  <a:srgbClr val="64748B"/>
+                  <a:srgbClr val="667085"/>
                 </a:solidFill>
               </a:rPr>
               <a:t>one browser</a:t>
@@ -2290,7 +2290,7 @@
           <p:cNvPr id="30" name="chunk-circle">
             <a:extLst xmlns:a="http://schemas.openxmlformats.org/drawingml/2006/main">
               <a:ext uri="{FF2B5EF4-FFF2-40B4-BE49-F238E27FC236}">
-                <a16:creationId xmlns:a16="http://schemas.microsoft.com/office/drawing/2014/main" id="{4D9E15AC-1783-4195-BB1C-D1A1A36E5E58}"/>
+                <a16:creationId xmlns:a16="http://schemas.microsoft.com/office/drawing/2014/main" id="{7F4E8BA4-81C9-4FCB-96A3-57372041063E}"/>
               </a:ext>
             </a:extLst>
           </p:cNvPr>
@@ -2312,7 +2312,7 @@
           </a:solidFill>
           <a:ln xmlns:a="http://schemas.openxmlformats.org/drawingml/2006/main" w="14288">
             <a:solidFill>
-              <a:srgbClr val="15365F"/>
+              <a:srgbClr val="172033"/>
             </a:solidFill>
             <a:prstDash val="solid"/>
           </a:ln>
@@ -2323,7 +2323,7 @@
           <p:cNvPr id="31" name="chunk-label">
             <a:extLst xmlns:a="http://schemas.openxmlformats.org/drawingml/2006/main">
               <a:ext uri="{FF2B5EF4-FFF2-40B4-BE49-F238E27FC236}">
-                <a16:creationId xmlns:a16="http://schemas.microsoft.com/office/drawing/2014/main" id="{012D81EE-4B6E-4C76-BA37-2E818C52678F}"/>
+                <a16:creationId xmlns:a16="http://schemas.microsoft.com/office/drawing/2014/main" id="{C8A56533-2625-44C6-BEEA-821FEAFBF3E3}"/>
               </a:ext>
             </a:extLst>
           </p:cNvPr>
@@ -2353,14 +2353,14 @@
             <a:pPr algn="ctr">
               <a:defRPr sz="938" b="1">
                 <a:solidFill>
-                  <a:srgbClr val="15365F"/>
+                  <a:srgbClr val="172033"/>
                 </a:solidFill>
               </a:defRPr>
             </a:pPr>
             <a:r>
               <a:rPr sz="938" b="1">
                 <a:solidFill>
-                  <a:srgbClr val="15365F"/>
+                  <a:srgbClr val="172033"/>
                 </a:solidFill>
               </a:rPr>
               <a:t>Chunk</a:t>
@@ -2373,7 +2373,7 @@
           <p:cNvPr id="32" name="chunk-detail">
             <a:extLst xmlns:a="http://schemas.openxmlformats.org/drawingml/2006/main">
               <a:ext uri="{FF2B5EF4-FFF2-40B4-BE49-F238E27FC236}">
-                <a16:creationId xmlns:a16="http://schemas.microsoft.com/office/drawing/2014/main" id="{BB730A5B-2313-4998-B4F0-7F0311F45178}"/>
+                <a16:creationId xmlns:a16="http://schemas.microsoft.com/office/drawing/2014/main" id="{92CD90A1-B8EE-4EC6-826B-0E39CCF0E540}"/>
               </a:ext>
             </a:extLst>
           </p:cNvPr>
@@ -2403,14 +2403,14 @@
             <a:pPr algn="ctr">
               <a:defRPr sz="713" b="0">
                 <a:solidFill>
-                  <a:srgbClr val="64748B"/>
+                  <a:srgbClr val="667085"/>
                 </a:solidFill>
               </a:defRPr>
             </a:pPr>
             <a:r>
               <a:rPr sz="713" b="0">
                 <a:solidFill>
-                  <a:srgbClr val="64748B"/>
+                  <a:srgbClr val="667085"/>
                 </a:solidFill>
               </a:rPr>
               <a:t>normalize</a:t>
@@ -2420,14 +2420,14 @@
             <a:pPr algn="ctr">
               <a:defRPr sz="713" b="0">
                 <a:solidFill>
-                  <a:srgbClr val="64748B"/>
+                  <a:srgbClr val="667085"/>
                 </a:solidFill>
               </a:defRPr>
             </a:pPr>
             <a:r>
               <a:rPr sz="713" b="0">
                 <a:solidFill>
-                  <a:srgbClr val="64748B"/>
+                  <a:srgbClr val="667085"/>
                 </a:solidFill>
               </a:rPr>
               <a:t>512 / overlap 100</a:t>
@@ -2440,7 +2440,7 @@
           <p:cNvPr id="33" name="corpus-embed-circle">
             <a:extLst xmlns:a="http://schemas.openxmlformats.org/drawingml/2006/main">
               <a:ext uri="{FF2B5EF4-FFF2-40B4-BE49-F238E27FC236}">
-                <a16:creationId xmlns:a16="http://schemas.microsoft.com/office/drawing/2014/main" id="{067B5AB1-C4AB-4919-B2BC-A0957B9EC865}"/>
+                <a16:creationId xmlns:a16="http://schemas.microsoft.com/office/drawing/2014/main" id="{3A49DD60-8B2B-4580-8976-64D958585487}"/>
               </a:ext>
             </a:extLst>
           </p:cNvPr>
@@ -2458,11 +2458,11 @@
             <a:avLst/>
           </a:prstGeom>
           <a:solidFill xmlns:a="http://schemas.openxmlformats.org/drawingml/2006/main">
-            <a:srgbClr val="E2F4F6"/>
+            <a:srgbClr val="E6F3F2"/>
           </a:solidFill>
           <a:ln xmlns:a="http://schemas.openxmlformats.org/drawingml/2006/main" w="14288">
             <a:solidFill>
-              <a:srgbClr val="1896A8"/>
+              <a:srgbClr val="127B78"/>
             </a:solidFill>
             <a:prstDash val="solid"/>
           </a:ln>
@@ -2473,7 +2473,7 @@
           <p:cNvPr id="34" name="corpus-embed-label">
             <a:extLst xmlns:a="http://schemas.openxmlformats.org/drawingml/2006/main">
               <a:ext uri="{FF2B5EF4-FFF2-40B4-BE49-F238E27FC236}">
-                <a16:creationId xmlns:a16="http://schemas.microsoft.com/office/drawing/2014/main" id="{483F1CC4-A5C1-426E-B0BD-5692E67262E9}"/>
+                <a16:creationId xmlns:a16="http://schemas.microsoft.com/office/drawing/2014/main" id="{E4395439-FAED-462E-A32F-60E64F572637}"/>
               </a:ext>
             </a:extLst>
           </p:cNvPr>
@@ -2503,14 +2503,14 @@
             <a:pPr algn="ctr">
               <a:defRPr sz="938" b="1">
                 <a:solidFill>
-                  <a:srgbClr val="1896A8"/>
+                  <a:srgbClr val="127B78"/>
                 </a:solidFill>
               </a:defRPr>
             </a:pPr>
             <a:r>
               <a:rPr sz="938" b="1">
                 <a:solidFill>
-                  <a:srgbClr val="1896A8"/>
+                  <a:srgbClr val="127B78"/>
                 </a:solidFill>
               </a:rPr>
               <a:t>Embed</a:t>
@@ -2523,7 +2523,7 @@
           <p:cNvPr id="35" name="corpus-embed-detail">
             <a:extLst xmlns:a="http://schemas.openxmlformats.org/drawingml/2006/main">
               <a:ext uri="{FF2B5EF4-FFF2-40B4-BE49-F238E27FC236}">
-                <a16:creationId xmlns:a16="http://schemas.microsoft.com/office/drawing/2014/main" id="{25F998E6-0AED-4D24-B30B-E01D941F3759}"/>
+                <a16:creationId xmlns:a16="http://schemas.microsoft.com/office/drawing/2014/main" id="{6A9185DE-A436-4B8D-B261-79B1C594B478}"/>
               </a:ext>
             </a:extLst>
           </p:cNvPr>
@@ -2553,14 +2553,14 @@
             <a:pPr algn="ctr">
               <a:defRPr sz="713" b="0">
                 <a:solidFill>
-                  <a:srgbClr val="64748B"/>
+                  <a:srgbClr val="667085"/>
                 </a:solidFill>
               </a:defRPr>
             </a:pPr>
             <a:r>
               <a:rPr sz="713" b="0">
                 <a:solidFill>
-                  <a:srgbClr val="64748B"/>
+                  <a:srgbClr val="667085"/>
                 </a:solidFill>
               </a:rPr>
               <a:t>MiniLM-L6-v2</a:t>
@@ -2570,14 +2570,14 @@
             <a:pPr algn="ctr">
               <a:defRPr sz="713" b="0">
                 <a:solidFill>
-                  <a:srgbClr val="64748B"/>
+                  <a:srgbClr val="667085"/>
                 </a:solidFill>
               </a:defRPr>
             </a:pPr>
             <a:r>
               <a:rPr sz="713" b="0">
                 <a:solidFill>
-                  <a:srgbClr val="64748B"/>
+                  <a:srgbClr val="667085"/>
                 </a:solidFill>
               </a:rPr>
               <a:t>384-D normalized</a:t>
@@ -2590,7 +2590,7 @@
           <p:cNvPr id="36" name="astra-outer">
             <a:extLst xmlns:a="http://schemas.openxmlformats.org/drawingml/2006/main">
               <a:ext uri="{FF2B5EF4-FFF2-40B4-BE49-F238E27FC236}">
-                <a16:creationId xmlns:a16="http://schemas.microsoft.com/office/drawing/2014/main" id="{5D6807EB-E060-42DE-A802-9D337B4B2FC1}"/>
+                <a16:creationId xmlns:a16="http://schemas.microsoft.com/office/drawing/2014/main" id="{844B8957-1736-483D-BEC0-FDC1B993FA62}"/>
               </a:ext>
             </a:extLst>
           </p:cNvPr>
@@ -2608,11 +2608,11 @@
             <a:avLst/>
           </a:prstGeom>
           <a:solidFill xmlns:a="http://schemas.openxmlformats.org/drawingml/2006/main">
-            <a:srgbClr val="FFF1B8"/>
+            <a:srgbClr val="FFF1AE"/>
           </a:solidFill>
           <a:ln xmlns:a="http://schemas.openxmlformats.org/drawingml/2006/main" w="17145">
             <a:solidFill>
-              <a:srgbClr val="B77A00"/>
+              <a:srgbClr val="9A6A00"/>
             </a:solidFill>
             <a:prstDash val="solid"/>
           </a:ln>
@@ -2623,7 +2623,7 @@
           <p:cNvPr id="37" name="astra-top">
             <a:extLst xmlns:a="http://schemas.openxmlformats.org/drawingml/2006/main">
               <a:ext uri="{FF2B5EF4-FFF2-40B4-BE49-F238E27FC236}">
-                <a16:creationId xmlns:a16="http://schemas.microsoft.com/office/drawing/2014/main" id="{D7DF7B04-171E-4E14-A693-5A077CD5C67C}"/>
+                <a16:creationId xmlns:a16="http://schemas.microsoft.com/office/drawing/2014/main" id="{F035988A-62CB-463F-AEC2-3DDD49EAA900}"/>
               </a:ext>
             </a:extLst>
           </p:cNvPr>
@@ -2645,7 +2645,7 @@
           </a:solidFill>
           <a:ln xmlns:a="http://schemas.openxmlformats.org/drawingml/2006/main" w="17145">
             <a:solidFill>
-              <a:srgbClr val="B77A00"/>
+              <a:srgbClr val="9A6A00"/>
             </a:solidFill>
             <a:prstDash val="solid"/>
           </a:ln>
@@ -2656,7 +2656,7 @@
           <p:cNvPr id="38" name="astra-bottom">
             <a:extLst xmlns:a="http://schemas.openxmlformats.org/drawingml/2006/main">
               <a:ext uri="{FF2B5EF4-FFF2-40B4-BE49-F238E27FC236}">
-                <a16:creationId xmlns:a16="http://schemas.microsoft.com/office/drawing/2014/main" id="{9AD09C5A-428A-4A94-AE47-D6CAD37298E3}"/>
+                <a16:creationId xmlns:a16="http://schemas.microsoft.com/office/drawing/2014/main" id="{39598258-A47F-4AB5-8429-73CE1CEECE43}"/>
               </a:ext>
             </a:extLst>
           </p:cNvPr>
@@ -2678,7 +2678,7 @@
           </a:solidFill>
           <a:ln xmlns:a="http://schemas.openxmlformats.org/drawingml/2006/main" w="17145">
             <a:solidFill>
-              <a:srgbClr val="B77A00"/>
+              <a:srgbClr val="9A6A00"/>
             </a:solidFill>
             <a:prstDash val="solid"/>
           </a:ln>
@@ -2689,7 +2689,7 @@
           <p:cNvPr id="39" name="astra-kicker">
             <a:extLst xmlns:a="http://schemas.openxmlformats.org/drawingml/2006/main">
               <a:ext uri="{FF2B5EF4-FFF2-40B4-BE49-F238E27FC236}">
-                <a16:creationId xmlns:a16="http://schemas.microsoft.com/office/drawing/2014/main" id="{DB5806FC-BDA4-4A1B-A62D-B481A416CBE9}"/>
+                <a16:creationId xmlns:a16="http://schemas.microsoft.com/office/drawing/2014/main" id="{FDAD84BC-EF98-45A9-91E0-7BCB67DD6819}"/>
               </a:ext>
             </a:extLst>
           </p:cNvPr>
@@ -2719,14 +2719,14 @@
             <a:pPr algn="ctr">
               <a:defRPr sz="750" b="1">
                 <a:solidFill>
-                  <a:srgbClr val="B77A00"/>
+                  <a:srgbClr val="9A6A00"/>
                 </a:solidFill>
               </a:defRPr>
             </a:pPr>
             <a:r>
               <a:rPr sz="750" b="1">
                 <a:solidFill>
-                  <a:srgbClr val="B77A00"/>
+                  <a:srgbClr val="9A6A00"/>
                 </a:solidFill>
               </a:rPr>
               <a:t>SHARED STATE</a:t>
@@ -2739,7 +2739,7 @@
           <p:cNvPr id="40" name="astra-title">
             <a:extLst xmlns:a="http://schemas.openxmlformats.org/drawingml/2006/main">
               <a:ext uri="{FF2B5EF4-FFF2-40B4-BE49-F238E27FC236}">
-                <a16:creationId xmlns:a16="http://schemas.microsoft.com/office/drawing/2014/main" id="{6F728A02-06A7-43E5-867B-2542C0AC5B0D}"/>
+                <a16:creationId xmlns:a16="http://schemas.microsoft.com/office/drawing/2014/main" id="{3F73DF59-9C7B-4D4B-A754-91576E324011}"/>
               </a:ext>
             </a:extLst>
           </p:cNvPr>
@@ -2769,14 +2769,14 @@
             <a:pPr algn="ctr">
               <a:defRPr sz="1500" b="1">
                 <a:solidFill>
-                  <a:srgbClr val="15365F"/>
+                  <a:srgbClr val="172033"/>
                 </a:solidFill>
               </a:defRPr>
             </a:pPr>
             <a:r>
               <a:rPr sz="1500" b="1">
                 <a:solidFill>
-                  <a:srgbClr val="15365F"/>
+                  <a:srgbClr val="172033"/>
                 </a:solidFill>
               </a:rPr>
               <a:t>Astra DB</a:t>
@@ -2789,7 +2789,7 @@
           <p:cNvPr id="41" name="astra-copy">
             <a:extLst xmlns:a="http://schemas.openxmlformats.org/drawingml/2006/main">
               <a:ext uri="{FF2B5EF4-FFF2-40B4-BE49-F238E27FC236}">
-                <a16:creationId xmlns:a16="http://schemas.microsoft.com/office/drawing/2014/main" id="{35402E9C-8EB5-4ADD-AF68-D11EA240E821}"/>
+                <a16:creationId xmlns:a16="http://schemas.microsoft.com/office/drawing/2014/main" id="{44ED77ED-9BD4-4EDF-918A-A31766A5EC0D}"/>
               </a:ext>
             </a:extLst>
           </p:cNvPr>
@@ -2819,14 +2819,14 @@
             <a:pPr algn="ctr">
               <a:defRPr sz="825" b="0">
                 <a:solidFill>
-                  <a:srgbClr val="12223D"/>
+                  <a:srgbClr val="172033"/>
                 </a:solidFill>
               </a:defRPr>
             </a:pPr>
             <a:r>
               <a:rPr sz="825" b="0">
                 <a:solidFill>
-                  <a:srgbClr val="12223D"/>
+                  <a:srgbClr val="172033"/>
                 </a:solidFill>
               </a:rPr>
               <a:t>vector collection</a:t>
@@ -2836,14 +2836,14 @@
             <a:pPr algn="ctr">
               <a:defRPr sz="825" b="0">
                 <a:solidFill>
-                  <a:srgbClr val="12223D"/>
+                  <a:srgbClr val="172033"/>
                 </a:solidFill>
               </a:defRPr>
             </a:pPr>
             <a:r>
               <a:rPr sz="825" b="0">
                 <a:solidFill>
-                  <a:srgbClr val="12223D"/>
+                  <a:srgbClr val="172033"/>
                 </a:solidFill>
               </a:rPr>
               <a:t>source metadata</a:t>
@@ -2853,14 +2853,14 @@
             <a:pPr algn="ctr">
               <a:defRPr sz="825" b="0">
                 <a:solidFill>
-                  <a:srgbClr val="12223D"/>
+                  <a:srgbClr val="172033"/>
                 </a:solidFill>
               </a:defRPr>
             </a:pPr>
             <a:r>
               <a:rPr sz="825" b="0">
                 <a:solidFill>
-                  <a:srgbClr val="12223D"/>
+                  <a:srgbClr val="172033"/>
                 </a:solidFill>
               </a:rPr>
               <a:t>dot-product search</a:t>
@@ -2873,7 +2873,7 @@
           <p:cNvPr id="42" name="astra-divider">
             <a:extLst xmlns:a="http://schemas.openxmlformats.org/drawingml/2006/main">
               <a:ext uri="{FF2B5EF4-FFF2-40B4-BE49-F238E27FC236}">
-                <a16:creationId xmlns:a16="http://schemas.microsoft.com/office/drawing/2014/main" id="{6E4FA402-464E-44E2-A9A3-BD13E158C0E2}"/>
+                <a16:creationId xmlns:a16="http://schemas.microsoft.com/office/drawing/2014/main" id="{91FFD754-F126-4ED4-B256-4725A57080C6}"/>
               </a:ext>
             </a:extLst>
           </p:cNvPr>
@@ -2893,7 +2893,7 @@
           <a:noFill xmlns:a="http://schemas.openxmlformats.org/drawingml/2006/main"/>
           <a:ln xmlns:a="http://schemas.openxmlformats.org/drawingml/2006/main" w="10478">
             <a:solidFill>
-              <a:srgbClr val="B77A00"/>
+              <a:srgbClr val="9A6A00"/>
             </a:solidFill>
             <a:prstDash val="solid"/>
           </a:ln>
@@ -2904,7 +2904,7 @@
           <p:cNvPr id="43" name="astra-secret">
             <a:extLst xmlns:a="http://schemas.openxmlformats.org/drawingml/2006/main">
               <a:ext uri="{FF2B5EF4-FFF2-40B4-BE49-F238E27FC236}">
-                <a16:creationId xmlns:a16="http://schemas.microsoft.com/office/drawing/2014/main" id="{FC4CFD0A-518D-44BB-9448-DB7D289F91F6}"/>
+                <a16:creationId xmlns:a16="http://schemas.microsoft.com/office/drawing/2014/main" id="{5257BA0B-191B-4EB1-A366-308F6D0E279C}"/>
               </a:ext>
             </a:extLst>
           </p:cNvPr>
@@ -2934,14 +2934,14 @@
             <a:pPr algn="ctr">
               <a:defRPr sz="713" b="0">
                 <a:solidFill>
-                  <a:srgbClr val="64748B"/>
+                  <a:srgbClr val="667085"/>
                 </a:solidFill>
               </a:defRPr>
             </a:pPr>
             <a:r>
               <a:rPr sz="713" b="0">
                 <a:solidFill>
-                  <a:srgbClr val="64748B"/>
+                  <a:srgbClr val="667085"/>
                 </a:solidFill>
               </a:rPr>
               <a:t>server-side token</a:t>
@@ -2954,7 +2954,7 @@
           <p:cNvPr id="44" name="query-label">
             <a:extLst xmlns:a="http://schemas.openxmlformats.org/drawingml/2006/main">
               <a:ext uri="{FF2B5EF4-FFF2-40B4-BE49-F238E27FC236}">
-                <a16:creationId xmlns:a16="http://schemas.microsoft.com/office/drawing/2014/main" id="{F5D23464-2B1B-45E4-9F8E-5876CF7DC804}"/>
+                <a16:creationId xmlns:a16="http://schemas.microsoft.com/office/drawing/2014/main" id="{8097A3EC-15E4-4E43-A89A-B05C67ED4439}"/>
               </a:ext>
             </a:extLst>
           </p:cNvPr>
@@ -2984,14 +2984,14 @@
             <a:pPr algn="l">
               <a:defRPr sz="900" b="1">
                 <a:solidFill>
-                  <a:srgbClr val="7451B9"/>
+                  <a:srgbClr val="1743A6"/>
                 </a:solidFill>
               </a:defRPr>
             </a:pPr>
             <a:r>
               <a:rPr sz="900" b="1">
                 <a:solidFill>
-                  <a:srgbClr val="7451B9"/>
+                  <a:srgbClr val="1743A6"/>
                 </a:solidFill>
               </a:rPr>
               <a:t>02 · ANSWER A QUESTION</a:t>
@@ -3004,7 +3004,7 @@
           <p:cNvPr id="45" name="query-copy">
             <a:extLst xmlns:a="http://schemas.openxmlformats.org/drawingml/2006/main">
               <a:ext uri="{FF2B5EF4-FFF2-40B4-BE49-F238E27FC236}">
-                <a16:creationId xmlns:a16="http://schemas.microsoft.com/office/drawing/2014/main" id="{9460E42D-2C00-417E-A358-00B923E51E59}"/>
+                <a16:creationId xmlns:a16="http://schemas.microsoft.com/office/drawing/2014/main" id="{C6150592-AECC-40EA-BB3D-1B3E79E7DDA0}"/>
               </a:ext>
             </a:extLst>
           </p:cNvPr>
@@ -3034,14 +3034,14 @@
             <a:pPr algn="l">
               <a:defRPr sz="863" b="0">
                 <a:solidFill>
-                  <a:srgbClr val="64748B"/>
+                  <a:srgbClr val="667085"/>
                 </a:solidFill>
               </a:defRPr>
             </a:pPr>
             <a:r>
               <a:rPr sz="863" b="0">
                 <a:solidFill>
-                  <a:srgbClr val="64748B"/>
+                  <a:srgbClr val="667085"/>
                 </a:solidFill>
               </a:rPr>
               <a:t>The latest user message enters the same vector space.</a:t>
@@ -3054,7 +3054,7 @@
           <p:cNvPr id="46" name="question">
             <a:extLst xmlns:a="http://schemas.openxmlformats.org/drawingml/2006/main">
               <a:ext uri="{FF2B5EF4-FFF2-40B4-BE49-F238E27FC236}">
-                <a16:creationId xmlns:a16="http://schemas.microsoft.com/office/drawing/2014/main" id="{119F3DBA-36B8-463A-BC22-6EEF0E841216}"/>
+                <a16:creationId xmlns:a16="http://schemas.microsoft.com/office/drawing/2014/main" id="{A7B59697-5B79-4883-83F7-1E206BF46CCD}"/>
               </a:ext>
             </a:extLst>
           </p:cNvPr>
@@ -3074,11 +3074,11 @@
             </a:avLst>
           </a:prstGeom>
           <a:solidFill xmlns:a="http://schemas.openxmlformats.org/drawingml/2006/main">
-            <a:srgbClr val="EEE8FA"/>
+            <a:srgbClr val="EAF1FF"/>
           </a:solidFill>
           <a:ln xmlns:a="http://schemas.openxmlformats.org/drawingml/2006/main" w="12383">
             <a:solidFill>
-              <a:srgbClr val="7451B9"/>
+              <a:srgbClr val="1743A6"/>
             </a:solidFill>
             <a:prstDash val="solid"/>
           </a:ln>
@@ -3089,7 +3089,7 @@
           <p:cNvPr id="47" name="question-title">
             <a:extLst xmlns:a="http://schemas.openxmlformats.org/drawingml/2006/main">
               <a:ext uri="{FF2B5EF4-FFF2-40B4-BE49-F238E27FC236}">
-                <a16:creationId xmlns:a16="http://schemas.microsoft.com/office/drawing/2014/main" id="{F79165DB-159B-491B-B05B-DD7FD0FBAF74}"/>
+                <a16:creationId xmlns:a16="http://schemas.microsoft.com/office/drawing/2014/main" id="{61C4B6C4-4772-432B-A995-BFD814C45E88}"/>
               </a:ext>
             </a:extLst>
           </p:cNvPr>
@@ -3119,14 +3119,14 @@
             <a:pPr algn="ctr">
               <a:defRPr sz="975" b="1">
                 <a:solidFill>
-                  <a:srgbClr val="7451B9"/>
+                  <a:srgbClr val="1743A6"/>
                 </a:solidFill>
               </a:defRPr>
             </a:pPr>
             <a:r>
               <a:rPr sz="975" b="1">
                 <a:solidFill>
-                  <a:srgbClr val="7451B9"/>
+                  <a:srgbClr val="1743A6"/>
                 </a:solidFill>
               </a:rPr>
               <a:t>Question</a:t>
@@ -3139,7 +3139,7 @@
           <p:cNvPr id="48" name="question-copy">
             <a:extLst xmlns:a="http://schemas.openxmlformats.org/drawingml/2006/main">
               <a:ext uri="{FF2B5EF4-FFF2-40B4-BE49-F238E27FC236}">
-                <a16:creationId xmlns:a16="http://schemas.microsoft.com/office/drawing/2014/main" id="{8F5C530F-CAEB-48B1-B9A0-D12BFC119724}"/>
+                <a16:creationId xmlns:a16="http://schemas.microsoft.com/office/drawing/2014/main" id="{1C4C6838-8B59-4C86-AA66-1CBAF23F634C}"/>
               </a:ext>
             </a:extLst>
           </p:cNvPr>
@@ -3169,14 +3169,14 @@
             <a:pPr algn="ctr">
               <a:defRPr sz="713" b="0">
                 <a:solidFill>
-                  <a:srgbClr val="64748B"/>
+                  <a:srgbClr val="667085"/>
                 </a:solidFill>
               </a:defRPr>
             </a:pPr>
             <a:r>
               <a:rPr sz="713" b="0">
                 <a:solidFill>
-                  <a:srgbClr val="64748B"/>
+                  <a:srgbClr val="667085"/>
                 </a:solidFill>
               </a:rPr>
               <a:t>latest turn</a:t>
@@ -3189,7 +3189,7 @@
           <p:cNvPr id="49" name="validate-circle">
             <a:extLst xmlns:a="http://schemas.openxmlformats.org/drawingml/2006/main">
               <a:ext uri="{FF2B5EF4-FFF2-40B4-BE49-F238E27FC236}">
-                <a16:creationId xmlns:a16="http://schemas.microsoft.com/office/drawing/2014/main" id="{16776A50-8272-4C93-86CF-E31F8E161EC0}"/>
+                <a16:creationId xmlns:a16="http://schemas.microsoft.com/office/drawing/2014/main" id="{14A64111-00EB-498D-9050-80A032DEFAA7}"/>
               </a:ext>
             </a:extLst>
           </p:cNvPr>
@@ -3211,7 +3211,7 @@
           </a:solidFill>
           <a:ln xmlns:a="http://schemas.openxmlformats.org/drawingml/2006/main" w="14288">
             <a:solidFill>
-              <a:srgbClr val="15365F"/>
+              <a:srgbClr val="172033"/>
             </a:solidFill>
             <a:prstDash val="solid"/>
           </a:ln>
@@ -3222,7 +3222,7 @@
           <p:cNvPr id="50" name="validate-label">
             <a:extLst xmlns:a="http://schemas.openxmlformats.org/drawingml/2006/main">
               <a:ext uri="{FF2B5EF4-FFF2-40B4-BE49-F238E27FC236}">
-                <a16:creationId xmlns:a16="http://schemas.microsoft.com/office/drawing/2014/main" id="{9E95D48C-0125-43B9-B1FF-1E419EA1EF1F}"/>
+                <a16:creationId xmlns:a16="http://schemas.microsoft.com/office/drawing/2014/main" id="{65B46CAF-1F88-451B-9BE8-0A7F367DEC69}"/>
               </a:ext>
             </a:extLst>
           </p:cNvPr>
@@ -3252,14 +3252,14 @@
             <a:pPr algn="ctr">
               <a:defRPr sz="938" b="1">
                 <a:solidFill>
-                  <a:srgbClr val="15365F"/>
+                  <a:srgbClr val="172033"/>
                 </a:solidFill>
               </a:defRPr>
             </a:pPr>
             <a:r>
               <a:rPr sz="938" b="1">
                 <a:solidFill>
-                  <a:srgbClr val="15365F"/>
+                  <a:srgbClr val="172033"/>
                 </a:solidFill>
               </a:rPr>
               <a:t>Validate</a:t>
@@ -3272,7 +3272,7 @@
           <p:cNvPr id="51" name="validate-detail">
             <a:extLst xmlns:a="http://schemas.openxmlformats.org/drawingml/2006/main">
               <a:ext uri="{FF2B5EF4-FFF2-40B4-BE49-F238E27FC236}">
-                <a16:creationId xmlns:a16="http://schemas.microsoft.com/office/drawing/2014/main" id="{7093C7E6-001E-4127-85BE-E71A0B20C34C}"/>
+                <a16:creationId xmlns:a16="http://schemas.microsoft.com/office/drawing/2014/main" id="{F3E9E68A-723C-4A0B-BA7E-AD32289905CE}"/>
               </a:ext>
             </a:extLst>
           </p:cNvPr>
@@ -3302,14 +3302,14 @@
             <a:pPr algn="ctr">
               <a:defRPr sz="713" b="0">
                 <a:solidFill>
-                  <a:srgbClr val="64748B"/>
+                  <a:srgbClr val="667085"/>
                 </a:solidFill>
               </a:defRPr>
             </a:pPr>
             <a:r>
               <a:rPr sz="713" b="0">
                 <a:solidFill>
-                  <a:srgbClr val="64748B"/>
+                  <a:srgbClr val="667085"/>
                 </a:solidFill>
               </a:rPr>
               <a:t>1–20 messages</a:t>
@@ -3319,14 +3319,14 @@
             <a:pPr algn="ctr">
               <a:defRPr sz="713" b="0">
                 <a:solidFill>
-                  <a:srgbClr val="64748B"/>
+                  <a:srgbClr val="667085"/>
                 </a:solidFill>
               </a:defRPr>
             </a:pPr>
             <a:r>
               <a:rPr sz="713" b="0">
                 <a:solidFill>
-                  <a:srgbClr val="64748B"/>
+                  <a:srgbClr val="667085"/>
                 </a:solidFill>
               </a:rPr>
               <a:t>≤2,000 chars</a:t>
@@ -3339,7 +3339,7 @@
           <p:cNvPr id="52" name="query-embed-circle">
             <a:extLst xmlns:a="http://schemas.openxmlformats.org/drawingml/2006/main">
               <a:ext uri="{FF2B5EF4-FFF2-40B4-BE49-F238E27FC236}">
-                <a16:creationId xmlns:a16="http://schemas.microsoft.com/office/drawing/2014/main" id="{1A16CA10-A3A7-45B5-8921-9647B74F1D2D}"/>
+                <a16:creationId xmlns:a16="http://schemas.microsoft.com/office/drawing/2014/main" id="{24D8B786-43BB-4FAF-8302-C83DAE9829E7}"/>
               </a:ext>
             </a:extLst>
           </p:cNvPr>
@@ -3357,11 +3357,11 @@
             <a:avLst/>
           </a:prstGeom>
           <a:solidFill xmlns:a="http://schemas.openxmlformats.org/drawingml/2006/main">
-            <a:srgbClr val="E2F4F6"/>
+            <a:srgbClr val="E6F3F2"/>
           </a:solidFill>
           <a:ln xmlns:a="http://schemas.openxmlformats.org/drawingml/2006/main" w="14288">
             <a:solidFill>
-              <a:srgbClr val="1896A8"/>
+              <a:srgbClr val="127B78"/>
             </a:solidFill>
             <a:prstDash val="solid"/>
           </a:ln>
@@ -3372,7 +3372,7 @@
           <p:cNvPr id="53" name="query-embed-label">
             <a:extLst xmlns:a="http://schemas.openxmlformats.org/drawingml/2006/main">
               <a:ext uri="{FF2B5EF4-FFF2-40B4-BE49-F238E27FC236}">
-                <a16:creationId xmlns:a16="http://schemas.microsoft.com/office/drawing/2014/main" id="{CD0F6C30-0641-47AF-AD92-91D5094438F4}"/>
+                <a16:creationId xmlns:a16="http://schemas.microsoft.com/office/drawing/2014/main" id="{E4EE4067-0B3A-4474-813E-B2D272920430}"/>
               </a:ext>
             </a:extLst>
           </p:cNvPr>
@@ -3402,14 +3402,14 @@
             <a:pPr algn="ctr">
               <a:defRPr sz="938" b="1">
                 <a:solidFill>
-                  <a:srgbClr val="1896A8"/>
+                  <a:srgbClr val="127B78"/>
                 </a:solidFill>
               </a:defRPr>
             </a:pPr>
             <a:r>
               <a:rPr sz="938" b="1">
                 <a:solidFill>
-                  <a:srgbClr val="1896A8"/>
+                  <a:srgbClr val="127B78"/>
                 </a:solidFill>
               </a:rPr>
               <a:t>Embed</a:t>
@@ -3422,7 +3422,7 @@
           <p:cNvPr id="54" name="query-embed-detail">
             <a:extLst xmlns:a="http://schemas.openxmlformats.org/drawingml/2006/main">
               <a:ext uri="{FF2B5EF4-FFF2-40B4-BE49-F238E27FC236}">
-                <a16:creationId xmlns:a16="http://schemas.microsoft.com/office/drawing/2014/main" id="{E4DA9E3F-7863-46C5-BC19-505261641F92}"/>
+                <a16:creationId xmlns:a16="http://schemas.microsoft.com/office/drawing/2014/main" id="{3D1B7711-87E6-48FC-A56D-33FA62CF9A0B}"/>
               </a:ext>
             </a:extLst>
           </p:cNvPr>
@@ -3452,14 +3452,14 @@
             <a:pPr algn="ctr">
               <a:defRPr sz="713" b="0">
                 <a:solidFill>
-                  <a:srgbClr val="64748B"/>
+                  <a:srgbClr val="667085"/>
                 </a:solidFill>
               </a:defRPr>
             </a:pPr>
             <a:r>
               <a:rPr sz="713" b="0">
                 <a:solidFill>
-                  <a:srgbClr val="64748B"/>
+                  <a:srgbClr val="667085"/>
                 </a:solidFill>
               </a:rPr>
               <a:t>same MiniLM</a:t>
@@ -3469,14 +3469,14 @@
             <a:pPr algn="ctr">
               <a:defRPr sz="713" b="0">
                 <a:solidFill>
-                  <a:srgbClr val="64748B"/>
+                  <a:srgbClr val="667085"/>
                 </a:solidFill>
               </a:defRPr>
             </a:pPr>
             <a:r>
               <a:rPr sz="713" b="0">
                 <a:solidFill>
-                  <a:srgbClr val="64748B"/>
+                  <a:srgbClr val="667085"/>
                 </a:solidFill>
               </a:rPr>
               <a:t>vector space</a:t>
@@ -3489,7 +3489,7 @@
           <p:cNvPr id="55" name="retrieve-circle">
             <a:extLst xmlns:a="http://schemas.openxmlformats.org/drawingml/2006/main">
               <a:ext uri="{FF2B5EF4-FFF2-40B4-BE49-F238E27FC236}">
-                <a16:creationId xmlns:a16="http://schemas.microsoft.com/office/drawing/2014/main" id="{7AF78818-3199-48B7-BB21-542D663DE2E8}"/>
+                <a16:creationId xmlns:a16="http://schemas.microsoft.com/office/drawing/2014/main" id="{8B01347F-4981-4015-ACDC-D7FBDE5BCC96}"/>
               </a:ext>
             </a:extLst>
           </p:cNvPr>
@@ -3507,11 +3507,11 @@
             <a:avLst/>
           </a:prstGeom>
           <a:solidFill xmlns:a="http://schemas.openxmlformats.org/drawingml/2006/main">
-            <a:srgbClr val="EEE8FA"/>
+            <a:srgbClr val="EAF1FF"/>
           </a:solidFill>
           <a:ln xmlns:a="http://schemas.openxmlformats.org/drawingml/2006/main" w="14288">
             <a:solidFill>
-              <a:srgbClr val="7451B9"/>
+              <a:srgbClr val="1743A6"/>
             </a:solidFill>
             <a:prstDash val="solid"/>
           </a:ln>
@@ -3522,7 +3522,7 @@
           <p:cNvPr id="56" name="retrieve-label">
             <a:extLst xmlns:a="http://schemas.openxmlformats.org/drawingml/2006/main">
               <a:ext uri="{FF2B5EF4-FFF2-40B4-BE49-F238E27FC236}">
-                <a16:creationId xmlns:a16="http://schemas.microsoft.com/office/drawing/2014/main" id="{14DC8F86-862E-43C3-A7FF-160577534E05}"/>
+                <a16:creationId xmlns:a16="http://schemas.microsoft.com/office/drawing/2014/main" id="{298DD323-4956-435B-B818-929239565D9B}"/>
               </a:ext>
             </a:extLst>
           </p:cNvPr>
@@ -3552,14 +3552,14 @@
             <a:pPr algn="ctr">
               <a:defRPr sz="938" b="1">
                 <a:solidFill>
-                  <a:srgbClr val="7451B9"/>
+                  <a:srgbClr val="1743A6"/>
                 </a:solidFill>
               </a:defRPr>
             </a:pPr>
             <a:r>
               <a:rPr sz="938" b="1">
                 <a:solidFill>
-                  <a:srgbClr val="7451B9"/>
+                  <a:srgbClr val="1743A6"/>
                 </a:solidFill>
               </a:rPr>
               <a:t>Top 6</a:t>
@@ -3572,7 +3572,7 @@
           <p:cNvPr id="57" name="retrieve-detail">
             <a:extLst xmlns:a="http://schemas.openxmlformats.org/drawingml/2006/main">
               <a:ext uri="{FF2B5EF4-FFF2-40B4-BE49-F238E27FC236}">
-                <a16:creationId xmlns:a16="http://schemas.microsoft.com/office/drawing/2014/main" id="{A0AA64F9-2C59-4683-A434-B7919BDF4107}"/>
+                <a16:creationId xmlns:a16="http://schemas.microsoft.com/office/drawing/2014/main" id="{B2B0D33D-C1FA-440B-AB5D-F5B6981FB2A7}"/>
               </a:ext>
             </a:extLst>
           </p:cNvPr>
@@ -3602,14 +3602,14 @@
             <a:pPr algn="ctr">
               <a:defRPr sz="713" b="0">
                 <a:solidFill>
-                  <a:srgbClr val="64748B"/>
+                  <a:srgbClr val="667085"/>
                 </a:solidFill>
               </a:defRPr>
             </a:pPr>
             <a:r>
               <a:rPr sz="713" b="0">
                 <a:solidFill>
-                  <a:srgbClr val="64748B"/>
+                  <a:srgbClr val="667085"/>
                 </a:solidFill>
               </a:rPr>
               <a:t>usable text</a:t>
@@ -3619,14 +3619,14 @@
             <a:pPr algn="ctr">
               <a:defRPr sz="713" b="0">
                 <a:solidFill>
-                  <a:srgbClr val="64748B"/>
+                  <a:srgbClr val="667085"/>
                 </a:solidFill>
               </a:defRPr>
             </a:pPr>
             <a:r>
               <a:rPr sz="713" b="0">
                 <a:solidFill>
-                  <a:srgbClr val="64748B"/>
+                  <a:srgbClr val="667085"/>
                 </a:solidFill>
               </a:rPr>
               <a:t>only</a:t>
@@ -3639,7 +3639,7 @@
           <p:cNvPr id="58" name="evidence-gate">
             <a:extLst xmlns:a="http://schemas.openxmlformats.org/drawingml/2006/main">
               <a:ext uri="{FF2B5EF4-FFF2-40B4-BE49-F238E27FC236}">
-                <a16:creationId xmlns:a16="http://schemas.microsoft.com/office/drawing/2014/main" id="{52BF2E34-90A8-42AA-BA06-92F43EB5FBCC}"/>
+                <a16:creationId xmlns:a16="http://schemas.microsoft.com/office/drawing/2014/main" id="{868E0AE6-4EFD-4077-B73A-2F6671F4F329}"/>
               </a:ext>
             </a:extLst>
           </p:cNvPr>
@@ -3657,11 +3657,11 @@
             <a:avLst/>
           </a:prstGeom>
           <a:solidFill xmlns:a="http://schemas.openxmlformats.org/drawingml/2006/main">
-            <a:srgbClr val="FFFFFF"/>
+            <a:srgbClr val="FFF1AE"/>
           </a:solidFill>
           <a:ln xmlns:a="http://schemas.openxmlformats.org/drawingml/2006/main" w="14288">
             <a:solidFill>
-              <a:srgbClr val="7451B9"/>
+              <a:srgbClr val="9A6A00"/>
             </a:solidFill>
             <a:prstDash val="solid"/>
           </a:ln>
@@ -3672,7 +3672,7 @@
           <p:cNvPr id="59" name="gate-text">
             <a:extLst xmlns:a="http://schemas.openxmlformats.org/drawingml/2006/main">
               <a:ext uri="{FF2B5EF4-FFF2-40B4-BE49-F238E27FC236}">
-                <a16:creationId xmlns:a16="http://schemas.microsoft.com/office/drawing/2014/main" id="{E2A18170-72A3-4B56-982B-6BF89CEFDDA2}"/>
+                <a16:creationId xmlns:a16="http://schemas.microsoft.com/office/drawing/2014/main" id="{6AFAA394-A57F-4A01-B217-F4BC7AD2FDC5}"/>
               </a:ext>
             </a:extLst>
           </p:cNvPr>
@@ -3702,14 +3702,14 @@
             <a:pPr algn="ctr">
               <a:defRPr sz="788" b="1">
                 <a:solidFill>
-                  <a:srgbClr val="7451B9"/>
+                  <a:srgbClr val="9A6A00"/>
                 </a:solidFill>
               </a:defRPr>
             </a:pPr>
             <a:r>
               <a:rPr sz="788" b="1">
                 <a:solidFill>
-                  <a:srgbClr val="7451B9"/>
+                  <a:srgbClr val="9A6A00"/>
                 </a:solidFill>
               </a:rPr>
               <a:t>text?</a:t>
@@ -3722,7 +3722,7 @@
           <p:cNvPr id="60" name="prompt">
             <a:extLst xmlns:a="http://schemas.openxmlformats.org/drawingml/2006/main">
               <a:ext uri="{FF2B5EF4-FFF2-40B4-BE49-F238E27FC236}">
-                <a16:creationId xmlns:a16="http://schemas.microsoft.com/office/drawing/2014/main" id="{AFE11DD7-33FC-480A-A2BE-BF9BCB6AE5F0}"/>
+                <a16:creationId xmlns:a16="http://schemas.microsoft.com/office/drawing/2014/main" id="{5F5E6A4A-FCA4-4A11-BA31-C1347C7B925E}"/>
               </a:ext>
             </a:extLst>
           </p:cNvPr>
@@ -3742,11 +3742,11 @@
             </a:avLst>
           </a:prstGeom>
           <a:solidFill xmlns:a="http://schemas.openxmlformats.org/drawingml/2006/main">
-            <a:srgbClr val="EEE8FA"/>
+            <a:srgbClr val="E6F3F2"/>
           </a:solidFill>
           <a:ln xmlns:a="http://schemas.openxmlformats.org/drawingml/2006/main" w="12383">
             <a:solidFill>
-              <a:srgbClr val="7451B9"/>
+              <a:srgbClr val="127B78"/>
             </a:solidFill>
             <a:prstDash val="solid"/>
           </a:ln>
@@ -3757,7 +3757,7 @@
           <p:cNvPr id="61" name="prompt-title">
             <a:extLst xmlns:a="http://schemas.openxmlformats.org/drawingml/2006/main">
               <a:ext uri="{FF2B5EF4-FFF2-40B4-BE49-F238E27FC236}">
-                <a16:creationId xmlns:a16="http://schemas.microsoft.com/office/drawing/2014/main" id="{F68C61C5-1A61-49AA-9FA7-EC85DA0BE6BD}"/>
+                <a16:creationId xmlns:a16="http://schemas.microsoft.com/office/drawing/2014/main" id="{08636C55-5AD2-4615-BCA5-A08A8CF89255}"/>
               </a:ext>
             </a:extLst>
           </p:cNvPr>
@@ -3787,14 +3787,14 @@
             <a:pPr algn="ctr">
               <a:defRPr sz="863" b="1">
                 <a:solidFill>
-                  <a:srgbClr val="7451B9"/>
+                  <a:srgbClr val="127B78"/>
                 </a:solidFill>
               </a:defRPr>
             </a:pPr>
             <a:r>
               <a:rPr sz="863" b="1">
                 <a:solidFill>
-                  <a:srgbClr val="7451B9"/>
+                  <a:srgbClr val="127B78"/>
                 </a:solidFill>
               </a:rPr>
               <a:t>Grounded prompt</a:t>
@@ -3807,7 +3807,7 @@
           <p:cNvPr id="62" name="prompt-note">
             <a:extLst xmlns:a="http://schemas.openxmlformats.org/drawingml/2006/main">
               <a:ext uri="{FF2B5EF4-FFF2-40B4-BE49-F238E27FC236}">
-                <a16:creationId xmlns:a16="http://schemas.microsoft.com/office/drawing/2014/main" id="{F81DCACE-C6AA-481E-94FC-54FD9C40BF1A}"/>
+                <a16:creationId xmlns:a16="http://schemas.microsoft.com/office/drawing/2014/main" id="{57248EAA-DA18-4ACA-B398-022CA1E0C984}"/>
               </a:ext>
             </a:extLst>
           </p:cNvPr>
@@ -3837,14 +3837,14 @@
             <a:pPr algn="ctr">
               <a:defRPr sz="660" b="0">
                 <a:solidFill>
-                  <a:srgbClr val="64748B"/>
+                  <a:srgbClr val="667085"/>
                 </a:solidFill>
               </a:defRPr>
             </a:pPr>
             <a:r>
               <a:rPr sz="660" b="0">
                 <a:solidFill>
-                  <a:srgbClr val="64748B"/>
+                  <a:srgbClr val="667085"/>
                 </a:solidFill>
               </a:rPr>
               <a:t>context only</a:t>
@@ -3857,7 +3857,7 @@
           <p:cNvPr id="63" name="model">
             <a:extLst xmlns:a="http://schemas.openxmlformats.org/drawingml/2006/main">
               <a:ext uri="{FF2B5EF4-FFF2-40B4-BE49-F238E27FC236}">
-                <a16:creationId xmlns:a16="http://schemas.microsoft.com/office/drawing/2014/main" id="{91DE846B-07F8-4E33-80BC-329EE137A5A4}"/>
+                <a16:creationId xmlns:a16="http://schemas.microsoft.com/office/drawing/2014/main" id="{DE0A77B6-28B0-45FF-99CF-DFDA4DB222D6}"/>
               </a:ext>
             </a:extLst>
           </p:cNvPr>
@@ -3875,11 +3875,11 @@
             <a:avLst/>
           </a:prstGeom>
           <a:solidFill xmlns:a="http://schemas.openxmlformats.org/drawingml/2006/main">
-            <a:srgbClr val="E5F0FF"/>
+            <a:srgbClr val="EAF1FF"/>
           </a:solidFill>
           <a:ln xmlns:a="http://schemas.openxmlformats.org/drawingml/2006/main" w="14288">
             <a:solidFill>
-              <a:srgbClr val="1769E0"/>
+              <a:srgbClr val="205BE5"/>
             </a:solidFill>
             <a:prstDash val="solid"/>
           </a:ln>
@@ -3890,7 +3890,7 @@
           <p:cNvPr id="64" name="model-title">
             <a:extLst xmlns:a="http://schemas.openxmlformats.org/drawingml/2006/main">
               <a:ext uri="{FF2B5EF4-FFF2-40B4-BE49-F238E27FC236}">
-                <a16:creationId xmlns:a16="http://schemas.microsoft.com/office/drawing/2014/main" id="{CE5EA8F7-FD32-4771-A4C3-424BAEF2D08C}"/>
+                <a16:creationId xmlns:a16="http://schemas.microsoft.com/office/drawing/2014/main" id="{F8876177-04BB-496C-85F2-57FB2BCF0EDE}"/>
               </a:ext>
             </a:extLst>
           </p:cNvPr>
@@ -3920,14 +3920,14 @@
             <a:pPr algn="ctr">
               <a:defRPr sz="900" b="1">
                 <a:solidFill>
-                  <a:srgbClr val="1769E0"/>
+                  <a:srgbClr val="205BE5"/>
                 </a:solidFill>
               </a:defRPr>
             </a:pPr>
             <a:r>
               <a:rPr sz="900" b="1">
                 <a:solidFill>
-                  <a:srgbClr val="1769E0"/>
+                  <a:srgbClr val="205BE5"/>
                 </a:solidFill>
               </a:rPr>
               <a:t>HF router</a:t>
@@ -3940,7 +3940,7 @@
           <p:cNvPr id="65" name="model-note">
             <a:extLst xmlns:a="http://schemas.openxmlformats.org/drawingml/2006/main">
               <a:ext uri="{FF2B5EF4-FFF2-40B4-BE49-F238E27FC236}">
-                <a16:creationId xmlns:a16="http://schemas.microsoft.com/office/drawing/2014/main" id="{6BB2FB2F-0104-41FD-94F7-DE70F798D0FD}"/>
+                <a16:creationId xmlns:a16="http://schemas.microsoft.com/office/drawing/2014/main" id="{EE55DB7B-E6A2-4AFE-91F3-99042CA66037}"/>
               </a:ext>
             </a:extLst>
           </p:cNvPr>
@@ -3970,14 +3970,14 @@
             <a:pPr algn="ctr">
               <a:defRPr sz="690" b="0">
                 <a:solidFill>
-                  <a:srgbClr val="64748B"/>
+                  <a:srgbClr val="667085"/>
                 </a:solidFill>
               </a:defRPr>
             </a:pPr>
             <a:r>
               <a:rPr sz="690" b="0">
                 <a:solidFill>
-                  <a:srgbClr val="64748B"/>
+                  <a:srgbClr val="667085"/>
                 </a:solidFill>
               </a:rPr>
               <a:t>temp 0.2</a:t>
@@ -3987,14 +3987,14 @@
             <a:pPr algn="ctr">
               <a:defRPr sz="690" b="0">
                 <a:solidFill>
-                  <a:srgbClr val="64748B"/>
+                  <a:srgbClr val="667085"/>
                 </a:solidFill>
               </a:defRPr>
             </a:pPr>
             <a:r>
               <a:rPr sz="690" b="0">
                 <a:solidFill>
-                  <a:srgbClr val="64748B"/>
+                  <a:srgbClr val="667085"/>
                 </a:solidFill>
               </a:rPr>
               <a:t>25 s timeout</a:t>
@@ -4007,7 +4007,7 @@
           <p:cNvPr id="66" name="refusal">
             <a:extLst xmlns:a="http://schemas.openxmlformats.org/drawingml/2006/main">
               <a:ext uri="{FF2B5EF4-FFF2-40B4-BE49-F238E27FC236}">
-                <a16:creationId xmlns:a16="http://schemas.microsoft.com/office/drawing/2014/main" id="{888F1DE0-3D67-49DB-A28F-3C9F26CB23B5}"/>
+                <a16:creationId xmlns:a16="http://schemas.microsoft.com/office/drawing/2014/main" id="{8CACE831-09AD-4A3D-8352-51B6BD25509F}"/>
               </a:ext>
             </a:extLst>
           </p:cNvPr>
@@ -4027,11 +4027,11 @@
             </a:avLst>
           </a:prstGeom>
           <a:solidFill xmlns:a="http://schemas.openxmlformats.org/drawingml/2006/main">
-            <a:srgbClr val="FCE8E4"/>
+            <a:srgbClr val="F8E9E5"/>
           </a:solidFill>
           <a:ln xmlns:a="http://schemas.openxmlformats.org/drawingml/2006/main" w="12383">
             <a:solidFill>
-              <a:srgbClr val="CC4B3E"/>
+              <a:srgbClr val="C85440"/>
             </a:solidFill>
             <a:prstDash val="solid"/>
           </a:ln>
@@ -4042,7 +4042,7 @@
           <p:cNvPr id="67" name="refusal-copy">
             <a:extLst xmlns:a="http://schemas.openxmlformats.org/drawingml/2006/main">
               <a:ext uri="{FF2B5EF4-FFF2-40B4-BE49-F238E27FC236}">
-                <a16:creationId xmlns:a16="http://schemas.microsoft.com/office/drawing/2014/main" id="{1F5F79EC-C379-4BA7-B3D9-D464CBCCAA15}"/>
+                <a16:creationId xmlns:a16="http://schemas.microsoft.com/office/drawing/2014/main" id="{06DD625E-1CC1-4A9B-8D2A-89FBD6BF2341}"/>
               </a:ext>
             </a:extLst>
           </p:cNvPr>
@@ -4072,14 +4072,14 @@
             <a:pPr algn="ctr">
               <a:defRPr sz="788" b="1">
                 <a:solidFill>
-                  <a:srgbClr val="CC4B3E"/>
+                  <a:srgbClr val="C85440"/>
                 </a:solidFill>
               </a:defRPr>
             </a:pPr>
             <a:r>
               <a:rPr sz="788" b="1">
                 <a:solidFill>
-                  <a:srgbClr val="CC4B3E"/>
+                  <a:srgbClr val="C85440"/>
                 </a:solidFill>
               </a:rPr>
               <a:t>422 · refuse</a:t>
@@ -4089,14 +4089,14 @@
             <a:pPr algn="ctr">
               <a:defRPr sz="788" b="1">
                 <a:solidFill>
-                  <a:srgbClr val="CC4B3E"/>
+                  <a:srgbClr val="C85440"/>
                 </a:solidFill>
               </a:defRPr>
             </a:pPr>
             <a:r>
               <a:rPr sz="788" b="1">
                 <a:solidFill>
-                  <a:srgbClr val="CC4B3E"/>
+                  <a:srgbClr val="C85440"/>
                 </a:solidFill>
               </a:rPr>
               <a:t>no generation</a:t>
@@ -4109,7 +4109,7 @@
           <p:cNvPr id="68" name="response">
             <a:extLst xmlns:a="http://schemas.openxmlformats.org/drawingml/2006/main">
               <a:ext uri="{FF2B5EF4-FFF2-40B4-BE49-F238E27FC236}">
-                <a16:creationId xmlns:a16="http://schemas.microsoft.com/office/drawing/2014/main" id="{7317162E-3D76-46E6-8AF3-29C18CAE96F1}"/>
+                <a16:creationId xmlns:a16="http://schemas.microsoft.com/office/drawing/2014/main" id="{DC10C4A5-2CFB-4A0D-B291-624E65A20E81}"/>
               </a:ext>
             </a:extLst>
           </p:cNvPr>
@@ -4129,11 +4129,11 @@
             </a:avLst>
           </a:prstGeom>
           <a:solidFill xmlns:a="http://schemas.openxmlformats.org/drawingml/2006/main">
-            <a:srgbClr val="E5F0FF"/>
+            <a:srgbClr val="EAF1FF"/>
           </a:solidFill>
           <a:ln xmlns:a="http://schemas.openxmlformats.org/drawingml/2006/main" w="12383">
             <a:solidFill>
-              <a:srgbClr val="1769E0"/>
+              <a:srgbClr val="205BE5"/>
             </a:solidFill>
             <a:prstDash val="solid"/>
           </a:ln>
@@ -4144,7 +4144,7 @@
           <p:cNvPr id="69" name="response-copy">
             <a:extLst xmlns:a="http://schemas.openxmlformats.org/drawingml/2006/main">
               <a:ext uri="{FF2B5EF4-FFF2-40B4-BE49-F238E27FC236}">
-                <a16:creationId xmlns:a16="http://schemas.microsoft.com/office/drawing/2014/main" id="{8FC9BEA8-F1A9-4431-9A9F-DC9E54641252}"/>
+                <a16:creationId xmlns:a16="http://schemas.microsoft.com/office/drawing/2014/main" id="{5FC31A9B-4BA5-40DC-BDED-9AD9352A5A84}"/>
               </a:ext>
             </a:extLst>
           </p:cNvPr>
@@ -4174,14 +4174,14 @@
             <a:pPr algn="ctr">
               <a:defRPr sz="750" b="1">
                 <a:solidFill>
-                  <a:srgbClr val="1769E0"/>
+                  <a:srgbClr val="205BE5"/>
                 </a:solidFill>
               </a:defRPr>
             </a:pPr>
             <a:r>
               <a:rPr sz="750" b="1">
                 <a:solidFill>
-                  <a:srgbClr val="1769E0"/>
+                  <a:srgbClr val="205BE5"/>
                 </a:solidFill>
               </a:rPr>
               <a:t>answer +</a:t>
@@ -4191,14 +4191,14 @@
             <a:pPr algn="ctr">
               <a:defRPr sz="750" b="1">
                 <a:solidFill>
-                  <a:srgbClr val="1769E0"/>
+                  <a:srgbClr val="205BE5"/>
                 </a:solidFill>
               </a:defRPr>
             </a:pPr>
             <a:r>
               <a:rPr sz="750" b="1">
                 <a:solidFill>
-                  <a:srgbClr val="1769E0"/>
+                  <a:srgbClr val="205BE5"/>
                 </a:solidFill>
               </a:rPr>
               <a:t>≤4 sources</a:t>
@@ -4211,7 +4211,7 @@
           <p:cNvPr id="70" name="bound-browser-num">
             <a:extLst xmlns:a="http://schemas.openxmlformats.org/drawingml/2006/main">
               <a:ext uri="{FF2B5EF4-FFF2-40B4-BE49-F238E27FC236}">
-                <a16:creationId xmlns:a16="http://schemas.microsoft.com/office/drawing/2014/main" id="{B513D161-3D1B-4BF7-8274-EE4074339C35}"/>
+                <a16:creationId xmlns:a16="http://schemas.microsoft.com/office/drawing/2014/main" id="{36908B72-8A30-4B71-99E8-7C7E42F8351F}"/>
               </a:ext>
             </a:extLst>
           </p:cNvPr>
@@ -4229,11 +4229,11 @@
             <a:avLst/>
           </a:prstGeom>
           <a:solidFill xmlns:a="http://schemas.openxmlformats.org/drawingml/2006/main">
-            <a:srgbClr val="15365F"/>
+            <a:srgbClr val="172033"/>
           </a:solidFill>
           <a:ln xmlns:a="http://schemas.openxmlformats.org/drawingml/2006/main" w="0">
             <a:solidFill>
-              <a:srgbClr val="15365F"/>
+              <a:srgbClr val="172033"/>
             </a:solidFill>
             <a:prstDash val="solid"/>
           </a:ln>
@@ -4244,7 +4244,7 @@
           <p:cNvPr id="71" name="bound-browser-n">
             <a:extLst xmlns:a="http://schemas.openxmlformats.org/drawingml/2006/main">
               <a:ext uri="{FF2B5EF4-FFF2-40B4-BE49-F238E27FC236}">
-                <a16:creationId xmlns:a16="http://schemas.microsoft.com/office/drawing/2014/main" id="{80F53CC5-BD65-46DE-96BD-F2583F75EA12}"/>
+                <a16:creationId xmlns:a16="http://schemas.microsoft.com/office/drawing/2014/main" id="{753C39D2-86B1-48ED-893F-E8185DD4C8A0}"/>
               </a:ext>
             </a:extLst>
           </p:cNvPr>
@@ -4294,7 +4294,7 @@
           <p:cNvPr id="72" name="bound-browser-title">
             <a:extLst xmlns:a="http://schemas.openxmlformats.org/drawingml/2006/main">
               <a:ext uri="{FF2B5EF4-FFF2-40B4-BE49-F238E27FC236}">
-                <a16:creationId xmlns:a16="http://schemas.microsoft.com/office/drawing/2014/main" id="{3E7177B5-52CC-44DF-814A-29E379BC3BA6}"/>
+                <a16:creationId xmlns:a16="http://schemas.microsoft.com/office/drawing/2014/main" id="{B5AE3119-ABBE-4B9D-8BE0-E95227895E2B}"/>
               </a:ext>
             </a:extLst>
           </p:cNvPr>
@@ -4324,14 +4324,14 @@
             <a:pPr algn="l">
               <a:defRPr sz="750" b="1">
                 <a:solidFill>
-                  <a:srgbClr val="15365F"/>
+                  <a:srgbClr val="172033"/>
                 </a:solidFill>
               </a:defRPr>
             </a:pPr>
             <a:r>
               <a:rPr sz="750" b="1">
                 <a:solidFill>
-                  <a:srgbClr val="15365F"/>
+                  <a:srgbClr val="172033"/>
                 </a:solidFill>
               </a:rPr>
               <a:t>SERVER BOUNDARY</a:t>
@@ -4344,7 +4344,7 @@
           <p:cNvPr id="73" name="bound-browser-body">
             <a:extLst xmlns:a="http://schemas.openxmlformats.org/drawingml/2006/main">
               <a:ext uri="{FF2B5EF4-FFF2-40B4-BE49-F238E27FC236}">
-                <a16:creationId xmlns:a16="http://schemas.microsoft.com/office/drawing/2014/main" id="{61B77D91-5CB2-4481-B252-F1DCAD8CDD25}"/>
+                <a16:creationId xmlns:a16="http://schemas.microsoft.com/office/drawing/2014/main" id="{99CC8252-CF4E-4485-BB2B-E5B810B80763}"/>
               </a:ext>
             </a:extLst>
           </p:cNvPr>
@@ -4374,14 +4374,14 @@
             <a:pPr algn="l">
               <a:defRPr sz="713" b="0">
                 <a:solidFill>
-                  <a:srgbClr val="64748B"/>
+                  <a:srgbClr val="667085"/>
                 </a:solidFill>
               </a:defRPr>
             </a:pPr>
             <a:r>
               <a:rPr sz="713" b="0">
                 <a:solidFill>
-                  <a:srgbClr val="64748B"/>
+                  <a:srgbClr val="667085"/>
                 </a:solidFill>
               </a:rPr>
               <a:t>Astra and model credentials never enter the browser.</a:t>
@@ -4394,7 +4394,7 @@
           <p:cNvPr id="74" name="bound-empty-num">
             <a:extLst xmlns:a="http://schemas.openxmlformats.org/drawingml/2006/main">
               <a:ext uri="{FF2B5EF4-FFF2-40B4-BE49-F238E27FC236}">
-                <a16:creationId xmlns:a16="http://schemas.microsoft.com/office/drawing/2014/main" id="{9BC44C7A-2C03-45C7-A978-0F3F9F8191AF}"/>
+                <a16:creationId xmlns:a16="http://schemas.microsoft.com/office/drawing/2014/main" id="{04B9A81A-3876-43FE-A2C4-0C7CCBD7ED3D}"/>
               </a:ext>
             </a:extLst>
           </p:cNvPr>
@@ -4412,11 +4412,11 @@
             <a:avLst/>
           </a:prstGeom>
           <a:solidFill xmlns:a="http://schemas.openxmlformats.org/drawingml/2006/main">
-            <a:srgbClr val="CC4B3E"/>
+            <a:srgbClr val="C85440"/>
           </a:solidFill>
           <a:ln xmlns:a="http://schemas.openxmlformats.org/drawingml/2006/main" w="0">
             <a:solidFill>
-              <a:srgbClr val="CC4B3E"/>
+              <a:srgbClr val="C85440"/>
             </a:solidFill>
             <a:prstDash val="solid"/>
           </a:ln>
@@ -4427,7 +4427,7 @@
           <p:cNvPr id="75" name="bound-empty-n">
             <a:extLst xmlns:a="http://schemas.openxmlformats.org/drawingml/2006/main">
               <a:ext uri="{FF2B5EF4-FFF2-40B4-BE49-F238E27FC236}">
-                <a16:creationId xmlns:a16="http://schemas.microsoft.com/office/drawing/2014/main" id="{DFCCEBB4-2E39-4686-8DA9-6FC797C9B9C7}"/>
+                <a16:creationId xmlns:a16="http://schemas.microsoft.com/office/drawing/2014/main" id="{3BA8D041-121E-4F13-8895-6547F543AFBF}"/>
               </a:ext>
             </a:extLst>
           </p:cNvPr>
@@ -4477,7 +4477,7 @@
           <p:cNvPr id="76" name="bound-empty-title">
             <a:extLst xmlns:a="http://schemas.openxmlformats.org/drawingml/2006/main">
               <a:ext uri="{FF2B5EF4-FFF2-40B4-BE49-F238E27FC236}">
-                <a16:creationId xmlns:a16="http://schemas.microsoft.com/office/drawing/2014/main" id="{71C121A2-A426-4392-B500-6ABF0F6EDD27}"/>
+                <a16:creationId xmlns:a16="http://schemas.microsoft.com/office/drawing/2014/main" id="{377F0D9E-83F2-4DD8-99DD-447A5E8026FF}"/>
               </a:ext>
             </a:extLst>
           </p:cNvPr>
@@ -4507,14 +4507,14 @@
             <a:pPr algn="l">
               <a:defRPr sz="750" b="1">
                 <a:solidFill>
-                  <a:srgbClr val="CC4B3E"/>
+                  <a:srgbClr val="C85440"/>
                 </a:solidFill>
               </a:defRPr>
             </a:pPr>
             <a:r>
               <a:rPr sz="750" b="1">
                 <a:solidFill>
-                  <a:srgbClr val="CC4B3E"/>
+                  <a:srgbClr val="C85440"/>
                 </a:solidFill>
               </a:rPr>
               <a:t>EMPTY RETRIEVAL</a:t>
@@ -4527,7 +4527,7 @@
           <p:cNvPr id="77" name="bound-empty-body">
             <a:extLst xmlns:a="http://schemas.openxmlformats.org/drawingml/2006/main">
               <a:ext uri="{FF2B5EF4-FFF2-40B4-BE49-F238E27FC236}">
-                <a16:creationId xmlns:a16="http://schemas.microsoft.com/office/drawing/2014/main" id="{75B3AC31-AAF9-425C-A4B6-64DBFCB1B2A8}"/>
+                <a16:creationId xmlns:a16="http://schemas.microsoft.com/office/drawing/2014/main" id="{FA542278-EC00-4747-8126-12BA688BA309}"/>
               </a:ext>
             </a:extLst>
           </p:cNvPr>
@@ -4557,14 +4557,14 @@
             <a:pPr algn="l">
               <a:defRPr sz="713" b="0">
                 <a:solidFill>
-                  <a:srgbClr val="64748B"/>
+                  <a:srgbClr val="667085"/>
                 </a:solidFill>
               </a:defRPr>
             </a:pPr>
             <a:r>
               <a:rPr sz="713" b="0">
                 <a:solidFill>
-                  <a:srgbClr val="64748B"/>
+                  <a:srgbClr val="667085"/>
                 </a:solidFill>
               </a:rPr>
               <a:t>The route refuses before generation—no general-knowledge fallback.</a:t>
@@ -4577,7 +4577,7 @@
           <p:cNvPr id="78" name="bound-scope-num">
             <a:extLst xmlns:a="http://schemas.openxmlformats.org/drawingml/2006/main">
               <a:ext uri="{FF2B5EF4-FFF2-40B4-BE49-F238E27FC236}">
-                <a16:creationId xmlns:a16="http://schemas.microsoft.com/office/drawing/2014/main" id="{BB8C4F66-155A-4920-9962-C57049BE836A}"/>
+                <a16:creationId xmlns:a16="http://schemas.microsoft.com/office/drawing/2014/main" id="{F99BB6BE-1803-45B7-94B3-B57778D887E7}"/>
               </a:ext>
             </a:extLst>
           </p:cNvPr>
@@ -4595,11 +4595,11 @@
             <a:avLst/>
           </a:prstGeom>
           <a:solidFill xmlns:a="http://schemas.openxmlformats.org/drawingml/2006/main">
-            <a:srgbClr val="1F8065"/>
+            <a:srgbClr val="127B78"/>
           </a:solidFill>
           <a:ln xmlns:a="http://schemas.openxmlformats.org/drawingml/2006/main" w="0">
             <a:solidFill>
-              <a:srgbClr val="1F8065"/>
+              <a:srgbClr val="127B78"/>
             </a:solidFill>
             <a:prstDash val="solid"/>
           </a:ln>
@@ -4610,7 +4610,7 @@
           <p:cNvPr id="79" name="bound-scope-n">
             <a:extLst xmlns:a="http://schemas.openxmlformats.org/drawingml/2006/main">
               <a:ext uri="{FF2B5EF4-FFF2-40B4-BE49-F238E27FC236}">
-                <a16:creationId xmlns:a16="http://schemas.microsoft.com/office/drawing/2014/main" id="{3AE74B03-69BB-4D65-9013-C6C068497BEF}"/>
+                <a16:creationId xmlns:a16="http://schemas.microsoft.com/office/drawing/2014/main" id="{2D8400D0-CACA-40C3-82C4-AB517F5660B3}"/>
               </a:ext>
             </a:extLst>
           </p:cNvPr>
@@ -4660,7 +4660,7 @@
           <p:cNvPr id="80" name="bound-scope-title">
             <a:extLst xmlns:a="http://schemas.openxmlformats.org/drawingml/2006/main">
               <a:ext uri="{FF2B5EF4-FFF2-40B4-BE49-F238E27FC236}">
-                <a16:creationId xmlns:a16="http://schemas.microsoft.com/office/drawing/2014/main" id="{726EA682-D1E0-4001-9280-E53E87E61A64}"/>
+                <a16:creationId xmlns:a16="http://schemas.microsoft.com/office/drawing/2014/main" id="{B3A7C7D7-AC6D-4A40-B270-FF565FF988F8}"/>
               </a:ext>
             </a:extLst>
           </p:cNvPr>
@@ -4690,14 +4690,14 @@
             <a:pPr algn="l">
               <a:defRPr sz="750" b="1">
                 <a:solidFill>
-                  <a:srgbClr val="1F8065"/>
+                  <a:srgbClr val="127B78"/>
                 </a:solidFill>
               </a:defRPr>
             </a:pPr>
             <a:r>
               <a:rPr sz="750" b="1">
                 <a:solidFill>
-                  <a:srgbClr val="1F8065"/>
+                  <a:srgbClr val="127B78"/>
                 </a:solidFill>
               </a:rPr>
               <a:t>SCOPE</a:t>
@@ -4710,7 +4710,7 @@
           <p:cNvPr id="81" name="bound-scope-body">
             <a:extLst xmlns:a="http://schemas.openxmlformats.org/drawingml/2006/main">
               <a:ext uri="{FF2B5EF4-FFF2-40B4-BE49-F238E27FC236}">
-                <a16:creationId xmlns:a16="http://schemas.microsoft.com/office/drawing/2014/main" id="{23E6DF64-82CA-40AC-A61F-E72E6BDB2AB9}"/>
+                <a16:creationId xmlns:a16="http://schemas.microsoft.com/office/drawing/2014/main" id="{F5D94EBF-94B5-4A2D-B261-4E9B8F4E459B}"/>
               </a:ext>
             </a:extLst>
           </p:cNvPr>
@@ -4740,14 +4740,14 @@
             <a:pPr algn="l">
               <a:defRPr sz="713" b="0">
                 <a:solidFill>
-                  <a:srgbClr val="64748B"/>
+                  <a:srgbClr val="667085"/>
                 </a:solidFill>
               </a:defRPr>
             </a:pPr>
             <a:r>
               <a:rPr sz="713" b="0">
                 <a:solidFill>
-                  <a:srgbClr val="64748B"/>
+                  <a:srgbClr val="667085"/>
                 </a:solidFill>
               </a:rPr>
               <a:t>Educational guidance only; no PHI, coverage, or amount-owed decision.</a:t>
@@ -4760,7 +4760,7 @@
           <p:cNvPr id="82" name="caption">
             <a:extLst xmlns:a="http://schemas.openxmlformats.org/drawingml/2006/main">
               <a:ext uri="{FF2B5EF4-FFF2-40B4-BE49-F238E27FC236}">
-                <a16:creationId xmlns:a16="http://schemas.microsoft.com/office/drawing/2014/main" id="{D1CE6787-F246-432D-9E7B-0A3FADA70FC4}"/>
+                <a16:creationId xmlns:a16="http://schemas.microsoft.com/office/drawing/2014/main" id="{F7FB6CA2-E2DC-4587-A412-E66EAEAA89E2}"/>
               </a:ext>
             </a:extLst>
           </p:cNvPr>
@@ -4790,14 +4790,14 @@
             <a:pPr algn="l">
               <a:defRPr sz="938" b="0">
                 <a:solidFill>
-                  <a:srgbClr val="12223D"/>
+                  <a:srgbClr val="172033"/>
                 </a:solidFill>
               </a:defRPr>
             </a:pPr>
             <a:r>
               <a:rPr sz="938" b="0">
                 <a:solidFill>
-                  <a:srgbClr val="12223D"/>
+                  <a:srgbClr val="172033"/>
                 </a:solidFill>
               </a:rPr>
               <a:t>The offline and online paths share only the embedding space and vector collection; the evidence gate decides whether generation is allowed.</a:t>
@@ -4810,7 +4810,7 @@
           <p:cNvPr id="83" name="sources">
             <a:extLst xmlns:a="http://schemas.openxmlformats.org/drawingml/2006/main">
               <a:ext uri="{FF2B5EF4-FFF2-40B4-BE49-F238E27FC236}">
-                <a16:creationId xmlns:a16="http://schemas.microsoft.com/office/drawing/2014/main" id="{13ADBAAF-8328-4F84-8A69-B62389256EE9}"/>
+                <a16:creationId xmlns:a16="http://schemas.microsoft.com/office/drawing/2014/main" id="{61B88C7F-8B6E-493F-8DCB-5728B5947836}"/>
               </a:ext>
             </a:extLst>
           </p:cNvPr>
@@ -4840,14 +4840,14 @@
             <a:pPr algn="l">
               <a:defRPr sz="690" b="0">
                 <a:solidFill>
-                  <a:srgbClr val="64748B"/>
+                  <a:srgbClr val="667085"/>
                 </a:solidFill>
               </a:defRPr>
             </a:pPr>
             <a:r>
               <a:rPr sz="690" b="0">
                 <a:solidFill>
-                  <a:srgbClr val="64748B"/>
+                  <a:srgbClr val="667085"/>
                 </a:solidFill>
               </a:rPr>
               <a:t>scripts/loadDB.ts · app/api/chat/route.ts · app/lib/chat.ts · app/types.ts</a:t>
@@ -4858,7 +4858,7 @@
     </p:spTree>
     <p:extLst>
       <p:ext uri="{BB962C8B-B14F-4D97-AF65-F5344CB8AC3E}">
-        <p14:creationId xmlns:p14="http://schemas.microsoft.com/office/powerpoint/2010/main" val="330265552"/>
+        <p14:creationId xmlns:p14="http://schemas.microsoft.com/office/powerpoint/2010/main" val="1766284720"/>
       </p:ext>
     </p:extLst>
   </p:cSld>

</xml_diff>